<commit_message>
feat: Update PowerPoint template by removing decorative elements and enhancing agenda visibility
</commit_message>
<xml_diff>
--- a/Plans/template-output/bsides-aarhus-2026-template.pptx
+++ b/Plans/template-output/bsides-aarhus-2026-template.pptx
@@ -3116,22 +3116,186 @@
           </a:prstGeom>
         </p:spPr>
       </p:pic>
-      <p:sp>
-        <p:nvSpPr>
-          <p:cNvPr id="3" name="Rectangle 2"/>
+      <p:pic>
+        <p:nvPicPr>
+          <p:cNvPr id="3" name="Picture 2" descr="logo.png"/>
+          <p:cNvPicPr>
+            <a:picLocks noChangeAspect="1"/>
+          </p:cNvPicPr>
+          <p:nvPr/>
+        </p:nvPicPr>
+        <p:blipFill>
+          <a:blip r:embed="rId3"/>
+          <a:stretch>
+            <a:fillRect/>
+          </a:stretch>
+        </p:blipFill>
+        <p:spPr>
+          <a:xfrm>
+            <a:off x="548640" y="502920"/>
+            <a:ext cx="864973" cy="640080"/>
+          </a:xfrm>
+          <a:prstGeom prst="rect">
+            <a:avLst/>
+          </a:prstGeom>
+        </p:spPr>
+      </p:pic>
+      <p:sp>
+        <p:nvSpPr>
+          <p:cNvPr id="4" name="TextBox 3"/>
+          <p:cNvSpPr txBox="1"/>
+          <p:nvPr/>
+        </p:nvSpPr>
+        <p:spPr>
+          <a:xfrm>
+            <a:off x="548640" y="2011680"/>
+            <a:ext cx="10972800" cy="457200"/>
+          </a:xfrm>
+          <a:prstGeom prst="rect">
+            <a:avLst/>
+          </a:prstGeom>
+          <a:noFill/>
+        </p:spPr>
+        <p:txBody>
+          <a:bodyPr wrap="square" lIns="0" rIns="0" tIns="0" bIns="0" anchor="t">
+            <a:spAutoFit/>
+          </a:bodyPr>
+          <a:lstStyle/>
+          <a:p>
+            <a:pPr algn="l"/>
+            <a:r>
+              <a:rPr sz="1400" b="1">
+                <a:solidFill>
+                  <a:srgbClr val="4AB8D2"/>
+                </a:solidFill>
+                <a:latin typeface="JetBrains Mono"/>
+              </a:rPr>
+              <a:t>SECURITY CONFERENCE  ·  AARHUS</a:t>
+            </a:r>
+          </a:p>
+        </p:txBody>
+      </p:sp>
+      <p:sp>
+        <p:nvSpPr>
+          <p:cNvPr id="5" name="TextBox 4"/>
+          <p:cNvSpPr txBox="1"/>
+          <p:nvPr/>
+        </p:nvSpPr>
+        <p:spPr>
+          <a:xfrm>
+            <a:off x="548640" y="2468880"/>
+            <a:ext cx="10972800" cy="1463040"/>
+          </a:xfrm>
+          <a:prstGeom prst="rect">
+            <a:avLst/>
+          </a:prstGeom>
+          <a:noFill/>
+        </p:spPr>
+        <p:txBody>
+          <a:bodyPr wrap="square" lIns="0" rIns="0" tIns="0" bIns="0" anchor="t">
+            <a:spAutoFit/>
+          </a:bodyPr>
+          <a:lstStyle/>
+          <a:p>
+            <a:pPr algn="l"/>
+            <a:r>
+              <a:rPr sz="7200" b="1">
+                <a:solidFill>
+                  <a:srgbClr val="E8E8ED"/>
+                </a:solidFill>
+                <a:latin typeface="Inter"/>
+              </a:rPr>
+              <a:t>BSides Aarhus 2026</a:t>
+            </a:r>
+          </a:p>
+        </p:txBody>
+      </p:sp>
+      <p:sp>
+        <p:nvSpPr>
+          <p:cNvPr id="6" name="TextBox 5"/>
+          <p:cNvSpPr txBox="1"/>
+          <p:nvPr/>
+        </p:nvSpPr>
+        <p:spPr>
+          <a:xfrm>
+            <a:off x="548640" y="4206240"/>
+            <a:ext cx="10972800" cy="548640"/>
+          </a:xfrm>
+          <a:prstGeom prst="rect">
+            <a:avLst/>
+          </a:prstGeom>
+          <a:noFill/>
+        </p:spPr>
+        <p:txBody>
+          <a:bodyPr wrap="square" lIns="0" rIns="0" tIns="0" bIns="0" anchor="t">
+            <a:spAutoFit/>
+          </a:bodyPr>
+          <a:lstStyle/>
+          <a:p>
+            <a:pPr algn="l"/>
+            <a:r>
+              <a:rPr sz="3200" b="0">
+                <a:solidFill>
+                  <a:srgbClr val="6DD0E7"/>
+                </a:solidFill>
+                <a:latin typeface="Inter"/>
+              </a:rPr>
+              <a:t>Talk title goes here</a:t>
+            </a:r>
+          </a:p>
+        </p:txBody>
+      </p:sp>
+      <p:sp>
+        <p:nvSpPr>
+          <p:cNvPr id="7" name="TextBox 6"/>
+          <p:cNvSpPr txBox="1"/>
+          <p:nvPr/>
+        </p:nvSpPr>
+        <p:spPr>
+          <a:xfrm>
+            <a:off x="548640" y="4937760"/>
+            <a:ext cx="10972800" cy="411480"/>
+          </a:xfrm>
+          <a:prstGeom prst="rect">
+            <a:avLst/>
+          </a:prstGeom>
+          <a:noFill/>
+        </p:spPr>
+        <p:txBody>
+          <a:bodyPr wrap="square" lIns="0" rIns="0" tIns="0" bIns="0" anchor="t">
+            <a:spAutoFit/>
+          </a:bodyPr>
+          <a:lstStyle/>
+          <a:p>
+            <a:pPr algn="l"/>
+            <a:r>
+              <a:rPr sz="2000" b="0">
+                <a:solidFill>
+                  <a:srgbClr val="8888A0"/>
+                </a:solidFill>
+                <a:latin typeface="Inter"/>
+              </a:rPr>
+              <a:t>Speaker Name  ·  Affiliation</a:t>
+            </a:r>
+          </a:p>
+        </p:txBody>
+      </p:sp>
+      <p:sp>
+        <p:nvSpPr>
+          <p:cNvPr id="8" name="Rectangle 7"/>
           <p:cNvSpPr/>
           <p:nvPr/>
         </p:nvSpPr>
         <p:spPr>
           <a:xfrm>
-            <a:off x="0" y="2743200"/>
-            <a:ext cx="12191695" cy="1463040"/>
+            <a:off x="0" y="6217920"/>
+            <a:ext cx="12191695" cy="38100"/>
           </a:xfrm>
           <a:prstGeom prst="rect">
             <a:avLst/>
           </a:prstGeom>
           <a:solidFill>
-            <a:srgbClr val="12121A"/>
+            <a:srgbClr val="4AB8D2"/>
           </a:solidFill>
           <a:ln>
             <a:noFill/>
@@ -3159,216 +3323,9 @@
           </a:p>
         </p:txBody>
       </p:sp>
-      <p:pic>
-        <p:nvPicPr>
-          <p:cNvPr id="4" name="Picture 3" descr="logo.png"/>
-          <p:cNvPicPr>
-            <a:picLocks noChangeAspect="1"/>
-          </p:cNvPicPr>
-          <p:nvPr/>
-        </p:nvPicPr>
-        <p:blipFill>
-          <a:blip r:embed="rId3"/>
-          <a:stretch>
-            <a:fillRect/>
-          </a:stretch>
-        </p:blipFill>
-        <p:spPr>
-          <a:xfrm>
-            <a:off x="548640" y="502920"/>
-            <a:ext cx="864973" cy="640080"/>
-          </a:xfrm>
-          <a:prstGeom prst="rect">
-            <a:avLst/>
-          </a:prstGeom>
-        </p:spPr>
-      </p:pic>
-      <p:sp>
-        <p:nvSpPr>
-          <p:cNvPr id="5" name="TextBox 4"/>
-          <p:cNvSpPr txBox="1"/>
-          <p:nvPr/>
-        </p:nvSpPr>
-        <p:spPr>
-          <a:xfrm>
-            <a:off x="548640" y="2011680"/>
-            <a:ext cx="10972800" cy="457200"/>
-          </a:xfrm>
-          <a:prstGeom prst="rect">
-            <a:avLst/>
-          </a:prstGeom>
-          <a:noFill/>
-        </p:spPr>
-        <p:txBody>
-          <a:bodyPr wrap="square" lIns="0" rIns="0" tIns="0" bIns="0" anchor="t">
-            <a:spAutoFit/>
-          </a:bodyPr>
-          <a:lstStyle/>
-          <a:p>
-            <a:pPr algn="l"/>
-            <a:r>
-              <a:rPr sz="1400" b="1">
-                <a:solidFill>
-                  <a:srgbClr val="4AB8D2"/>
-                </a:solidFill>
-                <a:latin typeface="JetBrains Mono"/>
-              </a:rPr>
-              <a:t>SECURITY CONFERENCE  ·  AARHUS</a:t>
-            </a:r>
-          </a:p>
-        </p:txBody>
-      </p:sp>
-      <p:sp>
-        <p:nvSpPr>
-          <p:cNvPr id="6" name="TextBox 5"/>
-          <p:cNvSpPr txBox="1"/>
-          <p:nvPr/>
-        </p:nvSpPr>
-        <p:spPr>
-          <a:xfrm>
-            <a:off x="548640" y="2468880"/>
-            <a:ext cx="10972800" cy="1463040"/>
-          </a:xfrm>
-          <a:prstGeom prst="rect">
-            <a:avLst/>
-          </a:prstGeom>
-          <a:noFill/>
-        </p:spPr>
-        <p:txBody>
-          <a:bodyPr wrap="square" lIns="0" rIns="0" tIns="0" bIns="0" anchor="t">
-            <a:spAutoFit/>
-          </a:bodyPr>
-          <a:lstStyle/>
-          <a:p>
-            <a:pPr algn="l"/>
-            <a:r>
-              <a:rPr sz="7200" b="1">
-                <a:solidFill>
-                  <a:srgbClr val="E8E8ED"/>
-                </a:solidFill>
-                <a:latin typeface="Inter"/>
-              </a:rPr>
-              <a:t>BSides Aarhus 2026</a:t>
-            </a:r>
-          </a:p>
-        </p:txBody>
-      </p:sp>
-      <p:sp>
-        <p:nvSpPr>
-          <p:cNvPr id="7" name="TextBox 6"/>
-          <p:cNvSpPr txBox="1"/>
-          <p:nvPr/>
-        </p:nvSpPr>
-        <p:spPr>
-          <a:xfrm>
-            <a:off x="548640" y="4206240"/>
-            <a:ext cx="10972800" cy="548640"/>
-          </a:xfrm>
-          <a:prstGeom prst="rect">
-            <a:avLst/>
-          </a:prstGeom>
-          <a:noFill/>
-        </p:spPr>
-        <p:txBody>
-          <a:bodyPr wrap="square" lIns="0" rIns="0" tIns="0" bIns="0" anchor="t">
-            <a:spAutoFit/>
-          </a:bodyPr>
-          <a:lstStyle/>
-          <a:p>
-            <a:pPr algn="l"/>
-            <a:r>
-              <a:rPr sz="3200" b="0">
-                <a:solidFill>
-                  <a:srgbClr val="6DD0E7"/>
-                </a:solidFill>
-                <a:latin typeface="Inter"/>
-              </a:rPr>
-              <a:t>Talk title goes here</a:t>
-            </a:r>
-          </a:p>
-        </p:txBody>
-      </p:sp>
-      <p:sp>
-        <p:nvSpPr>
-          <p:cNvPr id="8" name="TextBox 7"/>
-          <p:cNvSpPr txBox="1"/>
-          <p:nvPr/>
-        </p:nvSpPr>
-        <p:spPr>
-          <a:xfrm>
-            <a:off x="548640" y="4937760"/>
-            <a:ext cx="10972800" cy="411480"/>
-          </a:xfrm>
-          <a:prstGeom prst="rect">
-            <a:avLst/>
-          </a:prstGeom>
-          <a:noFill/>
-        </p:spPr>
-        <p:txBody>
-          <a:bodyPr wrap="square" lIns="0" rIns="0" tIns="0" bIns="0" anchor="t">
-            <a:spAutoFit/>
-          </a:bodyPr>
-          <a:lstStyle/>
-          <a:p>
-            <a:pPr algn="l"/>
-            <a:r>
-              <a:rPr sz="2000" b="0">
-                <a:solidFill>
-                  <a:srgbClr val="8888A0"/>
-                </a:solidFill>
-                <a:latin typeface="Inter"/>
-              </a:rPr>
-              <a:t>Speaker Name  ·  Affiliation</a:t>
-            </a:r>
-          </a:p>
-        </p:txBody>
-      </p:sp>
-      <p:sp>
-        <p:nvSpPr>
-          <p:cNvPr id="9" name="Rectangle 8"/>
-          <p:cNvSpPr/>
-          <p:nvPr/>
-        </p:nvSpPr>
-        <p:spPr>
-          <a:xfrm>
-            <a:off x="0" y="6217920"/>
-            <a:ext cx="12191695" cy="38100"/>
-          </a:xfrm>
-          <a:prstGeom prst="rect">
-            <a:avLst/>
-          </a:prstGeom>
-          <a:solidFill>
-            <a:srgbClr val="4AB8D2"/>
-          </a:solidFill>
-          <a:ln>
-            <a:noFill/>
-          </a:ln>
-        </p:spPr>
-        <p:style>
-          <a:lnRef idx="1">
-            <a:schemeClr val="accent1"/>
-          </a:lnRef>
-          <a:fillRef idx="3">
-            <a:schemeClr val="accent1"/>
-          </a:fillRef>
-          <a:effectRef idx="2">
-            <a:schemeClr val="accent1"/>
-          </a:effectRef>
-          <a:fontRef idx="minor">
-            <a:schemeClr val="lt1"/>
-          </a:fontRef>
-        </p:style>
-        <p:txBody>
-          <a:bodyPr rtlCol="0" anchor="ctr"/>
-          <a:lstStyle/>
-          <a:p>
-            <a:pPr algn="ctr"/>
-          </a:p>
-        </p:txBody>
-      </p:sp>
-      <p:sp>
-        <p:nvSpPr>
-          <p:cNvPr id="10" name="TextBox 9"/>
+      <p:sp>
+        <p:nvSpPr>
+          <p:cNvPr id="9" name="TextBox 8"/>
           <p:cNvSpPr txBox="1"/>
           <p:nvPr/>
         </p:nvSpPr>
@@ -3582,91 +3539,23 @@
       </p:sp>
       <p:sp>
         <p:nvSpPr>
-          <p:cNvPr id="7" name="TextBox 6"/>
-          <p:cNvSpPr txBox="1"/>
-          <p:nvPr/>
-        </p:nvSpPr>
-        <p:spPr>
-          <a:xfrm>
-            <a:off x="1645920" y="2148840"/>
-            <a:ext cx="4929987" cy="320040"/>
-          </a:xfrm>
-          <a:prstGeom prst="rect">
-            <a:avLst/>
-          </a:prstGeom>
-          <a:noFill/>
-        </p:spPr>
-        <p:txBody>
-          <a:bodyPr wrap="square" lIns="0" rIns="0" tIns="0" bIns="0" anchor="ctr">
-            <a:spAutoFit/>
-          </a:bodyPr>
-          <a:lstStyle/>
-          <a:p>
-            <a:pPr algn="ctr"/>
-            <a:r>
-              <a:rPr sz="1100" b="1">
-                <a:solidFill>
-                  <a:srgbClr val="4AB8D2"/>
-                </a:solidFill>
-                <a:latin typeface="JetBrains Mono"/>
-              </a:rPr>
-              <a:t>TRACK 1  ·  ROOM 1</a:t>
-            </a:r>
-          </a:p>
-        </p:txBody>
-      </p:sp>
-      <p:sp>
-        <p:nvSpPr>
-          <p:cNvPr id="8" name="TextBox 7"/>
-          <p:cNvSpPr txBox="1"/>
-          <p:nvPr/>
-        </p:nvSpPr>
-        <p:spPr>
-          <a:xfrm>
-            <a:off x="6713067" y="2148840"/>
-            <a:ext cx="4929987" cy="320040"/>
-          </a:xfrm>
-          <a:prstGeom prst="rect">
-            <a:avLst/>
-          </a:prstGeom>
-          <a:noFill/>
-        </p:spPr>
-        <p:txBody>
-          <a:bodyPr wrap="square" lIns="0" rIns="0" tIns="0" bIns="0" anchor="ctr">
-            <a:spAutoFit/>
-          </a:bodyPr>
-          <a:lstStyle/>
-          <a:p>
-            <a:pPr algn="ctr"/>
-            <a:r>
-              <a:rPr sz="1100" b="1">
-                <a:solidFill>
-                  <a:srgbClr val="4AB8D2"/>
-                </a:solidFill>
-                <a:latin typeface="JetBrains Mono"/>
-              </a:rPr>
-              <a:t>TRACK 2  ·  ROOM 2</a:t>
-            </a:r>
-          </a:p>
-        </p:txBody>
-      </p:sp>
-      <p:sp>
-        <p:nvSpPr>
-          <p:cNvPr id="9" name="Rectangle 8"/>
+          <p:cNvPr id="7" name="Rounded Rectangle 6"/>
           <p:cNvSpPr/>
           <p:nvPr/>
         </p:nvSpPr>
         <p:spPr>
           <a:xfrm>
-            <a:off x="548640" y="2542032"/>
-            <a:ext cx="11094415" cy="438912"/>
-          </a:xfrm>
-          <a:prstGeom prst="rect">
-            <a:avLst/>
+            <a:off x="548640" y="2103120"/>
+            <a:ext cx="11094415" cy="4407408"/>
+          </a:xfrm>
+          <a:prstGeom prst="roundRect">
+            <a:avLst>
+              <a:gd name="adj" fmla="val 2000"/>
+            </a:avLst>
           </a:prstGeom>
           <a:solidFill>
             <a:srgbClr val="1A1A25">
-              <a:alpha val="60000"/>
+              <a:alpha val="15000"/>
             </a:srgbClr>
           </a:solidFill>
           <a:ln>
@@ -3697,14 +3586,14 @@
       </p:sp>
       <p:sp>
         <p:nvSpPr>
-          <p:cNvPr id="10" name="TextBox 9"/>
+          <p:cNvPr id="8" name="TextBox 7"/>
           <p:cNvSpPr txBox="1"/>
           <p:nvPr/>
         </p:nvSpPr>
         <p:spPr>
           <a:xfrm>
-            <a:off x="548640" y="2542032"/>
-            <a:ext cx="960120" cy="438912"/>
+            <a:off x="1645920" y="2148840"/>
+            <a:ext cx="4929987" cy="320040"/>
           </a:xfrm>
           <a:prstGeom prst="rect">
             <a:avLst/>
@@ -3719,27 +3608,27 @@
           <a:p>
             <a:pPr algn="ctr"/>
             <a:r>
-              <a:rPr sz="1400" b="1">
+              <a:rPr sz="1100" b="1">
                 <a:solidFill>
                   <a:srgbClr val="4AB8D2"/>
                 </a:solidFill>
                 <a:latin typeface="JetBrains Mono"/>
               </a:rPr>
-              <a:t>09:00</a:t>
-            </a:r>
-          </a:p>
-        </p:txBody>
-      </p:sp>
-      <p:sp>
-        <p:nvSpPr>
-          <p:cNvPr id="11" name="TextBox 10"/>
+              <a:t>TRACK 1  ·  ROOM 1</a:t>
+            </a:r>
+          </a:p>
+        </p:txBody>
+      </p:sp>
+      <p:sp>
+        <p:nvSpPr>
+          <p:cNvPr id="9" name="TextBox 8"/>
           <p:cNvSpPr txBox="1"/>
           <p:nvPr/>
         </p:nvSpPr>
         <p:spPr>
           <a:xfrm>
-            <a:off x="1645920" y="2542032"/>
-            <a:ext cx="9997135" cy="438912"/>
+            <a:off x="6713067" y="2148840"/>
+            <a:ext cx="4929987" cy="320040"/>
           </a:xfrm>
           <a:prstGeom prst="rect">
             <a:avLst/>
@@ -3754,26 +3643,26 @@
           <a:p>
             <a:pPr algn="ctr"/>
             <a:r>
-              <a:rPr sz="1400" b="0">
-                <a:solidFill>
-                  <a:srgbClr val="8888A0"/>
-                </a:solidFill>
-                <a:latin typeface="Inter"/>
-              </a:rPr>
-              <a:t>Breakfast &amp; networking</a:t>
-            </a:r>
-          </a:p>
-        </p:txBody>
-      </p:sp>
-      <p:sp>
-        <p:nvSpPr>
-          <p:cNvPr id="12" name="TextBox 11"/>
+              <a:rPr sz="1100" b="1">
+                <a:solidFill>
+                  <a:srgbClr val="4AB8D2"/>
+                </a:solidFill>
+                <a:latin typeface="JetBrains Mono"/>
+              </a:rPr>
+              <a:t>TRACK 2  ·  ROOM 2</a:t>
+            </a:r>
+          </a:p>
+        </p:txBody>
+      </p:sp>
+      <p:sp>
+        <p:nvSpPr>
+          <p:cNvPr id="10" name="TextBox 9"/>
           <p:cNvSpPr txBox="1"/>
           <p:nvPr/>
         </p:nvSpPr>
         <p:spPr>
           <a:xfrm>
-            <a:off x="548640" y="2980944"/>
+            <a:off x="548640" y="2542032"/>
             <a:ext cx="960120" cy="438912"/>
           </a:xfrm>
           <a:prstGeom prst="rect">
@@ -3795,6 +3684,76 @@
                 </a:solidFill>
                 <a:latin typeface="JetBrains Mono"/>
               </a:rPr>
+              <a:t>09:00</a:t>
+            </a:r>
+          </a:p>
+        </p:txBody>
+      </p:sp>
+      <p:sp>
+        <p:nvSpPr>
+          <p:cNvPr id="11" name="TextBox 10"/>
+          <p:cNvSpPr txBox="1"/>
+          <p:nvPr/>
+        </p:nvSpPr>
+        <p:spPr>
+          <a:xfrm>
+            <a:off x="1645920" y="2542032"/>
+            <a:ext cx="9997135" cy="438912"/>
+          </a:xfrm>
+          <a:prstGeom prst="rect">
+            <a:avLst/>
+          </a:prstGeom>
+          <a:noFill/>
+        </p:spPr>
+        <p:txBody>
+          <a:bodyPr wrap="square" lIns="0" rIns="0" tIns="0" bIns="0" anchor="ctr">
+            <a:spAutoFit/>
+          </a:bodyPr>
+          <a:lstStyle/>
+          <a:p>
+            <a:pPr algn="ctr"/>
+            <a:r>
+              <a:rPr sz="1400" b="0">
+                <a:solidFill>
+                  <a:srgbClr val="8888A0"/>
+                </a:solidFill>
+                <a:latin typeface="Inter"/>
+              </a:rPr>
+              <a:t>Breakfast &amp; networking</a:t>
+            </a:r>
+          </a:p>
+        </p:txBody>
+      </p:sp>
+      <p:sp>
+        <p:nvSpPr>
+          <p:cNvPr id="12" name="TextBox 11"/>
+          <p:cNvSpPr txBox="1"/>
+          <p:nvPr/>
+        </p:nvSpPr>
+        <p:spPr>
+          <a:xfrm>
+            <a:off x="548640" y="2980944"/>
+            <a:ext cx="960120" cy="438912"/>
+          </a:xfrm>
+          <a:prstGeom prst="rect">
+            <a:avLst/>
+          </a:prstGeom>
+          <a:noFill/>
+        </p:spPr>
+        <p:txBody>
+          <a:bodyPr wrap="square" lIns="0" rIns="0" tIns="0" bIns="0" anchor="ctr">
+            <a:spAutoFit/>
+          </a:bodyPr>
+          <a:lstStyle/>
+          <a:p>
+            <a:pPr algn="ctr"/>
+            <a:r>
+              <a:rPr sz="1400" b="1">
+                <a:solidFill>
+                  <a:srgbClr val="4AB8D2"/>
+                </a:solidFill>
+                <a:latin typeface="JetBrains Mono"/>
+              </a:rPr>
               <a:t>10:00</a:t>
             </a:r>
           </a:p>
@@ -3896,52 +3855,7 @@
       </p:sp>
       <p:sp>
         <p:nvSpPr>
-          <p:cNvPr id="15" name="Rectangle 14"/>
-          <p:cNvSpPr/>
-          <p:nvPr/>
-        </p:nvSpPr>
-        <p:spPr>
-          <a:xfrm>
-            <a:off x="548640" y="3419856"/>
-            <a:ext cx="11094415" cy="438912"/>
-          </a:xfrm>
-          <a:prstGeom prst="rect">
-            <a:avLst/>
-          </a:prstGeom>
-          <a:solidFill>
-            <a:srgbClr val="1A1A25">
-              <a:alpha val="60000"/>
-            </a:srgbClr>
-          </a:solidFill>
-          <a:ln>
-            <a:noFill/>
-          </a:ln>
-        </p:spPr>
-        <p:style>
-          <a:lnRef idx="1">
-            <a:schemeClr val="accent1"/>
-          </a:lnRef>
-          <a:fillRef idx="3">
-            <a:schemeClr val="accent1"/>
-          </a:fillRef>
-          <a:effectRef idx="2">
-            <a:schemeClr val="accent1"/>
-          </a:effectRef>
-          <a:fontRef idx="minor">
-            <a:schemeClr val="lt1"/>
-          </a:fontRef>
-        </p:style>
-        <p:txBody>
-          <a:bodyPr rtlCol="0" anchor="ctr"/>
-          <a:lstStyle/>
-          <a:p>
-            <a:pPr algn="ctr"/>
-          </a:p>
-        </p:txBody>
-      </p:sp>
-      <p:sp>
-        <p:nvSpPr>
-          <p:cNvPr id="16" name="TextBox 15"/>
+          <p:cNvPr id="15" name="TextBox 14"/>
           <p:cNvSpPr txBox="1"/>
           <p:nvPr/>
         </p:nvSpPr>
@@ -3976,7 +3890,7 @@
       </p:sp>
       <p:sp>
         <p:nvSpPr>
-          <p:cNvPr id="17" name="TextBox 16"/>
+          <p:cNvPr id="16" name="TextBox 15"/>
           <p:cNvSpPr txBox="1"/>
           <p:nvPr/>
         </p:nvSpPr>
@@ -4023,7 +3937,7 @@
       </p:sp>
       <p:sp>
         <p:nvSpPr>
-          <p:cNvPr id="18" name="TextBox 17"/>
+          <p:cNvPr id="17" name="TextBox 16"/>
           <p:cNvSpPr txBox="1"/>
           <p:nvPr/>
         </p:nvSpPr>
@@ -4070,7 +3984,7 @@
       </p:sp>
       <p:sp>
         <p:nvSpPr>
-          <p:cNvPr id="19" name="TextBox 18"/>
+          <p:cNvPr id="18" name="TextBox 17"/>
           <p:cNvSpPr txBox="1"/>
           <p:nvPr/>
         </p:nvSpPr>
@@ -4105,7 +4019,7 @@
       </p:sp>
       <p:sp>
         <p:nvSpPr>
-          <p:cNvPr id="20" name="TextBox 19"/>
+          <p:cNvPr id="19" name="TextBox 18"/>
           <p:cNvSpPr txBox="1"/>
           <p:nvPr/>
         </p:nvSpPr>
@@ -4140,52 +4054,7 @@
       </p:sp>
       <p:sp>
         <p:nvSpPr>
-          <p:cNvPr id="21" name="Rectangle 20"/>
-          <p:cNvSpPr/>
-          <p:nvPr/>
-        </p:nvSpPr>
-        <p:spPr>
-          <a:xfrm>
-            <a:off x="548640" y="4297680"/>
-            <a:ext cx="11094415" cy="438912"/>
-          </a:xfrm>
-          <a:prstGeom prst="rect">
-            <a:avLst/>
-          </a:prstGeom>
-          <a:solidFill>
-            <a:srgbClr val="1A1A25">
-              <a:alpha val="60000"/>
-            </a:srgbClr>
-          </a:solidFill>
-          <a:ln>
-            <a:noFill/>
-          </a:ln>
-        </p:spPr>
-        <p:style>
-          <a:lnRef idx="1">
-            <a:schemeClr val="accent1"/>
-          </a:lnRef>
-          <a:fillRef idx="3">
-            <a:schemeClr val="accent1"/>
-          </a:fillRef>
-          <a:effectRef idx="2">
-            <a:schemeClr val="accent1"/>
-          </a:effectRef>
-          <a:fontRef idx="minor">
-            <a:schemeClr val="lt1"/>
-          </a:fontRef>
-        </p:style>
-        <p:txBody>
-          <a:bodyPr rtlCol="0" anchor="ctr"/>
-          <a:lstStyle/>
-          <a:p>
-            <a:pPr algn="ctr"/>
-          </a:p>
-        </p:txBody>
-      </p:sp>
-      <p:sp>
-        <p:nvSpPr>
-          <p:cNvPr id="22" name="TextBox 21"/>
+          <p:cNvPr id="20" name="TextBox 19"/>
           <p:cNvSpPr txBox="1"/>
           <p:nvPr/>
         </p:nvSpPr>
@@ -4220,7 +4089,7 @@
       </p:sp>
       <p:sp>
         <p:nvSpPr>
-          <p:cNvPr id="23" name="TextBox 22"/>
+          <p:cNvPr id="21" name="TextBox 20"/>
           <p:cNvSpPr txBox="1"/>
           <p:nvPr/>
         </p:nvSpPr>
@@ -4267,7 +4136,7 @@
       </p:sp>
       <p:sp>
         <p:nvSpPr>
-          <p:cNvPr id="24" name="TextBox 23"/>
+          <p:cNvPr id="22" name="TextBox 21"/>
           <p:cNvSpPr txBox="1"/>
           <p:nvPr/>
         </p:nvSpPr>
@@ -4314,7 +4183,7 @@
       </p:sp>
       <p:sp>
         <p:nvSpPr>
-          <p:cNvPr id="25" name="TextBox 24"/>
+          <p:cNvPr id="23" name="TextBox 22"/>
           <p:cNvSpPr txBox="1"/>
           <p:nvPr/>
         </p:nvSpPr>
@@ -4349,7 +4218,7 @@
       </p:sp>
       <p:sp>
         <p:nvSpPr>
-          <p:cNvPr id="26" name="TextBox 25"/>
+          <p:cNvPr id="24" name="TextBox 23"/>
           <p:cNvSpPr txBox="1"/>
           <p:nvPr/>
         </p:nvSpPr>
@@ -4396,7 +4265,7 @@
       </p:sp>
       <p:sp>
         <p:nvSpPr>
-          <p:cNvPr id="27" name="TextBox 26"/>
+          <p:cNvPr id="25" name="TextBox 24"/>
           <p:cNvSpPr txBox="1"/>
           <p:nvPr/>
         </p:nvSpPr>
@@ -4443,52 +4312,7 @@
       </p:sp>
       <p:sp>
         <p:nvSpPr>
-          <p:cNvPr id="28" name="Rectangle 27"/>
-          <p:cNvSpPr/>
-          <p:nvPr/>
-        </p:nvSpPr>
-        <p:spPr>
-          <a:xfrm>
-            <a:off x="548640" y="5175504"/>
-            <a:ext cx="11094415" cy="438912"/>
-          </a:xfrm>
-          <a:prstGeom prst="rect">
-            <a:avLst/>
-          </a:prstGeom>
-          <a:solidFill>
-            <a:srgbClr val="1A1A25">
-              <a:alpha val="60000"/>
-            </a:srgbClr>
-          </a:solidFill>
-          <a:ln>
-            <a:noFill/>
-          </a:ln>
-        </p:spPr>
-        <p:style>
-          <a:lnRef idx="1">
-            <a:schemeClr val="accent1"/>
-          </a:lnRef>
-          <a:fillRef idx="3">
-            <a:schemeClr val="accent1"/>
-          </a:fillRef>
-          <a:effectRef idx="2">
-            <a:schemeClr val="accent1"/>
-          </a:effectRef>
-          <a:fontRef idx="minor">
-            <a:schemeClr val="lt1"/>
-          </a:fontRef>
-        </p:style>
-        <p:txBody>
-          <a:bodyPr rtlCol="0" anchor="ctr"/>
-          <a:lstStyle/>
-          <a:p>
-            <a:pPr algn="ctr"/>
-          </a:p>
-        </p:txBody>
-      </p:sp>
-      <p:sp>
-        <p:nvSpPr>
-          <p:cNvPr id="29" name="TextBox 28"/>
+          <p:cNvPr id="26" name="TextBox 25"/>
           <p:cNvSpPr txBox="1"/>
           <p:nvPr/>
         </p:nvSpPr>
@@ -4523,7 +4347,7 @@
       </p:sp>
       <p:sp>
         <p:nvSpPr>
-          <p:cNvPr id="30" name="TextBox 29"/>
+          <p:cNvPr id="27" name="TextBox 26"/>
           <p:cNvSpPr txBox="1"/>
           <p:nvPr/>
         </p:nvSpPr>
@@ -4570,7 +4394,7 @@
       </p:sp>
       <p:sp>
         <p:nvSpPr>
-          <p:cNvPr id="31" name="TextBox 30"/>
+          <p:cNvPr id="28" name="TextBox 27"/>
           <p:cNvSpPr txBox="1"/>
           <p:nvPr/>
         </p:nvSpPr>
@@ -4617,7 +4441,7 @@
       </p:sp>
       <p:sp>
         <p:nvSpPr>
-          <p:cNvPr id="32" name="TextBox 31"/>
+          <p:cNvPr id="29" name="TextBox 28"/>
           <p:cNvSpPr txBox="1"/>
           <p:nvPr/>
         </p:nvSpPr>
@@ -4652,7 +4476,7 @@
       </p:sp>
       <p:sp>
         <p:nvSpPr>
-          <p:cNvPr id="33" name="TextBox 32"/>
+          <p:cNvPr id="30" name="TextBox 29"/>
           <p:cNvSpPr txBox="1"/>
           <p:nvPr/>
         </p:nvSpPr>
@@ -4687,52 +4511,7 @@
       </p:sp>
       <p:sp>
         <p:nvSpPr>
-          <p:cNvPr id="34" name="Rectangle 33"/>
-          <p:cNvSpPr/>
-          <p:nvPr/>
-        </p:nvSpPr>
-        <p:spPr>
-          <a:xfrm>
-            <a:off x="548640" y="6053328"/>
-            <a:ext cx="11094415" cy="438912"/>
-          </a:xfrm>
-          <a:prstGeom prst="rect">
-            <a:avLst/>
-          </a:prstGeom>
-          <a:solidFill>
-            <a:srgbClr val="1A1A25">
-              <a:alpha val="60000"/>
-            </a:srgbClr>
-          </a:solidFill>
-          <a:ln>
-            <a:noFill/>
-          </a:ln>
-        </p:spPr>
-        <p:style>
-          <a:lnRef idx="1">
-            <a:schemeClr val="accent1"/>
-          </a:lnRef>
-          <a:fillRef idx="3">
-            <a:schemeClr val="accent1"/>
-          </a:fillRef>
-          <a:effectRef idx="2">
-            <a:schemeClr val="accent1"/>
-          </a:effectRef>
-          <a:fontRef idx="minor">
-            <a:schemeClr val="lt1"/>
-          </a:fontRef>
-        </p:style>
-        <p:txBody>
-          <a:bodyPr rtlCol="0" anchor="ctr"/>
-          <a:lstStyle/>
-          <a:p>
-            <a:pPr algn="ctr"/>
-          </a:p>
-        </p:txBody>
-      </p:sp>
-      <p:sp>
-        <p:nvSpPr>
-          <p:cNvPr id="35" name="TextBox 34"/>
+          <p:cNvPr id="31" name="TextBox 30"/>
           <p:cNvSpPr txBox="1"/>
           <p:nvPr/>
         </p:nvSpPr>
@@ -4767,7 +4546,7 @@
       </p:sp>
       <p:sp>
         <p:nvSpPr>
-          <p:cNvPr id="36" name="TextBox 35"/>
+          <p:cNvPr id="32" name="TextBox 31"/>
           <p:cNvSpPr txBox="1"/>
           <p:nvPr/>
         </p:nvSpPr>
@@ -4802,7 +4581,7 @@
       </p:sp>
       <p:sp>
         <p:nvSpPr>
-          <p:cNvPr id="37" name="TextBox 36"/>
+          <p:cNvPr id="33" name="TextBox 32"/>
           <p:cNvSpPr txBox="1"/>
           <p:nvPr/>
         </p:nvSpPr>
@@ -4837,7 +4616,7 @@
       </p:sp>
       <p:sp>
         <p:nvSpPr>
-          <p:cNvPr id="38" name="TextBox 37"/>
+          <p:cNvPr id="34" name="TextBox 33"/>
           <p:cNvSpPr txBox="1"/>
           <p:nvPr/>
         </p:nvSpPr>

</xml_diff>

<commit_message>
feat: add script to generate speaker slides for BSides Aarhus 2026
</commit_message>
<xml_diff>
--- a/Plans/template-output/bsides-aarhus-2026-template.pptx
+++ b/Plans/template-output/bsides-aarhus-2026-template.pptx
@@ -10,6 +10,17 @@
     <p:sldId id="258" r:id="rId9"/>
     <p:sldId id="259" r:id="rId10"/>
     <p:sldId id="260" r:id="rId11"/>
+    <p:sldId id="261" r:id="rId12"/>
+    <p:sldId id="262" r:id="rId13"/>
+    <p:sldId id="263" r:id="rId14"/>
+    <p:sldId id="264" r:id="rId15"/>
+    <p:sldId id="265" r:id="rId16"/>
+    <p:sldId id="266" r:id="rId17"/>
+    <p:sldId id="267" r:id="rId18"/>
+    <p:sldId id="268" r:id="rId19"/>
+    <p:sldId id="269" r:id="rId20"/>
+    <p:sldId id="270" r:id="rId21"/>
+    <p:sldId id="271" r:id="rId22"/>
   </p:sldIdLst>
   <p:sldSz cx="12191695" cy="6858000" type="screen4x3"/>
   <p:notesSz cx="6858000" cy="9144000"/>
@@ -3366,6 +3377,3037 @@
 </p:sld>
 </file>
 
+<file path=ppt/slides/slide10.xml><?xml version="1.0" encoding="utf-8"?>
+<p:sld xmlns:a="http://schemas.openxmlformats.org/drawingml/2006/main" xmlns:r="http://schemas.openxmlformats.org/officeDocument/2006/relationships" xmlns:p="http://schemas.openxmlformats.org/presentationml/2006/main">
+  <p:cSld>
+    <p:spTree>
+      <p:nvGrpSpPr>
+        <p:cNvPr id="1" name=""/>
+        <p:cNvGrpSpPr/>
+        <p:nvPr/>
+      </p:nvGrpSpPr>
+      <p:grpSpPr>
+        <a:xfrm>
+          <a:off x="0" y="0"/>
+          <a:ext cx="0" cy="0"/>
+          <a:chOff x="0" y="0"/>
+          <a:chExt cx="0" cy="0"/>
+        </a:xfrm>
+      </p:grpSpPr>
+      <p:pic>
+        <p:nvPicPr>
+          <p:cNvPr id="2" name="Picture 1" descr="_bg.png"/>
+          <p:cNvPicPr>
+            <a:picLocks noChangeAspect="1"/>
+          </p:cNvPicPr>
+          <p:nvPr/>
+        </p:nvPicPr>
+        <p:blipFill>
+          <a:blip r:embed="rId2"/>
+          <a:stretch>
+            <a:fillRect/>
+          </a:stretch>
+        </p:blipFill>
+        <p:spPr>
+          <a:xfrm>
+            <a:off x="0" y="0"/>
+            <a:ext cx="12191695" cy="6858000"/>
+          </a:xfrm>
+          <a:prstGeom prst="rect">
+            <a:avLst/>
+          </a:prstGeom>
+        </p:spPr>
+      </p:pic>
+      <p:pic>
+        <p:nvPicPr>
+          <p:cNvPr id="3" name="Picture 2" descr="logo.png"/>
+          <p:cNvPicPr>
+            <a:picLocks noChangeAspect="1"/>
+          </p:cNvPicPr>
+          <p:nvPr/>
+        </p:nvPicPr>
+        <p:blipFill>
+          <a:blip r:embed="rId3"/>
+          <a:stretch>
+            <a:fillRect/>
+          </a:stretch>
+        </p:blipFill>
+        <p:spPr>
+          <a:xfrm>
+            <a:off x="548640" y="457200"/>
+            <a:ext cx="617838" cy="457200"/>
+          </a:xfrm>
+          <a:prstGeom prst="rect">
+            <a:avLst/>
+          </a:prstGeom>
+        </p:spPr>
+      </p:pic>
+      <p:sp>
+        <p:nvSpPr>
+          <p:cNvPr id="4" name="Rounded Rectangle 3"/>
+          <p:cNvSpPr/>
+          <p:nvPr/>
+        </p:nvSpPr>
+        <p:spPr>
+          <a:xfrm>
+            <a:off x="548640" y="1463040"/>
+            <a:ext cx="3840480" cy="4389120"/>
+          </a:xfrm>
+          <a:prstGeom prst="roundRect">
+            <a:avLst>
+              <a:gd name="adj" fmla="val 4000"/>
+            </a:avLst>
+          </a:prstGeom>
+          <a:solidFill>
+            <a:srgbClr val="1A1A25"/>
+          </a:solidFill>
+          <a:ln>
+            <a:noFill/>
+          </a:ln>
+        </p:spPr>
+        <p:style>
+          <a:lnRef idx="1">
+            <a:schemeClr val="accent1"/>
+          </a:lnRef>
+          <a:fillRef idx="3">
+            <a:schemeClr val="accent1"/>
+          </a:fillRef>
+          <a:effectRef idx="2">
+            <a:schemeClr val="accent1"/>
+          </a:effectRef>
+          <a:fontRef idx="minor">
+            <a:schemeClr val="lt1"/>
+          </a:fontRef>
+        </p:style>
+        <p:txBody>
+          <a:bodyPr rtlCol="0" anchor="ctr"/>
+          <a:lstStyle/>
+          <a:p>
+            <a:pPr algn="ctr"/>
+            <a:endParaRPr/>
+          </a:p>
+        </p:txBody>
+      </p:sp>
+      <p:pic>
+        <p:nvPicPr>
+          <p:cNvPr id="100" name="SpeakerPhoto"/>
+          <p:cNvPicPr>
+            <a:picLocks noChangeAspect="1"/>
+          </p:cNvPicPr>
+          <p:nvPr/>
+        </p:nvPicPr>
+        <p:blipFill>
+          <a:blip r:embed="rId4"/>
+          <a:srcRect/>
+          <a:stretch>
+            <a:fillRect/>
+          </a:stretch>
+        </p:blipFill>
+        <p:spPr>
+          <a:xfrm>
+            <a:off x="914400" y="1645920"/>
+            <a:ext cx="3108960" cy="3108960"/>
+          </a:xfrm>
+          <a:prstGeom prst="roundRect">
+            <a:avLst>
+              <a:gd name="adj" fmla="val 4000"/>
+            </a:avLst>
+          </a:prstGeom>
+        </p:spPr>
+      </p:pic>
+      <p:sp>
+        <p:nvSpPr>
+          <p:cNvPr id="6" name="Rectangle 5"/>
+          <p:cNvSpPr/>
+          <p:nvPr/>
+        </p:nvSpPr>
+        <p:spPr>
+          <a:xfrm>
+            <a:off x="4754880" y="1371600"/>
+            <a:ext cx="640080" cy="38100"/>
+          </a:xfrm>
+          <a:prstGeom prst="rect">
+            <a:avLst/>
+          </a:prstGeom>
+          <a:solidFill>
+            <a:srgbClr val="4AB8D2"/>
+          </a:solidFill>
+          <a:ln>
+            <a:noFill/>
+          </a:ln>
+        </p:spPr>
+        <p:style>
+          <a:lnRef idx="1">
+            <a:schemeClr val="accent1"/>
+          </a:lnRef>
+          <a:fillRef idx="3">
+            <a:schemeClr val="accent1"/>
+          </a:fillRef>
+          <a:effectRef idx="2">
+            <a:schemeClr val="accent1"/>
+          </a:effectRef>
+          <a:fontRef idx="minor">
+            <a:schemeClr val="lt1"/>
+          </a:fontRef>
+        </p:style>
+        <p:txBody>
+          <a:bodyPr rtlCol="0" anchor="ctr"/>
+          <a:lstStyle/>
+          <a:p>
+            <a:pPr algn="ctr"/>
+            <a:endParaRPr/>
+          </a:p>
+        </p:txBody>
+      </p:sp>
+      <p:sp>
+        <p:nvSpPr>
+          <p:cNvPr id="7" name="TextBox 6"/>
+          <p:cNvSpPr txBox="1"/>
+          <p:nvPr/>
+        </p:nvSpPr>
+        <p:spPr>
+          <a:xfrm>
+            <a:off x="4754880" y="1508760"/>
+            <a:ext cx="6858000" cy="365760"/>
+          </a:xfrm>
+          <a:prstGeom prst="rect">
+            <a:avLst/>
+          </a:prstGeom>
+          <a:noFill/>
+        </p:spPr>
+        <p:txBody>
+          <a:bodyPr wrap="square" lIns="0" tIns="0" rIns="0" bIns="0" anchor="t">
+            <a:spAutoFit/>
+          </a:bodyPr>
+          <a:lstStyle/>
+          <a:p>
+            <a:pPr algn="l"/>
+            <a:r>
+              <a:rPr sz="1400" b="1">
+                <a:solidFill>
+                  <a:srgbClr val="4AB8D2"/>
+                </a:solidFill>
+                <a:latin typeface="JetBrains Mono"/>
+              </a:rPr>
+              <a:t>SPEAKER</a:t>
+            </a:r>
+          </a:p>
+        </p:txBody>
+      </p:sp>
+      <p:sp>
+        <p:nvSpPr>
+          <p:cNvPr id="8" name="TextBox 7"/>
+          <p:cNvSpPr txBox="1"/>
+          <p:nvPr/>
+        </p:nvSpPr>
+        <p:spPr>
+          <a:xfrm>
+            <a:off x="4754880" y="1920240"/>
+            <a:ext cx="6858000" cy="822960"/>
+          </a:xfrm>
+          <a:prstGeom prst="rect">
+            <a:avLst/>
+          </a:prstGeom>
+          <a:noFill/>
+        </p:spPr>
+        <p:txBody>
+          <a:bodyPr wrap="square" lIns="0" tIns="0" rIns="0" bIns="0" anchor="t">
+            <a:spAutoFit/>
+          </a:bodyPr>
+          <a:lstStyle/>
+          <a:p>
+            <a:pPr algn="l"/>
+            <a:r>
+              <a:rPr sz="4000" b="1">
+                <a:solidFill>
+                  <a:srgbClr val="E8E8ED"/>
+                </a:solidFill>
+                <a:latin typeface="Inter"/>
+              </a:rPr>
+              <a:t>Joost van Dijk</a:t>
+            </a:r>
+          </a:p>
+        </p:txBody>
+      </p:sp>
+      <p:sp>
+        <p:nvSpPr>
+          <p:cNvPr id="9" name="TextBox 8"/>
+          <p:cNvSpPr txBox="1"/>
+          <p:nvPr/>
+        </p:nvSpPr>
+        <p:spPr>
+          <a:xfrm>
+            <a:off x="4754880" y="2788920"/>
+            <a:ext cx="6858000" cy="457200"/>
+          </a:xfrm>
+          <a:prstGeom prst="rect">
+            <a:avLst/>
+          </a:prstGeom>
+          <a:noFill/>
+        </p:spPr>
+        <p:txBody>
+          <a:bodyPr wrap="square" lIns="0" tIns="0" rIns="0" bIns="0" anchor="t">
+            <a:spAutoFit/>
+          </a:bodyPr>
+          <a:lstStyle/>
+          <a:p>
+            <a:pPr algn="l"/>
+            <a:r>
+              <a:rPr sz="2000" b="0">
+                <a:solidFill>
+                  <a:srgbClr val="6DD0E7"/>
+                </a:solidFill>
+                <a:latin typeface="Inter"/>
+              </a:rPr>
+              <a:t>Developer Advocate at Yubico</a:t>
+            </a:r>
+          </a:p>
+        </p:txBody>
+      </p:sp>
+      <p:sp>
+        <p:nvSpPr>
+          <p:cNvPr id="10" name="TextBox 9"/>
+          <p:cNvSpPr txBox="1"/>
+          <p:nvPr/>
+        </p:nvSpPr>
+        <p:spPr>
+          <a:xfrm>
+            <a:off x="4754880" y="3474720"/>
+            <a:ext cx="6858000" cy="2103120"/>
+          </a:xfrm>
+          <a:prstGeom prst="rect">
+            <a:avLst/>
+          </a:prstGeom>
+          <a:noFill/>
+        </p:spPr>
+        <p:txBody>
+          <a:bodyPr wrap="square" lIns="0" tIns="0" rIns="0" bIns="0" anchor="t"/>
+          <a:lstStyle/>
+          <a:p>
+            <a:pPr algn="l"/>
+            <a:r>
+              <a:rPr sz="1600" b="0">
+                <a:solidFill>
+                  <a:srgbClr val="8888A0"/>
+                </a:solidFill>
+                <a:latin typeface="Inter"/>
+              </a:rPr>
+              <a:t>Joost is a Developer Advocate at Yubico and a security and privacy professional with deep expertise in federated single sign-on, multi-factor authentication, FIDO, passkeys, PKI, TLS, and hardware security.</a:t>
+            </a:r>
+          </a:p>
+        </p:txBody>
+      </p:sp>
+      <p:sp>
+        <p:nvSpPr>
+          <p:cNvPr id="11" name="TextBox 10"/>
+          <p:cNvSpPr txBox="1"/>
+          <p:nvPr/>
+        </p:nvSpPr>
+        <p:spPr>
+          <a:xfrm>
+            <a:off x="4754880" y="5669280"/>
+            <a:ext cx="6858000" cy="365760"/>
+          </a:xfrm>
+          <a:prstGeom prst="rect">
+            <a:avLst/>
+          </a:prstGeom>
+          <a:noFill/>
+        </p:spPr>
+        <p:txBody>
+          <a:bodyPr wrap="square" lIns="0" tIns="0" rIns="0" bIns="0" anchor="t">
+            <a:spAutoFit/>
+          </a:bodyPr>
+          <a:lstStyle/>
+          <a:p>
+            <a:pPr algn="l"/>
+            <a:r>
+              <a:rPr sz="1400" b="0">
+                <a:solidFill>
+                  <a:srgbClr val="4AB8D2"/>
+                </a:solidFill>
+                <a:latin typeface="JetBrains Mono"/>
+              </a:rPr>
+              <a:t>linkedin.com/in/joostd</a:t>
+            </a:r>
+          </a:p>
+        </p:txBody>
+      </p:sp>
+      <p:sp>
+        <p:nvSpPr>
+          <p:cNvPr id="12" name="TextBox 11"/>
+          <p:cNvSpPr txBox="1"/>
+          <p:nvPr/>
+        </p:nvSpPr>
+        <p:spPr>
+          <a:xfrm>
+            <a:off x="548640" y="6446520"/>
+            <a:ext cx="7315200" cy="274320"/>
+          </a:xfrm>
+          <a:prstGeom prst="rect">
+            <a:avLst/>
+          </a:prstGeom>
+          <a:noFill/>
+        </p:spPr>
+        <p:txBody>
+          <a:bodyPr wrap="square" lIns="0" tIns="0" rIns="0" bIns="0" anchor="t">
+            <a:spAutoFit/>
+          </a:bodyPr>
+          <a:lstStyle/>
+          <a:p>
+            <a:pPr algn="l"/>
+            <a:r>
+              <a:rPr sz="1000" b="0">
+                <a:solidFill>
+                  <a:srgbClr val="8888A0"/>
+                </a:solidFill>
+                <a:latin typeface="JetBrains Mono"/>
+              </a:rPr>
+              <a:t>BSides Aarhus 2026  ·  June 20  ·  INCUBA Next, Aarhus</a:t>
+            </a:r>
+          </a:p>
+        </p:txBody>
+      </p:sp>
+      <p:sp>
+        <p:nvSpPr>
+          <p:cNvPr id="13" name="TextBox 12"/>
+          <p:cNvSpPr txBox="1"/>
+          <p:nvPr/>
+        </p:nvSpPr>
+        <p:spPr>
+          <a:xfrm>
+            <a:off x="10515600" y="6446520"/>
+            <a:ext cx="1188720" cy="274320"/>
+          </a:xfrm>
+          <a:prstGeom prst="rect">
+            <a:avLst/>
+          </a:prstGeom>
+          <a:noFill/>
+        </p:spPr>
+        <p:txBody>
+          <a:bodyPr wrap="square" lIns="0" tIns="0" rIns="0" bIns="0" anchor="t">
+            <a:spAutoFit/>
+          </a:bodyPr>
+          <a:lstStyle/>
+          <a:p>
+            <a:pPr algn="r"/>
+            <a:r>
+              <a:rPr sz="1000" b="0">
+                <a:solidFill>
+                  <a:srgbClr val="8888A0"/>
+                </a:solidFill>
+                <a:latin typeface="JetBrains Mono"/>
+              </a:rPr>
+              <a:t>Speaker</a:t>
+            </a:r>
+          </a:p>
+        </p:txBody>
+      </p:sp>
+    </p:spTree>
+  </p:cSld>
+  <p:clrMapOvr>
+    <a:masterClrMapping/>
+  </p:clrMapOvr>
+</p:sld>
+</file>
+
+<file path=ppt/slides/slide11.xml><?xml version="1.0" encoding="utf-8"?>
+<p:sld xmlns:a="http://schemas.openxmlformats.org/drawingml/2006/main" xmlns:r="http://schemas.openxmlformats.org/officeDocument/2006/relationships" xmlns:p="http://schemas.openxmlformats.org/presentationml/2006/main">
+  <p:cSld>
+    <p:spTree>
+      <p:nvGrpSpPr>
+        <p:cNvPr id="1" name=""/>
+        <p:cNvGrpSpPr/>
+        <p:nvPr/>
+      </p:nvGrpSpPr>
+      <p:grpSpPr>
+        <a:xfrm>
+          <a:off x="0" y="0"/>
+          <a:ext cx="0" cy="0"/>
+          <a:chOff x="0" y="0"/>
+          <a:chExt cx="0" cy="0"/>
+        </a:xfrm>
+      </p:grpSpPr>
+      <p:pic>
+        <p:nvPicPr>
+          <p:cNvPr id="2" name="Picture 1" descr="_bg.png"/>
+          <p:cNvPicPr>
+            <a:picLocks noChangeAspect="1"/>
+          </p:cNvPicPr>
+          <p:nvPr/>
+        </p:nvPicPr>
+        <p:blipFill>
+          <a:blip r:embed="rId2"/>
+          <a:stretch>
+            <a:fillRect/>
+          </a:stretch>
+        </p:blipFill>
+        <p:spPr>
+          <a:xfrm>
+            <a:off x="0" y="0"/>
+            <a:ext cx="12191695" cy="6858000"/>
+          </a:xfrm>
+          <a:prstGeom prst="rect">
+            <a:avLst/>
+          </a:prstGeom>
+        </p:spPr>
+      </p:pic>
+      <p:pic>
+        <p:nvPicPr>
+          <p:cNvPr id="3" name="Picture 2" descr="logo.png"/>
+          <p:cNvPicPr>
+            <a:picLocks noChangeAspect="1"/>
+          </p:cNvPicPr>
+          <p:nvPr/>
+        </p:nvPicPr>
+        <p:blipFill>
+          <a:blip r:embed="rId3"/>
+          <a:stretch>
+            <a:fillRect/>
+          </a:stretch>
+        </p:blipFill>
+        <p:spPr>
+          <a:xfrm>
+            <a:off x="548640" y="457200"/>
+            <a:ext cx="617838" cy="457200"/>
+          </a:xfrm>
+          <a:prstGeom prst="rect">
+            <a:avLst/>
+          </a:prstGeom>
+        </p:spPr>
+      </p:pic>
+      <p:sp>
+        <p:nvSpPr>
+          <p:cNvPr id="4" name="Rounded Rectangle 3"/>
+          <p:cNvSpPr/>
+          <p:nvPr/>
+        </p:nvSpPr>
+        <p:spPr>
+          <a:xfrm>
+            <a:off x="548640" y="1463040"/>
+            <a:ext cx="3840480" cy="4389120"/>
+          </a:xfrm>
+          <a:prstGeom prst="roundRect">
+            <a:avLst>
+              <a:gd name="adj" fmla="val 4000"/>
+            </a:avLst>
+          </a:prstGeom>
+          <a:solidFill>
+            <a:srgbClr val="1A1A25"/>
+          </a:solidFill>
+          <a:ln>
+            <a:noFill/>
+          </a:ln>
+        </p:spPr>
+        <p:style>
+          <a:lnRef idx="1">
+            <a:schemeClr val="accent1"/>
+          </a:lnRef>
+          <a:fillRef idx="3">
+            <a:schemeClr val="accent1"/>
+          </a:fillRef>
+          <a:effectRef idx="2">
+            <a:schemeClr val="accent1"/>
+          </a:effectRef>
+          <a:fontRef idx="minor">
+            <a:schemeClr val="lt1"/>
+          </a:fontRef>
+        </p:style>
+        <p:txBody>
+          <a:bodyPr rtlCol="0" anchor="ctr"/>
+          <a:lstStyle/>
+          <a:p>
+            <a:pPr algn="ctr"/>
+            <a:endParaRPr/>
+          </a:p>
+        </p:txBody>
+      </p:sp>
+      <p:pic>
+        <p:nvPicPr>
+          <p:cNvPr id="100" name="SpeakerPhoto"/>
+          <p:cNvPicPr>
+            <a:picLocks noChangeAspect="1"/>
+          </p:cNvPicPr>
+          <p:nvPr/>
+        </p:nvPicPr>
+        <p:blipFill>
+          <a:blip r:embed="rId4"/>
+          <a:srcRect/>
+          <a:stretch>
+            <a:fillRect/>
+          </a:stretch>
+        </p:blipFill>
+        <p:spPr>
+          <a:xfrm>
+            <a:off x="914400" y="1645920"/>
+            <a:ext cx="3108960" cy="3108960"/>
+          </a:xfrm>
+          <a:prstGeom prst="roundRect">
+            <a:avLst>
+              <a:gd name="adj" fmla="val 4000"/>
+            </a:avLst>
+          </a:prstGeom>
+        </p:spPr>
+      </p:pic>
+      <p:sp>
+        <p:nvSpPr>
+          <p:cNvPr id="6" name="Rectangle 5"/>
+          <p:cNvSpPr/>
+          <p:nvPr/>
+        </p:nvSpPr>
+        <p:spPr>
+          <a:xfrm>
+            <a:off x="4754880" y="1371600"/>
+            <a:ext cx="640080" cy="38100"/>
+          </a:xfrm>
+          <a:prstGeom prst="rect">
+            <a:avLst/>
+          </a:prstGeom>
+          <a:solidFill>
+            <a:srgbClr val="4AB8D2"/>
+          </a:solidFill>
+          <a:ln>
+            <a:noFill/>
+          </a:ln>
+        </p:spPr>
+        <p:style>
+          <a:lnRef idx="1">
+            <a:schemeClr val="accent1"/>
+          </a:lnRef>
+          <a:fillRef idx="3">
+            <a:schemeClr val="accent1"/>
+          </a:fillRef>
+          <a:effectRef idx="2">
+            <a:schemeClr val="accent1"/>
+          </a:effectRef>
+          <a:fontRef idx="minor">
+            <a:schemeClr val="lt1"/>
+          </a:fontRef>
+        </p:style>
+        <p:txBody>
+          <a:bodyPr rtlCol="0" anchor="ctr"/>
+          <a:lstStyle/>
+          <a:p>
+            <a:pPr algn="ctr"/>
+            <a:endParaRPr/>
+          </a:p>
+        </p:txBody>
+      </p:sp>
+      <p:sp>
+        <p:nvSpPr>
+          <p:cNvPr id="7" name="TextBox 6"/>
+          <p:cNvSpPr txBox="1"/>
+          <p:nvPr/>
+        </p:nvSpPr>
+        <p:spPr>
+          <a:xfrm>
+            <a:off x="4754880" y="1508760"/>
+            <a:ext cx="6858000" cy="365760"/>
+          </a:xfrm>
+          <a:prstGeom prst="rect">
+            <a:avLst/>
+          </a:prstGeom>
+          <a:noFill/>
+        </p:spPr>
+        <p:txBody>
+          <a:bodyPr wrap="square" lIns="0" tIns="0" rIns="0" bIns="0" anchor="t">
+            <a:spAutoFit/>
+          </a:bodyPr>
+          <a:lstStyle/>
+          <a:p>
+            <a:pPr algn="l"/>
+            <a:r>
+              <a:rPr sz="1400" b="1">
+                <a:solidFill>
+                  <a:srgbClr val="4AB8D2"/>
+                </a:solidFill>
+                <a:latin typeface="JetBrains Mono"/>
+              </a:rPr>
+              <a:t>SPEAKER</a:t>
+            </a:r>
+          </a:p>
+        </p:txBody>
+      </p:sp>
+      <p:sp>
+        <p:nvSpPr>
+          <p:cNvPr id="8" name="TextBox 7"/>
+          <p:cNvSpPr txBox="1"/>
+          <p:nvPr/>
+        </p:nvSpPr>
+        <p:spPr>
+          <a:xfrm>
+            <a:off x="4754880" y="1920240"/>
+            <a:ext cx="6858000" cy="822960"/>
+          </a:xfrm>
+          <a:prstGeom prst="rect">
+            <a:avLst/>
+          </a:prstGeom>
+          <a:noFill/>
+        </p:spPr>
+        <p:txBody>
+          <a:bodyPr wrap="square" lIns="0" tIns="0" rIns="0" bIns="0" anchor="t">
+            <a:spAutoFit/>
+          </a:bodyPr>
+          <a:lstStyle/>
+          <a:p>
+            <a:pPr algn="l"/>
+            <a:r>
+              <a:rPr sz="4000" b="1">
+                <a:solidFill>
+                  <a:srgbClr val="E8E8ED"/>
+                </a:solidFill>
+                <a:latin typeface="Inter"/>
+              </a:rPr>
+              <a:t>Kasper Hald</a:t>
+            </a:r>
+          </a:p>
+        </p:txBody>
+      </p:sp>
+      <p:sp>
+        <p:nvSpPr>
+          <p:cNvPr id="9" name="TextBox 8"/>
+          <p:cNvSpPr txBox="1"/>
+          <p:nvPr/>
+        </p:nvSpPr>
+        <p:spPr>
+          <a:xfrm>
+            <a:off x="4754880" y="2788920"/>
+            <a:ext cx="6858000" cy="457200"/>
+          </a:xfrm>
+          <a:prstGeom prst="rect">
+            <a:avLst/>
+          </a:prstGeom>
+          <a:noFill/>
+        </p:spPr>
+        <p:txBody>
+          <a:bodyPr wrap="square" lIns="0" tIns="0" rIns="0" bIns="0" anchor="t">
+            <a:spAutoFit/>
+          </a:bodyPr>
+          <a:lstStyle/>
+          <a:p>
+            <a:pPr algn="l"/>
+            <a:r>
+              <a:rPr sz="2000" b="0">
+                <a:solidFill>
+                  <a:srgbClr val="6DD0E7"/>
+                </a:solidFill>
+                <a:latin typeface="Inter"/>
+              </a:rPr>
+              <a:t>Freelance Consultant at ApplSec Consult</a:t>
+            </a:r>
+          </a:p>
+        </p:txBody>
+      </p:sp>
+      <p:sp>
+        <p:nvSpPr>
+          <p:cNvPr id="10" name="TextBox 9"/>
+          <p:cNvSpPr txBox="1"/>
+          <p:nvPr/>
+        </p:nvSpPr>
+        <p:spPr>
+          <a:xfrm>
+            <a:off x="4754880" y="3474720"/>
+            <a:ext cx="6858000" cy="2103120"/>
+          </a:xfrm>
+          <a:prstGeom prst="rect">
+            <a:avLst/>
+          </a:prstGeom>
+          <a:noFill/>
+        </p:spPr>
+        <p:txBody>
+          <a:bodyPr wrap="square" lIns="0" tIns="0" rIns="0" bIns="0" anchor="t"/>
+          <a:lstStyle/>
+          <a:p>
+            <a:pPr algn="l"/>
+            <a:r>
+              <a:rPr sz="1600" b="0">
+                <a:solidFill>
+                  <a:srgbClr val="8888A0"/>
+                </a:solidFill>
+                <a:latin typeface="Inter"/>
+              </a:rPr>
+              <a:t>With an educational background in quantum theory and 20+ years within application security, this topic is where Kasper's past and present meet.</a:t>
+            </a:r>
+          </a:p>
+        </p:txBody>
+      </p:sp>
+      <p:sp>
+        <p:nvSpPr>
+          <p:cNvPr id="11" name="TextBox 10"/>
+          <p:cNvSpPr txBox="1"/>
+          <p:nvPr/>
+        </p:nvSpPr>
+        <p:spPr>
+          <a:xfrm>
+            <a:off x="4754880" y="5669280"/>
+            <a:ext cx="6858000" cy="365760"/>
+          </a:xfrm>
+          <a:prstGeom prst="rect">
+            <a:avLst/>
+          </a:prstGeom>
+          <a:noFill/>
+        </p:spPr>
+        <p:txBody>
+          <a:bodyPr wrap="square" lIns="0" tIns="0" rIns="0" bIns="0" anchor="t">
+            <a:spAutoFit/>
+          </a:bodyPr>
+          <a:lstStyle/>
+          <a:p>
+            <a:pPr algn="l"/>
+            <a:r>
+              <a:rPr sz="1400" b="0">
+                <a:solidFill>
+                  <a:srgbClr val="4AB8D2"/>
+                </a:solidFill>
+                <a:latin typeface="JetBrains Mono"/>
+              </a:rPr>
+              <a:t>linkedin.com/in/kasper-hald-6622623</a:t>
+            </a:r>
+          </a:p>
+        </p:txBody>
+      </p:sp>
+      <p:sp>
+        <p:nvSpPr>
+          <p:cNvPr id="12" name="TextBox 11"/>
+          <p:cNvSpPr txBox="1"/>
+          <p:nvPr/>
+        </p:nvSpPr>
+        <p:spPr>
+          <a:xfrm>
+            <a:off x="548640" y="6446520"/>
+            <a:ext cx="7315200" cy="274320"/>
+          </a:xfrm>
+          <a:prstGeom prst="rect">
+            <a:avLst/>
+          </a:prstGeom>
+          <a:noFill/>
+        </p:spPr>
+        <p:txBody>
+          <a:bodyPr wrap="square" lIns="0" tIns="0" rIns="0" bIns="0" anchor="t">
+            <a:spAutoFit/>
+          </a:bodyPr>
+          <a:lstStyle/>
+          <a:p>
+            <a:pPr algn="l"/>
+            <a:r>
+              <a:rPr sz="1000" b="0">
+                <a:solidFill>
+                  <a:srgbClr val="8888A0"/>
+                </a:solidFill>
+                <a:latin typeface="JetBrains Mono"/>
+              </a:rPr>
+              <a:t>BSides Aarhus 2026  ·  June 20  ·  INCUBA Next, Aarhus</a:t>
+            </a:r>
+          </a:p>
+        </p:txBody>
+      </p:sp>
+      <p:sp>
+        <p:nvSpPr>
+          <p:cNvPr id="13" name="TextBox 12"/>
+          <p:cNvSpPr txBox="1"/>
+          <p:nvPr/>
+        </p:nvSpPr>
+        <p:spPr>
+          <a:xfrm>
+            <a:off x="10515600" y="6446520"/>
+            <a:ext cx="1188720" cy="274320"/>
+          </a:xfrm>
+          <a:prstGeom prst="rect">
+            <a:avLst/>
+          </a:prstGeom>
+          <a:noFill/>
+        </p:spPr>
+        <p:txBody>
+          <a:bodyPr wrap="square" lIns="0" tIns="0" rIns="0" bIns="0" anchor="t">
+            <a:spAutoFit/>
+          </a:bodyPr>
+          <a:lstStyle/>
+          <a:p>
+            <a:pPr algn="r"/>
+            <a:r>
+              <a:rPr sz="1000" b="0">
+                <a:solidFill>
+                  <a:srgbClr val="8888A0"/>
+                </a:solidFill>
+                <a:latin typeface="JetBrains Mono"/>
+              </a:rPr>
+              <a:t>Speaker</a:t>
+            </a:r>
+          </a:p>
+        </p:txBody>
+      </p:sp>
+    </p:spTree>
+  </p:cSld>
+  <p:clrMapOvr>
+    <a:masterClrMapping/>
+  </p:clrMapOvr>
+</p:sld>
+</file>
+
+<file path=ppt/slides/slide12.xml><?xml version="1.0" encoding="utf-8"?>
+<p:sld xmlns:a="http://schemas.openxmlformats.org/drawingml/2006/main" xmlns:r="http://schemas.openxmlformats.org/officeDocument/2006/relationships" xmlns:p="http://schemas.openxmlformats.org/presentationml/2006/main">
+  <p:cSld>
+    <p:spTree>
+      <p:nvGrpSpPr>
+        <p:cNvPr id="1" name=""/>
+        <p:cNvGrpSpPr/>
+        <p:nvPr/>
+      </p:nvGrpSpPr>
+      <p:grpSpPr>
+        <a:xfrm>
+          <a:off x="0" y="0"/>
+          <a:ext cx="0" cy="0"/>
+          <a:chOff x="0" y="0"/>
+          <a:chExt cx="0" cy="0"/>
+        </a:xfrm>
+      </p:grpSpPr>
+      <p:pic>
+        <p:nvPicPr>
+          <p:cNvPr id="2" name="Picture 1" descr="_bg.png"/>
+          <p:cNvPicPr>
+            <a:picLocks noChangeAspect="1"/>
+          </p:cNvPicPr>
+          <p:nvPr/>
+        </p:nvPicPr>
+        <p:blipFill>
+          <a:blip r:embed="rId2"/>
+          <a:stretch>
+            <a:fillRect/>
+          </a:stretch>
+        </p:blipFill>
+        <p:spPr>
+          <a:xfrm>
+            <a:off x="0" y="0"/>
+            <a:ext cx="12191695" cy="6858000"/>
+          </a:xfrm>
+          <a:prstGeom prst="rect">
+            <a:avLst/>
+          </a:prstGeom>
+        </p:spPr>
+      </p:pic>
+      <p:pic>
+        <p:nvPicPr>
+          <p:cNvPr id="3" name="Picture 2" descr="logo.png"/>
+          <p:cNvPicPr>
+            <a:picLocks noChangeAspect="1"/>
+          </p:cNvPicPr>
+          <p:nvPr/>
+        </p:nvPicPr>
+        <p:blipFill>
+          <a:blip r:embed="rId3"/>
+          <a:stretch>
+            <a:fillRect/>
+          </a:stretch>
+        </p:blipFill>
+        <p:spPr>
+          <a:xfrm>
+            <a:off x="548640" y="457200"/>
+            <a:ext cx="617838" cy="457200"/>
+          </a:xfrm>
+          <a:prstGeom prst="rect">
+            <a:avLst/>
+          </a:prstGeom>
+        </p:spPr>
+      </p:pic>
+      <p:sp>
+        <p:nvSpPr>
+          <p:cNvPr id="4" name="Rounded Rectangle 3"/>
+          <p:cNvSpPr/>
+          <p:nvPr/>
+        </p:nvSpPr>
+        <p:spPr>
+          <a:xfrm>
+            <a:off x="548640" y="1463040"/>
+            <a:ext cx="3840480" cy="4389120"/>
+          </a:xfrm>
+          <a:prstGeom prst="roundRect">
+            <a:avLst>
+              <a:gd name="adj" fmla="val 4000"/>
+            </a:avLst>
+          </a:prstGeom>
+          <a:solidFill>
+            <a:srgbClr val="1A1A25"/>
+          </a:solidFill>
+          <a:ln>
+            <a:noFill/>
+          </a:ln>
+        </p:spPr>
+        <p:style>
+          <a:lnRef idx="1">
+            <a:schemeClr val="accent1"/>
+          </a:lnRef>
+          <a:fillRef idx="3">
+            <a:schemeClr val="accent1"/>
+          </a:fillRef>
+          <a:effectRef idx="2">
+            <a:schemeClr val="accent1"/>
+          </a:effectRef>
+          <a:fontRef idx="minor">
+            <a:schemeClr val="lt1"/>
+          </a:fontRef>
+        </p:style>
+        <p:txBody>
+          <a:bodyPr rtlCol="0" anchor="ctr"/>
+          <a:lstStyle/>
+          <a:p>
+            <a:pPr algn="ctr"/>
+            <a:endParaRPr/>
+          </a:p>
+        </p:txBody>
+      </p:sp>
+      <p:pic>
+        <p:nvPicPr>
+          <p:cNvPr id="100" name="SpeakerPhoto"/>
+          <p:cNvPicPr>
+            <a:picLocks noChangeAspect="1"/>
+          </p:cNvPicPr>
+          <p:nvPr/>
+        </p:nvPicPr>
+        <p:blipFill>
+          <a:blip r:embed="rId4"/>
+          <a:srcRect/>
+          <a:stretch>
+            <a:fillRect/>
+          </a:stretch>
+        </p:blipFill>
+        <p:spPr>
+          <a:xfrm>
+            <a:off x="914400" y="1645920"/>
+            <a:ext cx="3108960" cy="3108960"/>
+          </a:xfrm>
+          <a:prstGeom prst="roundRect">
+            <a:avLst>
+              <a:gd name="adj" fmla="val 4000"/>
+            </a:avLst>
+          </a:prstGeom>
+        </p:spPr>
+      </p:pic>
+      <p:sp>
+        <p:nvSpPr>
+          <p:cNvPr id="6" name="Rectangle 5"/>
+          <p:cNvSpPr/>
+          <p:nvPr/>
+        </p:nvSpPr>
+        <p:spPr>
+          <a:xfrm>
+            <a:off x="4754880" y="1371600"/>
+            <a:ext cx="640080" cy="38100"/>
+          </a:xfrm>
+          <a:prstGeom prst="rect">
+            <a:avLst/>
+          </a:prstGeom>
+          <a:solidFill>
+            <a:srgbClr val="4AB8D2"/>
+          </a:solidFill>
+          <a:ln>
+            <a:noFill/>
+          </a:ln>
+        </p:spPr>
+        <p:style>
+          <a:lnRef idx="1">
+            <a:schemeClr val="accent1"/>
+          </a:lnRef>
+          <a:fillRef idx="3">
+            <a:schemeClr val="accent1"/>
+          </a:fillRef>
+          <a:effectRef idx="2">
+            <a:schemeClr val="accent1"/>
+          </a:effectRef>
+          <a:fontRef idx="minor">
+            <a:schemeClr val="lt1"/>
+          </a:fontRef>
+        </p:style>
+        <p:txBody>
+          <a:bodyPr rtlCol="0" anchor="ctr"/>
+          <a:lstStyle/>
+          <a:p>
+            <a:pPr algn="ctr"/>
+            <a:endParaRPr/>
+          </a:p>
+        </p:txBody>
+      </p:sp>
+      <p:sp>
+        <p:nvSpPr>
+          <p:cNvPr id="7" name="TextBox 6"/>
+          <p:cNvSpPr txBox="1"/>
+          <p:nvPr/>
+        </p:nvSpPr>
+        <p:spPr>
+          <a:xfrm>
+            <a:off x="4754880" y="1508760"/>
+            <a:ext cx="6858000" cy="365760"/>
+          </a:xfrm>
+          <a:prstGeom prst="rect">
+            <a:avLst/>
+          </a:prstGeom>
+          <a:noFill/>
+        </p:spPr>
+        <p:txBody>
+          <a:bodyPr wrap="square" lIns="0" tIns="0" rIns="0" bIns="0" anchor="t">
+            <a:spAutoFit/>
+          </a:bodyPr>
+          <a:lstStyle/>
+          <a:p>
+            <a:pPr algn="l"/>
+            <a:r>
+              <a:rPr sz="1400" b="1">
+                <a:solidFill>
+                  <a:srgbClr val="4AB8D2"/>
+                </a:solidFill>
+                <a:latin typeface="JetBrains Mono"/>
+              </a:rPr>
+              <a:t>SPEAKER</a:t>
+            </a:r>
+          </a:p>
+        </p:txBody>
+      </p:sp>
+      <p:sp>
+        <p:nvSpPr>
+          <p:cNvPr id="8" name="TextBox 7"/>
+          <p:cNvSpPr txBox="1"/>
+          <p:nvPr/>
+        </p:nvSpPr>
+        <p:spPr>
+          <a:xfrm>
+            <a:off x="4754880" y="1920240"/>
+            <a:ext cx="6858000" cy="822960"/>
+          </a:xfrm>
+          <a:prstGeom prst="rect">
+            <a:avLst/>
+          </a:prstGeom>
+          <a:noFill/>
+        </p:spPr>
+        <p:txBody>
+          <a:bodyPr wrap="square" lIns="0" tIns="0" rIns="0" bIns="0" anchor="t">
+            <a:spAutoFit/>
+          </a:bodyPr>
+          <a:lstStyle/>
+          <a:p>
+            <a:pPr algn="l"/>
+            <a:r>
+              <a:rPr sz="4000" b="1">
+                <a:solidFill>
+                  <a:srgbClr val="E8E8ED"/>
+                </a:solidFill>
+                <a:latin typeface="Inter"/>
+              </a:rPr>
+              <a:t>Martin Sohn Christensen</a:t>
+            </a:r>
+          </a:p>
+        </p:txBody>
+      </p:sp>
+      <p:sp>
+        <p:nvSpPr>
+          <p:cNvPr id="9" name="TextBox 8"/>
+          <p:cNvSpPr txBox="1"/>
+          <p:nvPr/>
+        </p:nvSpPr>
+        <p:spPr>
+          <a:xfrm>
+            <a:off x="4754880" y="2788920"/>
+            <a:ext cx="6858000" cy="457200"/>
+          </a:xfrm>
+          <a:prstGeom prst="rect">
+            <a:avLst/>
+          </a:prstGeom>
+          <a:noFill/>
+        </p:spPr>
+        <p:txBody>
+          <a:bodyPr wrap="square" lIns="0" tIns="0" rIns="0" bIns="0" anchor="t">
+            <a:spAutoFit/>
+          </a:bodyPr>
+          <a:lstStyle/>
+          <a:p>
+            <a:pPr algn="l"/>
+            <a:r>
+              <a:rPr sz="2000" b="0">
+                <a:solidFill>
+                  <a:srgbClr val="6DD0E7"/>
+                </a:solidFill>
+                <a:latin typeface="Inter"/>
+              </a:rPr>
+              <a:t>Security Researcher @ SpecterOps</a:t>
+            </a:r>
+          </a:p>
+        </p:txBody>
+      </p:sp>
+      <p:sp>
+        <p:nvSpPr>
+          <p:cNvPr id="10" name="TextBox 9"/>
+          <p:cNvSpPr txBox="1"/>
+          <p:nvPr/>
+        </p:nvSpPr>
+        <p:spPr>
+          <a:xfrm>
+            <a:off x="4754880" y="3474720"/>
+            <a:ext cx="6858000" cy="2103120"/>
+          </a:xfrm>
+          <a:prstGeom prst="rect">
+            <a:avLst/>
+          </a:prstGeom>
+          <a:noFill/>
+        </p:spPr>
+        <p:txBody>
+          <a:bodyPr wrap="square" lIns="0" tIns="0" rIns="0" bIns="0" anchor="t"/>
+          <a:lstStyle/>
+          <a:p>
+            <a:pPr algn="l"/>
+            <a:r>
+              <a:rPr sz="1600" b="0">
+                <a:solidFill>
+                  <a:srgbClr val="8888A0"/>
+                </a:solidFill>
+                <a:latin typeface="Inter"/>
+              </a:rPr>
+              <a:t>Martin is a Security Researcher at SpecterOps in Copenhagen, specializing in Microsoft technologies with expertise in Active Directory, identity attack paths, and secure system configuration. His perspective on security risks and challenges is shaped by a background spanning system administration, an information security degree, and information security consultancy. He is a frequent contributor to the community through online engagement and talks.</a:t>
+            </a:r>
+          </a:p>
+        </p:txBody>
+      </p:sp>
+      <p:sp>
+        <p:nvSpPr>
+          <p:cNvPr id="11" name="TextBox 10"/>
+          <p:cNvSpPr txBox="1"/>
+          <p:nvPr/>
+        </p:nvSpPr>
+        <p:spPr>
+          <a:xfrm>
+            <a:off x="4754880" y="5669280"/>
+            <a:ext cx="6858000" cy="365760"/>
+          </a:xfrm>
+          <a:prstGeom prst="rect">
+            <a:avLst/>
+          </a:prstGeom>
+          <a:noFill/>
+        </p:spPr>
+        <p:txBody>
+          <a:bodyPr wrap="square" lIns="0" tIns="0" rIns="0" bIns="0" anchor="t">
+            <a:spAutoFit/>
+          </a:bodyPr>
+          <a:lstStyle/>
+          <a:p>
+            <a:pPr algn="l"/>
+            <a:r>
+              <a:rPr sz="1400" b="0">
+                <a:solidFill>
+                  <a:srgbClr val="4AB8D2"/>
+                </a:solidFill>
+                <a:latin typeface="JetBrains Mono"/>
+              </a:rPr>
+              <a:t>linkedin.com/in/martinsohn  ·  martinsohn.dk</a:t>
+            </a:r>
+          </a:p>
+        </p:txBody>
+      </p:sp>
+      <p:sp>
+        <p:nvSpPr>
+          <p:cNvPr id="12" name="TextBox 11"/>
+          <p:cNvSpPr txBox="1"/>
+          <p:nvPr/>
+        </p:nvSpPr>
+        <p:spPr>
+          <a:xfrm>
+            <a:off x="548640" y="6446520"/>
+            <a:ext cx="7315200" cy="274320"/>
+          </a:xfrm>
+          <a:prstGeom prst="rect">
+            <a:avLst/>
+          </a:prstGeom>
+          <a:noFill/>
+        </p:spPr>
+        <p:txBody>
+          <a:bodyPr wrap="square" lIns="0" tIns="0" rIns="0" bIns="0" anchor="t">
+            <a:spAutoFit/>
+          </a:bodyPr>
+          <a:lstStyle/>
+          <a:p>
+            <a:pPr algn="l"/>
+            <a:r>
+              <a:rPr sz="1000" b="0">
+                <a:solidFill>
+                  <a:srgbClr val="8888A0"/>
+                </a:solidFill>
+                <a:latin typeface="JetBrains Mono"/>
+              </a:rPr>
+              <a:t>BSides Aarhus 2026  ·  June 20  ·  INCUBA Next, Aarhus</a:t>
+            </a:r>
+          </a:p>
+        </p:txBody>
+      </p:sp>
+      <p:sp>
+        <p:nvSpPr>
+          <p:cNvPr id="13" name="TextBox 12"/>
+          <p:cNvSpPr txBox="1"/>
+          <p:nvPr/>
+        </p:nvSpPr>
+        <p:spPr>
+          <a:xfrm>
+            <a:off x="10515600" y="6446520"/>
+            <a:ext cx="1188720" cy="274320"/>
+          </a:xfrm>
+          <a:prstGeom prst="rect">
+            <a:avLst/>
+          </a:prstGeom>
+          <a:noFill/>
+        </p:spPr>
+        <p:txBody>
+          <a:bodyPr wrap="square" lIns="0" tIns="0" rIns="0" bIns="0" anchor="t">
+            <a:spAutoFit/>
+          </a:bodyPr>
+          <a:lstStyle/>
+          <a:p>
+            <a:pPr algn="r"/>
+            <a:r>
+              <a:rPr sz="1000" b="0">
+                <a:solidFill>
+                  <a:srgbClr val="8888A0"/>
+                </a:solidFill>
+                <a:latin typeface="JetBrains Mono"/>
+              </a:rPr>
+              <a:t>Speaker</a:t>
+            </a:r>
+          </a:p>
+        </p:txBody>
+      </p:sp>
+    </p:spTree>
+  </p:cSld>
+  <p:clrMapOvr>
+    <a:masterClrMapping/>
+  </p:clrMapOvr>
+</p:sld>
+</file>
+
+<file path=ppt/slides/slide13.xml><?xml version="1.0" encoding="utf-8"?>
+<p:sld xmlns:a="http://schemas.openxmlformats.org/drawingml/2006/main" xmlns:r="http://schemas.openxmlformats.org/officeDocument/2006/relationships" xmlns:p="http://schemas.openxmlformats.org/presentationml/2006/main">
+  <p:cSld>
+    <p:spTree>
+      <p:nvGrpSpPr>
+        <p:cNvPr id="1" name=""/>
+        <p:cNvGrpSpPr/>
+        <p:nvPr/>
+      </p:nvGrpSpPr>
+      <p:grpSpPr>
+        <a:xfrm>
+          <a:off x="0" y="0"/>
+          <a:ext cx="0" cy="0"/>
+          <a:chOff x="0" y="0"/>
+          <a:chExt cx="0" cy="0"/>
+        </a:xfrm>
+      </p:grpSpPr>
+      <p:pic>
+        <p:nvPicPr>
+          <p:cNvPr id="2" name="Picture 1" descr="_bg.png"/>
+          <p:cNvPicPr>
+            <a:picLocks noChangeAspect="1"/>
+          </p:cNvPicPr>
+          <p:nvPr/>
+        </p:nvPicPr>
+        <p:blipFill>
+          <a:blip r:embed="rId2"/>
+          <a:stretch>
+            <a:fillRect/>
+          </a:stretch>
+        </p:blipFill>
+        <p:spPr>
+          <a:xfrm>
+            <a:off x="0" y="0"/>
+            <a:ext cx="12191695" cy="6858000"/>
+          </a:xfrm>
+          <a:prstGeom prst="rect">
+            <a:avLst/>
+          </a:prstGeom>
+        </p:spPr>
+      </p:pic>
+      <p:pic>
+        <p:nvPicPr>
+          <p:cNvPr id="3" name="Picture 2" descr="logo.png"/>
+          <p:cNvPicPr>
+            <a:picLocks noChangeAspect="1"/>
+          </p:cNvPicPr>
+          <p:nvPr/>
+        </p:nvPicPr>
+        <p:blipFill>
+          <a:blip r:embed="rId3"/>
+          <a:stretch>
+            <a:fillRect/>
+          </a:stretch>
+        </p:blipFill>
+        <p:spPr>
+          <a:xfrm>
+            <a:off x="548640" y="457200"/>
+            <a:ext cx="617838" cy="457200"/>
+          </a:xfrm>
+          <a:prstGeom prst="rect">
+            <a:avLst/>
+          </a:prstGeom>
+        </p:spPr>
+      </p:pic>
+      <p:sp>
+        <p:nvSpPr>
+          <p:cNvPr id="4" name="Rounded Rectangle 3"/>
+          <p:cNvSpPr/>
+          <p:nvPr/>
+        </p:nvSpPr>
+        <p:spPr>
+          <a:xfrm>
+            <a:off x="548640" y="1463040"/>
+            <a:ext cx="3840480" cy="4389120"/>
+          </a:xfrm>
+          <a:prstGeom prst="roundRect">
+            <a:avLst>
+              <a:gd name="adj" fmla="val 4000"/>
+            </a:avLst>
+          </a:prstGeom>
+          <a:solidFill>
+            <a:srgbClr val="1A1A25"/>
+          </a:solidFill>
+          <a:ln>
+            <a:noFill/>
+          </a:ln>
+        </p:spPr>
+        <p:style>
+          <a:lnRef idx="1">
+            <a:schemeClr val="accent1"/>
+          </a:lnRef>
+          <a:fillRef idx="3">
+            <a:schemeClr val="accent1"/>
+          </a:fillRef>
+          <a:effectRef idx="2">
+            <a:schemeClr val="accent1"/>
+          </a:effectRef>
+          <a:fontRef idx="minor">
+            <a:schemeClr val="lt1"/>
+          </a:fontRef>
+        </p:style>
+        <p:txBody>
+          <a:bodyPr rtlCol="0" anchor="ctr"/>
+          <a:lstStyle/>
+          <a:p>
+            <a:pPr algn="ctr"/>
+            <a:endParaRPr/>
+          </a:p>
+        </p:txBody>
+      </p:sp>
+      <p:pic>
+        <p:nvPicPr>
+          <p:cNvPr id="100" name="SpeakerPhoto"/>
+          <p:cNvPicPr>
+            <a:picLocks noChangeAspect="1"/>
+          </p:cNvPicPr>
+          <p:nvPr/>
+        </p:nvPicPr>
+        <p:blipFill>
+          <a:blip r:embed="rId4"/>
+          <a:srcRect/>
+          <a:stretch>
+            <a:fillRect/>
+          </a:stretch>
+        </p:blipFill>
+        <p:spPr>
+          <a:xfrm>
+            <a:off x="914400" y="1645920"/>
+            <a:ext cx="3108960" cy="3108960"/>
+          </a:xfrm>
+          <a:prstGeom prst="roundRect">
+            <a:avLst>
+              <a:gd name="adj" fmla="val 4000"/>
+            </a:avLst>
+          </a:prstGeom>
+        </p:spPr>
+      </p:pic>
+      <p:sp>
+        <p:nvSpPr>
+          <p:cNvPr id="6" name="Rectangle 5"/>
+          <p:cNvSpPr/>
+          <p:nvPr/>
+        </p:nvSpPr>
+        <p:spPr>
+          <a:xfrm>
+            <a:off x="4754880" y="1371600"/>
+            <a:ext cx="640080" cy="38100"/>
+          </a:xfrm>
+          <a:prstGeom prst="rect">
+            <a:avLst/>
+          </a:prstGeom>
+          <a:solidFill>
+            <a:srgbClr val="4AB8D2"/>
+          </a:solidFill>
+          <a:ln>
+            <a:noFill/>
+          </a:ln>
+        </p:spPr>
+        <p:style>
+          <a:lnRef idx="1">
+            <a:schemeClr val="accent1"/>
+          </a:lnRef>
+          <a:fillRef idx="3">
+            <a:schemeClr val="accent1"/>
+          </a:fillRef>
+          <a:effectRef idx="2">
+            <a:schemeClr val="accent1"/>
+          </a:effectRef>
+          <a:fontRef idx="minor">
+            <a:schemeClr val="lt1"/>
+          </a:fontRef>
+        </p:style>
+        <p:txBody>
+          <a:bodyPr rtlCol="0" anchor="ctr"/>
+          <a:lstStyle/>
+          <a:p>
+            <a:pPr algn="ctr"/>
+            <a:endParaRPr/>
+          </a:p>
+        </p:txBody>
+      </p:sp>
+      <p:sp>
+        <p:nvSpPr>
+          <p:cNvPr id="7" name="TextBox 6"/>
+          <p:cNvSpPr txBox="1"/>
+          <p:nvPr/>
+        </p:nvSpPr>
+        <p:spPr>
+          <a:xfrm>
+            <a:off x="4754880" y="1508760"/>
+            <a:ext cx="6858000" cy="365760"/>
+          </a:xfrm>
+          <a:prstGeom prst="rect">
+            <a:avLst/>
+          </a:prstGeom>
+          <a:noFill/>
+        </p:spPr>
+        <p:txBody>
+          <a:bodyPr wrap="square" lIns="0" tIns="0" rIns="0" bIns="0" anchor="t">
+            <a:spAutoFit/>
+          </a:bodyPr>
+          <a:lstStyle/>
+          <a:p>
+            <a:pPr algn="l"/>
+            <a:r>
+              <a:rPr sz="1400" b="1">
+                <a:solidFill>
+                  <a:srgbClr val="4AB8D2"/>
+                </a:solidFill>
+                <a:latin typeface="JetBrains Mono"/>
+              </a:rPr>
+              <a:t>SPEAKER</a:t>
+            </a:r>
+          </a:p>
+        </p:txBody>
+      </p:sp>
+      <p:sp>
+        <p:nvSpPr>
+          <p:cNvPr id="8" name="TextBox 7"/>
+          <p:cNvSpPr txBox="1"/>
+          <p:nvPr/>
+        </p:nvSpPr>
+        <p:spPr>
+          <a:xfrm>
+            <a:off x="4754880" y="1920240"/>
+            <a:ext cx="6858000" cy="822960"/>
+          </a:xfrm>
+          <a:prstGeom prst="rect">
+            <a:avLst/>
+          </a:prstGeom>
+          <a:noFill/>
+        </p:spPr>
+        <p:txBody>
+          <a:bodyPr wrap="square" lIns="0" tIns="0" rIns="0" bIns="0" anchor="t">
+            <a:spAutoFit/>
+          </a:bodyPr>
+          <a:lstStyle/>
+          <a:p>
+            <a:pPr algn="l"/>
+            <a:r>
+              <a:rPr sz="4000" b="1">
+                <a:solidFill>
+                  <a:srgbClr val="E8E8ED"/>
+                </a:solidFill>
+                <a:latin typeface="Inter"/>
+              </a:rPr>
+              <a:t>Marvin Ngoma</a:t>
+            </a:r>
+          </a:p>
+        </p:txBody>
+      </p:sp>
+      <p:sp>
+        <p:nvSpPr>
+          <p:cNvPr id="9" name="TextBox 8"/>
+          <p:cNvSpPr txBox="1"/>
+          <p:nvPr/>
+        </p:nvSpPr>
+        <p:spPr>
+          <a:xfrm>
+            <a:off x="4754880" y="2788920"/>
+            <a:ext cx="6858000" cy="457200"/>
+          </a:xfrm>
+          <a:prstGeom prst="rect">
+            <a:avLst/>
+          </a:prstGeom>
+          <a:noFill/>
+        </p:spPr>
+        <p:txBody>
+          <a:bodyPr wrap="square" lIns="0" tIns="0" rIns="0" bIns="0" anchor="t">
+            <a:spAutoFit/>
+          </a:bodyPr>
+          <a:lstStyle/>
+          <a:p>
+            <a:pPr algn="l"/>
+            <a:r>
+              <a:rPr sz="2000" b="0">
+                <a:solidFill>
+                  <a:srgbClr val="6DD0E7"/>
+                </a:solidFill>
+                <a:latin typeface="Inter"/>
+              </a:rPr>
+              <a:t>Elastic, Principal Security Architect, Security Evangelist</a:t>
+            </a:r>
+          </a:p>
+        </p:txBody>
+      </p:sp>
+      <p:sp>
+        <p:nvSpPr>
+          <p:cNvPr id="10" name="TextBox 9"/>
+          <p:cNvSpPr txBox="1"/>
+          <p:nvPr/>
+        </p:nvSpPr>
+        <p:spPr>
+          <a:xfrm>
+            <a:off x="4754880" y="3474720"/>
+            <a:ext cx="6858000" cy="2103120"/>
+          </a:xfrm>
+          <a:prstGeom prst="rect">
+            <a:avLst/>
+          </a:prstGeom>
+          <a:noFill/>
+        </p:spPr>
+        <p:txBody>
+          <a:bodyPr wrap="square" lIns="0" tIns="0" rIns="0" bIns="0" anchor="t"/>
+          <a:lstStyle/>
+          <a:p>
+            <a:pPr algn="l"/>
+            <a:r>
+              <a:rPr sz="1600" b="0">
+                <a:solidFill>
+                  <a:srgbClr val="8888A0"/>
+                </a:solidFill>
+                <a:latin typeface="Inter"/>
+              </a:rPr>
+              <a:t>Marvin is a Principal Security Architect and Security Evangelist at Elastic, and a seasoned consultant with a strong passion for helping organizations succeed in their cybersecurity programs. He has led many projects in both the private and public sectors — architecting and building Security Operations and Intelligence capabilities, and unifying tools, processes, and people. Before Elastic, he was a security consultant at IBM and the primary SME for QRadar in the Nordics.</a:t>
+            </a:r>
+          </a:p>
+        </p:txBody>
+      </p:sp>
+      <p:sp>
+        <p:nvSpPr>
+          <p:cNvPr id="11" name="TextBox 10"/>
+          <p:cNvSpPr txBox="1"/>
+          <p:nvPr/>
+        </p:nvSpPr>
+        <p:spPr>
+          <a:xfrm>
+            <a:off x="4754880" y="5669280"/>
+            <a:ext cx="6858000" cy="365760"/>
+          </a:xfrm>
+          <a:prstGeom prst="rect">
+            <a:avLst/>
+          </a:prstGeom>
+          <a:noFill/>
+        </p:spPr>
+        <p:txBody>
+          <a:bodyPr wrap="square" lIns="0" tIns="0" rIns="0" bIns="0" anchor="t">
+            <a:spAutoFit/>
+          </a:bodyPr>
+          <a:lstStyle/>
+          <a:p>
+            <a:pPr algn="l"/>
+            <a:r>
+              <a:rPr sz="1400" b="0">
+                <a:solidFill>
+                  <a:srgbClr val="4AB8D2"/>
+                </a:solidFill>
+                <a:latin typeface="JetBrains Mono"/>
+              </a:rPr>
+              <a:t>linkedin.com/in/tyolani  ·  www.elastic.co/blog/author/marvin-ngoma</a:t>
+            </a:r>
+          </a:p>
+        </p:txBody>
+      </p:sp>
+      <p:sp>
+        <p:nvSpPr>
+          <p:cNvPr id="12" name="TextBox 11"/>
+          <p:cNvSpPr txBox="1"/>
+          <p:nvPr/>
+        </p:nvSpPr>
+        <p:spPr>
+          <a:xfrm>
+            <a:off x="548640" y="6446520"/>
+            <a:ext cx="7315200" cy="274320"/>
+          </a:xfrm>
+          <a:prstGeom prst="rect">
+            <a:avLst/>
+          </a:prstGeom>
+          <a:noFill/>
+        </p:spPr>
+        <p:txBody>
+          <a:bodyPr wrap="square" lIns="0" tIns="0" rIns="0" bIns="0" anchor="t">
+            <a:spAutoFit/>
+          </a:bodyPr>
+          <a:lstStyle/>
+          <a:p>
+            <a:pPr algn="l"/>
+            <a:r>
+              <a:rPr sz="1000" b="0">
+                <a:solidFill>
+                  <a:srgbClr val="8888A0"/>
+                </a:solidFill>
+                <a:latin typeface="JetBrains Mono"/>
+              </a:rPr>
+              <a:t>BSides Aarhus 2026  ·  June 20  ·  INCUBA Next, Aarhus</a:t>
+            </a:r>
+          </a:p>
+        </p:txBody>
+      </p:sp>
+      <p:sp>
+        <p:nvSpPr>
+          <p:cNvPr id="13" name="TextBox 12"/>
+          <p:cNvSpPr txBox="1"/>
+          <p:nvPr/>
+        </p:nvSpPr>
+        <p:spPr>
+          <a:xfrm>
+            <a:off x="10515600" y="6446520"/>
+            <a:ext cx="1188720" cy="274320"/>
+          </a:xfrm>
+          <a:prstGeom prst="rect">
+            <a:avLst/>
+          </a:prstGeom>
+          <a:noFill/>
+        </p:spPr>
+        <p:txBody>
+          <a:bodyPr wrap="square" lIns="0" tIns="0" rIns="0" bIns="0" anchor="t">
+            <a:spAutoFit/>
+          </a:bodyPr>
+          <a:lstStyle/>
+          <a:p>
+            <a:pPr algn="r"/>
+            <a:r>
+              <a:rPr sz="1000" b="0">
+                <a:solidFill>
+                  <a:srgbClr val="8888A0"/>
+                </a:solidFill>
+                <a:latin typeface="JetBrains Mono"/>
+              </a:rPr>
+              <a:t>Speaker</a:t>
+            </a:r>
+          </a:p>
+        </p:txBody>
+      </p:sp>
+    </p:spTree>
+  </p:cSld>
+  <p:clrMapOvr>
+    <a:masterClrMapping/>
+  </p:clrMapOvr>
+</p:sld>
+</file>
+
+<file path=ppt/slides/slide14.xml><?xml version="1.0" encoding="utf-8"?>
+<p:sld xmlns:a="http://schemas.openxmlformats.org/drawingml/2006/main" xmlns:r="http://schemas.openxmlformats.org/officeDocument/2006/relationships" xmlns:p="http://schemas.openxmlformats.org/presentationml/2006/main">
+  <p:cSld>
+    <p:spTree>
+      <p:nvGrpSpPr>
+        <p:cNvPr id="1" name=""/>
+        <p:cNvGrpSpPr/>
+        <p:nvPr/>
+      </p:nvGrpSpPr>
+      <p:grpSpPr>
+        <a:xfrm>
+          <a:off x="0" y="0"/>
+          <a:ext cx="0" cy="0"/>
+          <a:chOff x="0" y="0"/>
+          <a:chExt cx="0" cy="0"/>
+        </a:xfrm>
+      </p:grpSpPr>
+      <p:pic>
+        <p:nvPicPr>
+          <p:cNvPr id="2" name="Picture 1" descr="_bg.png"/>
+          <p:cNvPicPr>
+            <a:picLocks noChangeAspect="1"/>
+          </p:cNvPicPr>
+          <p:nvPr/>
+        </p:nvPicPr>
+        <p:blipFill>
+          <a:blip r:embed="rId2"/>
+          <a:stretch>
+            <a:fillRect/>
+          </a:stretch>
+        </p:blipFill>
+        <p:spPr>
+          <a:xfrm>
+            <a:off x="0" y="0"/>
+            <a:ext cx="12191695" cy="6858000"/>
+          </a:xfrm>
+          <a:prstGeom prst="rect">
+            <a:avLst/>
+          </a:prstGeom>
+        </p:spPr>
+      </p:pic>
+      <p:pic>
+        <p:nvPicPr>
+          <p:cNvPr id="3" name="Picture 2" descr="logo.png"/>
+          <p:cNvPicPr>
+            <a:picLocks noChangeAspect="1"/>
+          </p:cNvPicPr>
+          <p:nvPr/>
+        </p:nvPicPr>
+        <p:blipFill>
+          <a:blip r:embed="rId3"/>
+          <a:stretch>
+            <a:fillRect/>
+          </a:stretch>
+        </p:blipFill>
+        <p:spPr>
+          <a:xfrm>
+            <a:off x="548640" y="457200"/>
+            <a:ext cx="617838" cy="457200"/>
+          </a:xfrm>
+          <a:prstGeom prst="rect">
+            <a:avLst/>
+          </a:prstGeom>
+        </p:spPr>
+      </p:pic>
+      <p:sp>
+        <p:nvSpPr>
+          <p:cNvPr id="4" name="Rounded Rectangle 3"/>
+          <p:cNvSpPr/>
+          <p:nvPr/>
+        </p:nvSpPr>
+        <p:spPr>
+          <a:xfrm>
+            <a:off x="548640" y="1463040"/>
+            <a:ext cx="3840480" cy="4389120"/>
+          </a:xfrm>
+          <a:prstGeom prst="roundRect">
+            <a:avLst>
+              <a:gd name="adj" fmla="val 4000"/>
+            </a:avLst>
+          </a:prstGeom>
+          <a:solidFill>
+            <a:srgbClr val="1A1A25"/>
+          </a:solidFill>
+          <a:ln>
+            <a:noFill/>
+          </a:ln>
+        </p:spPr>
+        <p:style>
+          <a:lnRef idx="1">
+            <a:schemeClr val="accent1"/>
+          </a:lnRef>
+          <a:fillRef idx="3">
+            <a:schemeClr val="accent1"/>
+          </a:fillRef>
+          <a:effectRef idx="2">
+            <a:schemeClr val="accent1"/>
+          </a:effectRef>
+          <a:fontRef idx="minor">
+            <a:schemeClr val="lt1"/>
+          </a:fontRef>
+        </p:style>
+        <p:txBody>
+          <a:bodyPr rtlCol="0" anchor="ctr"/>
+          <a:lstStyle/>
+          <a:p>
+            <a:pPr algn="ctr"/>
+            <a:endParaRPr/>
+          </a:p>
+        </p:txBody>
+      </p:sp>
+      <p:pic>
+        <p:nvPicPr>
+          <p:cNvPr id="100" name="SpeakerPhoto"/>
+          <p:cNvPicPr>
+            <a:picLocks noChangeAspect="1"/>
+          </p:cNvPicPr>
+          <p:nvPr/>
+        </p:nvPicPr>
+        <p:blipFill>
+          <a:blip r:embed="rId4"/>
+          <a:srcRect/>
+          <a:stretch>
+            <a:fillRect/>
+          </a:stretch>
+        </p:blipFill>
+        <p:spPr>
+          <a:xfrm>
+            <a:off x="914400" y="1645920"/>
+            <a:ext cx="3108960" cy="3108960"/>
+          </a:xfrm>
+          <a:prstGeom prst="roundRect">
+            <a:avLst>
+              <a:gd name="adj" fmla="val 4000"/>
+            </a:avLst>
+          </a:prstGeom>
+        </p:spPr>
+      </p:pic>
+      <p:sp>
+        <p:nvSpPr>
+          <p:cNvPr id="6" name="Rectangle 5"/>
+          <p:cNvSpPr/>
+          <p:nvPr/>
+        </p:nvSpPr>
+        <p:spPr>
+          <a:xfrm>
+            <a:off x="4754880" y="1371600"/>
+            <a:ext cx="640080" cy="38100"/>
+          </a:xfrm>
+          <a:prstGeom prst="rect">
+            <a:avLst/>
+          </a:prstGeom>
+          <a:solidFill>
+            <a:srgbClr val="4AB8D2"/>
+          </a:solidFill>
+          <a:ln>
+            <a:noFill/>
+          </a:ln>
+        </p:spPr>
+        <p:style>
+          <a:lnRef idx="1">
+            <a:schemeClr val="accent1"/>
+          </a:lnRef>
+          <a:fillRef idx="3">
+            <a:schemeClr val="accent1"/>
+          </a:fillRef>
+          <a:effectRef idx="2">
+            <a:schemeClr val="accent1"/>
+          </a:effectRef>
+          <a:fontRef idx="minor">
+            <a:schemeClr val="lt1"/>
+          </a:fontRef>
+        </p:style>
+        <p:txBody>
+          <a:bodyPr rtlCol="0" anchor="ctr"/>
+          <a:lstStyle/>
+          <a:p>
+            <a:pPr algn="ctr"/>
+            <a:endParaRPr/>
+          </a:p>
+        </p:txBody>
+      </p:sp>
+      <p:sp>
+        <p:nvSpPr>
+          <p:cNvPr id="7" name="TextBox 6"/>
+          <p:cNvSpPr txBox="1"/>
+          <p:nvPr/>
+        </p:nvSpPr>
+        <p:spPr>
+          <a:xfrm>
+            <a:off x="4754880" y="1508760"/>
+            <a:ext cx="6858000" cy="365760"/>
+          </a:xfrm>
+          <a:prstGeom prst="rect">
+            <a:avLst/>
+          </a:prstGeom>
+          <a:noFill/>
+        </p:spPr>
+        <p:txBody>
+          <a:bodyPr wrap="square" lIns="0" tIns="0" rIns="0" bIns="0" anchor="t">
+            <a:spAutoFit/>
+          </a:bodyPr>
+          <a:lstStyle/>
+          <a:p>
+            <a:pPr algn="l"/>
+            <a:r>
+              <a:rPr sz="1400" b="1">
+                <a:solidFill>
+                  <a:srgbClr val="4AB8D2"/>
+                </a:solidFill>
+                <a:latin typeface="JetBrains Mono"/>
+              </a:rPr>
+              <a:t>SPEAKER</a:t>
+            </a:r>
+          </a:p>
+        </p:txBody>
+      </p:sp>
+      <p:sp>
+        <p:nvSpPr>
+          <p:cNvPr id="8" name="TextBox 7"/>
+          <p:cNvSpPr txBox="1"/>
+          <p:nvPr/>
+        </p:nvSpPr>
+        <p:spPr>
+          <a:xfrm>
+            <a:off x="4754880" y="1920240"/>
+            <a:ext cx="6858000" cy="822960"/>
+          </a:xfrm>
+          <a:prstGeom prst="rect">
+            <a:avLst/>
+          </a:prstGeom>
+          <a:noFill/>
+        </p:spPr>
+        <p:txBody>
+          <a:bodyPr wrap="square" lIns="0" tIns="0" rIns="0" bIns="0" anchor="t">
+            <a:spAutoFit/>
+          </a:bodyPr>
+          <a:lstStyle/>
+          <a:p>
+            <a:pPr algn="l"/>
+            <a:r>
+              <a:rPr sz="4000" b="1">
+                <a:solidFill>
+                  <a:srgbClr val="E8E8ED"/>
+                </a:solidFill>
+                <a:latin typeface="Inter"/>
+              </a:rPr>
+              <a:t>Morten von Seelen</a:t>
+            </a:r>
+          </a:p>
+        </p:txBody>
+      </p:sp>
+      <p:sp>
+        <p:nvSpPr>
+          <p:cNvPr id="9" name="TextBox 8"/>
+          <p:cNvSpPr txBox="1"/>
+          <p:nvPr/>
+        </p:nvSpPr>
+        <p:spPr>
+          <a:xfrm>
+            <a:off x="4754880" y="2788920"/>
+            <a:ext cx="6858000" cy="457200"/>
+          </a:xfrm>
+          <a:prstGeom prst="rect">
+            <a:avLst/>
+          </a:prstGeom>
+          <a:noFill/>
+        </p:spPr>
+        <p:txBody>
+          <a:bodyPr wrap="square" lIns="0" tIns="0" rIns="0" bIns="0" anchor="t">
+            <a:spAutoFit/>
+          </a:bodyPr>
+          <a:lstStyle/>
+          <a:p>
+            <a:pPr algn="l"/>
+            <a:r>
+              <a:rPr sz="2000" b="0">
+                <a:solidFill>
+                  <a:srgbClr val="6DD0E7"/>
+                </a:solidFill>
+                <a:latin typeface="Inter"/>
+              </a:rPr>
+              <a:t>TRUESEC, Vice President</a:t>
+            </a:r>
+          </a:p>
+        </p:txBody>
+      </p:sp>
+      <p:sp>
+        <p:nvSpPr>
+          <p:cNvPr id="10" name="TextBox 9"/>
+          <p:cNvSpPr txBox="1"/>
+          <p:nvPr/>
+        </p:nvSpPr>
+        <p:spPr>
+          <a:xfrm>
+            <a:off x="4754880" y="3474720"/>
+            <a:ext cx="6858000" cy="2103120"/>
+          </a:xfrm>
+          <a:prstGeom prst="rect">
+            <a:avLst/>
+          </a:prstGeom>
+          <a:noFill/>
+        </p:spPr>
+        <p:txBody>
+          <a:bodyPr wrap="square" lIns="0" tIns="0" rIns="0" bIns="0" anchor="t"/>
+          <a:lstStyle/>
+          <a:p>
+            <a:pPr algn="l"/>
+            <a:r>
+              <a:rPr sz="1600" b="0">
+                <a:solidFill>
+                  <a:srgbClr val="8888A0"/>
+                </a:solidFill>
+                <a:latin typeface="Inter"/>
+              </a:rPr>
+              <a:t>Morten is Vice President at Truesec in Aarhus and builds cool companies. His work focuses on turning outside-in signals about real organizations into actionable risk insight at national scale.</a:t>
+            </a:r>
+          </a:p>
+        </p:txBody>
+      </p:sp>
+      <p:sp>
+        <p:nvSpPr>
+          <p:cNvPr id="11" name="TextBox 10"/>
+          <p:cNvSpPr txBox="1"/>
+          <p:nvPr/>
+        </p:nvSpPr>
+        <p:spPr>
+          <a:xfrm>
+            <a:off x="4754880" y="5669280"/>
+            <a:ext cx="6858000" cy="365760"/>
+          </a:xfrm>
+          <a:prstGeom prst="rect">
+            <a:avLst/>
+          </a:prstGeom>
+          <a:noFill/>
+        </p:spPr>
+        <p:txBody>
+          <a:bodyPr wrap="square" lIns="0" tIns="0" rIns="0" bIns="0" anchor="t">
+            <a:spAutoFit/>
+          </a:bodyPr>
+          <a:lstStyle/>
+          <a:p>
+            <a:pPr algn="l"/>
+            <a:r>
+              <a:rPr sz="1400" b="0">
+                <a:solidFill>
+                  <a:srgbClr val="4AB8D2"/>
+                </a:solidFill>
+                <a:latin typeface="JetBrains Mono"/>
+              </a:rPr>
+              <a:t>linkedin.com/in/vonseelen  ·  tinyurl.com/MvSeeBlog</a:t>
+            </a:r>
+          </a:p>
+        </p:txBody>
+      </p:sp>
+      <p:sp>
+        <p:nvSpPr>
+          <p:cNvPr id="12" name="TextBox 11"/>
+          <p:cNvSpPr txBox="1"/>
+          <p:nvPr/>
+        </p:nvSpPr>
+        <p:spPr>
+          <a:xfrm>
+            <a:off x="548640" y="6446520"/>
+            <a:ext cx="7315200" cy="274320"/>
+          </a:xfrm>
+          <a:prstGeom prst="rect">
+            <a:avLst/>
+          </a:prstGeom>
+          <a:noFill/>
+        </p:spPr>
+        <p:txBody>
+          <a:bodyPr wrap="square" lIns="0" tIns="0" rIns="0" bIns="0" anchor="t">
+            <a:spAutoFit/>
+          </a:bodyPr>
+          <a:lstStyle/>
+          <a:p>
+            <a:pPr algn="l"/>
+            <a:r>
+              <a:rPr sz="1000" b="0">
+                <a:solidFill>
+                  <a:srgbClr val="8888A0"/>
+                </a:solidFill>
+                <a:latin typeface="JetBrains Mono"/>
+              </a:rPr>
+              <a:t>BSides Aarhus 2026  ·  June 20  ·  INCUBA Next, Aarhus</a:t>
+            </a:r>
+          </a:p>
+        </p:txBody>
+      </p:sp>
+      <p:sp>
+        <p:nvSpPr>
+          <p:cNvPr id="13" name="TextBox 12"/>
+          <p:cNvSpPr txBox="1"/>
+          <p:nvPr/>
+        </p:nvSpPr>
+        <p:spPr>
+          <a:xfrm>
+            <a:off x="10515600" y="6446520"/>
+            <a:ext cx="1188720" cy="274320"/>
+          </a:xfrm>
+          <a:prstGeom prst="rect">
+            <a:avLst/>
+          </a:prstGeom>
+          <a:noFill/>
+        </p:spPr>
+        <p:txBody>
+          <a:bodyPr wrap="square" lIns="0" tIns="0" rIns="0" bIns="0" anchor="t">
+            <a:spAutoFit/>
+          </a:bodyPr>
+          <a:lstStyle/>
+          <a:p>
+            <a:pPr algn="r"/>
+            <a:r>
+              <a:rPr sz="1000" b="0">
+                <a:solidFill>
+                  <a:srgbClr val="8888A0"/>
+                </a:solidFill>
+                <a:latin typeface="JetBrains Mono"/>
+              </a:rPr>
+              <a:t>Speaker</a:t>
+            </a:r>
+          </a:p>
+        </p:txBody>
+      </p:sp>
+    </p:spTree>
+  </p:cSld>
+  <p:clrMapOvr>
+    <a:masterClrMapping/>
+  </p:clrMapOvr>
+</p:sld>
+</file>
+
+<file path=ppt/slides/slide15.xml><?xml version="1.0" encoding="utf-8"?>
+<p:sld xmlns:a="http://schemas.openxmlformats.org/drawingml/2006/main" xmlns:r="http://schemas.openxmlformats.org/officeDocument/2006/relationships" xmlns:p="http://schemas.openxmlformats.org/presentationml/2006/main">
+  <p:cSld>
+    <p:spTree>
+      <p:nvGrpSpPr>
+        <p:cNvPr id="1" name=""/>
+        <p:cNvGrpSpPr/>
+        <p:nvPr/>
+      </p:nvGrpSpPr>
+      <p:grpSpPr>
+        <a:xfrm>
+          <a:off x="0" y="0"/>
+          <a:ext cx="0" cy="0"/>
+          <a:chOff x="0" y="0"/>
+          <a:chExt cx="0" cy="0"/>
+        </a:xfrm>
+      </p:grpSpPr>
+      <p:pic>
+        <p:nvPicPr>
+          <p:cNvPr id="2" name="Picture 1" descr="_bg.png"/>
+          <p:cNvPicPr>
+            <a:picLocks noChangeAspect="1"/>
+          </p:cNvPicPr>
+          <p:nvPr/>
+        </p:nvPicPr>
+        <p:blipFill>
+          <a:blip r:embed="rId2"/>
+          <a:stretch>
+            <a:fillRect/>
+          </a:stretch>
+        </p:blipFill>
+        <p:spPr>
+          <a:xfrm>
+            <a:off x="0" y="0"/>
+            <a:ext cx="12191695" cy="6858000"/>
+          </a:xfrm>
+          <a:prstGeom prst="rect">
+            <a:avLst/>
+          </a:prstGeom>
+        </p:spPr>
+      </p:pic>
+      <p:pic>
+        <p:nvPicPr>
+          <p:cNvPr id="3" name="Picture 2" descr="logo.png"/>
+          <p:cNvPicPr>
+            <a:picLocks noChangeAspect="1"/>
+          </p:cNvPicPr>
+          <p:nvPr/>
+        </p:nvPicPr>
+        <p:blipFill>
+          <a:blip r:embed="rId3"/>
+          <a:stretch>
+            <a:fillRect/>
+          </a:stretch>
+        </p:blipFill>
+        <p:spPr>
+          <a:xfrm>
+            <a:off x="548640" y="457200"/>
+            <a:ext cx="617838" cy="457200"/>
+          </a:xfrm>
+          <a:prstGeom prst="rect">
+            <a:avLst/>
+          </a:prstGeom>
+        </p:spPr>
+      </p:pic>
+      <p:sp>
+        <p:nvSpPr>
+          <p:cNvPr id="4" name="Rounded Rectangle 3"/>
+          <p:cNvSpPr/>
+          <p:nvPr/>
+        </p:nvSpPr>
+        <p:spPr>
+          <a:xfrm>
+            <a:off x="548640" y="1463040"/>
+            <a:ext cx="3840480" cy="4389120"/>
+          </a:xfrm>
+          <a:prstGeom prst="roundRect">
+            <a:avLst>
+              <a:gd name="adj" fmla="val 4000"/>
+            </a:avLst>
+          </a:prstGeom>
+          <a:solidFill>
+            <a:srgbClr val="1A1A25"/>
+          </a:solidFill>
+          <a:ln>
+            <a:noFill/>
+          </a:ln>
+        </p:spPr>
+        <p:style>
+          <a:lnRef idx="1">
+            <a:schemeClr val="accent1"/>
+          </a:lnRef>
+          <a:fillRef idx="3">
+            <a:schemeClr val="accent1"/>
+          </a:fillRef>
+          <a:effectRef idx="2">
+            <a:schemeClr val="accent1"/>
+          </a:effectRef>
+          <a:fontRef idx="minor">
+            <a:schemeClr val="lt1"/>
+          </a:fontRef>
+        </p:style>
+        <p:txBody>
+          <a:bodyPr rtlCol="0" anchor="ctr"/>
+          <a:lstStyle/>
+          <a:p>
+            <a:pPr algn="ctr"/>
+            <a:endParaRPr/>
+          </a:p>
+        </p:txBody>
+      </p:sp>
+      <p:pic>
+        <p:nvPicPr>
+          <p:cNvPr id="100" name="SpeakerPhoto"/>
+          <p:cNvPicPr>
+            <a:picLocks noChangeAspect="1"/>
+          </p:cNvPicPr>
+          <p:nvPr/>
+        </p:nvPicPr>
+        <p:blipFill>
+          <a:blip r:embed="rId4"/>
+          <a:srcRect/>
+          <a:stretch>
+            <a:fillRect/>
+          </a:stretch>
+        </p:blipFill>
+        <p:spPr>
+          <a:xfrm>
+            <a:off x="914400" y="1645920"/>
+            <a:ext cx="3108960" cy="3108960"/>
+          </a:xfrm>
+          <a:prstGeom prst="roundRect">
+            <a:avLst>
+              <a:gd name="adj" fmla="val 4000"/>
+            </a:avLst>
+          </a:prstGeom>
+        </p:spPr>
+      </p:pic>
+      <p:sp>
+        <p:nvSpPr>
+          <p:cNvPr id="6" name="Rectangle 5"/>
+          <p:cNvSpPr/>
+          <p:nvPr/>
+        </p:nvSpPr>
+        <p:spPr>
+          <a:xfrm>
+            <a:off x="4754880" y="1371600"/>
+            <a:ext cx="640080" cy="38100"/>
+          </a:xfrm>
+          <a:prstGeom prst="rect">
+            <a:avLst/>
+          </a:prstGeom>
+          <a:solidFill>
+            <a:srgbClr val="4AB8D2"/>
+          </a:solidFill>
+          <a:ln>
+            <a:noFill/>
+          </a:ln>
+        </p:spPr>
+        <p:style>
+          <a:lnRef idx="1">
+            <a:schemeClr val="accent1"/>
+          </a:lnRef>
+          <a:fillRef idx="3">
+            <a:schemeClr val="accent1"/>
+          </a:fillRef>
+          <a:effectRef idx="2">
+            <a:schemeClr val="accent1"/>
+          </a:effectRef>
+          <a:fontRef idx="minor">
+            <a:schemeClr val="lt1"/>
+          </a:fontRef>
+        </p:style>
+        <p:txBody>
+          <a:bodyPr rtlCol="0" anchor="ctr"/>
+          <a:lstStyle/>
+          <a:p>
+            <a:pPr algn="ctr"/>
+            <a:endParaRPr/>
+          </a:p>
+        </p:txBody>
+      </p:sp>
+      <p:sp>
+        <p:nvSpPr>
+          <p:cNvPr id="7" name="TextBox 6"/>
+          <p:cNvSpPr txBox="1"/>
+          <p:nvPr/>
+        </p:nvSpPr>
+        <p:spPr>
+          <a:xfrm>
+            <a:off x="4754880" y="1508760"/>
+            <a:ext cx="6858000" cy="365760"/>
+          </a:xfrm>
+          <a:prstGeom prst="rect">
+            <a:avLst/>
+          </a:prstGeom>
+          <a:noFill/>
+        </p:spPr>
+        <p:txBody>
+          <a:bodyPr wrap="square" lIns="0" tIns="0" rIns="0" bIns="0" anchor="t">
+            <a:spAutoFit/>
+          </a:bodyPr>
+          <a:lstStyle/>
+          <a:p>
+            <a:pPr algn="l"/>
+            <a:r>
+              <a:rPr sz="1400" b="1">
+                <a:solidFill>
+                  <a:srgbClr val="4AB8D2"/>
+                </a:solidFill>
+                <a:latin typeface="JetBrains Mono"/>
+              </a:rPr>
+              <a:t>SPEAKER</a:t>
+            </a:r>
+          </a:p>
+        </p:txBody>
+      </p:sp>
+      <p:sp>
+        <p:nvSpPr>
+          <p:cNvPr id="8" name="TextBox 7"/>
+          <p:cNvSpPr txBox="1"/>
+          <p:nvPr/>
+        </p:nvSpPr>
+        <p:spPr>
+          <a:xfrm>
+            <a:off x="4754880" y="1920240"/>
+            <a:ext cx="6858000" cy="822960"/>
+          </a:xfrm>
+          <a:prstGeom prst="rect">
+            <a:avLst/>
+          </a:prstGeom>
+          <a:noFill/>
+        </p:spPr>
+        <p:txBody>
+          <a:bodyPr wrap="square" lIns="0" tIns="0" rIns="0" bIns="0" anchor="t">
+            <a:spAutoFit/>
+          </a:bodyPr>
+          <a:lstStyle/>
+          <a:p>
+            <a:pPr algn="l"/>
+            <a:r>
+              <a:rPr sz="4000" b="1">
+                <a:solidFill>
+                  <a:srgbClr val="E8E8ED"/>
+                </a:solidFill>
+                <a:latin typeface="Inter"/>
+              </a:rPr>
+              <a:t>Tom Kern</a:t>
+            </a:r>
+          </a:p>
+        </p:txBody>
+      </p:sp>
+      <p:sp>
+        <p:nvSpPr>
+          <p:cNvPr id="9" name="TextBox 8"/>
+          <p:cNvSpPr txBox="1"/>
+          <p:nvPr/>
+        </p:nvSpPr>
+        <p:spPr>
+          <a:xfrm>
+            <a:off x="4754880" y="2788920"/>
+            <a:ext cx="6858000" cy="457200"/>
+          </a:xfrm>
+          <a:prstGeom prst="rect">
+            <a:avLst/>
+          </a:prstGeom>
+          <a:noFill/>
+        </p:spPr>
+        <p:txBody>
+          <a:bodyPr wrap="square" lIns="0" tIns="0" rIns="0" bIns="0" anchor="t">
+            <a:spAutoFit/>
+          </a:bodyPr>
+          <a:lstStyle/>
+          <a:p>
+            <a:pPr algn="l"/>
+            <a:r>
+              <a:rPr sz="2000" b="0">
+                <a:solidFill>
+                  <a:srgbClr val="6DD0E7"/>
+                </a:solidFill>
+                <a:latin typeface="Inter"/>
+              </a:rPr>
+              <a:t>SecOps Automation Lead @ Conscia MDR</a:t>
+            </a:r>
+          </a:p>
+        </p:txBody>
+      </p:sp>
+      <p:sp>
+        <p:nvSpPr>
+          <p:cNvPr id="10" name="TextBox 9"/>
+          <p:cNvSpPr txBox="1"/>
+          <p:nvPr/>
+        </p:nvSpPr>
+        <p:spPr>
+          <a:xfrm>
+            <a:off x="4754880" y="3474720"/>
+            <a:ext cx="6858000" cy="2103120"/>
+          </a:xfrm>
+          <a:prstGeom prst="rect">
+            <a:avLst/>
+          </a:prstGeom>
+          <a:noFill/>
+        </p:spPr>
+        <p:txBody>
+          <a:bodyPr wrap="square" lIns="0" tIns="0" rIns="0" bIns="0" anchor="t"/>
+          <a:lstStyle/>
+          <a:p>
+            <a:pPr algn="l"/>
+            <a:r>
+              <a:rPr sz="1600" b="0">
+                <a:solidFill>
+                  <a:srgbClr val="8888A0"/>
+                </a:solidFill>
+                <a:latin typeface="Inter"/>
+              </a:rPr>
+              <a:t>Tom is a founding member of Conscia's Managed Detection and Response service, now protecting over 250,000 endpoints across Europe. As SecOps Automation Lead, his contributions include technical architecture, detection engineering, and automating security operations.</a:t>
+            </a:r>
+          </a:p>
+        </p:txBody>
+      </p:sp>
+      <p:sp>
+        <p:nvSpPr>
+          <p:cNvPr id="11" name="TextBox 10"/>
+          <p:cNvSpPr txBox="1"/>
+          <p:nvPr/>
+        </p:nvSpPr>
+        <p:spPr>
+          <a:xfrm>
+            <a:off x="4754880" y="5669280"/>
+            <a:ext cx="6858000" cy="365760"/>
+          </a:xfrm>
+          <a:prstGeom prst="rect">
+            <a:avLst/>
+          </a:prstGeom>
+          <a:noFill/>
+        </p:spPr>
+        <p:txBody>
+          <a:bodyPr wrap="square" lIns="0" tIns="0" rIns="0" bIns="0" anchor="t">
+            <a:spAutoFit/>
+          </a:bodyPr>
+          <a:lstStyle/>
+          <a:p>
+            <a:pPr algn="l"/>
+            <a:r>
+              <a:rPr sz="1400" b="0">
+                <a:solidFill>
+                  <a:srgbClr val="4AB8D2"/>
+                </a:solidFill>
+                <a:latin typeface="JetBrains Mono"/>
+              </a:rPr>
+              <a:t>linkedin.com/in/kerntom  ·  truly-smart.eu</a:t>
+            </a:r>
+          </a:p>
+        </p:txBody>
+      </p:sp>
+      <p:sp>
+        <p:nvSpPr>
+          <p:cNvPr id="12" name="TextBox 11"/>
+          <p:cNvSpPr txBox="1"/>
+          <p:nvPr/>
+        </p:nvSpPr>
+        <p:spPr>
+          <a:xfrm>
+            <a:off x="548640" y="6446520"/>
+            <a:ext cx="7315200" cy="274320"/>
+          </a:xfrm>
+          <a:prstGeom prst="rect">
+            <a:avLst/>
+          </a:prstGeom>
+          <a:noFill/>
+        </p:spPr>
+        <p:txBody>
+          <a:bodyPr wrap="square" lIns="0" tIns="0" rIns="0" bIns="0" anchor="t">
+            <a:spAutoFit/>
+          </a:bodyPr>
+          <a:lstStyle/>
+          <a:p>
+            <a:pPr algn="l"/>
+            <a:r>
+              <a:rPr sz="1000" b="0">
+                <a:solidFill>
+                  <a:srgbClr val="8888A0"/>
+                </a:solidFill>
+                <a:latin typeface="JetBrains Mono"/>
+              </a:rPr>
+              <a:t>BSides Aarhus 2026  ·  June 20  ·  INCUBA Next, Aarhus</a:t>
+            </a:r>
+          </a:p>
+        </p:txBody>
+      </p:sp>
+      <p:sp>
+        <p:nvSpPr>
+          <p:cNvPr id="13" name="TextBox 12"/>
+          <p:cNvSpPr txBox="1"/>
+          <p:nvPr/>
+        </p:nvSpPr>
+        <p:spPr>
+          <a:xfrm>
+            <a:off x="10515600" y="6446520"/>
+            <a:ext cx="1188720" cy="274320"/>
+          </a:xfrm>
+          <a:prstGeom prst="rect">
+            <a:avLst/>
+          </a:prstGeom>
+          <a:noFill/>
+        </p:spPr>
+        <p:txBody>
+          <a:bodyPr wrap="square" lIns="0" tIns="0" rIns="0" bIns="0" anchor="t">
+            <a:spAutoFit/>
+          </a:bodyPr>
+          <a:lstStyle/>
+          <a:p>
+            <a:pPr algn="r"/>
+            <a:r>
+              <a:rPr sz="1000" b="0">
+                <a:solidFill>
+                  <a:srgbClr val="8888A0"/>
+                </a:solidFill>
+                <a:latin typeface="JetBrains Mono"/>
+              </a:rPr>
+              <a:t>Speaker</a:t>
+            </a:r>
+          </a:p>
+        </p:txBody>
+      </p:sp>
+    </p:spTree>
+  </p:cSld>
+  <p:clrMapOvr>
+    <a:masterClrMapping/>
+  </p:clrMapOvr>
+</p:sld>
+</file>
+
+<file path=ppt/slides/slide16.xml><?xml version="1.0" encoding="utf-8"?>
+<p:sld xmlns:a="http://schemas.openxmlformats.org/drawingml/2006/main" xmlns:r="http://schemas.openxmlformats.org/officeDocument/2006/relationships" xmlns:p="http://schemas.openxmlformats.org/presentationml/2006/main">
+  <p:cSld>
+    <p:spTree>
+      <p:nvGrpSpPr>
+        <p:cNvPr id="1" name=""/>
+        <p:cNvGrpSpPr/>
+        <p:nvPr/>
+      </p:nvGrpSpPr>
+      <p:grpSpPr>
+        <a:xfrm>
+          <a:off x="0" y="0"/>
+          <a:ext cx="0" cy="0"/>
+          <a:chOff x="0" y="0"/>
+          <a:chExt cx="0" cy="0"/>
+        </a:xfrm>
+      </p:grpSpPr>
+      <p:pic>
+        <p:nvPicPr>
+          <p:cNvPr id="2" name="Picture 1" descr="_bg.png"/>
+          <p:cNvPicPr>
+            <a:picLocks noChangeAspect="1"/>
+          </p:cNvPicPr>
+          <p:nvPr/>
+        </p:nvPicPr>
+        <p:blipFill>
+          <a:blip r:embed="rId2"/>
+          <a:stretch>
+            <a:fillRect/>
+          </a:stretch>
+        </p:blipFill>
+        <p:spPr>
+          <a:xfrm>
+            <a:off x="0" y="0"/>
+            <a:ext cx="12191695" cy="6858000"/>
+          </a:xfrm>
+          <a:prstGeom prst="rect">
+            <a:avLst/>
+          </a:prstGeom>
+        </p:spPr>
+      </p:pic>
+      <p:pic>
+        <p:nvPicPr>
+          <p:cNvPr id="3" name="Picture 2" descr="logo.png"/>
+          <p:cNvPicPr>
+            <a:picLocks noChangeAspect="1"/>
+          </p:cNvPicPr>
+          <p:nvPr/>
+        </p:nvPicPr>
+        <p:blipFill>
+          <a:blip r:embed="rId3"/>
+          <a:stretch>
+            <a:fillRect/>
+          </a:stretch>
+        </p:blipFill>
+        <p:spPr>
+          <a:xfrm>
+            <a:off x="548640" y="457200"/>
+            <a:ext cx="617838" cy="457200"/>
+          </a:xfrm>
+          <a:prstGeom prst="rect">
+            <a:avLst/>
+          </a:prstGeom>
+        </p:spPr>
+      </p:pic>
+      <p:sp>
+        <p:nvSpPr>
+          <p:cNvPr id="4" name="Rounded Rectangle 3"/>
+          <p:cNvSpPr/>
+          <p:nvPr/>
+        </p:nvSpPr>
+        <p:spPr>
+          <a:xfrm>
+            <a:off x="548640" y="1463040"/>
+            <a:ext cx="3840480" cy="4389120"/>
+          </a:xfrm>
+          <a:prstGeom prst="roundRect">
+            <a:avLst>
+              <a:gd name="adj" fmla="val 4000"/>
+            </a:avLst>
+          </a:prstGeom>
+          <a:solidFill>
+            <a:srgbClr val="1A1A25"/>
+          </a:solidFill>
+          <a:ln>
+            <a:noFill/>
+          </a:ln>
+        </p:spPr>
+        <p:style>
+          <a:lnRef idx="1">
+            <a:schemeClr val="accent1"/>
+          </a:lnRef>
+          <a:fillRef idx="3">
+            <a:schemeClr val="accent1"/>
+          </a:fillRef>
+          <a:effectRef idx="2">
+            <a:schemeClr val="accent1"/>
+          </a:effectRef>
+          <a:fontRef idx="minor">
+            <a:schemeClr val="lt1"/>
+          </a:fontRef>
+        </p:style>
+        <p:txBody>
+          <a:bodyPr rtlCol="0" anchor="ctr"/>
+          <a:lstStyle/>
+          <a:p>
+            <a:pPr algn="ctr"/>
+            <a:endParaRPr/>
+          </a:p>
+        </p:txBody>
+      </p:sp>
+      <p:pic>
+        <p:nvPicPr>
+          <p:cNvPr id="100" name="SpeakerPhoto"/>
+          <p:cNvPicPr>
+            <a:picLocks noChangeAspect="1"/>
+          </p:cNvPicPr>
+          <p:nvPr/>
+        </p:nvPicPr>
+        <p:blipFill>
+          <a:blip r:embed="rId4"/>
+          <a:srcRect/>
+          <a:stretch>
+            <a:fillRect/>
+          </a:stretch>
+        </p:blipFill>
+        <p:spPr>
+          <a:xfrm>
+            <a:off x="914400" y="1645920"/>
+            <a:ext cx="3108960" cy="3108960"/>
+          </a:xfrm>
+          <a:prstGeom prst="roundRect">
+            <a:avLst>
+              <a:gd name="adj" fmla="val 4000"/>
+            </a:avLst>
+          </a:prstGeom>
+        </p:spPr>
+      </p:pic>
+      <p:sp>
+        <p:nvSpPr>
+          <p:cNvPr id="6" name="Rectangle 5"/>
+          <p:cNvSpPr/>
+          <p:nvPr/>
+        </p:nvSpPr>
+        <p:spPr>
+          <a:xfrm>
+            <a:off x="4754880" y="1371600"/>
+            <a:ext cx="640080" cy="38100"/>
+          </a:xfrm>
+          <a:prstGeom prst="rect">
+            <a:avLst/>
+          </a:prstGeom>
+          <a:solidFill>
+            <a:srgbClr val="4AB8D2"/>
+          </a:solidFill>
+          <a:ln>
+            <a:noFill/>
+          </a:ln>
+        </p:spPr>
+        <p:style>
+          <a:lnRef idx="1">
+            <a:schemeClr val="accent1"/>
+          </a:lnRef>
+          <a:fillRef idx="3">
+            <a:schemeClr val="accent1"/>
+          </a:fillRef>
+          <a:effectRef idx="2">
+            <a:schemeClr val="accent1"/>
+          </a:effectRef>
+          <a:fontRef idx="minor">
+            <a:schemeClr val="lt1"/>
+          </a:fontRef>
+        </p:style>
+        <p:txBody>
+          <a:bodyPr rtlCol="0" anchor="ctr"/>
+          <a:lstStyle/>
+          <a:p>
+            <a:pPr algn="ctr"/>
+            <a:endParaRPr/>
+          </a:p>
+        </p:txBody>
+      </p:sp>
+      <p:sp>
+        <p:nvSpPr>
+          <p:cNvPr id="7" name="TextBox 6"/>
+          <p:cNvSpPr txBox="1"/>
+          <p:nvPr/>
+        </p:nvSpPr>
+        <p:spPr>
+          <a:xfrm>
+            <a:off x="4754880" y="1508760"/>
+            <a:ext cx="6858000" cy="365760"/>
+          </a:xfrm>
+          <a:prstGeom prst="rect">
+            <a:avLst/>
+          </a:prstGeom>
+          <a:noFill/>
+        </p:spPr>
+        <p:txBody>
+          <a:bodyPr wrap="square" lIns="0" tIns="0" rIns="0" bIns="0" anchor="t">
+            <a:spAutoFit/>
+          </a:bodyPr>
+          <a:lstStyle/>
+          <a:p>
+            <a:pPr algn="l"/>
+            <a:r>
+              <a:rPr sz="1400" b="1">
+                <a:solidFill>
+                  <a:srgbClr val="4AB8D2"/>
+                </a:solidFill>
+                <a:latin typeface="JetBrains Mono"/>
+              </a:rPr>
+              <a:t>SPEAKER</a:t>
+            </a:r>
+          </a:p>
+        </p:txBody>
+      </p:sp>
+      <p:sp>
+        <p:nvSpPr>
+          <p:cNvPr id="8" name="TextBox 7"/>
+          <p:cNvSpPr txBox="1"/>
+          <p:nvPr/>
+        </p:nvSpPr>
+        <p:spPr>
+          <a:xfrm>
+            <a:off x="4754880" y="1920240"/>
+            <a:ext cx="6858000" cy="822960"/>
+          </a:xfrm>
+          <a:prstGeom prst="rect">
+            <a:avLst/>
+          </a:prstGeom>
+          <a:noFill/>
+        </p:spPr>
+        <p:txBody>
+          <a:bodyPr wrap="square" lIns="0" tIns="0" rIns="0" bIns="0" anchor="t">
+            <a:spAutoFit/>
+          </a:bodyPr>
+          <a:lstStyle/>
+          <a:p>
+            <a:pPr algn="l"/>
+            <a:r>
+              <a:rPr sz="4000" b="1">
+                <a:solidFill>
+                  <a:srgbClr val="E8E8ED"/>
+                </a:solidFill>
+                <a:latin typeface="Inter"/>
+              </a:rPr>
+              <a:t>Yuvaraj Govindarajulu</a:t>
+            </a:r>
+          </a:p>
+        </p:txBody>
+      </p:sp>
+      <p:sp>
+        <p:nvSpPr>
+          <p:cNvPr id="9" name="TextBox 8"/>
+          <p:cNvSpPr txBox="1"/>
+          <p:nvPr/>
+        </p:nvSpPr>
+        <p:spPr>
+          <a:xfrm>
+            <a:off x="4754880" y="2788920"/>
+            <a:ext cx="6858000" cy="457200"/>
+          </a:xfrm>
+          <a:prstGeom prst="rect">
+            <a:avLst/>
+          </a:prstGeom>
+          <a:noFill/>
+        </p:spPr>
+        <p:txBody>
+          <a:bodyPr wrap="square" lIns="0" tIns="0" rIns="0" bIns="0" anchor="t">
+            <a:spAutoFit/>
+          </a:bodyPr>
+          <a:lstStyle/>
+          <a:p>
+            <a:pPr algn="l"/>
+            <a:r>
+              <a:rPr sz="2000" b="0">
+                <a:solidFill>
+                  <a:srgbClr val="6DD0E7"/>
+                </a:solidFill>
+                <a:latin typeface="Inter"/>
+              </a:rPr>
+              <a:t>AVP - Product Engineering &amp; Head of Research at Protectt.ai</a:t>
+            </a:r>
+          </a:p>
+        </p:txBody>
+      </p:sp>
+      <p:sp>
+        <p:nvSpPr>
+          <p:cNvPr id="10" name="TextBox 9"/>
+          <p:cNvSpPr txBox="1"/>
+          <p:nvPr/>
+        </p:nvSpPr>
+        <p:spPr>
+          <a:xfrm>
+            <a:off x="4754880" y="3474720"/>
+            <a:ext cx="6858000" cy="2103120"/>
+          </a:xfrm>
+          <a:prstGeom prst="rect">
+            <a:avLst/>
+          </a:prstGeom>
+          <a:noFill/>
+        </p:spPr>
+        <p:txBody>
+          <a:bodyPr wrap="square" lIns="0" tIns="0" rIns="0" bIns="0" anchor="t"/>
+          <a:lstStyle/>
+          <a:p>
+            <a:pPr algn="l"/>
+            <a:r>
+              <a:rPr sz="1600" b="0">
+                <a:solidFill>
+                  <a:srgbClr val="8888A0"/>
+                </a:solidFill>
+                <a:latin typeface="Inter"/>
+              </a:rPr>
+              <a:t>Yuvaraj Govindarajulu is a technical leader with over a decade of experience in AI, Cybersecurity and Embedded Systems R&amp;D. He is the AVP - Product Engineering &amp; Head of Research at Protectt.ai. He is the co-lead of the OWASP AI Bill of Materials Project and the Co-Author, Workstream lead (Harmonization) at the OWASP AI Exchange. With over 22+ International patents filed, his key areas of focus include AI Red Teaming, GenAI Guardrails, Ransomware Attacks on AI and AI supply chain Security.</a:t>
+            </a:r>
+          </a:p>
+        </p:txBody>
+      </p:sp>
+      <p:sp>
+        <p:nvSpPr>
+          <p:cNvPr id="11" name="TextBox 10"/>
+          <p:cNvSpPr txBox="1"/>
+          <p:nvPr/>
+        </p:nvSpPr>
+        <p:spPr>
+          <a:xfrm>
+            <a:off x="4754880" y="5669280"/>
+            <a:ext cx="6858000" cy="365760"/>
+          </a:xfrm>
+          <a:prstGeom prst="rect">
+            <a:avLst/>
+          </a:prstGeom>
+          <a:noFill/>
+        </p:spPr>
+        <p:txBody>
+          <a:bodyPr wrap="square" lIns="0" tIns="0" rIns="0" bIns="0" anchor="t">
+            <a:spAutoFit/>
+          </a:bodyPr>
+          <a:lstStyle/>
+          <a:p>
+            <a:pPr algn="l"/>
+            <a:r>
+              <a:rPr sz="1400" b="0">
+                <a:solidFill>
+                  <a:srgbClr val="4AB8D2"/>
+                </a:solidFill>
+                <a:latin typeface="JetBrains Mono"/>
+              </a:rPr>
+              <a:t>linkedin.com/in/yuvaraj-govindarajulu</a:t>
+            </a:r>
+          </a:p>
+        </p:txBody>
+      </p:sp>
+      <p:sp>
+        <p:nvSpPr>
+          <p:cNvPr id="12" name="TextBox 11"/>
+          <p:cNvSpPr txBox="1"/>
+          <p:nvPr/>
+        </p:nvSpPr>
+        <p:spPr>
+          <a:xfrm>
+            <a:off x="548640" y="6446520"/>
+            <a:ext cx="7315200" cy="274320"/>
+          </a:xfrm>
+          <a:prstGeom prst="rect">
+            <a:avLst/>
+          </a:prstGeom>
+          <a:noFill/>
+        </p:spPr>
+        <p:txBody>
+          <a:bodyPr wrap="square" lIns="0" tIns="0" rIns="0" bIns="0" anchor="t">
+            <a:spAutoFit/>
+          </a:bodyPr>
+          <a:lstStyle/>
+          <a:p>
+            <a:pPr algn="l"/>
+            <a:r>
+              <a:rPr sz="1000" b="0">
+                <a:solidFill>
+                  <a:srgbClr val="8888A0"/>
+                </a:solidFill>
+                <a:latin typeface="JetBrains Mono"/>
+              </a:rPr>
+              <a:t>BSides Aarhus 2026  ·  June 20  ·  INCUBA Next, Aarhus</a:t>
+            </a:r>
+          </a:p>
+        </p:txBody>
+      </p:sp>
+      <p:sp>
+        <p:nvSpPr>
+          <p:cNvPr id="13" name="TextBox 12"/>
+          <p:cNvSpPr txBox="1"/>
+          <p:nvPr/>
+        </p:nvSpPr>
+        <p:spPr>
+          <a:xfrm>
+            <a:off x="10515600" y="6446520"/>
+            <a:ext cx="1188720" cy="274320"/>
+          </a:xfrm>
+          <a:prstGeom prst="rect">
+            <a:avLst/>
+          </a:prstGeom>
+          <a:noFill/>
+        </p:spPr>
+        <p:txBody>
+          <a:bodyPr wrap="square" lIns="0" tIns="0" rIns="0" bIns="0" anchor="t">
+            <a:spAutoFit/>
+          </a:bodyPr>
+          <a:lstStyle/>
+          <a:p>
+            <a:pPr algn="r"/>
+            <a:r>
+              <a:rPr sz="1000" b="0">
+                <a:solidFill>
+                  <a:srgbClr val="8888A0"/>
+                </a:solidFill>
+                <a:latin typeface="JetBrains Mono"/>
+              </a:rPr>
+              <a:t>Speaker</a:t>
+            </a:r>
+          </a:p>
+        </p:txBody>
+      </p:sp>
+    </p:spTree>
+  </p:cSld>
+  <p:clrMapOvr>
+    <a:masterClrMapping/>
+  </p:clrMapOvr>
+</p:sld>
+</file>
+
 <file path=ppt/slides/slide2.xml><?xml version="1.0" encoding="utf-8"?>
 <p:sld xmlns:a="http://schemas.openxmlformats.org/drawingml/2006/main" xmlns:p="http://schemas.openxmlformats.org/presentationml/2006/main" xmlns:r="http://schemas.openxmlformats.org/officeDocument/2006/relationships">
   <p:cSld>
@@ -5628,6 +8670,1738 @@
         </p:spPr>
         <p:txBody>
           <a:bodyPr wrap="square" lIns="0" rIns="0" tIns="0" bIns="0" anchor="t">
+            <a:spAutoFit/>
+          </a:bodyPr>
+          <a:lstStyle/>
+          <a:p>
+            <a:pPr algn="r"/>
+            <a:r>
+              <a:rPr sz="1000" b="0">
+                <a:solidFill>
+                  <a:srgbClr val="8888A0"/>
+                </a:solidFill>
+                <a:latin typeface="JetBrains Mono"/>
+              </a:rPr>
+              <a:t>Speaker</a:t>
+            </a:r>
+          </a:p>
+        </p:txBody>
+      </p:sp>
+    </p:spTree>
+  </p:cSld>
+  <p:clrMapOvr>
+    <a:masterClrMapping/>
+  </p:clrMapOvr>
+</p:sld>
+</file>
+
+<file path=ppt/slides/slide6.xml><?xml version="1.0" encoding="utf-8"?>
+<p:sld xmlns:a="http://schemas.openxmlformats.org/drawingml/2006/main" xmlns:r="http://schemas.openxmlformats.org/officeDocument/2006/relationships" xmlns:p="http://schemas.openxmlformats.org/presentationml/2006/main">
+  <p:cSld>
+    <p:spTree>
+      <p:nvGrpSpPr>
+        <p:cNvPr id="1" name=""/>
+        <p:cNvGrpSpPr/>
+        <p:nvPr/>
+      </p:nvGrpSpPr>
+      <p:grpSpPr>
+        <a:xfrm>
+          <a:off x="0" y="0"/>
+          <a:ext cx="0" cy="0"/>
+          <a:chOff x="0" y="0"/>
+          <a:chExt cx="0" cy="0"/>
+        </a:xfrm>
+      </p:grpSpPr>
+      <p:pic>
+        <p:nvPicPr>
+          <p:cNvPr id="2" name="Picture 1" descr="_bg.png"/>
+          <p:cNvPicPr>
+            <a:picLocks noChangeAspect="1"/>
+          </p:cNvPicPr>
+          <p:nvPr/>
+        </p:nvPicPr>
+        <p:blipFill>
+          <a:blip r:embed="rId2"/>
+          <a:stretch>
+            <a:fillRect/>
+          </a:stretch>
+        </p:blipFill>
+        <p:spPr>
+          <a:xfrm>
+            <a:off x="0" y="0"/>
+            <a:ext cx="12191695" cy="6858000"/>
+          </a:xfrm>
+          <a:prstGeom prst="rect">
+            <a:avLst/>
+          </a:prstGeom>
+        </p:spPr>
+      </p:pic>
+      <p:pic>
+        <p:nvPicPr>
+          <p:cNvPr id="3" name="Picture 2" descr="logo.png"/>
+          <p:cNvPicPr>
+            <a:picLocks noChangeAspect="1"/>
+          </p:cNvPicPr>
+          <p:nvPr/>
+        </p:nvPicPr>
+        <p:blipFill>
+          <a:blip r:embed="rId3"/>
+          <a:stretch>
+            <a:fillRect/>
+          </a:stretch>
+        </p:blipFill>
+        <p:spPr>
+          <a:xfrm>
+            <a:off x="548640" y="457200"/>
+            <a:ext cx="617838" cy="457200"/>
+          </a:xfrm>
+          <a:prstGeom prst="rect">
+            <a:avLst/>
+          </a:prstGeom>
+        </p:spPr>
+      </p:pic>
+      <p:sp>
+        <p:nvSpPr>
+          <p:cNvPr id="4" name="Rounded Rectangle 3"/>
+          <p:cNvSpPr/>
+          <p:nvPr/>
+        </p:nvSpPr>
+        <p:spPr>
+          <a:xfrm>
+            <a:off x="548640" y="1463040"/>
+            <a:ext cx="3840480" cy="4389120"/>
+          </a:xfrm>
+          <a:prstGeom prst="roundRect">
+            <a:avLst>
+              <a:gd name="adj" fmla="val 4000"/>
+            </a:avLst>
+          </a:prstGeom>
+          <a:solidFill>
+            <a:srgbClr val="1A1A25"/>
+          </a:solidFill>
+          <a:ln>
+            <a:noFill/>
+          </a:ln>
+        </p:spPr>
+        <p:style>
+          <a:lnRef idx="1">
+            <a:schemeClr val="accent1"/>
+          </a:lnRef>
+          <a:fillRef idx="3">
+            <a:schemeClr val="accent1"/>
+          </a:fillRef>
+          <a:effectRef idx="2">
+            <a:schemeClr val="accent1"/>
+          </a:effectRef>
+          <a:fontRef idx="minor">
+            <a:schemeClr val="lt1"/>
+          </a:fontRef>
+        </p:style>
+        <p:txBody>
+          <a:bodyPr rtlCol="0" anchor="ctr"/>
+          <a:lstStyle/>
+          <a:p>
+            <a:pPr algn="ctr"/>
+            <a:endParaRPr/>
+          </a:p>
+        </p:txBody>
+      </p:sp>
+      <p:pic>
+        <p:nvPicPr>
+          <p:cNvPr id="100" name="SpeakerPhoto"/>
+          <p:cNvPicPr>
+            <a:picLocks noChangeAspect="1"/>
+          </p:cNvPicPr>
+          <p:nvPr/>
+        </p:nvPicPr>
+        <p:blipFill>
+          <a:blip r:embed="rId4"/>
+          <a:srcRect/>
+          <a:stretch>
+            <a:fillRect/>
+          </a:stretch>
+        </p:blipFill>
+        <p:spPr>
+          <a:xfrm>
+            <a:off x="914400" y="1645920"/>
+            <a:ext cx="3108960" cy="3108960"/>
+          </a:xfrm>
+          <a:prstGeom prst="roundRect">
+            <a:avLst>
+              <a:gd name="adj" fmla="val 4000"/>
+            </a:avLst>
+          </a:prstGeom>
+        </p:spPr>
+      </p:pic>
+      <p:sp>
+        <p:nvSpPr>
+          <p:cNvPr id="6" name="Rectangle 5"/>
+          <p:cNvSpPr/>
+          <p:nvPr/>
+        </p:nvSpPr>
+        <p:spPr>
+          <a:xfrm>
+            <a:off x="4754880" y="1371600"/>
+            <a:ext cx="640080" cy="38100"/>
+          </a:xfrm>
+          <a:prstGeom prst="rect">
+            <a:avLst/>
+          </a:prstGeom>
+          <a:solidFill>
+            <a:srgbClr val="4AB8D2"/>
+          </a:solidFill>
+          <a:ln>
+            <a:noFill/>
+          </a:ln>
+        </p:spPr>
+        <p:style>
+          <a:lnRef idx="1">
+            <a:schemeClr val="accent1"/>
+          </a:lnRef>
+          <a:fillRef idx="3">
+            <a:schemeClr val="accent1"/>
+          </a:fillRef>
+          <a:effectRef idx="2">
+            <a:schemeClr val="accent1"/>
+          </a:effectRef>
+          <a:fontRef idx="minor">
+            <a:schemeClr val="lt1"/>
+          </a:fontRef>
+        </p:style>
+        <p:txBody>
+          <a:bodyPr rtlCol="0" anchor="ctr"/>
+          <a:lstStyle/>
+          <a:p>
+            <a:pPr algn="ctr"/>
+            <a:endParaRPr/>
+          </a:p>
+        </p:txBody>
+      </p:sp>
+      <p:sp>
+        <p:nvSpPr>
+          <p:cNvPr id="7" name="TextBox 6"/>
+          <p:cNvSpPr txBox="1"/>
+          <p:nvPr/>
+        </p:nvSpPr>
+        <p:spPr>
+          <a:xfrm>
+            <a:off x="4754880" y="1508760"/>
+            <a:ext cx="6858000" cy="365760"/>
+          </a:xfrm>
+          <a:prstGeom prst="rect">
+            <a:avLst/>
+          </a:prstGeom>
+          <a:noFill/>
+        </p:spPr>
+        <p:txBody>
+          <a:bodyPr wrap="square" lIns="0" tIns="0" rIns="0" bIns="0" anchor="t">
+            <a:spAutoFit/>
+          </a:bodyPr>
+          <a:lstStyle/>
+          <a:p>
+            <a:pPr algn="l"/>
+            <a:r>
+              <a:rPr sz="1400" b="1">
+                <a:solidFill>
+                  <a:srgbClr val="4AB8D2"/>
+                </a:solidFill>
+                <a:latin typeface="JetBrains Mono"/>
+              </a:rPr>
+              <a:t>SPEAKER</a:t>
+            </a:r>
+          </a:p>
+        </p:txBody>
+      </p:sp>
+      <p:sp>
+        <p:nvSpPr>
+          <p:cNvPr id="8" name="TextBox 7"/>
+          <p:cNvSpPr txBox="1"/>
+          <p:nvPr/>
+        </p:nvSpPr>
+        <p:spPr>
+          <a:xfrm>
+            <a:off x="4754880" y="1920240"/>
+            <a:ext cx="6858000" cy="822960"/>
+          </a:xfrm>
+          <a:prstGeom prst="rect">
+            <a:avLst/>
+          </a:prstGeom>
+          <a:noFill/>
+        </p:spPr>
+        <p:txBody>
+          <a:bodyPr wrap="square" lIns="0" tIns="0" rIns="0" bIns="0" anchor="t">
+            <a:spAutoFit/>
+          </a:bodyPr>
+          <a:lstStyle/>
+          <a:p>
+            <a:pPr algn="l"/>
+            <a:r>
+              <a:rPr sz="4000" b="1">
+                <a:solidFill>
+                  <a:srgbClr val="E8E8ED"/>
+                </a:solidFill>
+                <a:latin typeface="Inter"/>
+              </a:rPr>
+              <a:t>Behnaz Karimi</a:t>
+            </a:r>
+          </a:p>
+        </p:txBody>
+      </p:sp>
+      <p:sp>
+        <p:nvSpPr>
+          <p:cNvPr id="9" name="TextBox 8"/>
+          <p:cNvSpPr txBox="1"/>
+          <p:nvPr/>
+        </p:nvSpPr>
+        <p:spPr>
+          <a:xfrm>
+            <a:off x="4754880" y="2788920"/>
+            <a:ext cx="6858000" cy="457200"/>
+          </a:xfrm>
+          <a:prstGeom prst="rect">
+            <a:avLst/>
+          </a:prstGeom>
+          <a:noFill/>
+        </p:spPr>
+        <p:txBody>
+          <a:bodyPr wrap="square" lIns="0" tIns="0" rIns="0" bIns="0" anchor="t">
+            <a:spAutoFit/>
+          </a:bodyPr>
+          <a:lstStyle/>
+          <a:p>
+            <a:pPr algn="l"/>
+            <a:r>
+              <a:rPr sz="2000" b="0">
+                <a:solidFill>
+                  <a:srgbClr val="6DD0E7"/>
+                </a:solidFill>
+                <a:latin typeface="Inter"/>
+              </a:rPr>
+              <a:t>Co-Lead / Leader AI Red Teaming OWASP AI Exchange and Founder RAID-AI Framework</a:t>
+            </a:r>
+          </a:p>
+        </p:txBody>
+      </p:sp>
+      <p:sp>
+        <p:nvSpPr>
+          <p:cNvPr id="10" name="TextBox 9"/>
+          <p:cNvSpPr txBox="1"/>
+          <p:nvPr/>
+        </p:nvSpPr>
+        <p:spPr>
+          <a:xfrm>
+            <a:off x="4754880" y="3474720"/>
+            <a:ext cx="6858000" cy="2103120"/>
+          </a:xfrm>
+          <a:prstGeom prst="rect">
+            <a:avLst/>
+          </a:prstGeom>
+          <a:noFill/>
+        </p:spPr>
+        <p:txBody>
+          <a:bodyPr wrap="square" lIns="0" tIns="0" rIns="0" bIns="0" anchor="t"/>
+          <a:lstStyle/>
+          <a:p>
+            <a:pPr algn="l"/>
+            <a:r>
+              <a:rPr sz="1600" b="0">
+                <a:solidFill>
+                  <a:srgbClr val="8888A0"/>
+                </a:solidFill>
+                <a:latin typeface="Inter"/>
+              </a:rPr>
+              <a:t>Behnaz is an AI Security Researcher and the Founder/Creator of the RAID-AI Framework. She is also Co-Author, Co-Lead, and Leader of AI Red Teaming at OWASP AI Exchange, where she actively contributes to advancing security practices for AI systems.</a:t>
+            </a:r>
+          </a:p>
+        </p:txBody>
+      </p:sp>
+      <p:sp>
+        <p:nvSpPr>
+          <p:cNvPr id="11" name="TextBox 10"/>
+          <p:cNvSpPr txBox="1"/>
+          <p:nvPr/>
+        </p:nvSpPr>
+        <p:spPr>
+          <a:xfrm>
+            <a:off x="4754880" y="5669280"/>
+            <a:ext cx="6858000" cy="365760"/>
+          </a:xfrm>
+          <a:prstGeom prst="rect">
+            <a:avLst/>
+          </a:prstGeom>
+          <a:noFill/>
+        </p:spPr>
+        <p:txBody>
+          <a:bodyPr wrap="square" lIns="0" tIns="0" rIns="0" bIns="0" anchor="t">
+            <a:spAutoFit/>
+          </a:bodyPr>
+          <a:lstStyle/>
+          <a:p>
+            <a:pPr algn="l"/>
+            <a:r>
+              <a:rPr sz="1400" b="0">
+                <a:solidFill>
+                  <a:srgbClr val="4AB8D2"/>
+                </a:solidFill>
+                <a:latin typeface="JetBrains Mono"/>
+              </a:rPr>
+              <a:t>linkedin.com/in/behnaz-karimi-behi  ·  substack.com/@behnazkarimi</a:t>
+            </a:r>
+          </a:p>
+        </p:txBody>
+      </p:sp>
+      <p:sp>
+        <p:nvSpPr>
+          <p:cNvPr id="12" name="TextBox 11"/>
+          <p:cNvSpPr txBox="1"/>
+          <p:nvPr/>
+        </p:nvSpPr>
+        <p:spPr>
+          <a:xfrm>
+            <a:off x="548640" y="6446520"/>
+            <a:ext cx="7315200" cy="274320"/>
+          </a:xfrm>
+          <a:prstGeom prst="rect">
+            <a:avLst/>
+          </a:prstGeom>
+          <a:noFill/>
+        </p:spPr>
+        <p:txBody>
+          <a:bodyPr wrap="square" lIns="0" tIns="0" rIns="0" bIns="0" anchor="t">
+            <a:spAutoFit/>
+          </a:bodyPr>
+          <a:lstStyle/>
+          <a:p>
+            <a:pPr algn="l"/>
+            <a:r>
+              <a:rPr sz="1000" b="0">
+                <a:solidFill>
+                  <a:srgbClr val="8888A0"/>
+                </a:solidFill>
+                <a:latin typeface="JetBrains Mono"/>
+              </a:rPr>
+              <a:t>BSides Aarhus 2026  ·  June 20  ·  INCUBA Next, Aarhus</a:t>
+            </a:r>
+          </a:p>
+        </p:txBody>
+      </p:sp>
+      <p:sp>
+        <p:nvSpPr>
+          <p:cNvPr id="13" name="TextBox 12"/>
+          <p:cNvSpPr txBox="1"/>
+          <p:nvPr/>
+        </p:nvSpPr>
+        <p:spPr>
+          <a:xfrm>
+            <a:off x="10515600" y="6446520"/>
+            <a:ext cx="1188720" cy="274320"/>
+          </a:xfrm>
+          <a:prstGeom prst="rect">
+            <a:avLst/>
+          </a:prstGeom>
+          <a:noFill/>
+        </p:spPr>
+        <p:txBody>
+          <a:bodyPr wrap="square" lIns="0" tIns="0" rIns="0" bIns="0" anchor="t">
+            <a:spAutoFit/>
+          </a:bodyPr>
+          <a:lstStyle/>
+          <a:p>
+            <a:pPr algn="r"/>
+            <a:r>
+              <a:rPr sz="1000" b="0">
+                <a:solidFill>
+                  <a:srgbClr val="8888A0"/>
+                </a:solidFill>
+                <a:latin typeface="JetBrains Mono"/>
+              </a:rPr>
+              <a:t>Speaker</a:t>
+            </a:r>
+          </a:p>
+        </p:txBody>
+      </p:sp>
+    </p:spTree>
+  </p:cSld>
+  <p:clrMapOvr>
+    <a:masterClrMapping/>
+  </p:clrMapOvr>
+</p:sld>
+</file>
+
+<file path=ppt/slides/slide7.xml><?xml version="1.0" encoding="utf-8"?>
+<p:sld xmlns:a="http://schemas.openxmlformats.org/drawingml/2006/main" xmlns:r="http://schemas.openxmlformats.org/officeDocument/2006/relationships" xmlns:p="http://schemas.openxmlformats.org/presentationml/2006/main">
+  <p:cSld>
+    <p:spTree>
+      <p:nvGrpSpPr>
+        <p:cNvPr id="1" name=""/>
+        <p:cNvGrpSpPr/>
+        <p:nvPr/>
+      </p:nvGrpSpPr>
+      <p:grpSpPr>
+        <a:xfrm>
+          <a:off x="0" y="0"/>
+          <a:ext cx="0" cy="0"/>
+          <a:chOff x="0" y="0"/>
+          <a:chExt cx="0" cy="0"/>
+        </a:xfrm>
+      </p:grpSpPr>
+      <p:pic>
+        <p:nvPicPr>
+          <p:cNvPr id="2" name="Picture 1" descr="_bg.png"/>
+          <p:cNvPicPr>
+            <a:picLocks noChangeAspect="1"/>
+          </p:cNvPicPr>
+          <p:nvPr/>
+        </p:nvPicPr>
+        <p:blipFill>
+          <a:blip r:embed="rId2"/>
+          <a:stretch>
+            <a:fillRect/>
+          </a:stretch>
+        </p:blipFill>
+        <p:spPr>
+          <a:xfrm>
+            <a:off x="0" y="0"/>
+            <a:ext cx="12191695" cy="6858000"/>
+          </a:xfrm>
+          <a:prstGeom prst="rect">
+            <a:avLst/>
+          </a:prstGeom>
+        </p:spPr>
+      </p:pic>
+      <p:pic>
+        <p:nvPicPr>
+          <p:cNvPr id="3" name="Picture 2" descr="logo.png"/>
+          <p:cNvPicPr>
+            <a:picLocks noChangeAspect="1"/>
+          </p:cNvPicPr>
+          <p:nvPr/>
+        </p:nvPicPr>
+        <p:blipFill>
+          <a:blip r:embed="rId3"/>
+          <a:stretch>
+            <a:fillRect/>
+          </a:stretch>
+        </p:blipFill>
+        <p:spPr>
+          <a:xfrm>
+            <a:off x="548640" y="457200"/>
+            <a:ext cx="617838" cy="457200"/>
+          </a:xfrm>
+          <a:prstGeom prst="rect">
+            <a:avLst/>
+          </a:prstGeom>
+        </p:spPr>
+      </p:pic>
+      <p:sp>
+        <p:nvSpPr>
+          <p:cNvPr id="4" name="Rounded Rectangle 3"/>
+          <p:cNvSpPr/>
+          <p:nvPr/>
+        </p:nvSpPr>
+        <p:spPr>
+          <a:xfrm>
+            <a:off x="548640" y="1463040"/>
+            <a:ext cx="3840480" cy="4389120"/>
+          </a:xfrm>
+          <a:prstGeom prst="roundRect">
+            <a:avLst>
+              <a:gd name="adj" fmla="val 4000"/>
+            </a:avLst>
+          </a:prstGeom>
+          <a:solidFill>
+            <a:srgbClr val="1A1A25"/>
+          </a:solidFill>
+          <a:ln>
+            <a:noFill/>
+          </a:ln>
+        </p:spPr>
+        <p:style>
+          <a:lnRef idx="1">
+            <a:schemeClr val="accent1"/>
+          </a:lnRef>
+          <a:fillRef idx="3">
+            <a:schemeClr val="accent1"/>
+          </a:fillRef>
+          <a:effectRef idx="2">
+            <a:schemeClr val="accent1"/>
+          </a:effectRef>
+          <a:fontRef idx="minor">
+            <a:schemeClr val="lt1"/>
+          </a:fontRef>
+        </p:style>
+        <p:txBody>
+          <a:bodyPr rtlCol="0" anchor="ctr"/>
+          <a:lstStyle/>
+          <a:p>
+            <a:pPr algn="ctr"/>
+            <a:endParaRPr/>
+          </a:p>
+        </p:txBody>
+      </p:sp>
+      <p:pic>
+        <p:nvPicPr>
+          <p:cNvPr id="100" name="SpeakerPhoto"/>
+          <p:cNvPicPr>
+            <a:picLocks noChangeAspect="1"/>
+          </p:cNvPicPr>
+          <p:nvPr/>
+        </p:nvPicPr>
+        <p:blipFill>
+          <a:blip r:embed="rId4"/>
+          <a:srcRect/>
+          <a:stretch>
+            <a:fillRect/>
+          </a:stretch>
+        </p:blipFill>
+        <p:spPr>
+          <a:xfrm>
+            <a:off x="914400" y="1645920"/>
+            <a:ext cx="3108960" cy="3108960"/>
+          </a:xfrm>
+          <a:prstGeom prst="roundRect">
+            <a:avLst>
+              <a:gd name="adj" fmla="val 4000"/>
+            </a:avLst>
+          </a:prstGeom>
+        </p:spPr>
+      </p:pic>
+      <p:sp>
+        <p:nvSpPr>
+          <p:cNvPr id="6" name="Rectangle 5"/>
+          <p:cNvSpPr/>
+          <p:nvPr/>
+        </p:nvSpPr>
+        <p:spPr>
+          <a:xfrm>
+            <a:off x="4754880" y="1371600"/>
+            <a:ext cx="640080" cy="38100"/>
+          </a:xfrm>
+          <a:prstGeom prst="rect">
+            <a:avLst/>
+          </a:prstGeom>
+          <a:solidFill>
+            <a:srgbClr val="4AB8D2"/>
+          </a:solidFill>
+          <a:ln>
+            <a:noFill/>
+          </a:ln>
+        </p:spPr>
+        <p:style>
+          <a:lnRef idx="1">
+            <a:schemeClr val="accent1"/>
+          </a:lnRef>
+          <a:fillRef idx="3">
+            <a:schemeClr val="accent1"/>
+          </a:fillRef>
+          <a:effectRef idx="2">
+            <a:schemeClr val="accent1"/>
+          </a:effectRef>
+          <a:fontRef idx="minor">
+            <a:schemeClr val="lt1"/>
+          </a:fontRef>
+        </p:style>
+        <p:txBody>
+          <a:bodyPr rtlCol="0" anchor="ctr"/>
+          <a:lstStyle/>
+          <a:p>
+            <a:pPr algn="ctr"/>
+            <a:endParaRPr/>
+          </a:p>
+        </p:txBody>
+      </p:sp>
+      <p:sp>
+        <p:nvSpPr>
+          <p:cNvPr id="7" name="TextBox 6"/>
+          <p:cNvSpPr txBox="1"/>
+          <p:nvPr/>
+        </p:nvSpPr>
+        <p:spPr>
+          <a:xfrm>
+            <a:off x="4754880" y="1508760"/>
+            <a:ext cx="6858000" cy="365760"/>
+          </a:xfrm>
+          <a:prstGeom prst="rect">
+            <a:avLst/>
+          </a:prstGeom>
+          <a:noFill/>
+        </p:spPr>
+        <p:txBody>
+          <a:bodyPr wrap="square" lIns="0" tIns="0" rIns="0" bIns="0" anchor="t">
+            <a:spAutoFit/>
+          </a:bodyPr>
+          <a:lstStyle/>
+          <a:p>
+            <a:pPr algn="l"/>
+            <a:r>
+              <a:rPr sz="1400" b="1">
+                <a:solidFill>
+                  <a:srgbClr val="4AB8D2"/>
+                </a:solidFill>
+                <a:latin typeface="JetBrains Mono"/>
+              </a:rPr>
+              <a:t>SPEAKER</a:t>
+            </a:r>
+          </a:p>
+        </p:txBody>
+      </p:sp>
+      <p:sp>
+        <p:nvSpPr>
+          <p:cNvPr id="8" name="TextBox 7"/>
+          <p:cNvSpPr txBox="1"/>
+          <p:nvPr/>
+        </p:nvSpPr>
+        <p:spPr>
+          <a:xfrm>
+            <a:off x="4754880" y="1920240"/>
+            <a:ext cx="6858000" cy="822960"/>
+          </a:xfrm>
+          <a:prstGeom prst="rect">
+            <a:avLst/>
+          </a:prstGeom>
+          <a:noFill/>
+        </p:spPr>
+        <p:txBody>
+          <a:bodyPr wrap="square" lIns="0" tIns="0" rIns="0" bIns="0" anchor="t">
+            <a:spAutoFit/>
+          </a:bodyPr>
+          <a:lstStyle/>
+          <a:p>
+            <a:pPr algn="l"/>
+            <a:r>
+              <a:rPr sz="4000" b="1">
+                <a:solidFill>
+                  <a:srgbClr val="E8E8ED"/>
+                </a:solidFill>
+                <a:latin typeface="Inter"/>
+              </a:rPr>
+              <a:t>Bence Soóki-Tóth</a:t>
+            </a:r>
+          </a:p>
+        </p:txBody>
+      </p:sp>
+      <p:sp>
+        <p:nvSpPr>
+          <p:cNvPr id="9" name="TextBox 8"/>
+          <p:cNvSpPr txBox="1"/>
+          <p:nvPr/>
+        </p:nvSpPr>
+        <p:spPr>
+          <a:xfrm>
+            <a:off x="4754880" y="2788920"/>
+            <a:ext cx="6858000" cy="457200"/>
+          </a:xfrm>
+          <a:prstGeom prst="rect">
+            <a:avLst/>
+          </a:prstGeom>
+          <a:noFill/>
+        </p:spPr>
+        <p:txBody>
+          <a:bodyPr wrap="square" lIns="0" tIns="0" rIns="0" bIns="0" anchor="t">
+            <a:spAutoFit/>
+          </a:bodyPr>
+          <a:lstStyle/>
+          <a:p>
+            <a:pPr algn="l"/>
+            <a:r>
+              <a:rPr sz="2000" b="0">
+                <a:solidFill>
+                  <a:srgbClr val="6DD0E7"/>
+                </a:solidFill>
+                <a:latin typeface="Inter"/>
+              </a:rPr>
+              <a:t>Aarhus University, Master's Student</a:t>
+            </a:r>
+          </a:p>
+        </p:txBody>
+      </p:sp>
+      <p:sp>
+        <p:nvSpPr>
+          <p:cNvPr id="10" name="TextBox 9"/>
+          <p:cNvSpPr txBox="1"/>
+          <p:nvPr/>
+        </p:nvSpPr>
+        <p:spPr>
+          <a:xfrm>
+            <a:off x="4754880" y="3474720"/>
+            <a:ext cx="6858000" cy="2103120"/>
+          </a:xfrm>
+          <a:prstGeom prst="rect">
+            <a:avLst/>
+          </a:prstGeom>
+          <a:noFill/>
+        </p:spPr>
+        <p:txBody>
+          <a:bodyPr wrap="square" lIns="0" tIns="0" rIns="0" bIns="0" anchor="t"/>
+          <a:lstStyle/>
+          <a:p>
+            <a:pPr algn="l"/>
+            <a:r>
+              <a:rPr sz="1600" b="0">
+                <a:solidFill>
+                  <a:srgbClr val="8888A0"/>
+                </a:solidFill>
+                <a:latin typeface="Inter"/>
+              </a:rPr>
+              <a:t>Bence is a Master's student at Aarhus University and a research assistant at Eötvös Loránd University, working at the intersection of cryptography, game theory, and consensus protocols.</a:t>
+            </a:r>
+          </a:p>
+        </p:txBody>
+      </p:sp>
+      <p:sp>
+        <p:nvSpPr>
+          <p:cNvPr id="11" name="TextBox 10"/>
+          <p:cNvSpPr txBox="1"/>
+          <p:nvPr/>
+        </p:nvSpPr>
+        <p:spPr>
+          <a:xfrm>
+            <a:off x="4754880" y="5669280"/>
+            <a:ext cx="6858000" cy="365760"/>
+          </a:xfrm>
+          <a:prstGeom prst="rect">
+            <a:avLst/>
+          </a:prstGeom>
+          <a:noFill/>
+        </p:spPr>
+        <p:txBody>
+          <a:bodyPr wrap="square" lIns="0" tIns="0" rIns="0" bIns="0" anchor="t">
+            <a:spAutoFit/>
+          </a:bodyPr>
+          <a:lstStyle/>
+          <a:p>
+            <a:pPr algn="l"/>
+            <a:r>
+              <a:rPr sz="1400" b="0">
+                <a:solidFill>
+                  <a:srgbClr val="4AB8D2"/>
+                </a:solidFill>
+                <a:latin typeface="JetBrains Mono"/>
+              </a:rPr>
+              <a:t>linkedin.com/in/stbence  ·  0xsooki.github.io</a:t>
+            </a:r>
+          </a:p>
+        </p:txBody>
+      </p:sp>
+      <p:sp>
+        <p:nvSpPr>
+          <p:cNvPr id="12" name="TextBox 11"/>
+          <p:cNvSpPr txBox="1"/>
+          <p:nvPr/>
+        </p:nvSpPr>
+        <p:spPr>
+          <a:xfrm>
+            <a:off x="548640" y="6446520"/>
+            <a:ext cx="7315200" cy="274320"/>
+          </a:xfrm>
+          <a:prstGeom prst="rect">
+            <a:avLst/>
+          </a:prstGeom>
+          <a:noFill/>
+        </p:spPr>
+        <p:txBody>
+          <a:bodyPr wrap="square" lIns="0" tIns="0" rIns="0" bIns="0" anchor="t">
+            <a:spAutoFit/>
+          </a:bodyPr>
+          <a:lstStyle/>
+          <a:p>
+            <a:pPr algn="l"/>
+            <a:r>
+              <a:rPr sz="1000" b="0">
+                <a:solidFill>
+                  <a:srgbClr val="8888A0"/>
+                </a:solidFill>
+                <a:latin typeface="JetBrains Mono"/>
+              </a:rPr>
+              <a:t>BSides Aarhus 2026  ·  June 20  ·  INCUBA Next, Aarhus</a:t>
+            </a:r>
+          </a:p>
+        </p:txBody>
+      </p:sp>
+      <p:sp>
+        <p:nvSpPr>
+          <p:cNvPr id="13" name="TextBox 12"/>
+          <p:cNvSpPr txBox="1"/>
+          <p:nvPr/>
+        </p:nvSpPr>
+        <p:spPr>
+          <a:xfrm>
+            <a:off x="10515600" y="6446520"/>
+            <a:ext cx="1188720" cy="274320"/>
+          </a:xfrm>
+          <a:prstGeom prst="rect">
+            <a:avLst/>
+          </a:prstGeom>
+          <a:noFill/>
+        </p:spPr>
+        <p:txBody>
+          <a:bodyPr wrap="square" lIns="0" tIns="0" rIns="0" bIns="0" anchor="t">
+            <a:spAutoFit/>
+          </a:bodyPr>
+          <a:lstStyle/>
+          <a:p>
+            <a:pPr algn="r"/>
+            <a:r>
+              <a:rPr sz="1000" b="0">
+                <a:solidFill>
+                  <a:srgbClr val="8888A0"/>
+                </a:solidFill>
+                <a:latin typeface="JetBrains Mono"/>
+              </a:rPr>
+              <a:t>Speaker</a:t>
+            </a:r>
+          </a:p>
+        </p:txBody>
+      </p:sp>
+    </p:spTree>
+  </p:cSld>
+  <p:clrMapOvr>
+    <a:masterClrMapping/>
+  </p:clrMapOvr>
+</p:sld>
+</file>
+
+<file path=ppt/slides/slide8.xml><?xml version="1.0" encoding="utf-8"?>
+<p:sld xmlns:a="http://schemas.openxmlformats.org/drawingml/2006/main" xmlns:r="http://schemas.openxmlformats.org/officeDocument/2006/relationships" xmlns:p="http://schemas.openxmlformats.org/presentationml/2006/main">
+  <p:cSld>
+    <p:spTree>
+      <p:nvGrpSpPr>
+        <p:cNvPr id="1" name=""/>
+        <p:cNvGrpSpPr/>
+        <p:nvPr/>
+      </p:nvGrpSpPr>
+      <p:grpSpPr>
+        <a:xfrm>
+          <a:off x="0" y="0"/>
+          <a:ext cx="0" cy="0"/>
+          <a:chOff x="0" y="0"/>
+          <a:chExt cx="0" cy="0"/>
+        </a:xfrm>
+      </p:grpSpPr>
+      <p:pic>
+        <p:nvPicPr>
+          <p:cNvPr id="2" name="Picture 1" descr="_bg.png"/>
+          <p:cNvPicPr>
+            <a:picLocks noChangeAspect="1"/>
+          </p:cNvPicPr>
+          <p:nvPr/>
+        </p:nvPicPr>
+        <p:blipFill>
+          <a:blip r:embed="rId2"/>
+          <a:stretch>
+            <a:fillRect/>
+          </a:stretch>
+        </p:blipFill>
+        <p:spPr>
+          <a:xfrm>
+            <a:off x="0" y="0"/>
+            <a:ext cx="12191695" cy="6858000"/>
+          </a:xfrm>
+          <a:prstGeom prst="rect">
+            <a:avLst/>
+          </a:prstGeom>
+        </p:spPr>
+      </p:pic>
+      <p:pic>
+        <p:nvPicPr>
+          <p:cNvPr id="3" name="Picture 2" descr="logo.png"/>
+          <p:cNvPicPr>
+            <a:picLocks noChangeAspect="1"/>
+          </p:cNvPicPr>
+          <p:nvPr/>
+        </p:nvPicPr>
+        <p:blipFill>
+          <a:blip r:embed="rId3"/>
+          <a:stretch>
+            <a:fillRect/>
+          </a:stretch>
+        </p:blipFill>
+        <p:spPr>
+          <a:xfrm>
+            <a:off x="548640" y="457200"/>
+            <a:ext cx="617838" cy="457200"/>
+          </a:xfrm>
+          <a:prstGeom prst="rect">
+            <a:avLst/>
+          </a:prstGeom>
+        </p:spPr>
+      </p:pic>
+      <p:sp>
+        <p:nvSpPr>
+          <p:cNvPr id="4" name="Rounded Rectangle 3"/>
+          <p:cNvSpPr/>
+          <p:nvPr/>
+        </p:nvSpPr>
+        <p:spPr>
+          <a:xfrm>
+            <a:off x="548640" y="1463040"/>
+            <a:ext cx="3840480" cy="4389120"/>
+          </a:xfrm>
+          <a:prstGeom prst="roundRect">
+            <a:avLst>
+              <a:gd name="adj" fmla="val 4000"/>
+            </a:avLst>
+          </a:prstGeom>
+          <a:solidFill>
+            <a:srgbClr val="1A1A25"/>
+          </a:solidFill>
+          <a:ln>
+            <a:noFill/>
+          </a:ln>
+        </p:spPr>
+        <p:style>
+          <a:lnRef idx="1">
+            <a:schemeClr val="accent1"/>
+          </a:lnRef>
+          <a:fillRef idx="3">
+            <a:schemeClr val="accent1"/>
+          </a:fillRef>
+          <a:effectRef idx="2">
+            <a:schemeClr val="accent1"/>
+          </a:effectRef>
+          <a:fontRef idx="minor">
+            <a:schemeClr val="lt1"/>
+          </a:fontRef>
+        </p:style>
+        <p:txBody>
+          <a:bodyPr rtlCol="0" anchor="ctr"/>
+          <a:lstStyle/>
+          <a:p>
+            <a:pPr algn="ctr"/>
+            <a:endParaRPr/>
+          </a:p>
+        </p:txBody>
+      </p:sp>
+      <p:pic>
+        <p:nvPicPr>
+          <p:cNvPr id="100" name="SpeakerPhoto"/>
+          <p:cNvPicPr>
+            <a:picLocks noChangeAspect="1"/>
+          </p:cNvPicPr>
+          <p:nvPr/>
+        </p:nvPicPr>
+        <p:blipFill>
+          <a:blip r:embed="rId4"/>
+          <a:srcRect/>
+          <a:stretch>
+            <a:fillRect/>
+          </a:stretch>
+        </p:blipFill>
+        <p:spPr>
+          <a:xfrm>
+            <a:off x="914400" y="1645920"/>
+            <a:ext cx="3108960" cy="3108960"/>
+          </a:xfrm>
+          <a:prstGeom prst="roundRect">
+            <a:avLst>
+              <a:gd name="adj" fmla="val 4000"/>
+            </a:avLst>
+          </a:prstGeom>
+        </p:spPr>
+      </p:pic>
+      <p:sp>
+        <p:nvSpPr>
+          <p:cNvPr id="6" name="Rectangle 5"/>
+          <p:cNvSpPr/>
+          <p:nvPr/>
+        </p:nvSpPr>
+        <p:spPr>
+          <a:xfrm>
+            <a:off x="4754880" y="1371600"/>
+            <a:ext cx="640080" cy="38100"/>
+          </a:xfrm>
+          <a:prstGeom prst="rect">
+            <a:avLst/>
+          </a:prstGeom>
+          <a:solidFill>
+            <a:srgbClr val="4AB8D2"/>
+          </a:solidFill>
+          <a:ln>
+            <a:noFill/>
+          </a:ln>
+        </p:spPr>
+        <p:style>
+          <a:lnRef idx="1">
+            <a:schemeClr val="accent1"/>
+          </a:lnRef>
+          <a:fillRef idx="3">
+            <a:schemeClr val="accent1"/>
+          </a:fillRef>
+          <a:effectRef idx="2">
+            <a:schemeClr val="accent1"/>
+          </a:effectRef>
+          <a:fontRef idx="minor">
+            <a:schemeClr val="lt1"/>
+          </a:fontRef>
+        </p:style>
+        <p:txBody>
+          <a:bodyPr rtlCol="0" anchor="ctr"/>
+          <a:lstStyle/>
+          <a:p>
+            <a:pPr algn="ctr"/>
+            <a:endParaRPr/>
+          </a:p>
+        </p:txBody>
+      </p:sp>
+      <p:sp>
+        <p:nvSpPr>
+          <p:cNvPr id="7" name="TextBox 6"/>
+          <p:cNvSpPr txBox="1"/>
+          <p:nvPr/>
+        </p:nvSpPr>
+        <p:spPr>
+          <a:xfrm>
+            <a:off x="4754880" y="1508760"/>
+            <a:ext cx="6858000" cy="365760"/>
+          </a:xfrm>
+          <a:prstGeom prst="rect">
+            <a:avLst/>
+          </a:prstGeom>
+          <a:noFill/>
+        </p:spPr>
+        <p:txBody>
+          <a:bodyPr wrap="square" lIns="0" tIns="0" rIns="0" bIns="0" anchor="t">
+            <a:spAutoFit/>
+          </a:bodyPr>
+          <a:lstStyle/>
+          <a:p>
+            <a:pPr algn="l"/>
+            <a:r>
+              <a:rPr sz="1400" b="1">
+                <a:solidFill>
+                  <a:srgbClr val="4AB8D2"/>
+                </a:solidFill>
+                <a:latin typeface="JetBrains Mono"/>
+              </a:rPr>
+              <a:t>SPEAKER</a:t>
+            </a:r>
+          </a:p>
+        </p:txBody>
+      </p:sp>
+      <p:sp>
+        <p:nvSpPr>
+          <p:cNvPr id="8" name="TextBox 7"/>
+          <p:cNvSpPr txBox="1"/>
+          <p:nvPr/>
+        </p:nvSpPr>
+        <p:spPr>
+          <a:xfrm>
+            <a:off x="4754880" y="1920240"/>
+            <a:ext cx="6858000" cy="822960"/>
+          </a:xfrm>
+          <a:prstGeom prst="rect">
+            <a:avLst/>
+          </a:prstGeom>
+          <a:noFill/>
+        </p:spPr>
+        <p:txBody>
+          <a:bodyPr wrap="square" lIns="0" tIns="0" rIns="0" bIns="0" anchor="t">
+            <a:spAutoFit/>
+          </a:bodyPr>
+          <a:lstStyle/>
+          <a:p>
+            <a:pPr algn="l"/>
+            <a:r>
+              <a:rPr sz="4000" b="1">
+                <a:solidFill>
+                  <a:srgbClr val="E8E8ED"/>
+                </a:solidFill>
+                <a:latin typeface="Inter"/>
+              </a:rPr>
+              <a:t>Bleon Proko</a:t>
+            </a:r>
+          </a:p>
+        </p:txBody>
+      </p:sp>
+      <p:sp>
+        <p:nvSpPr>
+          <p:cNvPr id="9" name="TextBox 8"/>
+          <p:cNvSpPr txBox="1"/>
+          <p:nvPr/>
+        </p:nvSpPr>
+        <p:spPr>
+          <a:xfrm>
+            <a:off x="4754880" y="2788920"/>
+            <a:ext cx="6858000" cy="457200"/>
+          </a:xfrm>
+          <a:prstGeom prst="rect">
+            <a:avLst/>
+          </a:prstGeom>
+          <a:noFill/>
+        </p:spPr>
+        <p:txBody>
+          <a:bodyPr wrap="square" lIns="0" tIns="0" rIns="0" bIns="0" anchor="t">
+            <a:spAutoFit/>
+          </a:bodyPr>
+          <a:lstStyle/>
+          <a:p>
+            <a:pPr algn="l"/>
+            <a:r>
+              <a:rPr sz="2000" b="0">
+                <a:solidFill>
+                  <a:srgbClr val="6DD0E7"/>
+                </a:solidFill>
+                <a:latin typeface="Inter"/>
+              </a:rPr>
+              <a:t>Cloud Security Researcher</a:t>
+            </a:r>
+          </a:p>
+        </p:txBody>
+      </p:sp>
+      <p:sp>
+        <p:nvSpPr>
+          <p:cNvPr id="10" name="TextBox 9"/>
+          <p:cNvSpPr txBox="1"/>
+          <p:nvPr/>
+        </p:nvSpPr>
+        <p:spPr>
+          <a:xfrm>
+            <a:off x="4754880" y="3474720"/>
+            <a:ext cx="6858000" cy="2103120"/>
+          </a:xfrm>
+          <a:prstGeom prst="rect">
+            <a:avLst/>
+          </a:prstGeom>
+          <a:noFill/>
+        </p:spPr>
+        <p:txBody>
+          <a:bodyPr wrap="square" lIns="0" tIns="0" rIns="0" bIns="0" anchor="t"/>
+          <a:lstStyle/>
+          <a:p>
+            <a:pPr algn="l"/>
+            <a:r>
+              <a:rPr sz="1600" b="0">
+                <a:solidFill>
+                  <a:srgbClr val="8888A0"/>
+                </a:solidFill>
+                <a:latin typeface="Inter"/>
+              </a:rPr>
+              <a:t>Bleon is a Senior Security Researcher at Exaforce, passionate about Infrastructure Penetration Testing and Security across Active Directory, Cloud (AWS, Azure, GCP, Digital Ocean) and hybrid infrastructures, as well as defense, detection, and threat hunting. He has presented Cloud Penetration Testing and Security topics at conferences including Black Hat USA, Europe and Sector, DEF CON, SANS Pentest Hackfest Hollywood and Amsterdam, and several BSides events in the US and Europe.</a:t>
+            </a:r>
+          </a:p>
+        </p:txBody>
+      </p:sp>
+      <p:sp>
+        <p:nvSpPr>
+          <p:cNvPr id="11" name="TextBox 10"/>
+          <p:cNvSpPr txBox="1"/>
+          <p:nvPr/>
+        </p:nvSpPr>
+        <p:spPr>
+          <a:xfrm>
+            <a:off x="4754880" y="5669280"/>
+            <a:ext cx="6858000" cy="365760"/>
+          </a:xfrm>
+          <a:prstGeom prst="rect">
+            <a:avLst/>
+          </a:prstGeom>
+          <a:noFill/>
+        </p:spPr>
+        <p:txBody>
+          <a:bodyPr wrap="square" lIns="0" tIns="0" rIns="0" bIns="0" anchor="t">
+            <a:spAutoFit/>
+          </a:bodyPr>
+          <a:lstStyle/>
+          <a:p>
+            <a:pPr algn="l"/>
+            <a:r>
+              <a:rPr sz="1400" b="0">
+                <a:solidFill>
+                  <a:srgbClr val="4AB8D2"/>
+                </a:solidFill>
+                <a:latin typeface="JetBrains Mono"/>
+              </a:rPr>
+              <a:t>linkedin.com/in/bleon-p-9b2734143  ·  blog.pepperclipp.com</a:t>
+            </a:r>
+          </a:p>
+        </p:txBody>
+      </p:sp>
+      <p:sp>
+        <p:nvSpPr>
+          <p:cNvPr id="12" name="TextBox 11"/>
+          <p:cNvSpPr txBox="1"/>
+          <p:nvPr/>
+        </p:nvSpPr>
+        <p:spPr>
+          <a:xfrm>
+            <a:off x="548640" y="6446520"/>
+            <a:ext cx="7315200" cy="274320"/>
+          </a:xfrm>
+          <a:prstGeom prst="rect">
+            <a:avLst/>
+          </a:prstGeom>
+          <a:noFill/>
+        </p:spPr>
+        <p:txBody>
+          <a:bodyPr wrap="square" lIns="0" tIns="0" rIns="0" bIns="0" anchor="t">
+            <a:spAutoFit/>
+          </a:bodyPr>
+          <a:lstStyle/>
+          <a:p>
+            <a:pPr algn="l"/>
+            <a:r>
+              <a:rPr sz="1000" b="0">
+                <a:solidFill>
+                  <a:srgbClr val="8888A0"/>
+                </a:solidFill>
+                <a:latin typeface="JetBrains Mono"/>
+              </a:rPr>
+              <a:t>BSides Aarhus 2026  ·  June 20  ·  INCUBA Next, Aarhus</a:t>
+            </a:r>
+          </a:p>
+        </p:txBody>
+      </p:sp>
+      <p:sp>
+        <p:nvSpPr>
+          <p:cNvPr id="13" name="TextBox 12"/>
+          <p:cNvSpPr txBox="1"/>
+          <p:nvPr/>
+        </p:nvSpPr>
+        <p:spPr>
+          <a:xfrm>
+            <a:off x="10515600" y="6446520"/>
+            <a:ext cx="1188720" cy="274320"/>
+          </a:xfrm>
+          <a:prstGeom prst="rect">
+            <a:avLst/>
+          </a:prstGeom>
+          <a:noFill/>
+        </p:spPr>
+        <p:txBody>
+          <a:bodyPr wrap="square" lIns="0" tIns="0" rIns="0" bIns="0" anchor="t">
+            <a:spAutoFit/>
+          </a:bodyPr>
+          <a:lstStyle/>
+          <a:p>
+            <a:pPr algn="r"/>
+            <a:r>
+              <a:rPr sz="1000" b="0">
+                <a:solidFill>
+                  <a:srgbClr val="8888A0"/>
+                </a:solidFill>
+                <a:latin typeface="JetBrains Mono"/>
+              </a:rPr>
+              <a:t>Speaker</a:t>
+            </a:r>
+          </a:p>
+        </p:txBody>
+      </p:sp>
+    </p:spTree>
+  </p:cSld>
+  <p:clrMapOvr>
+    <a:masterClrMapping/>
+  </p:clrMapOvr>
+</p:sld>
+</file>
+
+<file path=ppt/slides/slide9.xml><?xml version="1.0" encoding="utf-8"?>
+<p:sld xmlns:a="http://schemas.openxmlformats.org/drawingml/2006/main" xmlns:r="http://schemas.openxmlformats.org/officeDocument/2006/relationships" xmlns:p="http://schemas.openxmlformats.org/presentationml/2006/main">
+  <p:cSld>
+    <p:spTree>
+      <p:nvGrpSpPr>
+        <p:cNvPr id="1" name=""/>
+        <p:cNvGrpSpPr/>
+        <p:nvPr/>
+      </p:nvGrpSpPr>
+      <p:grpSpPr>
+        <a:xfrm>
+          <a:off x="0" y="0"/>
+          <a:ext cx="0" cy="0"/>
+          <a:chOff x="0" y="0"/>
+          <a:chExt cx="0" cy="0"/>
+        </a:xfrm>
+      </p:grpSpPr>
+      <p:pic>
+        <p:nvPicPr>
+          <p:cNvPr id="2" name="Picture 1" descr="_bg.png"/>
+          <p:cNvPicPr>
+            <a:picLocks noChangeAspect="1"/>
+          </p:cNvPicPr>
+          <p:nvPr/>
+        </p:nvPicPr>
+        <p:blipFill>
+          <a:blip r:embed="rId2"/>
+          <a:stretch>
+            <a:fillRect/>
+          </a:stretch>
+        </p:blipFill>
+        <p:spPr>
+          <a:xfrm>
+            <a:off x="0" y="0"/>
+            <a:ext cx="12191695" cy="6858000"/>
+          </a:xfrm>
+          <a:prstGeom prst="rect">
+            <a:avLst/>
+          </a:prstGeom>
+        </p:spPr>
+      </p:pic>
+      <p:pic>
+        <p:nvPicPr>
+          <p:cNvPr id="3" name="Picture 2" descr="logo.png"/>
+          <p:cNvPicPr>
+            <a:picLocks noChangeAspect="1"/>
+          </p:cNvPicPr>
+          <p:nvPr/>
+        </p:nvPicPr>
+        <p:blipFill>
+          <a:blip r:embed="rId3"/>
+          <a:stretch>
+            <a:fillRect/>
+          </a:stretch>
+        </p:blipFill>
+        <p:spPr>
+          <a:xfrm>
+            <a:off x="548640" y="457200"/>
+            <a:ext cx="617838" cy="457200"/>
+          </a:xfrm>
+          <a:prstGeom prst="rect">
+            <a:avLst/>
+          </a:prstGeom>
+        </p:spPr>
+      </p:pic>
+      <p:sp>
+        <p:nvSpPr>
+          <p:cNvPr id="4" name="Rounded Rectangle 3"/>
+          <p:cNvSpPr/>
+          <p:nvPr/>
+        </p:nvSpPr>
+        <p:spPr>
+          <a:xfrm>
+            <a:off x="548640" y="1463040"/>
+            <a:ext cx="3840480" cy="4389120"/>
+          </a:xfrm>
+          <a:prstGeom prst="roundRect">
+            <a:avLst>
+              <a:gd name="adj" fmla="val 4000"/>
+            </a:avLst>
+          </a:prstGeom>
+          <a:solidFill>
+            <a:srgbClr val="1A1A25"/>
+          </a:solidFill>
+          <a:ln>
+            <a:noFill/>
+          </a:ln>
+        </p:spPr>
+        <p:style>
+          <a:lnRef idx="1">
+            <a:schemeClr val="accent1"/>
+          </a:lnRef>
+          <a:fillRef idx="3">
+            <a:schemeClr val="accent1"/>
+          </a:fillRef>
+          <a:effectRef idx="2">
+            <a:schemeClr val="accent1"/>
+          </a:effectRef>
+          <a:fontRef idx="minor">
+            <a:schemeClr val="lt1"/>
+          </a:fontRef>
+        </p:style>
+        <p:txBody>
+          <a:bodyPr rtlCol="0" anchor="ctr"/>
+          <a:lstStyle/>
+          <a:p>
+            <a:pPr algn="ctr"/>
+            <a:endParaRPr/>
+          </a:p>
+        </p:txBody>
+      </p:sp>
+      <p:pic>
+        <p:nvPicPr>
+          <p:cNvPr id="100" name="SpeakerPhoto"/>
+          <p:cNvPicPr>
+            <a:picLocks noChangeAspect="1"/>
+          </p:cNvPicPr>
+          <p:nvPr/>
+        </p:nvPicPr>
+        <p:blipFill>
+          <a:blip r:embed="rId4"/>
+          <a:srcRect/>
+          <a:stretch>
+            <a:fillRect/>
+          </a:stretch>
+        </p:blipFill>
+        <p:spPr>
+          <a:xfrm>
+            <a:off x="914400" y="1645920"/>
+            <a:ext cx="3108960" cy="3108960"/>
+          </a:xfrm>
+          <a:prstGeom prst="roundRect">
+            <a:avLst>
+              <a:gd name="adj" fmla="val 4000"/>
+            </a:avLst>
+          </a:prstGeom>
+        </p:spPr>
+      </p:pic>
+      <p:sp>
+        <p:nvSpPr>
+          <p:cNvPr id="6" name="Rectangle 5"/>
+          <p:cNvSpPr/>
+          <p:nvPr/>
+        </p:nvSpPr>
+        <p:spPr>
+          <a:xfrm>
+            <a:off x="4754880" y="1371600"/>
+            <a:ext cx="640080" cy="38100"/>
+          </a:xfrm>
+          <a:prstGeom prst="rect">
+            <a:avLst/>
+          </a:prstGeom>
+          <a:solidFill>
+            <a:srgbClr val="4AB8D2"/>
+          </a:solidFill>
+          <a:ln>
+            <a:noFill/>
+          </a:ln>
+        </p:spPr>
+        <p:style>
+          <a:lnRef idx="1">
+            <a:schemeClr val="accent1"/>
+          </a:lnRef>
+          <a:fillRef idx="3">
+            <a:schemeClr val="accent1"/>
+          </a:fillRef>
+          <a:effectRef idx="2">
+            <a:schemeClr val="accent1"/>
+          </a:effectRef>
+          <a:fontRef idx="minor">
+            <a:schemeClr val="lt1"/>
+          </a:fontRef>
+        </p:style>
+        <p:txBody>
+          <a:bodyPr rtlCol="0" anchor="ctr"/>
+          <a:lstStyle/>
+          <a:p>
+            <a:pPr algn="ctr"/>
+            <a:endParaRPr/>
+          </a:p>
+        </p:txBody>
+      </p:sp>
+      <p:sp>
+        <p:nvSpPr>
+          <p:cNvPr id="7" name="TextBox 6"/>
+          <p:cNvSpPr txBox="1"/>
+          <p:nvPr/>
+        </p:nvSpPr>
+        <p:spPr>
+          <a:xfrm>
+            <a:off x="4754880" y="1508760"/>
+            <a:ext cx="6858000" cy="365760"/>
+          </a:xfrm>
+          <a:prstGeom prst="rect">
+            <a:avLst/>
+          </a:prstGeom>
+          <a:noFill/>
+        </p:spPr>
+        <p:txBody>
+          <a:bodyPr wrap="square" lIns="0" tIns="0" rIns="0" bIns="0" anchor="t">
+            <a:spAutoFit/>
+          </a:bodyPr>
+          <a:lstStyle/>
+          <a:p>
+            <a:pPr algn="l"/>
+            <a:r>
+              <a:rPr sz="1400" b="1">
+                <a:solidFill>
+                  <a:srgbClr val="4AB8D2"/>
+                </a:solidFill>
+                <a:latin typeface="JetBrains Mono"/>
+              </a:rPr>
+              <a:t>SPEAKER</a:t>
+            </a:r>
+          </a:p>
+        </p:txBody>
+      </p:sp>
+      <p:sp>
+        <p:nvSpPr>
+          <p:cNvPr id="8" name="TextBox 7"/>
+          <p:cNvSpPr txBox="1"/>
+          <p:nvPr/>
+        </p:nvSpPr>
+        <p:spPr>
+          <a:xfrm>
+            <a:off x="4754880" y="1920240"/>
+            <a:ext cx="6858000" cy="822960"/>
+          </a:xfrm>
+          <a:prstGeom prst="rect">
+            <a:avLst/>
+          </a:prstGeom>
+          <a:noFill/>
+        </p:spPr>
+        <p:txBody>
+          <a:bodyPr wrap="square" lIns="0" tIns="0" rIns="0" bIns="0" anchor="t">
+            <a:spAutoFit/>
+          </a:bodyPr>
+          <a:lstStyle/>
+          <a:p>
+            <a:pPr algn="l"/>
+            <a:r>
+              <a:rPr sz="4000" b="1">
+                <a:solidFill>
+                  <a:srgbClr val="E8E8ED"/>
+                </a:solidFill>
+                <a:latin typeface="Inter"/>
+              </a:rPr>
+              <a:t>Eleni Ioakeim</a:t>
+            </a:r>
+          </a:p>
+        </p:txBody>
+      </p:sp>
+      <p:sp>
+        <p:nvSpPr>
+          <p:cNvPr id="9" name="TextBox 8"/>
+          <p:cNvSpPr txBox="1"/>
+          <p:nvPr/>
+        </p:nvSpPr>
+        <p:spPr>
+          <a:xfrm>
+            <a:off x="4754880" y="2788920"/>
+            <a:ext cx="6858000" cy="457200"/>
+          </a:xfrm>
+          <a:prstGeom prst="rect">
+            <a:avLst/>
+          </a:prstGeom>
+          <a:noFill/>
+        </p:spPr>
+        <p:txBody>
+          <a:bodyPr wrap="square" lIns="0" tIns="0" rIns="0" bIns="0" anchor="t">
+            <a:spAutoFit/>
+          </a:bodyPr>
+          <a:lstStyle/>
+          <a:p>
+            <a:pPr algn="l"/>
+            <a:r>
+              <a:rPr sz="2000" b="0">
+                <a:solidFill>
+                  <a:srgbClr val="6DD0E7"/>
+                </a:solidFill>
+                <a:latin typeface="Inter"/>
+              </a:rPr>
+              <a:t>Truesec, OT Threat Analyst</a:t>
+            </a:r>
+          </a:p>
+        </p:txBody>
+      </p:sp>
+      <p:sp>
+        <p:nvSpPr>
+          <p:cNvPr id="10" name="TextBox 9"/>
+          <p:cNvSpPr txBox="1"/>
+          <p:nvPr/>
+        </p:nvSpPr>
+        <p:spPr>
+          <a:xfrm>
+            <a:off x="4754880" y="3474720"/>
+            <a:ext cx="6858000" cy="2103120"/>
+          </a:xfrm>
+          <a:prstGeom prst="rect">
+            <a:avLst/>
+          </a:prstGeom>
+          <a:noFill/>
+        </p:spPr>
+        <p:txBody>
+          <a:bodyPr wrap="square" lIns="0" tIns="0" rIns="0" bIns="0" anchor="t"/>
+          <a:lstStyle/>
+          <a:p>
+            <a:pPr algn="l"/>
+            <a:r>
+              <a:rPr sz="1600" b="0">
+                <a:solidFill>
+                  <a:srgbClr val="8888A0"/>
+                </a:solidFill>
+                <a:latin typeface="Inter"/>
+              </a:rPr>
+              <a:t>Eleni is an OT Threat Analyst at Truesec SOC in Copenhagen, with expertise in OT network security monitoring. Her work contributes to improving SOC processes and detection capabilities for ICS environments.</a:t>
+            </a:r>
+          </a:p>
+        </p:txBody>
+      </p:sp>
+      <p:sp>
+        <p:nvSpPr>
+          <p:cNvPr id="11" name="TextBox 10"/>
+          <p:cNvSpPr txBox="1"/>
+          <p:nvPr/>
+        </p:nvSpPr>
+        <p:spPr>
+          <a:xfrm>
+            <a:off x="4754880" y="5669280"/>
+            <a:ext cx="6858000" cy="365760"/>
+          </a:xfrm>
+          <a:prstGeom prst="rect">
+            <a:avLst/>
+          </a:prstGeom>
+          <a:noFill/>
+        </p:spPr>
+        <p:txBody>
+          <a:bodyPr wrap="square" lIns="0" tIns="0" rIns="0" bIns="0" anchor="t">
+            <a:spAutoFit/>
+          </a:bodyPr>
+          <a:lstStyle/>
+          <a:p>
+            <a:pPr algn="l"/>
+            <a:r>
+              <a:rPr sz="1400" b="0">
+                <a:solidFill>
+                  <a:srgbClr val="4AB8D2"/>
+                </a:solidFill>
+                <a:latin typeface="JetBrains Mono"/>
+              </a:rPr>
+              <a:t/>
+            </a:r>
+          </a:p>
+        </p:txBody>
+      </p:sp>
+      <p:sp>
+        <p:nvSpPr>
+          <p:cNvPr id="12" name="TextBox 11"/>
+          <p:cNvSpPr txBox="1"/>
+          <p:nvPr/>
+        </p:nvSpPr>
+        <p:spPr>
+          <a:xfrm>
+            <a:off x="548640" y="6446520"/>
+            <a:ext cx="7315200" cy="274320"/>
+          </a:xfrm>
+          <a:prstGeom prst="rect">
+            <a:avLst/>
+          </a:prstGeom>
+          <a:noFill/>
+        </p:spPr>
+        <p:txBody>
+          <a:bodyPr wrap="square" lIns="0" tIns="0" rIns="0" bIns="0" anchor="t">
+            <a:spAutoFit/>
+          </a:bodyPr>
+          <a:lstStyle/>
+          <a:p>
+            <a:pPr algn="l"/>
+            <a:r>
+              <a:rPr sz="1000" b="0">
+                <a:solidFill>
+                  <a:srgbClr val="8888A0"/>
+                </a:solidFill>
+                <a:latin typeface="JetBrains Mono"/>
+              </a:rPr>
+              <a:t>BSides Aarhus 2026  ·  June 20  ·  INCUBA Next, Aarhus</a:t>
+            </a:r>
+          </a:p>
+        </p:txBody>
+      </p:sp>
+      <p:sp>
+        <p:nvSpPr>
+          <p:cNvPr id="13" name="TextBox 12"/>
+          <p:cNvSpPr txBox="1"/>
+          <p:nvPr/>
+        </p:nvSpPr>
+        <p:spPr>
+          <a:xfrm>
+            <a:off x="10515600" y="6446520"/>
+            <a:ext cx="1188720" cy="274320"/>
+          </a:xfrm>
+          <a:prstGeom prst="rect">
+            <a:avLst/>
+          </a:prstGeom>
+          <a:noFill/>
+        </p:spPr>
+        <p:txBody>
+          <a:bodyPr wrap="square" lIns="0" tIns="0" rIns="0" bIns="0" anchor="t">
             <a:spAutoFit/>
           </a:bodyPr>
           <a:lstStyle/>

</xml_diff>

<commit_message>
feat: update PowerPoint template generation to include dynamic speaker slides and remove legacy script
</commit_message>
<xml_diff>
--- a/Plans/template-output/bsides-aarhus-2026-template.pptx
+++ b/Plans/template-output/bsides-aarhus-2026-template.pptx
@@ -119,6 +119,40 @@
       </a:defRPr>
     </a:lvl9pPr>
   </p:defaultTextStyle>
+  <p:extLst>
+    <p:ext uri="{521415D9-36F7-43E2-AB2F-B90AF26B5E84}">
+      <p14:sectionLst xmlns:p14="http://schemas.microsoft.com/office/powerpoint/2010/main">
+        <p14:section name="Template" id="{1EB5D2B3-2B03-4757-9172-59047DFE093B}">
+          <p14:sldIdLst>
+            <p14:sldId id="256"/>
+            <p14:sldId id="257"/>
+            <p14:sldId id="258"/>
+            <p14:sldId id="259"/>
+            <p14:sldId id="260"/>
+          </p14:sldIdLst>
+        </p14:section>
+        <p14:section name="Track 1" id="{986B03BF-3781-4AD9-ABA4-A357E1F944A8}">
+          <p14:sldIdLst>
+            <p14:sldId id="261"/>
+            <p14:sldId id="262"/>
+            <p14:sldId id="263"/>
+            <p14:sldId id="264"/>
+            <p14:sldId id="265"/>
+          </p14:sldIdLst>
+        </p14:section>
+        <p14:section name="Track 2" id="{520966B5-C5D1-46E8-95E4-B66C7DD3E922}">
+          <p14:sldIdLst>
+            <p14:sldId id="266"/>
+            <p14:sldId id="267"/>
+            <p14:sldId id="268"/>
+            <p14:sldId id="269"/>
+            <p14:sldId id="270"/>
+            <p14:sldId id="271"/>
+          </p14:sldIdLst>
+        </p14:section>
+      </p14:sectionLst>
+    </p:ext>
+  </p:extLst>
 </p:presentation>
 </file>
 
@@ -3378,7 +3412,7 @@
 </file>
 
 <file path=ppt/slides/slide10.xml><?xml version="1.0" encoding="utf-8"?>
-<p:sld xmlns:a="http://schemas.openxmlformats.org/drawingml/2006/main" xmlns:r="http://schemas.openxmlformats.org/officeDocument/2006/relationships" xmlns:p="http://schemas.openxmlformats.org/presentationml/2006/main">
+<p:sld xmlns:a="http://schemas.openxmlformats.org/drawingml/2006/main" xmlns:p="http://schemas.openxmlformats.org/presentationml/2006/main" xmlns:r="http://schemas.openxmlformats.org/officeDocument/2006/relationships">
   <p:cSld>
     <p:spTree>
       <p:nvGrpSpPr>
@@ -3386,14 +3420,7 @@
         <p:cNvGrpSpPr/>
         <p:nvPr/>
       </p:nvGrpSpPr>
-      <p:grpSpPr>
-        <a:xfrm>
-          <a:off x="0" y="0"/>
-          <a:ext cx="0" cy="0"/>
-          <a:chOff x="0" y="0"/>
-          <a:chExt cx="0" cy="0"/>
-        </a:xfrm>
-      </p:grpSpPr>
+      <p:grpSpPr/>
       <p:pic>
         <p:nvPicPr>
           <p:cNvPr id="2" name="Picture 1" descr="_bg.png"/>
@@ -3484,13 +3511,12 @@
           <a:lstStyle/>
           <a:p>
             <a:pPr algn="ctr"/>
-            <a:endParaRPr/>
           </a:p>
         </p:txBody>
       </p:sp>
       <p:pic>
         <p:nvPicPr>
-          <p:cNvPr id="100" name="SpeakerPhoto"/>
+          <p:cNvPr id="5" name="Picture 4" descr="image.jpg"/>
           <p:cNvPicPr>
             <a:picLocks noChangeAspect="1"/>
           </p:cNvPicPr>
@@ -3498,20 +3524,17 @@
         </p:nvPicPr>
         <p:blipFill>
           <a:blip r:embed="rId4"/>
-          <a:srcRect/>
           <a:stretch>
             <a:fillRect/>
           </a:stretch>
         </p:blipFill>
         <p:spPr>
           <a:xfrm>
-            <a:off x="914400" y="1645920"/>
+            <a:off x="914400" y="2103120"/>
             <a:ext cx="3108960" cy="3108960"/>
           </a:xfrm>
-          <a:prstGeom prst="roundRect">
-            <a:avLst>
-              <a:gd name="adj" fmla="val 4000"/>
-            </a:avLst>
+          <a:prstGeom prst="rect">
+            <a:avLst/>
           </a:prstGeom>
         </p:spPr>
       </p:pic>
@@ -3555,7 +3578,6 @@
           <a:lstStyle/>
           <a:p>
             <a:pPr algn="ctr"/>
-            <a:endParaRPr/>
           </a:p>
         </p:txBody>
       </p:sp>
@@ -3576,7 +3598,7 @@
           <a:noFill/>
         </p:spPr>
         <p:txBody>
-          <a:bodyPr wrap="square" lIns="0" tIns="0" rIns="0" bIns="0" anchor="t">
+          <a:bodyPr wrap="square" lIns="0" rIns="0" tIns="0" bIns="0" anchor="t">
             <a:spAutoFit/>
           </a:bodyPr>
           <a:lstStyle/>
@@ -3611,7 +3633,7 @@
           <a:noFill/>
         </p:spPr>
         <p:txBody>
-          <a:bodyPr wrap="square" lIns="0" tIns="0" rIns="0" bIns="0" anchor="t">
+          <a:bodyPr wrap="square" lIns="0" rIns="0" tIns="0" bIns="0" anchor="t">
             <a:spAutoFit/>
           </a:bodyPr>
           <a:lstStyle/>
@@ -3624,7 +3646,7 @@
                 </a:solidFill>
                 <a:latin typeface="Inter"/>
               </a:rPr>
-              <a:t>Joost van Dijk</a:t>
+              <a:t>Morten von Seelen</a:t>
             </a:r>
           </a:p>
         </p:txBody>
@@ -3646,7 +3668,7 @@
           <a:noFill/>
         </p:spPr>
         <p:txBody>
-          <a:bodyPr wrap="square" lIns="0" tIns="0" rIns="0" bIns="0" anchor="t">
+          <a:bodyPr wrap="square" lIns="0" rIns="0" tIns="0" bIns="0" anchor="t">
             <a:spAutoFit/>
           </a:bodyPr>
           <a:lstStyle/>
@@ -3659,7 +3681,7 @@
                 </a:solidFill>
                 <a:latin typeface="Inter"/>
               </a:rPr>
-              <a:t>Developer Advocate at Yubico</a:t>
+              <a:t>TRUESEC, Vice President</a:t>
             </a:r>
           </a:p>
         </p:txBody>
@@ -3681,7 +3703,9 @@
           <a:noFill/>
         </p:spPr>
         <p:txBody>
-          <a:bodyPr wrap="square" lIns="0" tIns="0" rIns="0" bIns="0" anchor="t"/>
+          <a:bodyPr wrap="square" lIns="0" rIns="0" tIns="0" bIns="0" anchor="t">
+            <a:spAutoFit/>
+          </a:bodyPr>
           <a:lstStyle/>
           <a:p>
             <a:pPr algn="l"/>
@@ -3692,7 +3716,7 @@
                 </a:solidFill>
                 <a:latin typeface="Inter"/>
               </a:rPr>
-              <a:t>Joost is a Developer Advocate at Yubico and a security and privacy professional with deep expertise in federated single sign-on, multi-factor authentication, FIDO, passkeys, PKI, TLS, and hardware security.</a:t>
+              <a:t>Morten is Vice President at Truesec in Aarhus and builds cool companies. His work focuses on turning outside-in signals about real organizations into actionable risk insight at national scale.</a:t>
             </a:r>
           </a:p>
         </p:txBody>
@@ -3714,7 +3738,7 @@
           <a:noFill/>
         </p:spPr>
         <p:txBody>
-          <a:bodyPr wrap="square" lIns="0" tIns="0" rIns="0" bIns="0" anchor="t">
+          <a:bodyPr wrap="square" lIns="0" rIns="0" tIns="0" bIns="0" anchor="t">
             <a:spAutoFit/>
           </a:bodyPr>
           <a:lstStyle/>
@@ -3727,7 +3751,7 @@
                 </a:solidFill>
                 <a:latin typeface="JetBrains Mono"/>
               </a:rPr>
-              <a:t>linkedin.com/in/joostd</a:t>
+              <a:t>linkedin.com/in/vonseelen  ·  tinyurl.com/MvSeeBlog</a:t>
             </a:r>
           </a:p>
         </p:txBody>
@@ -3749,7 +3773,7 @@
           <a:noFill/>
         </p:spPr>
         <p:txBody>
-          <a:bodyPr wrap="square" lIns="0" tIns="0" rIns="0" bIns="0" anchor="t">
+          <a:bodyPr wrap="square" lIns="0" rIns="0" tIns="0" bIns="0" anchor="t">
             <a:spAutoFit/>
           </a:bodyPr>
           <a:lstStyle/>
@@ -3784,7 +3808,7 @@
           <a:noFill/>
         </p:spPr>
         <p:txBody>
-          <a:bodyPr wrap="square" lIns="0" tIns="0" rIns="0" bIns="0" anchor="t">
+          <a:bodyPr wrap="square" lIns="0" rIns="0" tIns="0" bIns="0" anchor="t">
             <a:spAutoFit/>
           </a:bodyPr>
           <a:lstStyle/>
@@ -3811,7 +3835,7 @@
 </file>
 
 <file path=ppt/slides/slide11.xml><?xml version="1.0" encoding="utf-8"?>
-<p:sld xmlns:a="http://schemas.openxmlformats.org/drawingml/2006/main" xmlns:r="http://schemas.openxmlformats.org/officeDocument/2006/relationships" xmlns:p="http://schemas.openxmlformats.org/presentationml/2006/main">
+<p:sld xmlns:a="http://schemas.openxmlformats.org/drawingml/2006/main" xmlns:p="http://schemas.openxmlformats.org/presentationml/2006/main" xmlns:r="http://schemas.openxmlformats.org/officeDocument/2006/relationships">
   <p:cSld>
     <p:spTree>
       <p:nvGrpSpPr>
@@ -3819,14 +3843,7 @@
         <p:cNvGrpSpPr/>
         <p:nvPr/>
       </p:nvGrpSpPr>
-      <p:grpSpPr>
-        <a:xfrm>
-          <a:off x="0" y="0"/>
-          <a:ext cx="0" cy="0"/>
-          <a:chOff x="0" y="0"/>
-          <a:chExt cx="0" cy="0"/>
-        </a:xfrm>
-      </p:grpSpPr>
+      <p:grpSpPr/>
       <p:pic>
         <p:nvPicPr>
           <p:cNvPr id="2" name="Picture 1" descr="_bg.png"/>
@@ -3917,13 +3934,12 @@
           <a:lstStyle/>
           <a:p>
             <a:pPr algn="ctr"/>
-            <a:endParaRPr/>
           </a:p>
         </p:txBody>
       </p:sp>
       <p:pic>
         <p:nvPicPr>
-          <p:cNvPr id="100" name="SpeakerPhoto"/>
+          <p:cNvPr id="5" name="Picture 4" descr="image.jpg"/>
           <p:cNvPicPr>
             <a:picLocks noChangeAspect="1"/>
           </p:cNvPicPr>
@@ -3931,20 +3947,17 @@
         </p:nvPicPr>
         <p:blipFill>
           <a:blip r:embed="rId4"/>
-          <a:srcRect/>
           <a:stretch>
             <a:fillRect/>
           </a:stretch>
         </p:blipFill>
         <p:spPr>
           <a:xfrm>
-            <a:off x="914400" y="1645920"/>
+            <a:off x="914400" y="2103120"/>
             <a:ext cx="3108960" cy="3108960"/>
           </a:xfrm>
-          <a:prstGeom prst="roundRect">
-            <a:avLst>
-              <a:gd name="adj" fmla="val 4000"/>
-            </a:avLst>
+          <a:prstGeom prst="rect">
+            <a:avLst/>
           </a:prstGeom>
         </p:spPr>
       </p:pic>
@@ -3988,7 +4001,6 @@
           <a:lstStyle/>
           <a:p>
             <a:pPr algn="ctr"/>
-            <a:endParaRPr/>
           </a:p>
         </p:txBody>
       </p:sp>
@@ -4009,7 +4021,7 @@
           <a:noFill/>
         </p:spPr>
         <p:txBody>
-          <a:bodyPr wrap="square" lIns="0" tIns="0" rIns="0" bIns="0" anchor="t">
+          <a:bodyPr wrap="square" lIns="0" rIns="0" tIns="0" bIns="0" anchor="t">
             <a:spAutoFit/>
           </a:bodyPr>
           <a:lstStyle/>
@@ -4044,7 +4056,7 @@
           <a:noFill/>
         </p:spPr>
         <p:txBody>
-          <a:bodyPr wrap="square" lIns="0" tIns="0" rIns="0" bIns="0" anchor="t">
+          <a:bodyPr wrap="square" lIns="0" rIns="0" tIns="0" bIns="0" anchor="t">
             <a:spAutoFit/>
           </a:bodyPr>
           <a:lstStyle/>
@@ -4057,7 +4069,7 @@
                 </a:solidFill>
                 <a:latin typeface="Inter"/>
               </a:rPr>
-              <a:t>Kasper Hald</a:t>
+              <a:t>Behnaz Karimi</a:t>
             </a:r>
           </a:p>
         </p:txBody>
@@ -4079,7 +4091,7 @@
           <a:noFill/>
         </p:spPr>
         <p:txBody>
-          <a:bodyPr wrap="square" lIns="0" tIns="0" rIns="0" bIns="0" anchor="t">
+          <a:bodyPr wrap="square" lIns="0" rIns="0" tIns="0" bIns="0" anchor="t">
             <a:spAutoFit/>
           </a:bodyPr>
           <a:lstStyle/>
@@ -4092,7 +4104,7 @@
                 </a:solidFill>
                 <a:latin typeface="Inter"/>
               </a:rPr>
-              <a:t>Freelance Consultant at ApplSec Consult</a:t>
+              <a:t>Co-Lead / Leader AI Red Teaming OWASP AI Exchange and Founder RAID-AI Framework</a:t>
             </a:r>
           </a:p>
         </p:txBody>
@@ -4114,7 +4126,9 @@
           <a:noFill/>
         </p:spPr>
         <p:txBody>
-          <a:bodyPr wrap="square" lIns="0" tIns="0" rIns="0" bIns="0" anchor="t"/>
+          <a:bodyPr wrap="square" lIns="0" rIns="0" tIns="0" bIns="0" anchor="t">
+            <a:spAutoFit/>
+          </a:bodyPr>
           <a:lstStyle/>
           <a:p>
             <a:pPr algn="l"/>
@@ -4125,7 +4139,7 @@
                 </a:solidFill>
                 <a:latin typeface="Inter"/>
               </a:rPr>
-              <a:t>With an educational background in quantum theory and 20+ years within application security, this topic is where Kasper's past and present meet.</a:t>
+              <a:t>Behnaz is an AI Security Researcher and the Founder/Creator of the RAID-AI Framework. She is also Co-Author, Co-Lead, and Leader of AI Red Teaming at OWASP AI Exchange, where she actively contributes to advancing security practices for AI systems.</a:t>
             </a:r>
           </a:p>
         </p:txBody>
@@ -4147,7 +4161,7 @@
           <a:noFill/>
         </p:spPr>
         <p:txBody>
-          <a:bodyPr wrap="square" lIns="0" tIns="0" rIns="0" bIns="0" anchor="t">
+          <a:bodyPr wrap="square" lIns="0" rIns="0" tIns="0" bIns="0" anchor="t">
             <a:spAutoFit/>
           </a:bodyPr>
           <a:lstStyle/>
@@ -4160,7 +4174,7 @@
                 </a:solidFill>
                 <a:latin typeface="JetBrains Mono"/>
               </a:rPr>
-              <a:t>linkedin.com/in/kasper-hald-6622623</a:t>
+              <a:t>linkedin.com/in/behnaz-karimi-behi  ·  substack.com/@behnazkarimi</a:t>
             </a:r>
           </a:p>
         </p:txBody>
@@ -4182,7 +4196,7 @@
           <a:noFill/>
         </p:spPr>
         <p:txBody>
-          <a:bodyPr wrap="square" lIns="0" tIns="0" rIns="0" bIns="0" anchor="t">
+          <a:bodyPr wrap="square" lIns="0" rIns="0" tIns="0" bIns="0" anchor="t">
             <a:spAutoFit/>
           </a:bodyPr>
           <a:lstStyle/>
@@ -4217,7 +4231,7 @@
           <a:noFill/>
         </p:spPr>
         <p:txBody>
-          <a:bodyPr wrap="square" lIns="0" tIns="0" rIns="0" bIns="0" anchor="t">
+          <a:bodyPr wrap="square" lIns="0" rIns="0" tIns="0" bIns="0" anchor="t">
             <a:spAutoFit/>
           </a:bodyPr>
           <a:lstStyle/>
@@ -4244,7 +4258,7 @@
 </file>
 
 <file path=ppt/slides/slide12.xml><?xml version="1.0" encoding="utf-8"?>
-<p:sld xmlns:a="http://schemas.openxmlformats.org/drawingml/2006/main" xmlns:r="http://schemas.openxmlformats.org/officeDocument/2006/relationships" xmlns:p="http://schemas.openxmlformats.org/presentationml/2006/main">
+<p:sld xmlns:a="http://schemas.openxmlformats.org/drawingml/2006/main" xmlns:p="http://schemas.openxmlformats.org/presentationml/2006/main" xmlns:r="http://schemas.openxmlformats.org/officeDocument/2006/relationships">
   <p:cSld>
     <p:spTree>
       <p:nvGrpSpPr>
@@ -4252,14 +4266,7 @@
         <p:cNvGrpSpPr/>
         <p:nvPr/>
       </p:nvGrpSpPr>
-      <p:grpSpPr>
-        <a:xfrm>
-          <a:off x="0" y="0"/>
-          <a:ext cx="0" cy="0"/>
-          <a:chOff x="0" y="0"/>
-          <a:chExt cx="0" cy="0"/>
-        </a:xfrm>
-      </p:grpSpPr>
+      <p:grpSpPr/>
       <p:pic>
         <p:nvPicPr>
           <p:cNvPr id="2" name="Picture 1" descr="_bg.png"/>
@@ -4350,13 +4357,12 @@
           <a:lstStyle/>
           <a:p>
             <a:pPr algn="ctr"/>
-            <a:endParaRPr/>
           </a:p>
         </p:txBody>
       </p:sp>
       <p:pic>
         <p:nvPicPr>
-          <p:cNvPr id="100" name="SpeakerPhoto"/>
+          <p:cNvPr id="5" name="Picture 4" descr="image.jpg"/>
           <p:cNvPicPr>
             <a:picLocks noChangeAspect="1"/>
           </p:cNvPicPr>
@@ -4364,20 +4370,17 @@
         </p:nvPicPr>
         <p:blipFill>
           <a:blip r:embed="rId4"/>
-          <a:srcRect/>
           <a:stretch>
             <a:fillRect/>
           </a:stretch>
         </p:blipFill>
         <p:spPr>
           <a:xfrm>
-            <a:off x="914400" y="1645920"/>
+            <a:off x="914400" y="2103120"/>
             <a:ext cx="3108960" cy="3108960"/>
           </a:xfrm>
-          <a:prstGeom prst="roundRect">
-            <a:avLst>
-              <a:gd name="adj" fmla="val 4000"/>
-            </a:avLst>
+          <a:prstGeom prst="rect">
+            <a:avLst/>
           </a:prstGeom>
         </p:spPr>
       </p:pic>
@@ -4421,7 +4424,6 @@
           <a:lstStyle/>
           <a:p>
             <a:pPr algn="ctr"/>
-            <a:endParaRPr/>
           </a:p>
         </p:txBody>
       </p:sp>
@@ -4442,7 +4444,7 @@
           <a:noFill/>
         </p:spPr>
         <p:txBody>
-          <a:bodyPr wrap="square" lIns="0" tIns="0" rIns="0" bIns="0" anchor="t">
+          <a:bodyPr wrap="square" lIns="0" rIns="0" tIns="0" bIns="0" anchor="t">
             <a:spAutoFit/>
           </a:bodyPr>
           <a:lstStyle/>
@@ -4477,7 +4479,7 @@
           <a:noFill/>
         </p:spPr>
         <p:txBody>
-          <a:bodyPr wrap="square" lIns="0" tIns="0" rIns="0" bIns="0" anchor="t">
+          <a:bodyPr wrap="square" lIns="0" rIns="0" tIns="0" bIns="0" anchor="t">
             <a:spAutoFit/>
           </a:bodyPr>
           <a:lstStyle/>
@@ -4490,7 +4492,7 @@
                 </a:solidFill>
                 <a:latin typeface="Inter"/>
               </a:rPr>
-              <a:t>Martin Sohn Christensen</a:t>
+              <a:t>Bence Soóki-Tóth</a:t>
             </a:r>
           </a:p>
         </p:txBody>
@@ -4512,7 +4514,7 @@
           <a:noFill/>
         </p:spPr>
         <p:txBody>
-          <a:bodyPr wrap="square" lIns="0" tIns="0" rIns="0" bIns="0" anchor="t">
+          <a:bodyPr wrap="square" lIns="0" rIns="0" tIns="0" bIns="0" anchor="t">
             <a:spAutoFit/>
           </a:bodyPr>
           <a:lstStyle/>
@@ -4525,7 +4527,7 @@
                 </a:solidFill>
                 <a:latin typeface="Inter"/>
               </a:rPr>
-              <a:t>Security Researcher @ SpecterOps</a:t>
+              <a:t>Aarhus University, Master's Student</a:t>
             </a:r>
           </a:p>
         </p:txBody>
@@ -4547,7 +4549,9 @@
           <a:noFill/>
         </p:spPr>
         <p:txBody>
-          <a:bodyPr wrap="square" lIns="0" tIns="0" rIns="0" bIns="0" anchor="t"/>
+          <a:bodyPr wrap="square" lIns="0" rIns="0" tIns="0" bIns="0" anchor="t">
+            <a:spAutoFit/>
+          </a:bodyPr>
           <a:lstStyle/>
           <a:p>
             <a:pPr algn="l"/>
@@ -4558,7 +4562,7 @@
                 </a:solidFill>
                 <a:latin typeface="Inter"/>
               </a:rPr>
-              <a:t>Martin is a Security Researcher at SpecterOps in Copenhagen, specializing in Microsoft technologies with expertise in Active Directory, identity attack paths, and secure system configuration. His perspective on security risks and challenges is shaped by a background spanning system administration, an information security degree, and information security consultancy. He is a frequent contributor to the community through online engagement and talks.</a:t>
+              <a:t>Bence is a Master's student at Aarhus University and a research assistant at Eötvös Loránd University, working at the intersection of cryptography, game theory, and consensus protocols.</a:t>
             </a:r>
           </a:p>
         </p:txBody>
@@ -4580,7 +4584,7 @@
           <a:noFill/>
         </p:spPr>
         <p:txBody>
-          <a:bodyPr wrap="square" lIns="0" tIns="0" rIns="0" bIns="0" anchor="t">
+          <a:bodyPr wrap="square" lIns="0" rIns="0" tIns="0" bIns="0" anchor="t">
             <a:spAutoFit/>
           </a:bodyPr>
           <a:lstStyle/>
@@ -4593,7 +4597,7 @@
                 </a:solidFill>
                 <a:latin typeface="JetBrains Mono"/>
               </a:rPr>
-              <a:t>linkedin.com/in/martinsohn  ·  martinsohn.dk</a:t>
+              <a:t>linkedin.com/in/stbence  ·  0xsooki.github.io</a:t>
             </a:r>
           </a:p>
         </p:txBody>
@@ -4615,7 +4619,7 @@
           <a:noFill/>
         </p:spPr>
         <p:txBody>
-          <a:bodyPr wrap="square" lIns="0" tIns="0" rIns="0" bIns="0" anchor="t">
+          <a:bodyPr wrap="square" lIns="0" rIns="0" tIns="0" bIns="0" anchor="t">
             <a:spAutoFit/>
           </a:bodyPr>
           <a:lstStyle/>
@@ -4650,7 +4654,7 @@
           <a:noFill/>
         </p:spPr>
         <p:txBody>
-          <a:bodyPr wrap="square" lIns="0" tIns="0" rIns="0" bIns="0" anchor="t">
+          <a:bodyPr wrap="square" lIns="0" rIns="0" tIns="0" bIns="0" anchor="t">
             <a:spAutoFit/>
           </a:bodyPr>
           <a:lstStyle/>
@@ -4677,7 +4681,7 @@
 </file>
 
 <file path=ppt/slides/slide13.xml><?xml version="1.0" encoding="utf-8"?>
-<p:sld xmlns:a="http://schemas.openxmlformats.org/drawingml/2006/main" xmlns:r="http://schemas.openxmlformats.org/officeDocument/2006/relationships" xmlns:p="http://schemas.openxmlformats.org/presentationml/2006/main">
+<p:sld xmlns:a="http://schemas.openxmlformats.org/drawingml/2006/main" xmlns:p="http://schemas.openxmlformats.org/presentationml/2006/main" xmlns:r="http://schemas.openxmlformats.org/officeDocument/2006/relationships">
   <p:cSld>
     <p:spTree>
       <p:nvGrpSpPr>
@@ -4685,14 +4689,7 @@
         <p:cNvGrpSpPr/>
         <p:nvPr/>
       </p:nvGrpSpPr>
-      <p:grpSpPr>
-        <a:xfrm>
-          <a:off x="0" y="0"/>
-          <a:ext cx="0" cy="0"/>
-          <a:chOff x="0" y="0"/>
-          <a:chExt cx="0" cy="0"/>
-        </a:xfrm>
-      </p:grpSpPr>
+      <p:grpSpPr/>
       <p:pic>
         <p:nvPicPr>
           <p:cNvPr id="2" name="Picture 1" descr="_bg.png"/>
@@ -4783,13 +4780,12 @@
           <a:lstStyle/>
           <a:p>
             <a:pPr algn="ctr"/>
-            <a:endParaRPr/>
           </a:p>
         </p:txBody>
       </p:sp>
       <p:pic>
         <p:nvPicPr>
-          <p:cNvPr id="100" name="SpeakerPhoto"/>
+          <p:cNvPr id="5" name="Picture 4" descr="image.jpg"/>
           <p:cNvPicPr>
             <a:picLocks noChangeAspect="1"/>
           </p:cNvPicPr>
@@ -4797,20 +4793,17 @@
         </p:nvPicPr>
         <p:blipFill>
           <a:blip r:embed="rId4"/>
-          <a:srcRect/>
           <a:stretch>
             <a:fillRect/>
           </a:stretch>
         </p:blipFill>
         <p:spPr>
           <a:xfrm>
-            <a:off x="914400" y="1645920"/>
+            <a:off x="914400" y="2103120"/>
             <a:ext cx="3108960" cy="3108960"/>
           </a:xfrm>
-          <a:prstGeom prst="roundRect">
-            <a:avLst>
-              <a:gd name="adj" fmla="val 4000"/>
-            </a:avLst>
+          <a:prstGeom prst="rect">
+            <a:avLst/>
           </a:prstGeom>
         </p:spPr>
       </p:pic>
@@ -4854,7 +4847,6 @@
           <a:lstStyle/>
           <a:p>
             <a:pPr algn="ctr"/>
-            <a:endParaRPr/>
           </a:p>
         </p:txBody>
       </p:sp>
@@ -4875,7 +4867,7 @@
           <a:noFill/>
         </p:spPr>
         <p:txBody>
-          <a:bodyPr wrap="square" lIns="0" tIns="0" rIns="0" bIns="0" anchor="t">
+          <a:bodyPr wrap="square" lIns="0" rIns="0" tIns="0" bIns="0" anchor="t">
             <a:spAutoFit/>
           </a:bodyPr>
           <a:lstStyle/>
@@ -4910,7 +4902,7 @@
           <a:noFill/>
         </p:spPr>
         <p:txBody>
-          <a:bodyPr wrap="square" lIns="0" tIns="0" rIns="0" bIns="0" anchor="t">
+          <a:bodyPr wrap="square" lIns="0" rIns="0" tIns="0" bIns="0" anchor="t">
             <a:spAutoFit/>
           </a:bodyPr>
           <a:lstStyle/>
@@ -4923,7 +4915,7 @@
                 </a:solidFill>
                 <a:latin typeface="Inter"/>
               </a:rPr>
-              <a:t>Marvin Ngoma</a:t>
+              <a:t>Bleon Proko</a:t>
             </a:r>
           </a:p>
         </p:txBody>
@@ -4945,7 +4937,7 @@
           <a:noFill/>
         </p:spPr>
         <p:txBody>
-          <a:bodyPr wrap="square" lIns="0" tIns="0" rIns="0" bIns="0" anchor="t">
+          <a:bodyPr wrap="square" lIns="0" rIns="0" tIns="0" bIns="0" anchor="t">
             <a:spAutoFit/>
           </a:bodyPr>
           <a:lstStyle/>
@@ -4958,7 +4950,7 @@
                 </a:solidFill>
                 <a:latin typeface="Inter"/>
               </a:rPr>
-              <a:t>Elastic, Principal Security Architect, Security Evangelist</a:t>
+              <a:t>Cloud Security Researcher</a:t>
             </a:r>
           </a:p>
         </p:txBody>
@@ -4980,7 +4972,9 @@
           <a:noFill/>
         </p:spPr>
         <p:txBody>
-          <a:bodyPr wrap="square" lIns="0" tIns="0" rIns="0" bIns="0" anchor="t"/>
+          <a:bodyPr wrap="square" lIns="0" rIns="0" tIns="0" bIns="0" anchor="t">
+            <a:spAutoFit/>
+          </a:bodyPr>
           <a:lstStyle/>
           <a:p>
             <a:pPr algn="l"/>
@@ -4991,7 +4985,7 @@
                 </a:solidFill>
                 <a:latin typeface="Inter"/>
               </a:rPr>
-              <a:t>Marvin is a Principal Security Architect and Security Evangelist at Elastic, and a seasoned consultant with a strong passion for helping organizations succeed in their cybersecurity programs. He has led many projects in both the private and public sectors — architecting and building Security Operations and Intelligence capabilities, and unifying tools, processes, and people. Before Elastic, he was a security consultant at IBM and the primary SME for QRadar in the Nordics.</a:t>
+              <a:t>Bleon is a Senior Security Researcher at Exaforce, passionate about Infrastructure Penetration Testing and Security across Active Directory, Cloud (AWS, Azure, GCP, Digital Ocean) and hybrid infrastructures, as well as defense, detection, and threat hunting. He has presented Cloud Penetration Testing and Security topics at conferences including Black Hat USA, Europe and Sector, DEF CON, SANS Pentest Hackfest Hollywood and Amsterdam, and several BSides events in the US and Europe.</a:t>
             </a:r>
           </a:p>
         </p:txBody>
@@ -5013,7 +5007,7 @@
           <a:noFill/>
         </p:spPr>
         <p:txBody>
-          <a:bodyPr wrap="square" lIns="0" tIns="0" rIns="0" bIns="0" anchor="t">
+          <a:bodyPr wrap="square" lIns="0" rIns="0" tIns="0" bIns="0" anchor="t">
             <a:spAutoFit/>
           </a:bodyPr>
           <a:lstStyle/>
@@ -5026,7 +5020,7 @@
                 </a:solidFill>
                 <a:latin typeface="JetBrains Mono"/>
               </a:rPr>
-              <a:t>linkedin.com/in/tyolani  ·  www.elastic.co/blog/author/marvin-ngoma</a:t>
+              <a:t>linkedin.com/in/bleon-p-9b2734143  ·  blog.pepperclipp.com</a:t>
             </a:r>
           </a:p>
         </p:txBody>
@@ -5048,7 +5042,7 @@
           <a:noFill/>
         </p:spPr>
         <p:txBody>
-          <a:bodyPr wrap="square" lIns="0" tIns="0" rIns="0" bIns="0" anchor="t">
+          <a:bodyPr wrap="square" lIns="0" rIns="0" tIns="0" bIns="0" anchor="t">
             <a:spAutoFit/>
           </a:bodyPr>
           <a:lstStyle/>
@@ -5083,7 +5077,7 @@
           <a:noFill/>
         </p:spPr>
         <p:txBody>
-          <a:bodyPr wrap="square" lIns="0" tIns="0" rIns="0" bIns="0" anchor="t">
+          <a:bodyPr wrap="square" lIns="0" rIns="0" tIns="0" bIns="0" anchor="t">
             <a:spAutoFit/>
           </a:bodyPr>
           <a:lstStyle/>
@@ -5110,7 +5104,7 @@
 </file>
 
 <file path=ppt/slides/slide14.xml><?xml version="1.0" encoding="utf-8"?>
-<p:sld xmlns:a="http://schemas.openxmlformats.org/drawingml/2006/main" xmlns:r="http://schemas.openxmlformats.org/officeDocument/2006/relationships" xmlns:p="http://schemas.openxmlformats.org/presentationml/2006/main">
+<p:sld xmlns:a="http://schemas.openxmlformats.org/drawingml/2006/main" xmlns:p="http://schemas.openxmlformats.org/presentationml/2006/main" xmlns:r="http://schemas.openxmlformats.org/officeDocument/2006/relationships">
   <p:cSld>
     <p:spTree>
       <p:nvGrpSpPr>
@@ -5118,14 +5112,7 @@
         <p:cNvGrpSpPr/>
         <p:nvPr/>
       </p:nvGrpSpPr>
-      <p:grpSpPr>
-        <a:xfrm>
-          <a:off x="0" y="0"/>
-          <a:ext cx="0" cy="0"/>
-          <a:chOff x="0" y="0"/>
-          <a:chExt cx="0" cy="0"/>
-        </a:xfrm>
-      </p:grpSpPr>
+      <p:grpSpPr/>
       <p:pic>
         <p:nvPicPr>
           <p:cNvPr id="2" name="Picture 1" descr="_bg.png"/>
@@ -5216,13 +5203,12 @@
           <a:lstStyle/>
           <a:p>
             <a:pPr algn="ctr"/>
-            <a:endParaRPr/>
           </a:p>
         </p:txBody>
       </p:sp>
       <p:pic>
         <p:nvPicPr>
-          <p:cNvPr id="100" name="SpeakerPhoto"/>
+          <p:cNvPr id="5" name="Picture 4" descr="image.jpg"/>
           <p:cNvPicPr>
             <a:picLocks noChangeAspect="1"/>
           </p:cNvPicPr>
@@ -5230,20 +5216,17 @@
         </p:nvPicPr>
         <p:blipFill>
           <a:blip r:embed="rId4"/>
-          <a:srcRect/>
           <a:stretch>
             <a:fillRect/>
           </a:stretch>
         </p:blipFill>
         <p:spPr>
           <a:xfrm>
-            <a:off x="914400" y="1645920"/>
+            <a:off x="914400" y="2103120"/>
             <a:ext cx="3108960" cy="3108960"/>
           </a:xfrm>
-          <a:prstGeom prst="roundRect">
-            <a:avLst>
-              <a:gd name="adj" fmla="val 4000"/>
-            </a:avLst>
+          <a:prstGeom prst="rect">
+            <a:avLst/>
           </a:prstGeom>
         </p:spPr>
       </p:pic>
@@ -5287,7 +5270,6 @@
           <a:lstStyle/>
           <a:p>
             <a:pPr algn="ctr"/>
-            <a:endParaRPr/>
           </a:p>
         </p:txBody>
       </p:sp>
@@ -5308,7 +5290,7 @@
           <a:noFill/>
         </p:spPr>
         <p:txBody>
-          <a:bodyPr wrap="square" lIns="0" tIns="0" rIns="0" bIns="0" anchor="t">
+          <a:bodyPr wrap="square" lIns="0" rIns="0" tIns="0" bIns="0" anchor="t">
             <a:spAutoFit/>
           </a:bodyPr>
           <a:lstStyle/>
@@ -5343,7 +5325,7 @@
           <a:noFill/>
         </p:spPr>
         <p:txBody>
-          <a:bodyPr wrap="square" lIns="0" tIns="0" rIns="0" bIns="0" anchor="t">
+          <a:bodyPr wrap="square" lIns="0" rIns="0" tIns="0" bIns="0" anchor="t">
             <a:spAutoFit/>
           </a:bodyPr>
           <a:lstStyle/>
@@ -5356,7 +5338,7 @@
                 </a:solidFill>
                 <a:latin typeface="Inter"/>
               </a:rPr>
-              <a:t>Morten von Seelen</a:t>
+              <a:t>Kasper Hald</a:t>
             </a:r>
           </a:p>
         </p:txBody>
@@ -5378,7 +5360,7 @@
           <a:noFill/>
         </p:spPr>
         <p:txBody>
-          <a:bodyPr wrap="square" lIns="0" tIns="0" rIns="0" bIns="0" anchor="t">
+          <a:bodyPr wrap="square" lIns="0" rIns="0" tIns="0" bIns="0" anchor="t">
             <a:spAutoFit/>
           </a:bodyPr>
           <a:lstStyle/>
@@ -5391,7 +5373,7 @@
                 </a:solidFill>
                 <a:latin typeface="Inter"/>
               </a:rPr>
-              <a:t>TRUESEC, Vice President</a:t>
+              <a:t>Freelance Consultant at ApplSec Consult</a:t>
             </a:r>
           </a:p>
         </p:txBody>
@@ -5413,7 +5395,9 @@
           <a:noFill/>
         </p:spPr>
         <p:txBody>
-          <a:bodyPr wrap="square" lIns="0" tIns="0" rIns="0" bIns="0" anchor="t"/>
+          <a:bodyPr wrap="square" lIns="0" rIns="0" tIns="0" bIns="0" anchor="t">
+            <a:spAutoFit/>
+          </a:bodyPr>
           <a:lstStyle/>
           <a:p>
             <a:pPr algn="l"/>
@@ -5424,7 +5408,7 @@
                 </a:solidFill>
                 <a:latin typeface="Inter"/>
               </a:rPr>
-              <a:t>Morten is Vice President at Truesec in Aarhus and builds cool companies. His work focuses on turning outside-in signals about real organizations into actionable risk insight at national scale.</a:t>
+              <a:t>With an educational background in quantum theory and 20+ years within application security, this topic is where Kasper's past and present meet.</a:t>
             </a:r>
           </a:p>
         </p:txBody>
@@ -5446,7 +5430,7 @@
           <a:noFill/>
         </p:spPr>
         <p:txBody>
-          <a:bodyPr wrap="square" lIns="0" tIns="0" rIns="0" bIns="0" anchor="t">
+          <a:bodyPr wrap="square" lIns="0" rIns="0" tIns="0" bIns="0" anchor="t">
             <a:spAutoFit/>
           </a:bodyPr>
           <a:lstStyle/>
@@ -5459,7 +5443,7 @@
                 </a:solidFill>
                 <a:latin typeface="JetBrains Mono"/>
               </a:rPr>
-              <a:t>linkedin.com/in/vonseelen  ·  tinyurl.com/MvSeeBlog</a:t>
+              <a:t>linkedin.com/in/kasper-hald-6622623</a:t>
             </a:r>
           </a:p>
         </p:txBody>
@@ -5481,7 +5465,7 @@
           <a:noFill/>
         </p:spPr>
         <p:txBody>
-          <a:bodyPr wrap="square" lIns="0" tIns="0" rIns="0" bIns="0" anchor="t">
+          <a:bodyPr wrap="square" lIns="0" rIns="0" tIns="0" bIns="0" anchor="t">
             <a:spAutoFit/>
           </a:bodyPr>
           <a:lstStyle/>
@@ -5516,7 +5500,7 @@
           <a:noFill/>
         </p:spPr>
         <p:txBody>
-          <a:bodyPr wrap="square" lIns="0" tIns="0" rIns="0" bIns="0" anchor="t">
+          <a:bodyPr wrap="square" lIns="0" rIns="0" tIns="0" bIns="0" anchor="t">
             <a:spAutoFit/>
           </a:bodyPr>
           <a:lstStyle/>
@@ -5543,7 +5527,7 @@
 </file>
 
 <file path=ppt/slides/slide15.xml><?xml version="1.0" encoding="utf-8"?>
-<p:sld xmlns:a="http://schemas.openxmlformats.org/drawingml/2006/main" xmlns:r="http://schemas.openxmlformats.org/officeDocument/2006/relationships" xmlns:p="http://schemas.openxmlformats.org/presentationml/2006/main">
+<p:sld xmlns:a="http://schemas.openxmlformats.org/drawingml/2006/main" xmlns:p="http://schemas.openxmlformats.org/presentationml/2006/main" xmlns:r="http://schemas.openxmlformats.org/officeDocument/2006/relationships">
   <p:cSld>
     <p:spTree>
       <p:nvGrpSpPr>
@@ -5551,14 +5535,7 @@
         <p:cNvGrpSpPr/>
         <p:nvPr/>
       </p:nvGrpSpPr>
-      <p:grpSpPr>
-        <a:xfrm>
-          <a:off x="0" y="0"/>
-          <a:ext cx="0" cy="0"/>
-          <a:chOff x="0" y="0"/>
-          <a:chExt cx="0" cy="0"/>
-        </a:xfrm>
-      </p:grpSpPr>
+      <p:grpSpPr/>
       <p:pic>
         <p:nvPicPr>
           <p:cNvPr id="2" name="Picture 1" descr="_bg.png"/>
@@ -5649,13 +5626,12 @@
           <a:lstStyle/>
           <a:p>
             <a:pPr algn="ctr"/>
-            <a:endParaRPr/>
           </a:p>
         </p:txBody>
       </p:sp>
       <p:pic>
         <p:nvPicPr>
-          <p:cNvPr id="100" name="SpeakerPhoto"/>
+          <p:cNvPr id="5" name="Picture 4" descr="image.jpg"/>
           <p:cNvPicPr>
             <a:picLocks noChangeAspect="1"/>
           </p:cNvPicPr>
@@ -5663,20 +5639,17 @@
         </p:nvPicPr>
         <p:blipFill>
           <a:blip r:embed="rId4"/>
-          <a:srcRect/>
           <a:stretch>
             <a:fillRect/>
           </a:stretch>
         </p:blipFill>
         <p:spPr>
           <a:xfrm>
-            <a:off x="914400" y="1645920"/>
+            <a:off x="914400" y="2103120"/>
             <a:ext cx="3108960" cy="3108960"/>
           </a:xfrm>
-          <a:prstGeom prst="roundRect">
-            <a:avLst>
-              <a:gd name="adj" fmla="val 4000"/>
-            </a:avLst>
+          <a:prstGeom prst="rect">
+            <a:avLst/>
           </a:prstGeom>
         </p:spPr>
       </p:pic>
@@ -5720,7 +5693,6 @@
           <a:lstStyle/>
           <a:p>
             <a:pPr algn="ctr"/>
-            <a:endParaRPr/>
           </a:p>
         </p:txBody>
       </p:sp>
@@ -5741,7 +5713,7 @@
           <a:noFill/>
         </p:spPr>
         <p:txBody>
-          <a:bodyPr wrap="square" lIns="0" tIns="0" rIns="0" bIns="0" anchor="t">
+          <a:bodyPr wrap="square" lIns="0" rIns="0" tIns="0" bIns="0" anchor="t">
             <a:spAutoFit/>
           </a:bodyPr>
           <a:lstStyle/>
@@ -5776,7 +5748,7 @@
           <a:noFill/>
         </p:spPr>
         <p:txBody>
-          <a:bodyPr wrap="square" lIns="0" tIns="0" rIns="0" bIns="0" anchor="t">
+          <a:bodyPr wrap="square" lIns="0" rIns="0" tIns="0" bIns="0" anchor="t">
             <a:spAutoFit/>
           </a:bodyPr>
           <a:lstStyle/>
@@ -5811,7 +5783,7 @@
           <a:noFill/>
         </p:spPr>
         <p:txBody>
-          <a:bodyPr wrap="square" lIns="0" tIns="0" rIns="0" bIns="0" anchor="t">
+          <a:bodyPr wrap="square" lIns="0" rIns="0" tIns="0" bIns="0" anchor="t">
             <a:spAutoFit/>
           </a:bodyPr>
           <a:lstStyle/>
@@ -5846,7 +5818,9 @@
           <a:noFill/>
         </p:spPr>
         <p:txBody>
-          <a:bodyPr wrap="square" lIns="0" tIns="0" rIns="0" bIns="0" anchor="t"/>
+          <a:bodyPr wrap="square" lIns="0" rIns="0" tIns="0" bIns="0" anchor="t">
+            <a:spAutoFit/>
+          </a:bodyPr>
           <a:lstStyle/>
           <a:p>
             <a:pPr algn="l"/>
@@ -5879,7 +5853,7 @@
           <a:noFill/>
         </p:spPr>
         <p:txBody>
-          <a:bodyPr wrap="square" lIns="0" tIns="0" rIns="0" bIns="0" anchor="t">
+          <a:bodyPr wrap="square" lIns="0" rIns="0" tIns="0" bIns="0" anchor="t">
             <a:spAutoFit/>
           </a:bodyPr>
           <a:lstStyle/>
@@ -5914,7 +5888,7 @@
           <a:noFill/>
         </p:spPr>
         <p:txBody>
-          <a:bodyPr wrap="square" lIns="0" tIns="0" rIns="0" bIns="0" anchor="t">
+          <a:bodyPr wrap="square" lIns="0" rIns="0" tIns="0" bIns="0" anchor="t">
             <a:spAutoFit/>
           </a:bodyPr>
           <a:lstStyle/>
@@ -5949,7 +5923,7 @@
           <a:noFill/>
         </p:spPr>
         <p:txBody>
-          <a:bodyPr wrap="square" lIns="0" tIns="0" rIns="0" bIns="0" anchor="t">
+          <a:bodyPr wrap="square" lIns="0" rIns="0" tIns="0" bIns="0" anchor="t">
             <a:spAutoFit/>
           </a:bodyPr>
           <a:lstStyle/>
@@ -5976,7 +5950,7 @@
 </file>
 
 <file path=ppt/slides/slide16.xml><?xml version="1.0" encoding="utf-8"?>
-<p:sld xmlns:a="http://schemas.openxmlformats.org/drawingml/2006/main" xmlns:r="http://schemas.openxmlformats.org/officeDocument/2006/relationships" xmlns:p="http://schemas.openxmlformats.org/presentationml/2006/main">
+<p:sld xmlns:a="http://schemas.openxmlformats.org/drawingml/2006/main" xmlns:p="http://schemas.openxmlformats.org/presentationml/2006/main" xmlns:r="http://schemas.openxmlformats.org/officeDocument/2006/relationships">
   <p:cSld>
     <p:spTree>
       <p:nvGrpSpPr>
@@ -5984,14 +5958,7 @@
         <p:cNvGrpSpPr/>
         <p:nvPr/>
       </p:nvGrpSpPr>
-      <p:grpSpPr>
-        <a:xfrm>
-          <a:off x="0" y="0"/>
-          <a:ext cx="0" cy="0"/>
-          <a:chOff x="0" y="0"/>
-          <a:chExt cx="0" cy="0"/>
-        </a:xfrm>
-      </p:grpSpPr>
+      <p:grpSpPr/>
       <p:pic>
         <p:nvPicPr>
           <p:cNvPr id="2" name="Picture 1" descr="_bg.png"/>
@@ -6082,13 +6049,12 @@
           <a:lstStyle/>
           <a:p>
             <a:pPr algn="ctr"/>
-            <a:endParaRPr/>
           </a:p>
         </p:txBody>
       </p:sp>
       <p:pic>
         <p:nvPicPr>
-          <p:cNvPr id="100" name="SpeakerPhoto"/>
+          <p:cNvPr id="5" name="Picture 4" descr="image.jpg"/>
           <p:cNvPicPr>
             <a:picLocks noChangeAspect="1"/>
           </p:cNvPicPr>
@@ -6096,20 +6062,17 @@
         </p:nvPicPr>
         <p:blipFill>
           <a:blip r:embed="rId4"/>
-          <a:srcRect/>
           <a:stretch>
             <a:fillRect/>
           </a:stretch>
         </p:blipFill>
         <p:spPr>
           <a:xfrm>
-            <a:off x="914400" y="1645920"/>
+            <a:off x="914400" y="2103120"/>
             <a:ext cx="3108960" cy="3108960"/>
           </a:xfrm>
-          <a:prstGeom prst="roundRect">
-            <a:avLst>
-              <a:gd name="adj" fmla="val 4000"/>
-            </a:avLst>
+          <a:prstGeom prst="rect">
+            <a:avLst/>
           </a:prstGeom>
         </p:spPr>
       </p:pic>
@@ -6153,7 +6116,6 @@
           <a:lstStyle/>
           <a:p>
             <a:pPr algn="ctr"/>
-            <a:endParaRPr/>
           </a:p>
         </p:txBody>
       </p:sp>
@@ -6174,7 +6136,7 @@
           <a:noFill/>
         </p:spPr>
         <p:txBody>
-          <a:bodyPr wrap="square" lIns="0" tIns="0" rIns="0" bIns="0" anchor="t">
+          <a:bodyPr wrap="square" lIns="0" rIns="0" tIns="0" bIns="0" anchor="t">
             <a:spAutoFit/>
           </a:bodyPr>
           <a:lstStyle/>
@@ -6209,7 +6171,7 @@
           <a:noFill/>
         </p:spPr>
         <p:txBody>
-          <a:bodyPr wrap="square" lIns="0" tIns="0" rIns="0" bIns="0" anchor="t">
+          <a:bodyPr wrap="square" lIns="0" rIns="0" tIns="0" bIns="0" anchor="t">
             <a:spAutoFit/>
           </a:bodyPr>
           <a:lstStyle/>
@@ -6244,7 +6206,7 @@
           <a:noFill/>
         </p:spPr>
         <p:txBody>
-          <a:bodyPr wrap="square" lIns="0" tIns="0" rIns="0" bIns="0" anchor="t">
+          <a:bodyPr wrap="square" lIns="0" rIns="0" tIns="0" bIns="0" anchor="t">
             <a:spAutoFit/>
           </a:bodyPr>
           <a:lstStyle/>
@@ -6279,7 +6241,9 @@
           <a:noFill/>
         </p:spPr>
         <p:txBody>
-          <a:bodyPr wrap="square" lIns="0" tIns="0" rIns="0" bIns="0" anchor="t"/>
+          <a:bodyPr wrap="square" lIns="0" rIns="0" tIns="0" bIns="0" anchor="t">
+            <a:spAutoFit/>
+          </a:bodyPr>
           <a:lstStyle/>
           <a:p>
             <a:pPr algn="l"/>
@@ -6312,7 +6276,7 @@
           <a:noFill/>
         </p:spPr>
         <p:txBody>
-          <a:bodyPr wrap="square" lIns="0" tIns="0" rIns="0" bIns="0" anchor="t">
+          <a:bodyPr wrap="square" lIns="0" rIns="0" tIns="0" bIns="0" anchor="t">
             <a:spAutoFit/>
           </a:bodyPr>
           <a:lstStyle/>
@@ -6347,7 +6311,7 @@
           <a:noFill/>
         </p:spPr>
         <p:txBody>
-          <a:bodyPr wrap="square" lIns="0" tIns="0" rIns="0" bIns="0" anchor="t">
+          <a:bodyPr wrap="square" lIns="0" rIns="0" tIns="0" bIns="0" anchor="t">
             <a:spAutoFit/>
           </a:bodyPr>
           <a:lstStyle/>
@@ -6382,7 +6346,7 @@
           <a:noFill/>
         </p:spPr>
         <p:txBody>
-          <a:bodyPr wrap="square" lIns="0" tIns="0" rIns="0" bIns="0" anchor="t">
+          <a:bodyPr wrap="square" lIns="0" rIns="0" tIns="0" bIns="0" anchor="t">
             <a:spAutoFit/>
           </a:bodyPr>
           <a:lstStyle/>
@@ -8556,7 +8520,7 @@
         <p:spPr>
           <a:xfrm>
             <a:off x="4754880" y="3474720"/>
-            <a:ext cx="6858000" cy="2560320"/>
+            <a:ext cx="6858000" cy="2103120"/>
           </a:xfrm>
           <a:prstGeom prst="rect">
             <a:avLst/>
@@ -8571,7 +8535,7 @@
           <a:p>
             <a:pPr algn="l"/>
             <a:r>
-              <a:rPr sz="1800" b="0">
+              <a:rPr sz="1600" b="0">
                 <a:solidFill>
                   <a:srgbClr val="8888A0"/>
                 </a:solidFill>
@@ -8696,7 +8660,7 @@
 </file>
 
 <file path=ppt/slides/slide6.xml><?xml version="1.0" encoding="utf-8"?>
-<p:sld xmlns:a="http://schemas.openxmlformats.org/drawingml/2006/main" xmlns:r="http://schemas.openxmlformats.org/officeDocument/2006/relationships" xmlns:p="http://schemas.openxmlformats.org/presentationml/2006/main">
+<p:sld xmlns:a="http://schemas.openxmlformats.org/drawingml/2006/main" xmlns:p="http://schemas.openxmlformats.org/presentationml/2006/main" xmlns:r="http://schemas.openxmlformats.org/officeDocument/2006/relationships">
   <p:cSld>
     <p:spTree>
       <p:nvGrpSpPr>
@@ -8704,14 +8668,7 @@
         <p:cNvGrpSpPr/>
         <p:nvPr/>
       </p:nvGrpSpPr>
-      <p:grpSpPr>
-        <a:xfrm>
-          <a:off x="0" y="0"/>
-          <a:ext cx="0" cy="0"/>
-          <a:chOff x="0" y="0"/>
-          <a:chExt cx="0" cy="0"/>
-        </a:xfrm>
-      </p:grpSpPr>
+      <p:grpSpPr/>
       <p:pic>
         <p:nvPicPr>
           <p:cNvPr id="2" name="Picture 1" descr="_bg.png"/>
@@ -8802,13 +8759,12 @@
           <a:lstStyle/>
           <a:p>
             <a:pPr algn="ctr"/>
-            <a:endParaRPr/>
           </a:p>
         </p:txBody>
       </p:sp>
       <p:pic>
         <p:nvPicPr>
-          <p:cNvPr id="100" name="SpeakerPhoto"/>
+          <p:cNvPr id="5" name="Picture 4" descr="image.jpg"/>
           <p:cNvPicPr>
             <a:picLocks noChangeAspect="1"/>
           </p:cNvPicPr>
@@ -8816,20 +8772,17 @@
         </p:nvPicPr>
         <p:blipFill>
           <a:blip r:embed="rId4"/>
-          <a:srcRect/>
           <a:stretch>
             <a:fillRect/>
           </a:stretch>
         </p:blipFill>
         <p:spPr>
           <a:xfrm>
-            <a:off x="914400" y="1645920"/>
+            <a:off x="914400" y="2103120"/>
             <a:ext cx="3108960" cy="3108960"/>
           </a:xfrm>
-          <a:prstGeom prst="roundRect">
-            <a:avLst>
-              <a:gd name="adj" fmla="val 4000"/>
-            </a:avLst>
+          <a:prstGeom prst="rect">
+            <a:avLst/>
           </a:prstGeom>
         </p:spPr>
       </p:pic>
@@ -8873,7 +8826,6 @@
           <a:lstStyle/>
           <a:p>
             <a:pPr algn="ctr"/>
-            <a:endParaRPr/>
           </a:p>
         </p:txBody>
       </p:sp>
@@ -8894,7 +8846,7 @@
           <a:noFill/>
         </p:spPr>
         <p:txBody>
-          <a:bodyPr wrap="square" lIns="0" tIns="0" rIns="0" bIns="0" anchor="t">
+          <a:bodyPr wrap="square" lIns="0" rIns="0" tIns="0" bIns="0" anchor="t">
             <a:spAutoFit/>
           </a:bodyPr>
           <a:lstStyle/>
@@ -8929,7 +8881,7 @@
           <a:noFill/>
         </p:spPr>
         <p:txBody>
-          <a:bodyPr wrap="square" lIns="0" tIns="0" rIns="0" bIns="0" anchor="t">
+          <a:bodyPr wrap="square" lIns="0" rIns="0" tIns="0" bIns="0" anchor="t">
             <a:spAutoFit/>
           </a:bodyPr>
           <a:lstStyle/>
@@ -8942,7 +8894,7 @@
                 </a:solidFill>
                 <a:latin typeface="Inter"/>
               </a:rPr>
-              <a:t>Behnaz Karimi</a:t>
+              <a:t>Eleni Ioakeim</a:t>
             </a:r>
           </a:p>
         </p:txBody>
@@ -8964,7 +8916,7 @@
           <a:noFill/>
         </p:spPr>
         <p:txBody>
-          <a:bodyPr wrap="square" lIns="0" tIns="0" rIns="0" bIns="0" anchor="t">
+          <a:bodyPr wrap="square" lIns="0" rIns="0" tIns="0" bIns="0" anchor="t">
             <a:spAutoFit/>
           </a:bodyPr>
           <a:lstStyle/>
@@ -8977,7 +8929,7 @@
                 </a:solidFill>
                 <a:latin typeface="Inter"/>
               </a:rPr>
-              <a:t>Co-Lead / Leader AI Red Teaming OWASP AI Exchange and Founder RAID-AI Framework</a:t>
+              <a:t>Truesec, OT Threat Analyst</a:t>
             </a:r>
           </a:p>
         </p:txBody>
@@ -8999,7 +8951,9 @@
           <a:noFill/>
         </p:spPr>
         <p:txBody>
-          <a:bodyPr wrap="square" lIns="0" tIns="0" rIns="0" bIns="0" anchor="t"/>
+          <a:bodyPr wrap="square" lIns="0" rIns="0" tIns="0" bIns="0" anchor="t">
+            <a:spAutoFit/>
+          </a:bodyPr>
           <a:lstStyle/>
           <a:p>
             <a:pPr algn="l"/>
@@ -9010,7 +8964,7 @@
                 </a:solidFill>
                 <a:latin typeface="Inter"/>
               </a:rPr>
-              <a:t>Behnaz is an AI Security Researcher and the Founder/Creator of the RAID-AI Framework. She is also Co-Author, Co-Lead, and Leader of AI Red Teaming at OWASP AI Exchange, where she actively contributes to advancing security practices for AI systems.</a:t>
+              <a:t>Eleni is an OT Threat Analyst at Truesec SOC in Copenhagen, with expertise in OT network security monitoring. Her work contributes to improving SOC processes and detection capabilities for ICS environments.</a:t>
             </a:r>
           </a:p>
         </p:txBody>
@@ -9032,7 +8986,7 @@
           <a:noFill/>
         </p:spPr>
         <p:txBody>
-          <a:bodyPr wrap="square" lIns="0" tIns="0" rIns="0" bIns="0" anchor="t">
+          <a:bodyPr wrap="square" lIns="0" rIns="0" tIns="0" bIns="0" anchor="t">
             <a:spAutoFit/>
           </a:bodyPr>
           <a:lstStyle/>
@@ -9045,7 +8999,7 @@
                 </a:solidFill>
                 <a:latin typeface="JetBrains Mono"/>
               </a:rPr>
-              <a:t>linkedin.com/in/behnaz-karimi-behi  ·  substack.com/@behnazkarimi</a:t>
+              <a:t/>
             </a:r>
           </a:p>
         </p:txBody>
@@ -9067,7 +9021,7 @@
           <a:noFill/>
         </p:spPr>
         <p:txBody>
-          <a:bodyPr wrap="square" lIns="0" tIns="0" rIns="0" bIns="0" anchor="t">
+          <a:bodyPr wrap="square" lIns="0" rIns="0" tIns="0" bIns="0" anchor="t">
             <a:spAutoFit/>
           </a:bodyPr>
           <a:lstStyle/>
@@ -9102,7 +9056,7 @@
           <a:noFill/>
         </p:spPr>
         <p:txBody>
-          <a:bodyPr wrap="square" lIns="0" tIns="0" rIns="0" bIns="0" anchor="t">
+          <a:bodyPr wrap="square" lIns="0" rIns="0" tIns="0" bIns="0" anchor="t">
             <a:spAutoFit/>
           </a:bodyPr>
           <a:lstStyle/>
@@ -9129,7 +9083,7 @@
 </file>
 
 <file path=ppt/slides/slide7.xml><?xml version="1.0" encoding="utf-8"?>
-<p:sld xmlns:a="http://schemas.openxmlformats.org/drawingml/2006/main" xmlns:r="http://schemas.openxmlformats.org/officeDocument/2006/relationships" xmlns:p="http://schemas.openxmlformats.org/presentationml/2006/main">
+<p:sld xmlns:a="http://schemas.openxmlformats.org/drawingml/2006/main" xmlns:p="http://schemas.openxmlformats.org/presentationml/2006/main" xmlns:r="http://schemas.openxmlformats.org/officeDocument/2006/relationships">
   <p:cSld>
     <p:spTree>
       <p:nvGrpSpPr>
@@ -9137,14 +9091,7 @@
         <p:cNvGrpSpPr/>
         <p:nvPr/>
       </p:nvGrpSpPr>
-      <p:grpSpPr>
-        <a:xfrm>
-          <a:off x="0" y="0"/>
-          <a:ext cx="0" cy="0"/>
-          <a:chOff x="0" y="0"/>
-          <a:chExt cx="0" cy="0"/>
-        </a:xfrm>
-      </p:grpSpPr>
+      <p:grpSpPr/>
       <p:pic>
         <p:nvPicPr>
           <p:cNvPr id="2" name="Picture 1" descr="_bg.png"/>
@@ -9235,13 +9182,12 @@
           <a:lstStyle/>
           <a:p>
             <a:pPr algn="ctr"/>
-            <a:endParaRPr/>
           </a:p>
         </p:txBody>
       </p:sp>
       <p:pic>
         <p:nvPicPr>
-          <p:cNvPr id="100" name="SpeakerPhoto"/>
+          <p:cNvPr id="5" name="Picture 4" descr="image.jpg"/>
           <p:cNvPicPr>
             <a:picLocks noChangeAspect="1"/>
           </p:cNvPicPr>
@@ -9249,20 +9195,17 @@
         </p:nvPicPr>
         <p:blipFill>
           <a:blip r:embed="rId4"/>
-          <a:srcRect/>
           <a:stretch>
             <a:fillRect/>
           </a:stretch>
         </p:blipFill>
         <p:spPr>
           <a:xfrm>
-            <a:off x="914400" y="1645920"/>
+            <a:off x="914400" y="2103120"/>
             <a:ext cx="3108960" cy="3108960"/>
           </a:xfrm>
-          <a:prstGeom prst="roundRect">
-            <a:avLst>
-              <a:gd name="adj" fmla="val 4000"/>
-            </a:avLst>
+          <a:prstGeom prst="rect">
+            <a:avLst/>
           </a:prstGeom>
         </p:spPr>
       </p:pic>
@@ -9306,7 +9249,6 @@
           <a:lstStyle/>
           <a:p>
             <a:pPr algn="ctr"/>
-            <a:endParaRPr/>
           </a:p>
         </p:txBody>
       </p:sp>
@@ -9327,7 +9269,7 @@
           <a:noFill/>
         </p:spPr>
         <p:txBody>
-          <a:bodyPr wrap="square" lIns="0" tIns="0" rIns="0" bIns="0" anchor="t">
+          <a:bodyPr wrap="square" lIns="0" rIns="0" tIns="0" bIns="0" anchor="t">
             <a:spAutoFit/>
           </a:bodyPr>
           <a:lstStyle/>
@@ -9362,7 +9304,7 @@
           <a:noFill/>
         </p:spPr>
         <p:txBody>
-          <a:bodyPr wrap="square" lIns="0" tIns="0" rIns="0" bIns="0" anchor="t">
+          <a:bodyPr wrap="square" lIns="0" rIns="0" tIns="0" bIns="0" anchor="t">
             <a:spAutoFit/>
           </a:bodyPr>
           <a:lstStyle/>
@@ -9375,7 +9317,7 @@
                 </a:solidFill>
                 <a:latin typeface="Inter"/>
               </a:rPr>
-              <a:t>Bence Soóki-Tóth</a:t>
+              <a:t>Joost van Dijk</a:t>
             </a:r>
           </a:p>
         </p:txBody>
@@ -9397,7 +9339,7 @@
           <a:noFill/>
         </p:spPr>
         <p:txBody>
-          <a:bodyPr wrap="square" lIns="0" tIns="0" rIns="0" bIns="0" anchor="t">
+          <a:bodyPr wrap="square" lIns="0" rIns="0" tIns="0" bIns="0" anchor="t">
             <a:spAutoFit/>
           </a:bodyPr>
           <a:lstStyle/>
@@ -9410,7 +9352,7 @@
                 </a:solidFill>
                 <a:latin typeface="Inter"/>
               </a:rPr>
-              <a:t>Aarhus University, Master's Student</a:t>
+              <a:t>Developer Advocate at Yubico</a:t>
             </a:r>
           </a:p>
         </p:txBody>
@@ -9432,7 +9374,9 @@
           <a:noFill/>
         </p:spPr>
         <p:txBody>
-          <a:bodyPr wrap="square" lIns="0" tIns="0" rIns="0" bIns="0" anchor="t"/>
+          <a:bodyPr wrap="square" lIns="0" rIns="0" tIns="0" bIns="0" anchor="t">
+            <a:spAutoFit/>
+          </a:bodyPr>
           <a:lstStyle/>
           <a:p>
             <a:pPr algn="l"/>
@@ -9443,7 +9387,7 @@
                 </a:solidFill>
                 <a:latin typeface="Inter"/>
               </a:rPr>
-              <a:t>Bence is a Master's student at Aarhus University and a research assistant at Eötvös Loránd University, working at the intersection of cryptography, game theory, and consensus protocols.</a:t>
+              <a:t>Joost is a Developer Advocate at Yubico and a security and privacy professional with deep expertise in federated single sign-on, multi-factor authentication, FIDO, passkeys, PKI, TLS, and hardware security.</a:t>
             </a:r>
           </a:p>
         </p:txBody>
@@ -9465,7 +9409,7 @@
           <a:noFill/>
         </p:spPr>
         <p:txBody>
-          <a:bodyPr wrap="square" lIns="0" tIns="0" rIns="0" bIns="0" anchor="t">
+          <a:bodyPr wrap="square" lIns="0" rIns="0" tIns="0" bIns="0" anchor="t">
             <a:spAutoFit/>
           </a:bodyPr>
           <a:lstStyle/>
@@ -9478,7 +9422,7 @@
                 </a:solidFill>
                 <a:latin typeface="JetBrains Mono"/>
               </a:rPr>
-              <a:t>linkedin.com/in/stbence  ·  0xsooki.github.io</a:t>
+              <a:t>linkedin.com/in/joostd</a:t>
             </a:r>
           </a:p>
         </p:txBody>
@@ -9500,7 +9444,7 @@
           <a:noFill/>
         </p:spPr>
         <p:txBody>
-          <a:bodyPr wrap="square" lIns="0" tIns="0" rIns="0" bIns="0" anchor="t">
+          <a:bodyPr wrap="square" lIns="0" rIns="0" tIns="0" bIns="0" anchor="t">
             <a:spAutoFit/>
           </a:bodyPr>
           <a:lstStyle/>
@@ -9535,7 +9479,7 @@
           <a:noFill/>
         </p:spPr>
         <p:txBody>
-          <a:bodyPr wrap="square" lIns="0" tIns="0" rIns="0" bIns="0" anchor="t">
+          <a:bodyPr wrap="square" lIns="0" rIns="0" tIns="0" bIns="0" anchor="t">
             <a:spAutoFit/>
           </a:bodyPr>
           <a:lstStyle/>
@@ -9562,7 +9506,7 @@
 </file>
 
 <file path=ppt/slides/slide8.xml><?xml version="1.0" encoding="utf-8"?>
-<p:sld xmlns:a="http://schemas.openxmlformats.org/drawingml/2006/main" xmlns:r="http://schemas.openxmlformats.org/officeDocument/2006/relationships" xmlns:p="http://schemas.openxmlformats.org/presentationml/2006/main">
+<p:sld xmlns:a="http://schemas.openxmlformats.org/drawingml/2006/main" xmlns:p="http://schemas.openxmlformats.org/presentationml/2006/main" xmlns:r="http://schemas.openxmlformats.org/officeDocument/2006/relationships">
   <p:cSld>
     <p:spTree>
       <p:nvGrpSpPr>
@@ -9570,14 +9514,7 @@
         <p:cNvGrpSpPr/>
         <p:nvPr/>
       </p:nvGrpSpPr>
-      <p:grpSpPr>
-        <a:xfrm>
-          <a:off x="0" y="0"/>
-          <a:ext cx="0" cy="0"/>
-          <a:chOff x="0" y="0"/>
-          <a:chExt cx="0" cy="0"/>
-        </a:xfrm>
-      </p:grpSpPr>
+      <p:grpSpPr/>
       <p:pic>
         <p:nvPicPr>
           <p:cNvPr id="2" name="Picture 1" descr="_bg.png"/>
@@ -9668,13 +9605,12 @@
           <a:lstStyle/>
           <a:p>
             <a:pPr algn="ctr"/>
-            <a:endParaRPr/>
           </a:p>
         </p:txBody>
       </p:sp>
       <p:pic>
         <p:nvPicPr>
-          <p:cNvPr id="100" name="SpeakerPhoto"/>
+          <p:cNvPr id="5" name="Picture 4" descr="image.jpg"/>
           <p:cNvPicPr>
             <a:picLocks noChangeAspect="1"/>
           </p:cNvPicPr>
@@ -9682,20 +9618,17 @@
         </p:nvPicPr>
         <p:blipFill>
           <a:blip r:embed="rId4"/>
-          <a:srcRect/>
           <a:stretch>
             <a:fillRect/>
           </a:stretch>
         </p:blipFill>
         <p:spPr>
           <a:xfrm>
-            <a:off x="914400" y="1645920"/>
+            <a:off x="914400" y="2103120"/>
             <a:ext cx="3108960" cy="3108960"/>
           </a:xfrm>
-          <a:prstGeom prst="roundRect">
-            <a:avLst>
-              <a:gd name="adj" fmla="val 4000"/>
-            </a:avLst>
+          <a:prstGeom prst="rect">
+            <a:avLst/>
           </a:prstGeom>
         </p:spPr>
       </p:pic>
@@ -9739,7 +9672,6 @@
           <a:lstStyle/>
           <a:p>
             <a:pPr algn="ctr"/>
-            <a:endParaRPr/>
           </a:p>
         </p:txBody>
       </p:sp>
@@ -9760,7 +9692,7 @@
           <a:noFill/>
         </p:spPr>
         <p:txBody>
-          <a:bodyPr wrap="square" lIns="0" tIns="0" rIns="0" bIns="0" anchor="t">
+          <a:bodyPr wrap="square" lIns="0" rIns="0" tIns="0" bIns="0" anchor="t">
             <a:spAutoFit/>
           </a:bodyPr>
           <a:lstStyle/>
@@ -9795,7 +9727,7 @@
           <a:noFill/>
         </p:spPr>
         <p:txBody>
-          <a:bodyPr wrap="square" lIns="0" tIns="0" rIns="0" bIns="0" anchor="t">
+          <a:bodyPr wrap="square" lIns="0" rIns="0" tIns="0" bIns="0" anchor="t">
             <a:spAutoFit/>
           </a:bodyPr>
           <a:lstStyle/>
@@ -9808,7 +9740,7 @@
                 </a:solidFill>
                 <a:latin typeface="Inter"/>
               </a:rPr>
-              <a:t>Bleon Proko</a:t>
+              <a:t>Martin Sohn Christensen</a:t>
             </a:r>
           </a:p>
         </p:txBody>
@@ -9830,7 +9762,7 @@
           <a:noFill/>
         </p:spPr>
         <p:txBody>
-          <a:bodyPr wrap="square" lIns="0" tIns="0" rIns="0" bIns="0" anchor="t">
+          <a:bodyPr wrap="square" lIns="0" rIns="0" tIns="0" bIns="0" anchor="t">
             <a:spAutoFit/>
           </a:bodyPr>
           <a:lstStyle/>
@@ -9843,7 +9775,7 @@
                 </a:solidFill>
                 <a:latin typeface="Inter"/>
               </a:rPr>
-              <a:t>Cloud Security Researcher</a:t>
+              <a:t>Security Researcher @ SpecterOps</a:t>
             </a:r>
           </a:p>
         </p:txBody>
@@ -9865,7 +9797,9 @@
           <a:noFill/>
         </p:spPr>
         <p:txBody>
-          <a:bodyPr wrap="square" lIns="0" tIns="0" rIns="0" bIns="0" anchor="t"/>
+          <a:bodyPr wrap="square" lIns="0" rIns="0" tIns="0" bIns="0" anchor="t">
+            <a:spAutoFit/>
+          </a:bodyPr>
           <a:lstStyle/>
           <a:p>
             <a:pPr algn="l"/>
@@ -9876,7 +9810,7 @@
                 </a:solidFill>
                 <a:latin typeface="Inter"/>
               </a:rPr>
-              <a:t>Bleon is a Senior Security Researcher at Exaforce, passionate about Infrastructure Penetration Testing and Security across Active Directory, Cloud (AWS, Azure, GCP, Digital Ocean) and hybrid infrastructures, as well as defense, detection, and threat hunting. He has presented Cloud Penetration Testing and Security topics at conferences including Black Hat USA, Europe and Sector, DEF CON, SANS Pentest Hackfest Hollywood and Amsterdam, and several BSides events in the US and Europe.</a:t>
+              <a:t>Martin is a Security Researcher at SpecterOps in Copenhagen, specializing in Microsoft technologies with expertise in Active Directory, identity attack paths, and secure system configuration. His perspective on security risks and challenges is shaped by a background spanning system administration, an information security degree, and information security consultancy. He is a frequent contributor to the community through online engagement and talks.</a:t>
             </a:r>
           </a:p>
         </p:txBody>
@@ -9898,7 +9832,7 @@
           <a:noFill/>
         </p:spPr>
         <p:txBody>
-          <a:bodyPr wrap="square" lIns="0" tIns="0" rIns="0" bIns="0" anchor="t">
+          <a:bodyPr wrap="square" lIns="0" rIns="0" tIns="0" bIns="0" anchor="t">
             <a:spAutoFit/>
           </a:bodyPr>
           <a:lstStyle/>
@@ -9911,7 +9845,7 @@
                 </a:solidFill>
                 <a:latin typeface="JetBrains Mono"/>
               </a:rPr>
-              <a:t>linkedin.com/in/bleon-p-9b2734143  ·  blog.pepperclipp.com</a:t>
+              <a:t>linkedin.com/in/martinsohn  ·  martinsohn.dk</a:t>
             </a:r>
           </a:p>
         </p:txBody>
@@ -9933,7 +9867,7 @@
           <a:noFill/>
         </p:spPr>
         <p:txBody>
-          <a:bodyPr wrap="square" lIns="0" tIns="0" rIns="0" bIns="0" anchor="t">
+          <a:bodyPr wrap="square" lIns="0" rIns="0" tIns="0" bIns="0" anchor="t">
             <a:spAutoFit/>
           </a:bodyPr>
           <a:lstStyle/>
@@ -9968,7 +9902,7 @@
           <a:noFill/>
         </p:spPr>
         <p:txBody>
-          <a:bodyPr wrap="square" lIns="0" tIns="0" rIns="0" bIns="0" anchor="t">
+          <a:bodyPr wrap="square" lIns="0" rIns="0" tIns="0" bIns="0" anchor="t">
             <a:spAutoFit/>
           </a:bodyPr>
           <a:lstStyle/>
@@ -9995,7 +9929,7 @@
 </file>
 
 <file path=ppt/slides/slide9.xml><?xml version="1.0" encoding="utf-8"?>
-<p:sld xmlns:a="http://schemas.openxmlformats.org/drawingml/2006/main" xmlns:r="http://schemas.openxmlformats.org/officeDocument/2006/relationships" xmlns:p="http://schemas.openxmlformats.org/presentationml/2006/main">
+<p:sld xmlns:a="http://schemas.openxmlformats.org/drawingml/2006/main" xmlns:p="http://schemas.openxmlformats.org/presentationml/2006/main" xmlns:r="http://schemas.openxmlformats.org/officeDocument/2006/relationships">
   <p:cSld>
     <p:spTree>
       <p:nvGrpSpPr>
@@ -10003,14 +9937,7 @@
         <p:cNvGrpSpPr/>
         <p:nvPr/>
       </p:nvGrpSpPr>
-      <p:grpSpPr>
-        <a:xfrm>
-          <a:off x="0" y="0"/>
-          <a:ext cx="0" cy="0"/>
-          <a:chOff x="0" y="0"/>
-          <a:chExt cx="0" cy="0"/>
-        </a:xfrm>
-      </p:grpSpPr>
+      <p:grpSpPr/>
       <p:pic>
         <p:nvPicPr>
           <p:cNvPr id="2" name="Picture 1" descr="_bg.png"/>
@@ -10101,13 +10028,12 @@
           <a:lstStyle/>
           <a:p>
             <a:pPr algn="ctr"/>
-            <a:endParaRPr/>
           </a:p>
         </p:txBody>
       </p:sp>
       <p:pic>
         <p:nvPicPr>
-          <p:cNvPr id="100" name="SpeakerPhoto"/>
+          <p:cNvPr id="5" name="Picture 4" descr="image.jpg"/>
           <p:cNvPicPr>
             <a:picLocks noChangeAspect="1"/>
           </p:cNvPicPr>
@@ -10115,20 +10041,17 @@
         </p:nvPicPr>
         <p:blipFill>
           <a:blip r:embed="rId4"/>
-          <a:srcRect/>
           <a:stretch>
             <a:fillRect/>
           </a:stretch>
         </p:blipFill>
         <p:spPr>
           <a:xfrm>
-            <a:off x="914400" y="1645920"/>
+            <a:off x="914400" y="2103120"/>
             <a:ext cx="3108960" cy="3108960"/>
           </a:xfrm>
-          <a:prstGeom prst="roundRect">
-            <a:avLst>
-              <a:gd name="adj" fmla="val 4000"/>
-            </a:avLst>
+          <a:prstGeom prst="rect">
+            <a:avLst/>
           </a:prstGeom>
         </p:spPr>
       </p:pic>
@@ -10172,7 +10095,6 @@
           <a:lstStyle/>
           <a:p>
             <a:pPr algn="ctr"/>
-            <a:endParaRPr/>
           </a:p>
         </p:txBody>
       </p:sp>
@@ -10193,7 +10115,7 @@
           <a:noFill/>
         </p:spPr>
         <p:txBody>
-          <a:bodyPr wrap="square" lIns="0" tIns="0" rIns="0" bIns="0" anchor="t">
+          <a:bodyPr wrap="square" lIns="0" rIns="0" tIns="0" bIns="0" anchor="t">
             <a:spAutoFit/>
           </a:bodyPr>
           <a:lstStyle/>
@@ -10228,7 +10150,7 @@
           <a:noFill/>
         </p:spPr>
         <p:txBody>
-          <a:bodyPr wrap="square" lIns="0" tIns="0" rIns="0" bIns="0" anchor="t">
+          <a:bodyPr wrap="square" lIns="0" rIns="0" tIns="0" bIns="0" anchor="t">
             <a:spAutoFit/>
           </a:bodyPr>
           <a:lstStyle/>
@@ -10241,7 +10163,7 @@
                 </a:solidFill>
                 <a:latin typeface="Inter"/>
               </a:rPr>
-              <a:t>Eleni Ioakeim</a:t>
+              <a:t>Marvin Ngoma</a:t>
             </a:r>
           </a:p>
         </p:txBody>
@@ -10263,7 +10185,7 @@
           <a:noFill/>
         </p:spPr>
         <p:txBody>
-          <a:bodyPr wrap="square" lIns="0" tIns="0" rIns="0" bIns="0" anchor="t">
+          <a:bodyPr wrap="square" lIns="0" rIns="0" tIns="0" bIns="0" anchor="t">
             <a:spAutoFit/>
           </a:bodyPr>
           <a:lstStyle/>
@@ -10276,7 +10198,7 @@
                 </a:solidFill>
                 <a:latin typeface="Inter"/>
               </a:rPr>
-              <a:t>Truesec, OT Threat Analyst</a:t>
+              <a:t>Elastic, Principal Security Architect, Security Evangelist</a:t>
             </a:r>
           </a:p>
         </p:txBody>
@@ -10298,7 +10220,9 @@
           <a:noFill/>
         </p:spPr>
         <p:txBody>
-          <a:bodyPr wrap="square" lIns="0" tIns="0" rIns="0" bIns="0" anchor="t"/>
+          <a:bodyPr wrap="square" lIns="0" rIns="0" tIns="0" bIns="0" anchor="t">
+            <a:spAutoFit/>
+          </a:bodyPr>
           <a:lstStyle/>
           <a:p>
             <a:pPr algn="l"/>
@@ -10309,7 +10233,7 @@
                 </a:solidFill>
                 <a:latin typeface="Inter"/>
               </a:rPr>
-              <a:t>Eleni is an OT Threat Analyst at Truesec SOC in Copenhagen, with expertise in OT network security monitoring. Her work contributes to improving SOC processes and detection capabilities for ICS environments.</a:t>
+              <a:t>Marvin is a Principal Security Architect and Security Evangelist at Elastic, and a seasoned consultant with a strong passion for helping organizations succeed in their cybersecurity programs. He has led many projects in both the private and public sectors — architecting and building Security Operations and Intelligence capabilities, and unifying tools, processes, and people. Before Elastic, he was a security consultant at IBM and the primary SME for QRadar in the Nordics.</a:t>
             </a:r>
           </a:p>
         </p:txBody>
@@ -10331,7 +10255,7 @@
           <a:noFill/>
         </p:spPr>
         <p:txBody>
-          <a:bodyPr wrap="square" lIns="0" tIns="0" rIns="0" bIns="0" anchor="t">
+          <a:bodyPr wrap="square" lIns="0" rIns="0" tIns="0" bIns="0" anchor="t">
             <a:spAutoFit/>
           </a:bodyPr>
           <a:lstStyle/>
@@ -10344,7 +10268,7 @@
                 </a:solidFill>
                 <a:latin typeface="JetBrains Mono"/>
               </a:rPr>
-              <a:t/>
+              <a:t>linkedin.com/in/tyolani  ·  www.elastic.co/blog/author/marvin-ngoma</a:t>
             </a:r>
           </a:p>
         </p:txBody>
@@ -10366,7 +10290,7 @@
           <a:noFill/>
         </p:spPr>
         <p:txBody>
-          <a:bodyPr wrap="square" lIns="0" tIns="0" rIns="0" bIns="0" anchor="t">
+          <a:bodyPr wrap="square" lIns="0" rIns="0" tIns="0" bIns="0" anchor="t">
             <a:spAutoFit/>
           </a:bodyPr>
           <a:lstStyle/>
@@ -10401,7 +10325,7 @@
           <a:noFill/>
         </p:spPr>
         <p:txBody>
-          <a:bodyPr wrap="square" lIns="0" tIns="0" rIns="0" bIns="0" anchor="t">
+          <a:bodyPr wrap="square" lIns="0" rIns="0" tIns="0" bIns="0" anchor="t">
             <a:spAutoFit/>
           </a:bodyPr>
           <a:lstStyle/>

</xml_diff>

<commit_message>
fix: adjust Discord QR code position and size in agenda slide
</commit_message>
<xml_diff>
--- a/Plans/template-output/bsides-aarhus-2026-template.pptx
+++ b/Plans/template-output/bsides-aarhus-2026-template.pptx
@@ -122,7 +122,7 @@
   <p:extLst>
     <p:ext uri="{521415D9-36F7-43E2-AB2F-B90AF26B5E84}">
       <p14:sectionLst xmlns:p14="http://schemas.microsoft.com/office/powerpoint/2010/main">
-        <p14:section name="Template" id="{F0F12564-39C5-48AF-8619-279E66EDD251}">
+        <p14:section name="Template" id="{79EFF6C4-89BC-4219-B07A-8FA9531E2281}">
           <p14:sldIdLst>
             <p14:sldId id="256"/>
             <p14:sldId id="257"/>
@@ -131,7 +131,7 @@
             <p14:sldId id="260"/>
           </p14:sldIdLst>
         </p14:section>
-        <p14:section name="Track 1" id="{36614270-8D9D-4A04-B030-25B8D08768D2}">
+        <p14:section name="Track 1" id="{15C4B4F6-1C9D-43A4-997C-B010C257DCB1}">
           <p14:sldIdLst>
             <p14:sldId id="261"/>
             <p14:sldId id="262"/>
@@ -140,7 +140,7 @@
             <p14:sldId id="265"/>
           </p14:sldIdLst>
         </p14:section>
-        <p14:section name="Track 2" id="{F0A0241F-90C1-46C2-9E06-C62277F55D53}">
+        <p14:section name="Track 2" id="{0EBCB2A8-7096-4D76-8C8B-EE9EFACF99E8}">
           <p14:sldIdLst>
             <p14:sldId id="266"/>
             <p14:sldId id="267"/>
@@ -6551,8 +6551,8 @@
         </p:nvSpPr>
         <p:spPr>
           <a:xfrm>
-            <a:off x="10488168" y="429768"/>
-            <a:ext cx="1243584" cy="1243584"/>
+            <a:off x="10012680" y="429768"/>
+            <a:ext cx="1700784" cy="1700784"/>
           </a:xfrm>
           <a:prstGeom prst="roundRect">
             <a:avLst>
@@ -6604,8 +6604,8 @@
         </p:blipFill>
         <p:spPr>
           <a:xfrm>
-            <a:off x="10561320" y="502920"/>
-            <a:ext cx="1097280" cy="1097280"/>
+            <a:off x="10085832" y="502920"/>
+            <a:ext cx="1554480" cy="1554480"/>
           </a:xfrm>
           <a:prstGeom prst="rect">
             <a:avLst/>
@@ -6620,8 +6620,8 @@
         </p:nvSpPr>
         <p:spPr>
           <a:xfrm>
-            <a:off x="9098280" y="548640"/>
-            <a:ext cx="1371600" cy="274320"/>
+            <a:off x="8119872" y="548640"/>
+            <a:ext cx="1645920" cy="274320"/>
           </a:xfrm>
           <a:prstGeom prst="rect">
             <a:avLst/>
@@ -6655,8 +6655,8 @@
         </p:nvSpPr>
         <p:spPr>
           <a:xfrm>
-            <a:off x="9098280" y="822960"/>
-            <a:ext cx="1371600" cy="822960"/>
+            <a:off x="8119872" y="822960"/>
+            <a:ext cx="1645920" cy="822960"/>
           </a:xfrm>
           <a:prstGeom prst="rect">
             <a:avLst/>

</xml_diff>

<commit_message>
fix: update session times for Post-Quantum Cryptography and Ransomware in schedule
</commit_message>
<xml_diff>
--- a/Plans/template-output/bsides-aarhus-2026-template.pptx
+++ b/Plans/template-output/bsides-aarhus-2026-template.pptx
@@ -20,7 +20,6 @@
     <p:sldId id="268" r:id="rId19"/>
     <p:sldId id="269" r:id="rId20"/>
     <p:sldId id="270" r:id="rId21"/>
-    <p:sldId id="271" r:id="rId22"/>
   </p:sldIdLst>
   <p:sldSz cx="12191695" cy="6858000" type="screen4x3"/>
   <p:notesSz cx="6858000" cy="9144000"/>
@@ -122,7 +121,7 @@
   <p:extLst>
     <p:ext uri="{521415D9-36F7-43E2-AB2F-B90AF26B5E84}">
       <p14:sectionLst xmlns:p14="http://schemas.microsoft.com/office/powerpoint/2010/main">
-        <p14:section name="Template" id="{79EFF6C4-89BC-4219-B07A-8FA9531E2281}">
+        <p14:section name="Template" id="{775CAB82-98D7-4A8E-BA16-157722E20189}">
           <p14:sldIdLst>
             <p14:sldId id="256"/>
             <p14:sldId id="257"/>
@@ -131,7 +130,7 @@
             <p14:sldId id="260"/>
           </p14:sldIdLst>
         </p14:section>
-        <p14:section name="Track 1" id="{15C4B4F6-1C9D-43A4-997C-B010C257DCB1}">
+        <p14:section name="Track 1" id="{F9E55C75-2AE8-443D-99BC-22825B4FCBAD}">
           <p14:sldIdLst>
             <p14:sldId id="261"/>
             <p14:sldId id="262"/>
@@ -140,14 +139,13 @@
             <p14:sldId id="265"/>
           </p14:sldIdLst>
         </p14:section>
-        <p14:section name="Track 2" id="{0EBCB2A8-7096-4D76-8C8B-EE9EFACF99E8}">
+        <p14:section name="Track 2" id="{5138053A-7EA0-40C8-8707-61DA22ABB877}">
           <p14:sldIdLst>
             <p14:sldId id="266"/>
             <p14:sldId id="267"/>
             <p14:sldId id="268"/>
             <p14:sldId id="269"/>
             <p14:sldId id="270"/>
-            <p14:sldId id="271"/>
           </p14:sldIdLst>
         </p14:section>
       </p14:sectionLst>
@@ -3408,6 +3406,18 @@
   <p:clrMapOvr>
     <a:masterClrMapping/>
   </p:clrMapOvr>
+  <mc:AlternateContent xmlns:mc="http://schemas.openxmlformats.org/markup-compatibility/2006">
+    <mc:Choice xmlns:p14="http://schemas.microsoft.com/office/powerpoint/2010/main" Requires="p14">
+      <p:transition spd="med" p14:dur="700">
+        <p:fade/>
+      </p:transition>
+    </mc:Choice>
+    <mc:Fallback>
+      <p:transition spd="med">
+        <p:fade/>
+      </p:transition>
+    </mc:Fallback>
+  </mc:AlternateContent>
 </p:sld>
 </file>
 
@@ -3831,6 +3841,18 @@
   <p:clrMapOvr>
     <a:masterClrMapping/>
   </p:clrMapOvr>
+  <mc:AlternateContent xmlns:mc="http://schemas.openxmlformats.org/markup-compatibility/2006">
+    <mc:Choice xmlns:p14="http://schemas.microsoft.com/office/powerpoint/2010/main" Requires="p14">
+      <p:transition spd="med" p14:dur="700">
+        <p:fade/>
+      </p:transition>
+    </mc:Choice>
+    <mc:Fallback>
+      <p:transition spd="med">
+        <p:fade/>
+      </p:transition>
+    </mc:Fallback>
+  </mc:AlternateContent>
 </p:sld>
 </file>
 
@@ -4254,6 +4276,18 @@
   <p:clrMapOvr>
     <a:masterClrMapping/>
   </p:clrMapOvr>
+  <mc:AlternateContent xmlns:mc="http://schemas.openxmlformats.org/markup-compatibility/2006">
+    <mc:Choice xmlns:p14="http://schemas.microsoft.com/office/powerpoint/2010/main" Requires="p14">
+      <p:transition spd="med" p14:dur="700">
+        <p:fade/>
+      </p:transition>
+    </mc:Choice>
+    <mc:Fallback>
+      <p:transition spd="med">
+        <p:fade/>
+      </p:transition>
+    </mc:Fallback>
+  </mc:AlternateContent>
 </p:sld>
 </file>
 
@@ -4677,6 +4711,18 @@
   <p:clrMapOvr>
     <a:masterClrMapping/>
   </p:clrMapOvr>
+  <mc:AlternateContent xmlns:mc="http://schemas.openxmlformats.org/markup-compatibility/2006">
+    <mc:Choice xmlns:p14="http://schemas.microsoft.com/office/powerpoint/2010/main" Requires="p14">
+      <p:transition spd="med" p14:dur="700">
+        <p:fade/>
+      </p:transition>
+    </mc:Choice>
+    <mc:Fallback>
+      <p:transition spd="med">
+        <p:fade/>
+      </p:transition>
+    </mc:Fallback>
+  </mc:AlternateContent>
 </p:sld>
 </file>
 
@@ -5100,6 +5146,18 @@
   <p:clrMapOvr>
     <a:masterClrMapping/>
   </p:clrMapOvr>
+  <mc:AlternateContent xmlns:mc="http://schemas.openxmlformats.org/markup-compatibility/2006">
+    <mc:Choice xmlns:p14="http://schemas.microsoft.com/office/powerpoint/2010/main" Requires="p14">
+      <p:transition spd="med" p14:dur="700">
+        <p:fade/>
+      </p:transition>
+    </mc:Choice>
+    <mc:Fallback>
+      <p:transition spd="med">
+        <p:fade/>
+      </p:transition>
+    </mc:Fallback>
+  </mc:AlternateContent>
 </p:sld>
 </file>
 
@@ -5523,6 +5581,18 @@
   <p:clrMapOvr>
     <a:masterClrMapping/>
   </p:clrMapOvr>
+  <mc:AlternateContent xmlns:mc="http://schemas.openxmlformats.org/markup-compatibility/2006">
+    <mc:Choice xmlns:p14="http://schemas.microsoft.com/office/powerpoint/2010/main" Requires="p14">
+      <p:transition spd="med" p14:dur="700">
+        <p:fade/>
+      </p:transition>
+    </mc:Choice>
+    <mc:Fallback>
+      <p:transition spd="med">
+        <p:fade/>
+      </p:transition>
+    </mc:Fallback>
+  </mc:AlternateContent>
 </p:sld>
 </file>
 
@@ -5946,429 +6016,18 @@
   <p:clrMapOvr>
     <a:masterClrMapping/>
   </p:clrMapOvr>
-</p:sld>
-</file>
-
-<file path=ppt/slides/slide16.xml><?xml version="1.0" encoding="utf-8"?>
-<p:sld xmlns:a="http://schemas.openxmlformats.org/drawingml/2006/main" xmlns:p="http://schemas.openxmlformats.org/presentationml/2006/main" xmlns:r="http://schemas.openxmlformats.org/officeDocument/2006/relationships">
-  <p:cSld>
-    <p:spTree>
-      <p:nvGrpSpPr>
-        <p:cNvPr id="1" name=""/>
-        <p:cNvGrpSpPr/>
-        <p:nvPr/>
-      </p:nvGrpSpPr>
-      <p:grpSpPr/>
-      <p:pic>
-        <p:nvPicPr>
-          <p:cNvPr id="2" name="Picture 1" descr="_bg.png"/>
-          <p:cNvPicPr>
-            <a:picLocks noChangeAspect="1"/>
-          </p:cNvPicPr>
-          <p:nvPr/>
-        </p:nvPicPr>
-        <p:blipFill>
-          <a:blip r:embed="rId2"/>
-          <a:stretch>
-            <a:fillRect/>
-          </a:stretch>
-        </p:blipFill>
-        <p:spPr>
-          <a:xfrm>
-            <a:off x="0" y="0"/>
-            <a:ext cx="12191695" cy="6858000"/>
-          </a:xfrm>
-          <a:prstGeom prst="rect">
-            <a:avLst/>
-          </a:prstGeom>
-        </p:spPr>
-      </p:pic>
-      <p:pic>
-        <p:nvPicPr>
-          <p:cNvPr id="3" name="Picture 2" descr="logo.png"/>
-          <p:cNvPicPr>
-            <a:picLocks noChangeAspect="1"/>
-          </p:cNvPicPr>
-          <p:nvPr/>
-        </p:nvPicPr>
-        <p:blipFill>
-          <a:blip r:embed="rId3"/>
-          <a:stretch>
-            <a:fillRect/>
-          </a:stretch>
-        </p:blipFill>
-        <p:spPr>
-          <a:xfrm>
-            <a:off x="548640" y="457200"/>
-            <a:ext cx="617838" cy="457200"/>
-          </a:xfrm>
-          <a:prstGeom prst="rect">
-            <a:avLst/>
-          </a:prstGeom>
-        </p:spPr>
-      </p:pic>
-      <p:sp>
-        <p:nvSpPr>
-          <p:cNvPr id="4" name="Rounded Rectangle 3"/>
-          <p:cNvSpPr/>
-          <p:nvPr/>
-        </p:nvSpPr>
-        <p:spPr>
-          <a:xfrm>
-            <a:off x="548640" y="1463040"/>
-            <a:ext cx="3840480" cy="4389120"/>
-          </a:xfrm>
-          <a:prstGeom prst="roundRect">
-            <a:avLst>
-              <a:gd name="adj" fmla="val 4000"/>
-            </a:avLst>
-          </a:prstGeom>
-          <a:solidFill>
-            <a:srgbClr val="1A1A25"/>
-          </a:solidFill>
-          <a:ln>
-            <a:noFill/>
-          </a:ln>
-        </p:spPr>
-        <p:style>
-          <a:lnRef idx="1">
-            <a:schemeClr val="accent1"/>
-          </a:lnRef>
-          <a:fillRef idx="3">
-            <a:schemeClr val="accent1"/>
-          </a:fillRef>
-          <a:effectRef idx="2">
-            <a:schemeClr val="accent1"/>
-          </a:effectRef>
-          <a:fontRef idx="minor">
-            <a:schemeClr val="lt1"/>
-          </a:fontRef>
-        </p:style>
-        <p:txBody>
-          <a:bodyPr rtlCol="0" anchor="ctr"/>
-          <a:lstStyle/>
-          <a:p>
-            <a:pPr algn="ctr"/>
-          </a:p>
-        </p:txBody>
-      </p:sp>
-      <p:pic>
-        <p:nvPicPr>
-          <p:cNvPr id="5" name="Picture 4" descr="image.jpg"/>
-          <p:cNvPicPr>
-            <a:picLocks noChangeAspect="1"/>
-          </p:cNvPicPr>
-          <p:nvPr/>
-        </p:nvPicPr>
-        <p:blipFill>
-          <a:blip r:embed="rId4"/>
-          <a:stretch>
-            <a:fillRect/>
-          </a:stretch>
-        </p:blipFill>
-        <p:spPr>
-          <a:xfrm>
-            <a:off x="914400" y="2103120"/>
-            <a:ext cx="3108960" cy="3108960"/>
-          </a:xfrm>
-          <a:prstGeom prst="rect">
-            <a:avLst/>
-          </a:prstGeom>
-        </p:spPr>
-      </p:pic>
-      <p:sp>
-        <p:nvSpPr>
-          <p:cNvPr id="6" name="Rectangle 5"/>
-          <p:cNvSpPr/>
-          <p:nvPr/>
-        </p:nvSpPr>
-        <p:spPr>
-          <a:xfrm>
-            <a:off x="4754880" y="1371600"/>
-            <a:ext cx="640080" cy="38100"/>
-          </a:xfrm>
-          <a:prstGeom prst="rect">
-            <a:avLst/>
-          </a:prstGeom>
-          <a:solidFill>
-            <a:srgbClr val="4AB8D2"/>
-          </a:solidFill>
-          <a:ln>
-            <a:noFill/>
-          </a:ln>
-        </p:spPr>
-        <p:style>
-          <a:lnRef idx="1">
-            <a:schemeClr val="accent1"/>
-          </a:lnRef>
-          <a:fillRef idx="3">
-            <a:schemeClr val="accent1"/>
-          </a:fillRef>
-          <a:effectRef idx="2">
-            <a:schemeClr val="accent1"/>
-          </a:effectRef>
-          <a:fontRef idx="minor">
-            <a:schemeClr val="lt1"/>
-          </a:fontRef>
-        </p:style>
-        <p:txBody>
-          <a:bodyPr rtlCol="0" anchor="ctr"/>
-          <a:lstStyle/>
-          <a:p>
-            <a:pPr algn="ctr"/>
-          </a:p>
-        </p:txBody>
-      </p:sp>
-      <p:sp>
-        <p:nvSpPr>
-          <p:cNvPr id="7" name="TextBox 6"/>
-          <p:cNvSpPr txBox="1"/>
-          <p:nvPr/>
-        </p:nvSpPr>
-        <p:spPr>
-          <a:xfrm>
-            <a:off x="4754880" y="1508760"/>
-            <a:ext cx="6858000" cy="365760"/>
-          </a:xfrm>
-          <a:prstGeom prst="rect">
-            <a:avLst/>
-          </a:prstGeom>
-          <a:noFill/>
-        </p:spPr>
-        <p:txBody>
-          <a:bodyPr wrap="square" lIns="0" rIns="0" tIns="0" bIns="0" anchor="t">
-            <a:spAutoFit/>
-          </a:bodyPr>
-          <a:lstStyle/>
-          <a:p>
-            <a:pPr algn="l"/>
-            <a:r>
-              <a:rPr sz="1400" b="1">
-                <a:solidFill>
-                  <a:srgbClr val="4AB8D2"/>
-                </a:solidFill>
-                <a:latin typeface="JetBrains Mono"/>
-              </a:rPr>
-              <a:t>SPEAKER</a:t>
-            </a:r>
-          </a:p>
-        </p:txBody>
-      </p:sp>
-      <p:sp>
-        <p:nvSpPr>
-          <p:cNvPr id="8" name="TextBox 7"/>
-          <p:cNvSpPr txBox="1"/>
-          <p:nvPr/>
-        </p:nvSpPr>
-        <p:spPr>
-          <a:xfrm>
-            <a:off x="4754880" y="1920240"/>
-            <a:ext cx="6858000" cy="822960"/>
-          </a:xfrm>
-          <a:prstGeom prst="rect">
-            <a:avLst/>
-          </a:prstGeom>
-          <a:noFill/>
-        </p:spPr>
-        <p:txBody>
-          <a:bodyPr wrap="square" lIns="0" rIns="0" tIns="0" bIns="0" anchor="t">
-            <a:spAutoFit/>
-          </a:bodyPr>
-          <a:lstStyle/>
-          <a:p>
-            <a:pPr algn="l"/>
-            <a:r>
-              <a:rPr sz="4000" b="1">
-                <a:solidFill>
-                  <a:srgbClr val="E8E8ED"/>
-                </a:solidFill>
-                <a:latin typeface="Inter"/>
-              </a:rPr>
-              <a:t>Yuvaraj Govindarajulu</a:t>
-            </a:r>
-          </a:p>
-        </p:txBody>
-      </p:sp>
-      <p:sp>
-        <p:nvSpPr>
-          <p:cNvPr id="9" name="TextBox 8"/>
-          <p:cNvSpPr txBox="1"/>
-          <p:nvPr/>
-        </p:nvSpPr>
-        <p:spPr>
-          <a:xfrm>
-            <a:off x="4754880" y="2788920"/>
-            <a:ext cx="6858000" cy="457200"/>
-          </a:xfrm>
-          <a:prstGeom prst="rect">
-            <a:avLst/>
-          </a:prstGeom>
-          <a:noFill/>
-        </p:spPr>
-        <p:txBody>
-          <a:bodyPr wrap="square" lIns="0" rIns="0" tIns="0" bIns="0" anchor="t">
-            <a:spAutoFit/>
-          </a:bodyPr>
-          <a:lstStyle/>
-          <a:p>
-            <a:pPr algn="l"/>
-            <a:r>
-              <a:rPr sz="2000" b="0">
-                <a:solidFill>
-                  <a:srgbClr val="6DD0E7"/>
-                </a:solidFill>
-                <a:latin typeface="Inter"/>
-              </a:rPr>
-              <a:t>AVP - Product Engineering &amp; Head of Research at Protectt.ai</a:t>
-            </a:r>
-          </a:p>
-        </p:txBody>
-      </p:sp>
-      <p:sp>
-        <p:nvSpPr>
-          <p:cNvPr id="10" name="TextBox 9"/>
-          <p:cNvSpPr txBox="1"/>
-          <p:nvPr/>
-        </p:nvSpPr>
-        <p:spPr>
-          <a:xfrm>
-            <a:off x="4754880" y="3474720"/>
-            <a:ext cx="6858000" cy="2103120"/>
-          </a:xfrm>
-          <a:prstGeom prst="rect">
-            <a:avLst/>
-          </a:prstGeom>
-          <a:noFill/>
-        </p:spPr>
-        <p:txBody>
-          <a:bodyPr wrap="square" lIns="0" rIns="0" tIns="0" bIns="0" anchor="t">
-            <a:spAutoFit/>
-          </a:bodyPr>
-          <a:lstStyle/>
-          <a:p>
-            <a:pPr algn="l"/>
-            <a:r>
-              <a:rPr sz="1600" b="0">
-                <a:solidFill>
-                  <a:srgbClr val="8888A0"/>
-                </a:solidFill>
-                <a:latin typeface="Inter"/>
-              </a:rPr>
-              <a:t>Yuvaraj Govindarajulu is a technical leader with over a decade of experience in AI, Cybersecurity and Embedded Systems R&amp;D. He is the AVP - Product Engineering &amp; Head of Research at Protectt.ai. He is the co-lead of the OWASP AI Bill of Materials Project and the Co-Author, Workstream lead (Harmonization) at the OWASP AI Exchange. With over 22+ International patents filed, his key areas of focus include AI Red Teaming, GenAI Guardrails, Ransomware Attacks on AI and AI supply chain Security.</a:t>
-            </a:r>
-          </a:p>
-        </p:txBody>
-      </p:sp>
-      <p:sp>
-        <p:nvSpPr>
-          <p:cNvPr id="11" name="TextBox 10"/>
-          <p:cNvSpPr txBox="1"/>
-          <p:nvPr/>
-        </p:nvSpPr>
-        <p:spPr>
-          <a:xfrm>
-            <a:off x="4754880" y="5669280"/>
-            <a:ext cx="6858000" cy="365760"/>
-          </a:xfrm>
-          <a:prstGeom prst="rect">
-            <a:avLst/>
-          </a:prstGeom>
-          <a:noFill/>
-        </p:spPr>
-        <p:txBody>
-          <a:bodyPr wrap="square" lIns="0" rIns="0" tIns="0" bIns="0" anchor="t">
-            <a:spAutoFit/>
-          </a:bodyPr>
-          <a:lstStyle/>
-          <a:p>
-            <a:pPr algn="l"/>
-            <a:r>
-              <a:rPr sz="1400" b="0">
-                <a:solidFill>
-                  <a:srgbClr val="4AB8D2"/>
-                </a:solidFill>
-                <a:latin typeface="JetBrains Mono"/>
-              </a:rPr>
-              <a:t>linkedin.com/in/yuvaraj-govindarajulu</a:t>
-            </a:r>
-          </a:p>
-        </p:txBody>
-      </p:sp>
-      <p:sp>
-        <p:nvSpPr>
-          <p:cNvPr id="12" name="TextBox 11"/>
-          <p:cNvSpPr txBox="1"/>
-          <p:nvPr/>
-        </p:nvSpPr>
-        <p:spPr>
-          <a:xfrm>
-            <a:off x="548640" y="6446520"/>
-            <a:ext cx="7315200" cy="274320"/>
-          </a:xfrm>
-          <a:prstGeom prst="rect">
-            <a:avLst/>
-          </a:prstGeom>
-          <a:noFill/>
-        </p:spPr>
-        <p:txBody>
-          <a:bodyPr wrap="square" lIns="0" rIns="0" tIns="0" bIns="0" anchor="t">
-            <a:spAutoFit/>
-          </a:bodyPr>
-          <a:lstStyle/>
-          <a:p>
-            <a:pPr algn="l"/>
-            <a:r>
-              <a:rPr sz="1000" b="0">
-                <a:solidFill>
-                  <a:srgbClr val="8888A0"/>
-                </a:solidFill>
-                <a:latin typeface="JetBrains Mono"/>
-              </a:rPr>
-              <a:t>BSides Aarhus 2026  ·  June 20  ·  INCUBA Next, Aarhus</a:t>
-            </a:r>
-          </a:p>
-        </p:txBody>
-      </p:sp>
-      <p:sp>
-        <p:nvSpPr>
-          <p:cNvPr id="13" name="TextBox 12"/>
-          <p:cNvSpPr txBox="1"/>
-          <p:nvPr/>
-        </p:nvSpPr>
-        <p:spPr>
-          <a:xfrm>
-            <a:off x="10515600" y="6446520"/>
-            <a:ext cx="1188720" cy="274320"/>
-          </a:xfrm>
-          <a:prstGeom prst="rect">
-            <a:avLst/>
-          </a:prstGeom>
-          <a:noFill/>
-        </p:spPr>
-        <p:txBody>
-          <a:bodyPr wrap="square" lIns="0" rIns="0" tIns="0" bIns="0" anchor="t">
-            <a:spAutoFit/>
-          </a:bodyPr>
-          <a:lstStyle/>
-          <a:p>
-            <a:pPr algn="r"/>
-            <a:r>
-              <a:rPr sz="1000" b="0">
-                <a:solidFill>
-                  <a:srgbClr val="8888A0"/>
-                </a:solidFill>
-                <a:latin typeface="JetBrains Mono"/>
-              </a:rPr>
-              <a:t>Speaker</a:t>
-            </a:r>
-          </a:p>
-        </p:txBody>
-      </p:sp>
-    </p:spTree>
-  </p:cSld>
-  <p:clrMapOvr>
-    <a:masterClrMapping/>
-  </p:clrMapOvr>
+  <mc:AlternateContent xmlns:mc="http://schemas.openxmlformats.org/markup-compatibility/2006">
+    <mc:Choice xmlns:p14="http://schemas.microsoft.com/office/powerpoint/2010/main" Requires="p14">
+      <p:transition spd="med" p14:dur="700">
+        <p:fade/>
+      </p:transition>
+    </mc:Choice>
+    <mc:Fallback>
+      <p:transition spd="med">
+        <p:fade/>
+      </p:transition>
+    </mc:Fallback>
+  </mc:AlternateContent>
 </p:sld>
 </file>
 
@@ -6981,7 +6640,7 @@
                 </a:solidFill>
                 <a:latin typeface="Inter"/>
               </a:rPr>
-              <a:t>Kernel Wars: Anti-Cheat Reversing, BYOVD &amp; Mitigations</a:t>
+              <a:t>Emerging Frontiers: Ransomware Attacks in AI Systems</a:t>
             </a:r>
           </a:p>
           <a:p>
@@ -6993,7 +6652,7 @@
                 </a:solidFill>
                 <a:latin typeface="JetBrains Mono"/>
               </a:rPr>
-              <a:t>Ravshan Rikhsiev</a:t>
+              <a:t>Behnaz Karimi</a:t>
             </a:r>
           </a:p>
         </p:txBody>
@@ -7391,7 +7050,7 @@
                 </a:solidFill>
                 <a:latin typeface="Inter"/>
               </a:rPr>
-              <a:t>RTFM — When Documentation Creates Critical Misconfiguration</a:t>
+              <a:t>RTFM - Read The Fatal Manual: When Documentation Creates Critical Misconfiguration</a:t>
             </a:r>
           </a:p>
           <a:p>
@@ -7438,7 +7097,7 @@
                 </a:solidFill>
                 <a:latin typeface="Inter"/>
               </a:rPr>
-              <a:t>Emerging Frontiers: Ransomware Attacks in AI Systems</a:t>
+              <a:t>An introduction to Post-Quantum Cryptography for the practitioner</a:t>
             </a:r>
           </a:p>
           <a:p>
@@ -7450,7 +7109,7 @@
                 </a:solidFill>
                 <a:latin typeface="JetBrains Mono"/>
               </a:rPr>
-              <a:t>Behnaz Karimi &amp; Yuvaraj Govindarajulu</a:t>
+              <a:t>Kasper Hald</a:t>
             </a:r>
           </a:p>
         </p:txBody>
@@ -7567,7 +7226,7 @@
                 </a:solidFill>
                 <a:latin typeface="Inter"/>
               </a:rPr>
-              <a:t>Nebula — 5 years, still kicking *aaS</a:t>
+              <a:t>Nebula - 5 years, still kicking *aaS</a:t>
             </a:r>
           </a:p>
           <a:p>
@@ -7799,6 +7458,18 @@
   <p:clrMapOvr>
     <a:masterClrMapping/>
   </p:clrMapOvr>
+  <mc:AlternateContent xmlns:mc="http://schemas.openxmlformats.org/markup-compatibility/2006">
+    <mc:Choice xmlns:p14="http://schemas.microsoft.com/office/powerpoint/2010/main" Requires="p14">
+      <p:transition spd="med" p14:dur="700">
+        <p:fade/>
+      </p:transition>
+    </mc:Choice>
+    <mc:Fallback>
+      <p:transition spd="med">
+        <p:fade/>
+      </p:transition>
+    </mc:Fallback>
+  </mc:AlternateContent>
 </p:sld>
 </file>
 
@@ -8024,6 +7695,18 @@
   <p:clrMapOvr>
     <a:masterClrMapping/>
   </p:clrMapOvr>
+  <mc:AlternateContent xmlns:mc="http://schemas.openxmlformats.org/markup-compatibility/2006">
+    <mc:Choice xmlns:p14="http://schemas.microsoft.com/office/powerpoint/2010/main" Requires="p14">
+      <p:transition spd="med" p14:dur="700">
+        <p:fade/>
+      </p:transition>
+    </mc:Choice>
+    <mc:Fallback>
+      <p:transition spd="med">
+        <p:fade/>
+      </p:transition>
+    </mc:Fallback>
+  </mc:AlternateContent>
 </p:sld>
 </file>
 
@@ -8361,6 +8044,18 @@
   <p:clrMapOvr>
     <a:masterClrMapping/>
   </p:clrMapOvr>
+  <mc:AlternateContent xmlns:mc="http://schemas.openxmlformats.org/markup-compatibility/2006">
+    <mc:Choice xmlns:p14="http://schemas.microsoft.com/office/powerpoint/2010/main" Requires="p14">
+      <p:transition spd="med" p14:dur="700">
+        <p:fade/>
+      </p:transition>
+    </mc:Choice>
+    <mc:Fallback>
+      <p:transition spd="med">
+        <p:fade/>
+      </p:transition>
+    </mc:Fallback>
+  </mc:AlternateContent>
 </p:sld>
 </file>
 
@@ -8795,6 +8490,18 @@
   <p:clrMapOvr>
     <a:masterClrMapping/>
   </p:clrMapOvr>
+  <mc:AlternateContent xmlns:mc="http://schemas.openxmlformats.org/markup-compatibility/2006">
+    <mc:Choice xmlns:p14="http://schemas.microsoft.com/office/powerpoint/2010/main" Requires="p14">
+      <p:transition spd="med" p14:dur="700">
+        <p:fade/>
+      </p:transition>
+    </mc:Choice>
+    <mc:Fallback>
+      <p:transition spd="med">
+        <p:fade/>
+      </p:transition>
+    </mc:Fallback>
+  </mc:AlternateContent>
 </p:sld>
 </file>
 
@@ -9218,6 +8925,18 @@
   <p:clrMapOvr>
     <a:masterClrMapping/>
   </p:clrMapOvr>
+  <mc:AlternateContent xmlns:mc="http://schemas.openxmlformats.org/markup-compatibility/2006">
+    <mc:Choice xmlns:p14="http://schemas.microsoft.com/office/powerpoint/2010/main" Requires="p14">
+      <p:transition spd="med" p14:dur="700">
+        <p:fade/>
+      </p:transition>
+    </mc:Choice>
+    <mc:Fallback>
+      <p:transition spd="med">
+        <p:fade/>
+      </p:transition>
+    </mc:Fallback>
+  </mc:AlternateContent>
 </p:sld>
 </file>
 
@@ -9641,6 +9360,18 @@
   <p:clrMapOvr>
     <a:masterClrMapping/>
   </p:clrMapOvr>
+  <mc:AlternateContent xmlns:mc="http://schemas.openxmlformats.org/markup-compatibility/2006">
+    <mc:Choice xmlns:p14="http://schemas.microsoft.com/office/powerpoint/2010/main" Requires="p14">
+      <p:transition spd="med" p14:dur="700">
+        <p:fade/>
+      </p:transition>
+    </mc:Choice>
+    <mc:Fallback>
+      <p:transition spd="med">
+        <p:fade/>
+      </p:transition>
+    </mc:Fallback>
+  </mc:AlternateContent>
 </p:sld>
 </file>
 
@@ -10064,6 +9795,18 @@
   <p:clrMapOvr>
     <a:masterClrMapping/>
   </p:clrMapOvr>
+  <mc:AlternateContent xmlns:mc="http://schemas.openxmlformats.org/markup-compatibility/2006">
+    <mc:Choice xmlns:p14="http://schemas.microsoft.com/office/powerpoint/2010/main" Requires="p14">
+      <p:transition spd="med" p14:dur="700">
+        <p:fade/>
+      </p:transition>
+    </mc:Choice>
+    <mc:Fallback>
+      <p:transition spd="med">
+        <p:fade/>
+      </p:transition>
+    </mc:Fallback>
+  </mc:AlternateContent>
 </p:sld>
 </file>
 
@@ -10487,6 +10230,18 @@
   <p:clrMapOvr>
     <a:masterClrMapping/>
   </p:clrMapOvr>
+  <mc:AlternateContent xmlns:mc="http://schemas.openxmlformats.org/markup-compatibility/2006">
+    <mc:Choice xmlns:p14="http://schemas.microsoft.com/office/powerpoint/2010/main" Requires="p14">
+      <p:transition spd="med" p14:dur="700">
+        <p:fade/>
+      </p:transition>
+    </mc:Choice>
+    <mc:Fallback>
+      <p:transition spd="med">
+        <p:fade/>
+      </p:transition>
+    </mc:Fallback>
+  </mc:AlternateContent>
 </p:sld>
 </file>
 

</xml_diff>

<commit_message>
feat: update session room assignments and localization for agenda tracks
</commit_message>
<xml_diff>
--- a/Plans/template-output/bsides-aarhus-2026-template.pptx
+++ b/Plans/template-output/bsides-aarhus-2026-template.pptx
@@ -121,7 +121,7 @@
   <p:extLst>
     <p:ext uri="{521415D9-36F7-43E2-AB2F-B90AF26B5E84}">
       <p14:sectionLst xmlns:p14="http://schemas.microsoft.com/office/powerpoint/2010/main">
-        <p14:section name="Template" id="{775CAB82-98D7-4A8E-BA16-157722E20189}">
+        <p14:section name="Template" id="{DA91B642-B284-4732-BB14-4418F25D473E}">
           <p14:sldIdLst>
             <p14:sldId id="256"/>
             <p14:sldId id="257"/>
@@ -130,7 +130,7 @@
             <p14:sldId id="260"/>
           </p14:sldIdLst>
         </p14:section>
-        <p14:section name="Track 1" id="{F9E55C75-2AE8-443D-99BC-22825B4FCBAD}">
+        <p14:section name="Track 1" id="{BBA44FA3-1A66-4C36-B477-00542159E915}">
           <p14:sldIdLst>
             <p14:sldId id="261"/>
             <p14:sldId id="262"/>
@@ -139,7 +139,7 @@
             <p14:sldId id="265"/>
           </p14:sldIdLst>
         </p14:section>
-        <p14:section name="Track 2" id="{5138053A-7EA0-40C8-8707-61DA22ABB877}">
+        <p14:section name="Track 2" id="{A2BB4417-96C4-482C-B1B4-E6AD199B98B1}">
           <p14:sldIdLst>
             <p14:sldId id="266"/>
             <p14:sldId id="267"/>
@@ -4091,7 +4091,7 @@
                 </a:solidFill>
                 <a:latin typeface="Inter"/>
               </a:rPr>
-              <a:t>Behnaz Karimi</a:t>
+              <a:t>Bence Soóki-Tóth</a:t>
             </a:r>
           </a:p>
         </p:txBody>
@@ -4126,7 +4126,7 @@
                 </a:solidFill>
                 <a:latin typeface="Inter"/>
               </a:rPr>
-              <a:t>Co-Lead / Leader AI Red Teaming OWASP AI Exchange and Founder RAID-AI Framework</a:t>
+              <a:t>Aarhus University, Master's Student</a:t>
             </a:r>
           </a:p>
         </p:txBody>
@@ -4161,7 +4161,7 @@
                 </a:solidFill>
                 <a:latin typeface="Inter"/>
               </a:rPr>
-              <a:t>Behnaz is an AI Security Researcher and the Founder/Creator of the RAID-AI Framework. She is also Co-Author, Co-Lead, and Leader of AI Red Teaming at OWASP AI Exchange, where she actively contributes to advancing security practices for AI systems.</a:t>
+              <a:t>Bence is a Master's student at Aarhus University and a research assistant at Eötvös Loránd University, working at the intersection of cryptography, game theory, and consensus protocols.</a:t>
             </a:r>
           </a:p>
         </p:txBody>
@@ -4196,7 +4196,7 @@
                 </a:solidFill>
                 <a:latin typeface="JetBrains Mono"/>
               </a:rPr>
-              <a:t>linkedin.com/in/behnaz-karimi-behi  ·  substack.com/@behnazkarimi</a:t>
+              <a:t>linkedin.com/in/stbence  ·  0xsooki.github.io</a:t>
             </a:r>
           </a:p>
         </p:txBody>
@@ -4526,7 +4526,7 @@
                 </a:solidFill>
                 <a:latin typeface="Inter"/>
               </a:rPr>
-              <a:t>Bence Soóki-Tóth</a:t>
+              <a:t>Eleni Ioakeim</a:t>
             </a:r>
           </a:p>
         </p:txBody>
@@ -4561,7 +4561,7 @@
                 </a:solidFill>
                 <a:latin typeface="Inter"/>
               </a:rPr>
-              <a:t>Aarhus University, Master's Student</a:t>
+              <a:t>Truesec, OT Threat Analyst</a:t>
             </a:r>
           </a:p>
         </p:txBody>
@@ -4596,7 +4596,7 @@
                 </a:solidFill>
                 <a:latin typeface="Inter"/>
               </a:rPr>
-              <a:t>Bence is a Master's student at Aarhus University and a research assistant at Eötvös Loránd University, working at the intersection of cryptography, game theory, and consensus protocols.</a:t>
+              <a:t>Eleni is an OT Threat Analyst at Truesec SOC in Copenhagen, with expertise in OT network security monitoring. Her work contributes to improving SOC processes and detection capabilities for ICS environments.</a:t>
             </a:r>
           </a:p>
         </p:txBody>
@@ -4631,7 +4631,7 @@
                 </a:solidFill>
                 <a:latin typeface="JetBrains Mono"/>
               </a:rPr>
-              <a:t>linkedin.com/in/stbence  ·  0xsooki.github.io</a:t>
+              <a:t/>
             </a:r>
           </a:p>
         </p:txBody>
@@ -4961,7 +4961,7 @@
                 </a:solidFill>
                 <a:latin typeface="Inter"/>
               </a:rPr>
-              <a:t>Bleon Proko</a:t>
+              <a:t>Joost van Dijk</a:t>
             </a:r>
           </a:p>
         </p:txBody>
@@ -4996,7 +4996,7 @@
                 </a:solidFill>
                 <a:latin typeface="Inter"/>
               </a:rPr>
-              <a:t>Cloud Security Researcher</a:t>
+              <a:t>Developer Advocate at Yubico</a:t>
             </a:r>
           </a:p>
         </p:txBody>
@@ -5031,7 +5031,7 @@
                 </a:solidFill>
                 <a:latin typeface="Inter"/>
               </a:rPr>
-              <a:t>Bleon is a Senior Security Researcher at Exaforce, passionate about Infrastructure Penetration Testing and Security across Active Directory, Cloud (AWS, Azure, GCP, Digital Ocean) and hybrid infrastructures, as well as defense, detection, and threat hunting. He has presented Cloud Penetration Testing and Security topics at conferences including Black Hat USA, Europe and Sector, DEF CON, SANS Pentest Hackfest Hollywood and Amsterdam, and several BSides events in the US and Europe.</a:t>
+              <a:t>Joost is a Developer Advocate at Yubico and a security and privacy professional with deep expertise in federated single sign-on, multi-factor authentication, FIDO, passkeys, PKI, TLS, and hardware security.</a:t>
             </a:r>
           </a:p>
         </p:txBody>
@@ -5066,7 +5066,7 @@
                 </a:solidFill>
                 <a:latin typeface="JetBrains Mono"/>
               </a:rPr>
-              <a:t>linkedin.com/in/bleon-p-9b2734143  ·  blog.pepperclipp.com</a:t>
+              <a:t>linkedin.com/in/joostd</a:t>
             </a:r>
           </a:p>
         </p:txBody>
@@ -6418,7 +6418,7 @@
                 </a:solidFill>
                 <a:latin typeface="JetBrains Mono"/>
               </a:rPr>
-              <a:t>TRACK 1  ·  ROOM 1</a:t>
+              <a:t>TRACK 1  ·  STORE AUD</a:t>
             </a:r>
           </a:p>
         </p:txBody>
@@ -6453,7 +6453,7 @@
                 </a:solidFill>
                 <a:latin typeface="JetBrains Mono"/>
               </a:rPr>
-              <a:t>TRACK 2  ·  ROOM 2</a:t>
+              <a:t>TRACK 2  ·  LILLE AUD</a:t>
             </a:r>
           </a:p>
         </p:txBody>
@@ -6593,7 +6593,7 @@
                 </a:solidFill>
                 <a:latin typeface="Inter"/>
               </a:rPr>
-              <a:t>WebAuthn: How to get rid of passwords.</a:t>
+              <a:t>Emerging Frontiers: Ransomware Attacks in AI Systems</a:t>
             </a:r>
           </a:p>
           <a:p>
@@ -6605,7 +6605,7 @@
                 </a:solidFill>
                 <a:latin typeface="JetBrains Mono"/>
               </a:rPr>
-              <a:t>Joost van Dijk</a:t>
+              <a:t>Behnaz Karimi</a:t>
             </a:r>
           </a:p>
         </p:txBody>
@@ -6640,7 +6640,7 @@
                 </a:solidFill>
                 <a:latin typeface="Inter"/>
               </a:rPr>
-              <a:t>Emerging Frontiers: Ransomware Attacks in AI Systems</a:t>
+              <a:t>WebAuthn: How to get rid of passwords.</a:t>
             </a:r>
           </a:p>
           <a:p>
@@ -6652,7 +6652,7 @@
                 </a:solidFill>
                 <a:latin typeface="JetBrains Mono"/>
               </a:rPr>
-              <a:t>Behnaz Karimi</a:t>
+              <a:t>Joost van Dijk</a:t>
             </a:r>
           </a:p>
         </p:txBody>
@@ -7179,7 +7179,7 @@
                 </a:solidFill>
                 <a:latin typeface="Inter"/>
               </a:rPr>
-              <a:t>Build your own IDS</a:t>
+              <a:t>Nebula - 5 years, still kicking *aaS</a:t>
             </a:r>
           </a:p>
           <a:p>
@@ -7191,7 +7191,7 @@
                 </a:solidFill>
                 <a:latin typeface="JetBrains Mono"/>
               </a:rPr>
-              <a:t>Eleni Ioakeim</a:t>
+              <a:t>Bleon Proko</a:t>
             </a:r>
           </a:p>
         </p:txBody>
@@ -7226,7 +7226,7 @@
                 </a:solidFill>
                 <a:latin typeface="Inter"/>
               </a:rPr>
-              <a:t>Nebula - 5 years, still kicking *aaS</a:t>
+              <a:t>Build your own IDS</a:t>
             </a:r>
           </a:p>
           <a:p>
@@ -7238,7 +7238,7 @@
                 </a:solidFill>
                 <a:latin typeface="JetBrains Mono"/>
               </a:rPr>
-              <a:t>Bleon Proko</a:t>
+              <a:t>Eleni Ioakeim</a:t>
             </a:r>
           </a:p>
         </p:txBody>
@@ -8740,7 +8740,7 @@
                 </a:solidFill>
                 <a:latin typeface="Inter"/>
               </a:rPr>
-              <a:t>Eleni Ioakeim</a:t>
+              <a:t>Behnaz Karimi</a:t>
             </a:r>
           </a:p>
         </p:txBody>
@@ -8775,7 +8775,7 @@
                 </a:solidFill>
                 <a:latin typeface="Inter"/>
               </a:rPr>
-              <a:t>Truesec, OT Threat Analyst</a:t>
+              <a:t>Co-Lead / Leader AI Red Teaming OWASP AI Exchange and Founder RAID-AI Framework</a:t>
             </a:r>
           </a:p>
         </p:txBody>
@@ -8810,7 +8810,7 @@
                 </a:solidFill>
                 <a:latin typeface="Inter"/>
               </a:rPr>
-              <a:t>Eleni is an OT Threat Analyst at Truesec SOC in Copenhagen, with expertise in OT network security monitoring. Her work contributes to improving SOC processes and detection capabilities for ICS environments.</a:t>
+              <a:t>Behnaz is an AI Security Researcher and the Founder/Creator of the RAID-AI Framework. She is also Co-Author, Co-Lead, and Leader of AI Red Teaming at OWASP AI Exchange, where she actively contributes to advancing security practices for AI systems.</a:t>
             </a:r>
           </a:p>
         </p:txBody>
@@ -8845,7 +8845,7 @@
                 </a:solidFill>
                 <a:latin typeface="JetBrains Mono"/>
               </a:rPr>
-              <a:t/>
+              <a:t>linkedin.com/in/behnaz-karimi-behi  ·  substack.com/@behnazkarimi</a:t>
             </a:r>
           </a:p>
         </p:txBody>
@@ -9175,7 +9175,7 @@
                 </a:solidFill>
                 <a:latin typeface="Inter"/>
               </a:rPr>
-              <a:t>Joost van Dijk</a:t>
+              <a:t>Bleon Proko</a:t>
             </a:r>
           </a:p>
         </p:txBody>
@@ -9210,7 +9210,7 @@
                 </a:solidFill>
                 <a:latin typeface="Inter"/>
               </a:rPr>
-              <a:t>Developer Advocate at Yubico</a:t>
+              <a:t>Cloud Security Researcher</a:t>
             </a:r>
           </a:p>
         </p:txBody>
@@ -9245,7 +9245,7 @@
                 </a:solidFill>
                 <a:latin typeface="Inter"/>
               </a:rPr>
-              <a:t>Joost is a Developer Advocate at Yubico and a security and privacy professional with deep expertise in federated single sign-on, multi-factor authentication, FIDO, passkeys, PKI, TLS, and hardware security.</a:t>
+              <a:t>Bleon is a Senior Security Researcher at Exaforce, passionate about Infrastructure Penetration Testing and Security across Active Directory, Cloud (AWS, Azure, GCP, Digital Ocean) and hybrid infrastructures, as well as defense, detection, and threat hunting. He has presented Cloud Penetration Testing and Security topics at conferences including Black Hat USA, Europe and Sector, DEF CON, SANS Pentest Hackfest Hollywood and Amsterdam, and several BSides events in the US and Europe.</a:t>
             </a:r>
           </a:p>
         </p:txBody>
@@ -9280,7 +9280,7 @@
                 </a:solidFill>
                 <a:latin typeface="JetBrains Mono"/>
               </a:rPr>
-              <a:t>linkedin.com/in/joostd</a:t>
+              <a:t>linkedin.com/in/bleon-p-9b2734143  ·  blog.pepperclipp.com</a:t>
             </a:r>
           </a:p>
         </p:txBody>

</xml_diff>

<commit_message>
feat: add company links for speakers to enhance profiles
</commit_message>
<xml_diff>
--- a/Plans/template-output/bsides-aarhus-2026-template.pptx
+++ b/Plans/template-output/bsides-aarhus-2026-template.pptx
@@ -122,7 +122,7 @@
   <p:extLst>
     <p:ext uri="{521415D9-36F7-43E2-AB2F-B90AF26B5E84}">
       <p14:sectionLst xmlns:p14="http://schemas.microsoft.com/office/powerpoint/2010/main">
-        <p14:section name="Template" id="{7D5D6CFB-B621-44F2-9900-249FE2D5F253}">
+        <p14:section name="Template" id="{0764BF56-5AD5-4FED-8E27-40E15AA27A37}">
           <p14:sldIdLst>
             <p14:sldId id="256"/>
             <p14:sldId id="257"/>
@@ -132,7 +132,7 @@
             <p14:sldId id="261"/>
           </p14:sldIdLst>
         </p14:section>
-        <p14:section name="Track 1" id="{0A07AE93-01DD-4F8D-9AF0-3E8879A3B7F8}">
+        <p14:section name="Track 1" id="{603174A3-86F7-4EE2-975B-4B2876DFE73B}">
           <p14:sldIdLst>
             <p14:sldId id="262"/>
             <p14:sldId id="263"/>
@@ -141,7 +141,7 @@
             <p14:sldId id="266"/>
           </p14:sldIdLst>
         </p14:section>
-        <p14:section name="Track 2" id="{F8B21C01-CBF5-4FD5-87DB-B5BB1258D935}">
+        <p14:section name="Track 2" id="{56754DAA-9F65-4EE4-8656-0C315BF6089C}">
           <p14:sldIdLst>
             <p14:sldId id="267"/>
             <p14:sldId id="268"/>
@@ -3693,7 +3693,7 @@
                 </a:solidFill>
                 <a:latin typeface="Inter"/>
               </a:rPr>
-              <a:t>Truesec, Head of Offensive Security</a:t>
+              <a:t>Head of Offensive Security, Truesec</a:t>
             </a:r>
           </a:p>
         </p:txBody>
@@ -4128,7 +4128,7 @@
                 </a:solidFill>
                 <a:latin typeface="Inter"/>
               </a:rPr>
-              <a:t>TRUESEC, Vice President</a:t>
+              <a:t>Vice President, Truesec</a:t>
             </a:r>
           </a:p>
         </p:txBody>
@@ -4563,7 +4563,7 @@
                 </a:solidFill>
                 <a:latin typeface="Inter"/>
               </a:rPr>
-              <a:t>Aarhus University, Master's Student</a:t>
+              <a:t>Master's Student, Aarhus University</a:t>
             </a:r>
           </a:p>
         </p:txBody>
@@ -4998,7 +4998,7 @@
                 </a:solidFill>
                 <a:latin typeface="Inter"/>
               </a:rPr>
-              <a:t>Truesec, OT Threat Analyst</a:t>
+              <a:t>OT Threat Analyst, Truesec</a:t>
             </a:r>
           </a:p>
         </p:txBody>
@@ -5068,7 +5068,7 @@
                 </a:solidFill>
                 <a:latin typeface="JetBrains Mono"/>
               </a:rPr>
-              <a:t/>
+              <a:t>linkedin.com/in/eleni-ioakeim-9bb262aa</a:t>
             </a:r>
           </a:p>
         </p:txBody>
@@ -5433,7 +5433,7 @@
                 </a:solidFill>
                 <a:latin typeface="Inter"/>
               </a:rPr>
-              <a:t>Developer Advocate at Yubico</a:t>
+              <a:t>Developer Advocate, Yubico</a:t>
             </a:r>
           </a:p>
         </p:txBody>
@@ -5868,7 +5868,7 @@
                 </a:solidFill>
                 <a:latin typeface="Inter"/>
               </a:rPr>
-              <a:t>Freelance Consultant at ApplSec Consult</a:t>
+              <a:t>Freelance Consultant, ApplSec Consult</a:t>
             </a:r>
           </a:p>
         </p:txBody>
@@ -6303,7 +6303,7 @@
                 </a:solidFill>
                 <a:latin typeface="Inter"/>
               </a:rPr>
-              <a:t>SecOps Automation Lead @ Conscia MDR</a:t>
+              <a:t>SecOps Automation Lead, Conscia MDR</a:t>
             </a:r>
           </a:p>
         </p:txBody>
@@ -10351,7 +10351,7 @@
                 </a:solidFill>
                 <a:latin typeface="Inter"/>
               </a:rPr>
-              <a:t>Security Researcher @ SpecterOps</a:t>
+              <a:t>Security Researcher, SpecterOps</a:t>
             </a:r>
           </a:p>
         </p:txBody>
@@ -10786,7 +10786,7 @@
                 </a:solidFill>
                 <a:latin typeface="Inter"/>
               </a:rPr>
-              <a:t>Elastic, Principal Security Architect, Security Evangelist</a:t>
+              <a:t>Principal Security Architect, Security Evangelist, Elastic</a:t>
             </a:r>
           </a:p>
         </p:txBody>

</xml_diff>

<commit_message>
feat: enhance sponsor logo display with uniform card sizing and improved layout
</commit_message>
<xml_diff>
--- a/Plans/template-output/bsides-aarhus-2026-template.pptx
+++ b/Plans/template-output/bsides-aarhus-2026-template.pptx
@@ -122,7 +122,7 @@
   <p:extLst>
     <p:ext uri="{521415D9-36F7-43E2-AB2F-B90AF26B5E84}">
       <p14:sectionLst xmlns:p14="http://schemas.microsoft.com/office/powerpoint/2010/main">
-        <p14:section name="Template" id="{0764BF56-5AD5-4FED-8E27-40E15AA27A37}">
+        <p14:section name="Template" id="{2C0F9697-2D1C-430E-A95C-B01BA30A179D}">
           <p14:sldIdLst>
             <p14:sldId id="256"/>
             <p14:sldId id="257"/>
@@ -132,7 +132,7 @@
             <p14:sldId id="261"/>
           </p14:sldIdLst>
         </p14:section>
-        <p14:section name="Track 1" id="{603174A3-86F7-4EE2-975B-4B2876DFE73B}">
+        <p14:section name="Track 1" id="{39A9BF40-CB57-41E2-A15B-90EFF3F750B7}">
           <p14:sldIdLst>
             <p14:sldId id="262"/>
             <p14:sldId id="263"/>
@@ -141,7 +141,7 @@
             <p14:sldId id="266"/>
           </p14:sldIdLst>
         </p14:section>
-        <p14:section name="Track 2" id="{56754DAA-9F65-4EE4-8656-0C315BF6089C}">
+        <p14:section name="Track 2" id="{E9A2597B-766B-4B9B-8203-459B9980B212}">
           <p14:sldIdLst>
             <p14:sldId id="267"/>
             <p14:sldId id="268"/>
@@ -9121,8 +9121,8 @@
         </p:nvSpPr>
         <p:spPr>
           <a:xfrm>
-            <a:off x="548640" y="2331720"/>
-            <a:ext cx="11094415" cy="274320"/>
+            <a:off x="548640" y="1874519"/>
+            <a:ext cx="11094415" cy="256032"/>
           </a:xfrm>
           <a:prstGeom prst="rect">
             <a:avLst/>
@@ -9156,20 +9156,25 @@
         </p:nvSpPr>
         <p:spPr>
           <a:xfrm>
-            <a:off x="3819358" y="2638043"/>
-            <a:ext cx="1097280" cy="640080"/>
+            <a:off x="2232507" y="2185416"/>
+            <a:ext cx="3657600" cy="740664"/>
           </a:xfrm>
           <a:prstGeom prst="roundRect">
             <a:avLst>
-              <a:gd name="adj" fmla="val 12000"/>
+              <a:gd name="adj" fmla="val 8000"/>
             </a:avLst>
           </a:prstGeom>
           <a:solidFill>
-            <a:srgbClr val="FFFFFF"/>
+            <a:srgbClr val="1A1A25">
+              <a:alpha val="12000"/>
+            </a:srgbClr>
           </a:solidFill>
-          <a:ln>
-            <a:noFill/>
+          <a:ln w="9525">
+            <a:solidFill>
+              <a:srgbClr val="2A2A3A"/>
+            </a:solidFill>
           </a:ln>
+          <a:effectLst/>
         </p:spPr>
         <p:style>
           <a:lnRef idx="1">
@@ -9193,127 +9198,20 @@
           </a:p>
         </p:txBody>
       </p:sp>
-      <p:pic>
-        <p:nvPicPr>
-          <p:cNvPr id="9" name="Picture 8" descr="AarhusKommuneErhverv_Logo.png"/>
-          <p:cNvPicPr>
-            <a:picLocks noChangeAspect="1"/>
-          </p:cNvPicPr>
-          <p:nvPr/>
-        </p:nvPicPr>
-        <p:blipFill>
-          <a:blip r:embed="rId4"/>
-          <a:stretch>
-            <a:fillRect/>
-          </a:stretch>
-        </p:blipFill>
-        <p:spPr>
-          <a:xfrm>
-            <a:off x="3910798" y="2729483"/>
-            <a:ext cx="914400" cy="457200"/>
-          </a:xfrm>
-          <a:prstGeom prst="rect">
-            <a:avLst/>
-          </a:prstGeom>
-        </p:spPr>
-      </p:pic>
-      <p:pic>
-        <p:nvPicPr>
-          <p:cNvPr id="10" name="Picture 9" descr="Truesec-Logo-Large-White.png"/>
-          <p:cNvPicPr>
-            <a:picLocks noChangeAspect="1"/>
-          </p:cNvPicPr>
-          <p:nvPr/>
-        </p:nvPicPr>
-        <p:blipFill>
-          <a:blip r:embed="rId5"/>
-          <a:stretch>
-            <a:fillRect/>
-          </a:stretch>
-        </p:blipFill>
-        <p:spPr>
-          <a:xfrm>
-            <a:off x="5282398" y="2729483"/>
-            <a:ext cx="2998497" cy="457200"/>
-          </a:xfrm>
-          <a:prstGeom prst="rect">
-            <a:avLst/>
-          </a:prstGeom>
-        </p:spPr>
-      </p:pic>
-      <p:sp>
-        <p:nvSpPr>
-          <p:cNvPr id="11" name="TextBox 10"/>
-          <p:cNvSpPr txBox="1"/>
-          <p:nvPr/>
-        </p:nvSpPr>
-        <p:spPr>
-          <a:xfrm>
-            <a:off x="548640" y="3291839"/>
-            <a:ext cx="11094415" cy="274320"/>
-          </a:xfrm>
-          <a:prstGeom prst="rect">
-            <a:avLst/>
-          </a:prstGeom>
-          <a:noFill/>
-        </p:spPr>
-        <p:txBody>
-          <a:bodyPr wrap="square" lIns="0" rIns="0" tIns="0" bIns="0" anchor="t">
-            <a:spAutoFit/>
-          </a:bodyPr>
-          <a:lstStyle/>
-          <a:p>
-            <a:pPr algn="ctr"/>
-            <a:r>
-              <a:rPr sz="1200" b="1">
-                <a:solidFill>
-                  <a:srgbClr val="4AB8D2"/>
-                </a:solidFill>
-                <a:latin typeface="JetBrains Mono"/>
-              </a:rPr>
-              <a:t>COMMUNITY FRIENDS</a:t>
-            </a:r>
-          </a:p>
-        </p:txBody>
-      </p:sp>
-      <p:pic>
-        <p:nvPicPr>
-          <p:cNvPr id="12" name="Picture 11" descr="tech-hub-aarhus.png"/>
-          <p:cNvPicPr>
-            <a:picLocks noChangeAspect="1"/>
-          </p:cNvPicPr>
-          <p:nvPr/>
-        </p:nvPicPr>
-        <p:blipFill>
-          <a:blip r:embed="rId6"/>
-          <a:stretch>
-            <a:fillRect/>
-          </a:stretch>
-        </p:blipFill>
-        <p:spPr>
-          <a:xfrm>
-            <a:off x="4838306" y="3689603"/>
-            <a:ext cx="1305246" cy="457200"/>
-          </a:xfrm>
-          <a:prstGeom prst="rect">
-            <a:avLst/>
-          </a:prstGeom>
-        </p:spPr>
-      </p:pic>
-      <p:sp>
-        <p:nvSpPr>
-          <p:cNvPr id="13" name="Rounded Rectangle 12"/>
+      <p:sp>
+        <p:nvSpPr>
+          <p:cNvPr id="9" name="Rounded Rectangle 8"/>
           <p:cNvSpPr/>
           <p:nvPr/>
         </p:nvSpPr>
         <p:spPr>
           <a:xfrm>
-            <a:off x="6509313" y="3598163"/>
-            <a:ext cx="935515" cy="640080"/>
+            <a:off x="2305659" y="2258568"/>
+            <a:ext cx="3511296" cy="594359"/>
           </a:xfrm>
           <a:prstGeom prst="roundRect">
             <a:avLst>
-              <a:gd name="adj" fmla="val 12000"/>
+              <a:gd name="adj" fmla="val 8000"/>
             </a:avLst>
           </a:prstGeom>
           <a:solidFill>
@@ -9322,6 +9220,7 @@
           <a:ln>
             <a:noFill/>
           </a:ln>
+          <a:effectLst/>
         </p:spPr>
         <p:style>
           <a:lnRef idx="1">
@@ -9347,22 +9246,22 @@
       </p:sp>
       <p:pic>
         <p:nvPicPr>
-          <p:cNvPr id="14" name="Picture 13" descr="sticker-mule.png"/>
+          <p:cNvPr id="10" name="Picture 9" descr="AarhusKommuneErhverv_Logo.png"/>
           <p:cNvPicPr>
             <a:picLocks noChangeAspect="1"/>
           </p:cNvPicPr>
           <p:nvPr/>
         </p:nvPicPr>
         <p:blipFill>
-          <a:blip r:embed="rId7"/>
+          <a:blip r:embed="rId4"/>
           <a:stretch>
             <a:fillRect/>
           </a:stretch>
         </p:blipFill>
         <p:spPr>
           <a:xfrm>
-            <a:off x="6600753" y="3689603"/>
-            <a:ext cx="752635" cy="457200"/>
+            <a:off x="3540099" y="2295144"/>
+            <a:ext cx="1042415" cy="521207"/>
           </a:xfrm>
           <a:prstGeom prst="rect">
             <a:avLst/>
@@ -9371,120 +9270,31 @@
       </p:pic>
       <p:sp>
         <p:nvSpPr>
-          <p:cNvPr id="15" name="TextBox 14"/>
-          <p:cNvSpPr txBox="1"/>
-          <p:nvPr/>
-        </p:nvSpPr>
-        <p:spPr>
-          <a:xfrm>
-            <a:off x="548640" y="4251960"/>
-            <a:ext cx="11094415" cy="274320"/>
-          </a:xfrm>
-          <a:prstGeom prst="rect">
-            <a:avLst/>
-          </a:prstGeom>
-          <a:noFill/>
-        </p:spPr>
-        <p:txBody>
-          <a:bodyPr wrap="square" lIns="0" rIns="0" tIns="0" bIns="0" anchor="t">
-            <a:spAutoFit/>
-          </a:bodyPr>
-          <a:lstStyle/>
-          <a:p>
-            <a:pPr algn="ctr"/>
-            <a:r>
-              <a:rPr sz="1200" b="1">
-                <a:solidFill>
-                  <a:srgbClr val="4AB8D2"/>
-                </a:solidFill>
-                <a:latin typeface="JetBrains Mono"/>
-              </a:rPr>
-              <a:t>COMMUNITY STUDENT FRIENDS</a:t>
-            </a:r>
-          </a:p>
-        </p:txBody>
-      </p:sp>
-      <p:pic>
-        <p:nvPicPr>
-          <p:cNvPr id="16" name="Picture 15" descr="Danske BankLogo White RGB.png"/>
-          <p:cNvPicPr>
-            <a:picLocks noChangeAspect="1"/>
-          </p:cNvPicPr>
-          <p:nvPr/>
-        </p:nvPicPr>
-        <p:blipFill>
-          <a:blip r:embed="rId8"/>
-          <a:stretch>
-            <a:fillRect/>
-          </a:stretch>
-        </p:blipFill>
-        <p:spPr>
-          <a:xfrm>
-            <a:off x="4541367" y="4649724"/>
-            <a:ext cx="3108960" cy="457200"/>
-          </a:xfrm>
-          <a:prstGeom prst="rect">
-            <a:avLst/>
-          </a:prstGeom>
-        </p:spPr>
-      </p:pic>
-      <p:sp>
-        <p:nvSpPr>
-          <p:cNvPr id="17" name="TextBox 16"/>
-          <p:cNvSpPr txBox="1"/>
-          <p:nvPr/>
-        </p:nvSpPr>
-        <p:spPr>
-          <a:xfrm>
-            <a:off x="548640" y="5212080"/>
-            <a:ext cx="11094415" cy="274320"/>
-          </a:xfrm>
-          <a:prstGeom prst="rect">
-            <a:avLst/>
-          </a:prstGeom>
-          <a:noFill/>
-        </p:spPr>
-        <p:txBody>
-          <a:bodyPr wrap="square" lIns="0" rIns="0" tIns="0" bIns="0" anchor="t">
-            <a:spAutoFit/>
-          </a:bodyPr>
-          <a:lstStyle/>
-          <a:p>
-            <a:pPr algn="ctr"/>
-            <a:r>
-              <a:rPr sz="1200" b="1">
-                <a:solidFill>
-                  <a:srgbClr val="4AB8D2"/>
-                </a:solidFill>
-                <a:latin typeface="JetBrains Mono"/>
-              </a:rPr>
-              <a:t>VENUE SPONSORS</a:t>
-            </a:r>
-          </a:p>
-        </p:txBody>
-      </p:sp>
-      <p:sp>
-        <p:nvSpPr>
-          <p:cNvPr id="18" name="Rounded Rectangle 17"/>
+          <p:cNvPr id="11" name="Rounded Rectangle 10"/>
           <p:cNvSpPr/>
           <p:nvPr/>
         </p:nvSpPr>
         <p:spPr>
           <a:xfrm>
-            <a:off x="3976960" y="5518404"/>
-            <a:ext cx="1618488" cy="640080"/>
+            <a:off x="6301587" y="2185416"/>
+            <a:ext cx="3657600" cy="740664"/>
           </a:xfrm>
           <a:prstGeom prst="roundRect">
             <a:avLst>
-              <a:gd name="adj" fmla="val 12000"/>
+              <a:gd name="adj" fmla="val 8000"/>
             </a:avLst>
           </a:prstGeom>
           <a:solidFill>
-            <a:srgbClr val="FFFFFF"/>
+            <a:srgbClr val="1A1A25">
+              <a:alpha val="12000"/>
+            </a:srgbClr>
           </a:solidFill>
-          <a:ln>
-            <a:noFill/>
+          <a:ln w="9525">
+            <a:solidFill>
+              <a:srgbClr val="2A2A3A"/>
+            </a:solidFill>
           </a:ln>
+          <a:effectLst/>
         </p:spPr>
         <p:style>
           <a:lnRef idx="1">
@@ -9510,7 +9320,500 @@
       </p:sp>
       <p:pic>
         <p:nvPicPr>
-          <p:cNvPr id="19" name="Picture 18" descr="_sponsor_incuba-logo.png"/>
+          <p:cNvPr id="12" name="Picture 11" descr="Truesec-Logo-Large-White.png"/>
+          <p:cNvPicPr>
+            <a:picLocks noChangeAspect="1"/>
+          </p:cNvPicPr>
+          <p:nvPr/>
+        </p:nvPicPr>
+        <p:blipFill>
+          <a:blip r:embed="rId5"/>
+          <a:stretch>
+            <a:fillRect/>
+          </a:stretch>
+        </p:blipFill>
+        <p:spPr>
+          <a:xfrm>
+            <a:off x="6421243" y="2295144"/>
+            <a:ext cx="3418287" cy="521207"/>
+          </a:xfrm>
+          <a:prstGeom prst="rect">
+            <a:avLst/>
+          </a:prstGeom>
+        </p:spPr>
+      </p:pic>
+      <p:sp>
+        <p:nvSpPr>
+          <p:cNvPr id="13" name="TextBox 12"/>
+          <p:cNvSpPr txBox="1"/>
+          <p:nvPr/>
+        </p:nvSpPr>
+        <p:spPr>
+          <a:xfrm>
+            <a:off x="548640" y="3017520"/>
+            <a:ext cx="11094415" cy="256032"/>
+          </a:xfrm>
+          <a:prstGeom prst="rect">
+            <a:avLst/>
+          </a:prstGeom>
+          <a:noFill/>
+        </p:spPr>
+        <p:txBody>
+          <a:bodyPr wrap="square" lIns="0" rIns="0" tIns="0" bIns="0" anchor="t">
+            <a:spAutoFit/>
+          </a:bodyPr>
+          <a:lstStyle/>
+          <a:p>
+            <a:pPr algn="ctr"/>
+            <a:r>
+              <a:rPr sz="1200" b="1">
+                <a:solidFill>
+                  <a:srgbClr val="4AB8D2"/>
+                </a:solidFill>
+                <a:latin typeface="JetBrains Mono"/>
+              </a:rPr>
+              <a:t>COMMUNITY FRIENDS</a:t>
+            </a:r>
+          </a:p>
+        </p:txBody>
+      </p:sp>
+      <p:sp>
+        <p:nvSpPr>
+          <p:cNvPr id="14" name="Rounded Rectangle 13"/>
+          <p:cNvSpPr/>
+          <p:nvPr/>
+        </p:nvSpPr>
+        <p:spPr>
+          <a:xfrm>
+            <a:off x="2232507" y="3328416"/>
+            <a:ext cx="3657600" cy="740664"/>
+          </a:xfrm>
+          <a:prstGeom prst="roundRect">
+            <a:avLst>
+              <a:gd name="adj" fmla="val 8000"/>
+            </a:avLst>
+          </a:prstGeom>
+          <a:solidFill>
+            <a:srgbClr val="1A1A25">
+              <a:alpha val="12000"/>
+            </a:srgbClr>
+          </a:solidFill>
+          <a:ln w="9525">
+            <a:solidFill>
+              <a:srgbClr val="2A2A3A"/>
+            </a:solidFill>
+          </a:ln>
+          <a:effectLst/>
+        </p:spPr>
+        <p:style>
+          <a:lnRef idx="1">
+            <a:schemeClr val="accent1"/>
+          </a:lnRef>
+          <a:fillRef idx="3">
+            <a:schemeClr val="accent1"/>
+          </a:fillRef>
+          <a:effectRef idx="2">
+            <a:schemeClr val="accent1"/>
+          </a:effectRef>
+          <a:fontRef idx="minor">
+            <a:schemeClr val="lt1"/>
+          </a:fontRef>
+        </p:style>
+        <p:txBody>
+          <a:bodyPr rtlCol="0" anchor="ctr"/>
+          <a:lstStyle/>
+          <a:p>
+            <a:pPr algn="ctr"/>
+          </a:p>
+        </p:txBody>
+      </p:sp>
+      <p:pic>
+        <p:nvPicPr>
+          <p:cNvPr id="15" name="Picture 14" descr="tech-hub-aarhus.png"/>
+          <p:cNvPicPr>
+            <a:picLocks noChangeAspect="1"/>
+          </p:cNvPicPr>
+          <p:nvPr/>
+        </p:nvPicPr>
+        <p:blipFill>
+          <a:blip r:embed="rId6"/>
+          <a:stretch>
+            <a:fillRect/>
+          </a:stretch>
+        </p:blipFill>
+        <p:spPr>
+          <a:xfrm>
+            <a:off x="3317316" y="3438144"/>
+            <a:ext cx="1487981" cy="521207"/>
+          </a:xfrm>
+          <a:prstGeom prst="rect">
+            <a:avLst/>
+          </a:prstGeom>
+        </p:spPr>
+      </p:pic>
+      <p:sp>
+        <p:nvSpPr>
+          <p:cNvPr id="16" name="Rounded Rectangle 15"/>
+          <p:cNvSpPr/>
+          <p:nvPr/>
+        </p:nvSpPr>
+        <p:spPr>
+          <a:xfrm>
+            <a:off x="6301587" y="3328416"/>
+            <a:ext cx="3657600" cy="740664"/>
+          </a:xfrm>
+          <a:prstGeom prst="roundRect">
+            <a:avLst>
+              <a:gd name="adj" fmla="val 8000"/>
+            </a:avLst>
+          </a:prstGeom>
+          <a:solidFill>
+            <a:srgbClr val="1A1A25">
+              <a:alpha val="12000"/>
+            </a:srgbClr>
+          </a:solidFill>
+          <a:ln w="9525">
+            <a:solidFill>
+              <a:srgbClr val="2A2A3A"/>
+            </a:solidFill>
+          </a:ln>
+          <a:effectLst/>
+        </p:spPr>
+        <p:style>
+          <a:lnRef idx="1">
+            <a:schemeClr val="accent1"/>
+          </a:lnRef>
+          <a:fillRef idx="3">
+            <a:schemeClr val="accent1"/>
+          </a:fillRef>
+          <a:effectRef idx="2">
+            <a:schemeClr val="accent1"/>
+          </a:effectRef>
+          <a:fontRef idx="minor">
+            <a:schemeClr val="lt1"/>
+          </a:fontRef>
+        </p:style>
+        <p:txBody>
+          <a:bodyPr rtlCol="0" anchor="ctr"/>
+          <a:lstStyle/>
+          <a:p>
+            <a:pPr algn="ctr"/>
+          </a:p>
+        </p:txBody>
+      </p:sp>
+      <p:sp>
+        <p:nvSpPr>
+          <p:cNvPr id="17" name="Rounded Rectangle 16"/>
+          <p:cNvSpPr/>
+          <p:nvPr/>
+        </p:nvSpPr>
+        <p:spPr>
+          <a:xfrm>
+            <a:off x="6374739" y="3401568"/>
+            <a:ext cx="3511296" cy="594359"/>
+          </a:xfrm>
+          <a:prstGeom prst="roundRect">
+            <a:avLst>
+              <a:gd name="adj" fmla="val 8000"/>
+            </a:avLst>
+          </a:prstGeom>
+          <a:solidFill>
+            <a:srgbClr val="FFFFFF"/>
+          </a:solidFill>
+          <a:ln>
+            <a:noFill/>
+          </a:ln>
+          <a:effectLst/>
+        </p:spPr>
+        <p:style>
+          <a:lnRef idx="1">
+            <a:schemeClr val="accent1"/>
+          </a:lnRef>
+          <a:fillRef idx="3">
+            <a:schemeClr val="accent1"/>
+          </a:fillRef>
+          <a:effectRef idx="2">
+            <a:schemeClr val="accent1"/>
+          </a:effectRef>
+          <a:fontRef idx="minor">
+            <a:schemeClr val="lt1"/>
+          </a:fontRef>
+        </p:style>
+        <p:txBody>
+          <a:bodyPr rtlCol="0" anchor="ctr"/>
+          <a:lstStyle/>
+          <a:p>
+            <a:pPr algn="ctr"/>
+          </a:p>
+        </p:txBody>
+      </p:sp>
+      <p:pic>
+        <p:nvPicPr>
+          <p:cNvPr id="18" name="Picture 17" descr="sticker-mule.png"/>
+          <p:cNvPicPr>
+            <a:picLocks noChangeAspect="1"/>
+          </p:cNvPicPr>
+          <p:nvPr/>
+        </p:nvPicPr>
+        <p:blipFill>
+          <a:blip r:embed="rId7"/>
+          <a:stretch>
+            <a:fillRect/>
+          </a:stretch>
+        </p:blipFill>
+        <p:spPr>
+          <a:xfrm>
+            <a:off x="7701385" y="3438144"/>
+            <a:ext cx="858004" cy="521207"/>
+          </a:xfrm>
+          <a:prstGeom prst="rect">
+            <a:avLst/>
+          </a:prstGeom>
+        </p:spPr>
+      </p:pic>
+      <p:sp>
+        <p:nvSpPr>
+          <p:cNvPr id="19" name="TextBox 18"/>
+          <p:cNvSpPr txBox="1"/>
+          <p:nvPr/>
+        </p:nvSpPr>
+        <p:spPr>
+          <a:xfrm>
+            <a:off x="548640" y="4160520"/>
+            <a:ext cx="11094415" cy="256032"/>
+          </a:xfrm>
+          <a:prstGeom prst="rect">
+            <a:avLst/>
+          </a:prstGeom>
+          <a:noFill/>
+        </p:spPr>
+        <p:txBody>
+          <a:bodyPr wrap="square" lIns="0" rIns="0" tIns="0" bIns="0" anchor="t">
+            <a:spAutoFit/>
+          </a:bodyPr>
+          <a:lstStyle/>
+          <a:p>
+            <a:pPr algn="ctr"/>
+            <a:r>
+              <a:rPr sz="1200" b="1">
+                <a:solidFill>
+                  <a:srgbClr val="4AB8D2"/>
+                </a:solidFill>
+                <a:latin typeface="JetBrains Mono"/>
+              </a:rPr>
+              <a:t>COMMUNITY STUDENT FRIENDS</a:t>
+            </a:r>
+          </a:p>
+        </p:txBody>
+      </p:sp>
+      <p:sp>
+        <p:nvSpPr>
+          <p:cNvPr id="20" name="Rounded Rectangle 19"/>
+          <p:cNvSpPr/>
+          <p:nvPr/>
+        </p:nvSpPr>
+        <p:spPr>
+          <a:xfrm>
+            <a:off x="4267047" y="4471416"/>
+            <a:ext cx="3657600" cy="740664"/>
+          </a:xfrm>
+          <a:prstGeom prst="roundRect">
+            <a:avLst>
+              <a:gd name="adj" fmla="val 8000"/>
+            </a:avLst>
+          </a:prstGeom>
+          <a:solidFill>
+            <a:srgbClr val="1A1A25">
+              <a:alpha val="12000"/>
+            </a:srgbClr>
+          </a:solidFill>
+          <a:ln w="9525">
+            <a:solidFill>
+              <a:srgbClr val="2A2A3A"/>
+            </a:solidFill>
+          </a:ln>
+          <a:effectLst/>
+        </p:spPr>
+        <p:style>
+          <a:lnRef idx="1">
+            <a:schemeClr val="accent1"/>
+          </a:lnRef>
+          <a:fillRef idx="3">
+            <a:schemeClr val="accent1"/>
+          </a:fillRef>
+          <a:effectRef idx="2">
+            <a:schemeClr val="accent1"/>
+          </a:effectRef>
+          <a:fontRef idx="minor">
+            <a:schemeClr val="lt1"/>
+          </a:fontRef>
+        </p:style>
+        <p:txBody>
+          <a:bodyPr rtlCol="0" anchor="ctr"/>
+          <a:lstStyle/>
+          <a:p>
+            <a:pPr algn="ctr"/>
+          </a:p>
+        </p:txBody>
+      </p:sp>
+      <p:pic>
+        <p:nvPicPr>
+          <p:cNvPr id="21" name="Picture 20" descr="Danske BankLogo White RGB.png"/>
+          <p:cNvPicPr>
+            <a:picLocks noChangeAspect="1"/>
+          </p:cNvPicPr>
+          <p:nvPr/>
+        </p:nvPicPr>
+        <p:blipFill>
+          <a:blip r:embed="rId8"/>
+          <a:stretch>
+            <a:fillRect/>
+          </a:stretch>
+        </p:blipFill>
+        <p:spPr>
+          <a:xfrm>
+            <a:off x="4376775" y="4665768"/>
+            <a:ext cx="3438144" cy="351958"/>
+          </a:xfrm>
+          <a:prstGeom prst="rect">
+            <a:avLst/>
+          </a:prstGeom>
+        </p:spPr>
+      </p:pic>
+      <p:sp>
+        <p:nvSpPr>
+          <p:cNvPr id="22" name="TextBox 21"/>
+          <p:cNvSpPr txBox="1"/>
+          <p:nvPr/>
+        </p:nvSpPr>
+        <p:spPr>
+          <a:xfrm>
+            <a:off x="548640" y="5303520"/>
+            <a:ext cx="11094415" cy="256032"/>
+          </a:xfrm>
+          <a:prstGeom prst="rect">
+            <a:avLst/>
+          </a:prstGeom>
+          <a:noFill/>
+        </p:spPr>
+        <p:txBody>
+          <a:bodyPr wrap="square" lIns="0" rIns="0" tIns="0" bIns="0" anchor="t">
+            <a:spAutoFit/>
+          </a:bodyPr>
+          <a:lstStyle/>
+          <a:p>
+            <a:pPr algn="ctr"/>
+            <a:r>
+              <a:rPr sz="1200" b="1">
+                <a:solidFill>
+                  <a:srgbClr val="4AB8D2"/>
+                </a:solidFill>
+                <a:latin typeface="JetBrains Mono"/>
+              </a:rPr>
+              <a:t>VENUE SPONSORS</a:t>
+            </a:r>
+          </a:p>
+        </p:txBody>
+      </p:sp>
+      <p:sp>
+        <p:nvSpPr>
+          <p:cNvPr id="23" name="Rounded Rectangle 22"/>
+          <p:cNvSpPr/>
+          <p:nvPr/>
+        </p:nvSpPr>
+        <p:spPr>
+          <a:xfrm>
+            <a:off x="2232507" y="5614416"/>
+            <a:ext cx="3657600" cy="740664"/>
+          </a:xfrm>
+          <a:prstGeom prst="roundRect">
+            <a:avLst>
+              <a:gd name="adj" fmla="val 8000"/>
+            </a:avLst>
+          </a:prstGeom>
+          <a:solidFill>
+            <a:srgbClr val="1A1A25">
+              <a:alpha val="12000"/>
+            </a:srgbClr>
+          </a:solidFill>
+          <a:ln w="9525">
+            <a:solidFill>
+              <a:srgbClr val="2A2A3A"/>
+            </a:solidFill>
+          </a:ln>
+          <a:effectLst/>
+        </p:spPr>
+        <p:style>
+          <a:lnRef idx="1">
+            <a:schemeClr val="accent1"/>
+          </a:lnRef>
+          <a:fillRef idx="3">
+            <a:schemeClr val="accent1"/>
+          </a:fillRef>
+          <a:effectRef idx="2">
+            <a:schemeClr val="accent1"/>
+          </a:effectRef>
+          <a:fontRef idx="minor">
+            <a:schemeClr val="lt1"/>
+          </a:fontRef>
+        </p:style>
+        <p:txBody>
+          <a:bodyPr rtlCol="0" anchor="ctr"/>
+          <a:lstStyle/>
+          <a:p>
+            <a:pPr algn="ctr"/>
+          </a:p>
+        </p:txBody>
+      </p:sp>
+      <p:sp>
+        <p:nvSpPr>
+          <p:cNvPr id="24" name="Rounded Rectangle 23"/>
+          <p:cNvSpPr/>
+          <p:nvPr/>
+        </p:nvSpPr>
+        <p:spPr>
+          <a:xfrm>
+            <a:off x="2305659" y="5687568"/>
+            <a:ext cx="3511296" cy="594359"/>
+          </a:xfrm>
+          <a:prstGeom prst="roundRect">
+            <a:avLst>
+              <a:gd name="adj" fmla="val 8000"/>
+            </a:avLst>
+          </a:prstGeom>
+          <a:solidFill>
+            <a:srgbClr val="FFFFFF"/>
+          </a:solidFill>
+          <a:ln>
+            <a:noFill/>
+          </a:ln>
+          <a:effectLst/>
+        </p:spPr>
+        <p:style>
+          <a:lnRef idx="1">
+            <a:schemeClr val="accent1"/>
+          </a:lnRef>
+          <a:fillRef idx="3">
+            <a:schemeClr val="accent1"/>
+          </a:fillRef>
+          <a:effectRef idx="2">
+            <a:schemeClr val="accent1"/>
+          </a:effectRef>
+          <a:fontRef idx="minor">
+            <a:schemeClr val="lt1"/>
+          </a:fontRef>
+        </p:style>
+        <p:txBody>
+          <a:bodyPr rtlCol="0" anchor="ctr"/>
+          <a:lstStyle/>
+          <a:p>
+            <a:pPr algn="ctr"/>
+          </a:p>
+        </p:txBody>
+      </p:sp>
+      <p:pic>
+        <p:nvPicPr>
+          <p:cNvPr id="25" name="Picture 24" descr="_sponsor_incuba-logo.png"/>
           <p:cNvPicPr>
             <a:picLocks noChangeAspect="1"/>
           </p:cNvPicPr>
@@ -9524,17 +9827,67 @@
         </p:blipFill>
         <p:spPr>
           <a:xfrm>
-            <a:off x="4068400" y="5609844"/>
-            <a:ext cx="1435608" cy="457200"/>
+            <a:off x="3243011" y="5724144"/>
+            <a:ext cx="1636593" cy="521207"/>
           </a:xfrm>
           <a:prstGeom prst="rect">
             <a:avLst/>
           </a:prstGeom>
         </p:spPr>
       </p:pic>
+      <p:sp>
+        <p:nvSpPr>
+          <p:cNvPr id="26" name="Rounded Rectangle 25"/>
+          <p:cNvSpPr/>
+          <p:nvPr/>
+        </p:nvSpPr>
+        <p:spPr>
+          <a:xfrm>
+            <a:off x="6301587" y="5614416"/>
+            <a:ext cx="3657600" cy="740664"/>
+          </a:xfrm>
+          <a:prstGeom prst="roundRect">
+            <a:avLst>
+              <a:gd name="adj" fmla="val 8000"/>
+            </a:avLst>
+          </a:prstGeom>
+          <a:solidFill>
+            <a:srgbClr val="1A1A25">
+              <a:alpha val="12000"/>
+            </a:srgbClr>
+          </a:solidFill>
+          <a:ln w="9525">
+            <a:solidFill>
+              <a:srgbClr val="2A2A3A"/>
+            </a:solidFill>
+          </a:ln>
+          <a:effectLst/>
+        </p:spPr>
+        <p:style>
+          <a:lnRef idx="1">
+            <a:schemeClr val="accent1"/>
+          </a:lnRef>
+          <a:fillRef idx="3">
+            <a:schemeClr val="accent1"/>
+          </a:fillRef>
+          <a:effectRef idx="2">
+            <a:schemeClr val="accent1"/>
+          </a:effectRef>
+          <a:fontRef idx="minor">
+            <a:schemeClr val="lt1"/>
+          </a:fontRef>
+        </p:style>
+        <p:txBody>
+          <a:bodyPr rtlCol="0" anchor="ctr"/>
+          <a:lstStyle/>
+          <a:p>
+            <a:pPr algn="ctr"/>
+          </a:p>
+        </p:txBody>
+      </p:sp>
       <p:pic>
         <p:nvPicPr>
-          <p:cNvPr id="20" name="Picture 19" descr="aulogo_uk_var2_white.png"/>
+          <p:cNvPr id="27" name="Picture 26" descr="aulogo_uk_var2_white.png"/>
           <p:cNvPicPr>
             <a:picLocks noChangeAspect="1"/>
           </p:cNvPicPr>
@@ -9548,8 +9901,8 @@
         </p:blipFill>
         <p:spPr>
           <a:xfrm>
-            <a:off x="5961208" y="5609844"/>
-            <a:ext cx="2162085" cy="457200"/>
+            <a:off x="6897998" y="5724144"/>
+            <a:ext cx="2464778" cy="521207"/>
           </a:xfrm>
           <a:prstGeom prst="rect">
             <a:avLst/>
@@ -9558,7 +9911,7 @@
       </p:pic>
       <p:sp>
         <p:nvSpPr>
-          <p:cNvPr id="21" name="TextBox 20"/>
+          <p:cNvPr id="28" name="TextBox 27"/>
           <p:cNvSpPr txBox="1"/>
           <p:nvPr/>
         </p:nvSpPr>
@@ -9593,7 +9946,7 @@
       </p:sp>
       <p:sp>
         <p:nvSpPr>
-          <p:cNvPr id="22" name="TextBox 21"/>
+          <p:cNvPr id="29" name="TextBox 28"/>
           <p:cNvSpPr txBox="1"/>
           <p:nvPr/>
         </p:nvSpPr>

</xml_diff>

<commit_message>
feat: increase logo size on multiple slides for better visibility
</commit_message>
<xml_diff>
--- a/Plans/template-output/bsides-aarhus-2026-template.pptx
+++ b/Plans/template-output/bsides-aarhus-2026-template.pptx
@@ -20,7 +20,6 @@
     <p:sldId id="268" r:id="rId19"/>
     <p:sldId id="269" r:id="rId20"/>
     <p:sldId id="270" r:id="rId21"/>
-    <p:sldId id="271" r:id="rId22"/>
   </p:sldIdLst>
   <p:sldSz cx="12191695" cy="6858000" type="screen4x3"/>
   <p:notesSz cx="6858000" cy="9144000"/>
@@ -122,7 +121,7 @@
   <p:extLst>
     <p:ext uri="{521415D9-36F7-43E2-AB2F-B90AF26B5E84}">
       <p14:sectionLst xmlns:p14="http://schemas.microsoft.com/office/powerpoint/2010/main">
-        <p14:section name="Template" id="{2C0F9697-2D1C-430E-A95C-B01BA30A179D}">
+        <p14:section name="Template" id="{66F203C2-021A-4CF0-8F42-517E208A9591}">
           <p14:sldIdLst>
             <p14:sldId id="256"/>
             <p14:sldId id="257"/>
@@ -132,22 +131,21 @@
             <p14:sldId id="261"/>
           </p14:sldIdLst>
         </p14:section>
-        <p14:section name="Track 1" id="{39A9BF40-CB57-41E2-A15B-90EFF3F750B7}">
+        <p14:section name="Track 1" id="{735B71DC-E450-4C2F-84C0-9460D21BD227}">
           <p14:sldIdLst>
             <p14:sldId id="262"/>
             <p14:sldId id="263"/>
             <p14:sldId id="264"/>
             <p14:sldId id="265"/>
-            <p14:sldId id="266"/>
           </p14:sldIdLst>
         </p14:section>
-        <p14:section name="Track 2" id="{E9A2597B-766B-4B9B-8203-459B9980B212}">
+        <p14:section name="Track 2" id="{029481B8-7A7B-4E8F-9EA7-B1C93A0C1F19}">
           <p14:sldIdLst>
+            <p14:sldId id="266"/>
             <p14:sldId id="267"/>
             <p14:sldId id="268"/>
             <p14:sldId id="269"/>
             <p14:sldId id="270"/>
-            <p14:sldId id="271"/>
           </p14:sldIdLst>
         </p14:section>
       </p14:sectionLst>
@@ -3178,7 +3176,7 @@
         <p:spPr>
           <a:xfrm>
             <a:off x="548640" y="502920"/>
-            <a:ext cx="864973" cy="640080"/>
+            <a:ext cx="1235676" cy="914400"/>
           </a:xfrm>
           <a:prstGeom prst="rect">
             <a:avLst/>
@@ -3474,7 +3472,7 @@
         <p:spPr>
           <a:xfrm>
             <a:off x="548640" y="457200"/>
-            <a:ext cx="617838" cy="457200"/>
+            <a:ext cx="889686" cy="658368"/>
           </a:xfrm>
           <a:prstGeom prst="rect">
             <a:avLst/>
@@ -3658,7 +3656,7 @@
                 </a:solidFill>
                 <a:latin typeface="Inter"/>
               </a:rPr>
-              <a:t>Mikkel Ole Rømer</a:t>
+              <a:t>Morten von Seelen</a:t>
             </a:r>
           </a:p>
         </p:txBody>
@@ -3693,7 +3691,7 @@
                 </a:solidFill>
                 <a:latin typeface="Inter"/>
               </a:rPr>
-              <a:t>Head of Offensive Security, Truesec</a:t>
+              <a:t>Vice President, Truesec</a:t>
             </a:r>
           </a:p>
         </p:txBody>
@@ -3728,7 +3726,7 @@
                 </a:solidFill>
                 <a:latin typeface="Inter"/>
               </a:rPr>
-              <a:t>Cyber Security Expert - I am mainly engaged with adversary simulation for breach prevention. This experience includes penetration testing and adversary emulation within highly complex infrastructures of some of the largest national and international companies. Besides offensive cyber engagements I have led and designed thorough security analysis exercises of enterprise applications, including review and guidance within secure development practices.</a:t>
+              <a:t>Morten is Vice President at Truesec in Aarhus and builds cool companies. His work focuses on turning outside-in signals about real organizations into actionable risk insight at national scale.</a:t>
             </a:r>
           </a:p>
         </p:txBody>
@@ -3763,7 +3761,7 @@
                 </a:solidFill>
                 <a:latin typeface="JetBrains Mono"/>
               </a:rPr>
-              <a:t>linkedin.com/in/mikkel-r%C3%B8mer  ·  sessionize.com/mikkel-ole-romer</a:t>
+              <a:t>linkedin.com/in/vonseelen  ·  tinyurl.com/MvSeeBlog</a:t>
             </a:r>
           </a:p>
         </p:txBody>
@@ -3909,7 +3907,7 @@
         <p:spPr>
           <a:xfrm>
             <a:off x="548640" y="457200"/>
-            <a:ext cx="617838" cy="457200"/>
+            <a:ext cx="889686" cy="658368"/>
           </a:xfrm>
           <a:prstGeom prst="rect">
             <a:avLst/>
@@ -4093,7 +4091,7 @@
                 </a:solidFill>
                 <a:latin typeface="Inter"/>
               </a:rPr>
-              <a:t>Morten von Seelen</a:t>
+              <a:t>Bence Soóki-Tóth</a:t>
             </a:r>
           </a:p>
         </p:txBody>
@@ -4128,7 +4126,7 @@
                 </a:solidFill>
                 <a:latin typeface="Inter"/>
               </a:rPr>
-              <a:t>Vice President, Truesec</a:t>
+              <a:t>Master's Student, Aarhus University</a:t>
             </a:r>
           </a:p>
         </p:txBody>
@@ -4163,7 +4161,7 @@
                 </a:solidFill>
                 <a:latin typeface="Inter"/>
               </a:rPr>
-              <a:t>Morten is Vice President at Truesec in Aarhus and builds cool companies. His work focuses on turning outside-in signals about real organizations into actionable risk insight at national scale.</a:t>
+              <a:t>Bence is a Master's student at Aarhus University and a research assistant at Eötvös Loránd University, working at the intersection of cryptography, game theory, and consensus protocols.</a:t>
             </a:r>
           </a:p>
         </p:txBody>
@@ -4198,7 +4196,7 @@
                 </a:solidFill>
                 <a:latin typeface="JetBrains Mono"/>
               </a:rPr>
-              <a:t>linkedin.com/in/vonseelen  ·  tinyurl.com/MvSeeBlog</a:t>
+              <a:t>linkedin.com/in/stbence  ·  0xsooki.github.io</a:t>
             </a:r>
           </a:p>
         </p:txBody>
@@ -4344,7 +4342,7 @@
         <p:spPr>
           <a:xfrm>
             <a:off x="548640" y="457200"/>
-            <a:ext cx="617838" cy="457200"/>
+            <a:ext cx="889686" cy="658368"/>
           </a:xfrm>
           <a:prstGeom prst="rect">
             <a:avLst/>
@@ -4528,7 +4526,7 @@
                 </a:solidFill>
                 <a:latin typeface="Inter"/>
               </a:rPr>
-              <a:t>Bence Soóki-Tóth</a:t>
+              <a:t>Eleni Ioakeim</a:t>
             </a:r>
           </a:p>
         </p:txBody>
@@ -4563,7 +4561,7 @@
                 </a:solidFill>
                 <a:latin typeface="Inter"/>
               </a:rPr>
-              <a:t>Master's Student, Aarhus University</a:t>
+              <a:t>OT Threat Analyst, Truesec</a:t>
             </a:r>
           </a:p>
         </p:txBody>
@@ -4598,7 +4596,7 @@
                 </a:solidFill>
                 <a:latin typeface="Inter"/>
               </a:rPr>
-              <a:t>Bence is a Master's student at Aarhus University and a research assistant at Eötvös Loránd University, working at the intersection of cryptography, game theory, and consensus protocols.</a:t>
+              <a:t>Eleni is an OT Threat Analyst at Truesec SOC in Copenhagen, with expertise in OT network security monitoring. Her work contributes to improving SOC processes and detection capabilities for ICS environments.</a:t>
             </a:r>
           </a:p>
         </p:txBody>
@@ -4633,7 +4631,7 @@
                 </a:solidFill>
                 <a:latin typeface="JetBrains Mono"/>
               </a:rPr>
-              <a:t>linkedin.com/in/stbence  ·  0xsooki.github.io</a:t>
+              <a:t>linkedin.com/in/eleni-ioakeim-9bb262aa</a:t>
             </a:r>
           </a:p>
         </p:txBody>
@@ -4779,7 +4777,7 @@
         <p:spPr>
           <a:xfrm>
             <a:off x="548640" y="457200"/>
-            <a:ext cx="617838" cy="457200"/>
+            <a:ext cx="889686" cy="658368"/>
           </a:xfrm>
           <a:prstGeom prst="rect">
             <a:avLst/>
@@ -4963,7 +4961,7 @@
                 </a:solidFill>
                 <a:latin typeface="Inter"/>
               </a:rPr>
-              <a:t>Eleni Ioakeim</a:t>
+              <a:t>Joost van Dijk</a:t>
             </a:r>
           </a:p>
         </p:txBody>
@@ -4998,7 +4996,7 @@
                 </a:solidFill>
                 <a:latin typeface="Inter"/>
               </a:rPr>
-              <a:t>OT Threat Analyst, Truesec</a:t>
+              <a:t>Developer Advocate, Yubico</a:t>
             </a:r>
           </a:p>
         </p:txBody>
@@ -5033,7 +5031,7 @@
                 </a:solidFill>
                 <a:latin typeface="Inter"/>
               </a:rPr>
-              <a:t>Eleni is an OT Threat Analyst at Truesec SOC in Copenhagen, with expertise in OT network security monitoring. Her work contributes to improving SOC processes and detection capabilities for ICS environments.</a:t>
+              <a:t>Joost is a Developer Advocate at Yubico and a security and privacy professional with deep expertise in federated single sign-on, multi-factor authentication, FIDO, passkeys, PKI, TLS, and hardware security.</a:t>
             </a:r>
           </a:p>
         </p:txBody>
@@ -5068,7 +5066,7 @@
                 </a:solidFill>
                 <a:latin typeface="JetBrains Mono"/>
               </a:rPr>
-              <a:t>linkedin.com/in/eleni-ioakeim-9bb262aa</a:t>
+              <a:t>linkedin.com/in/joostd</a:t>
             </a:r>
           </a:p>
         </p:txBody>
@@ -5214,7 +5212,7 @@
         <p:spPr>
           <a:xfrm>
             <a:off x="548640" y="457200"/>
-            <a:ext cx="617838" cy="457200"/>
+            <a:ext cx="889686" cy="658368"/>
           </a:xfrm>
           <a:prstGeom prst="rect">
             <a:avLst/>
@@ -5398,7 +5396,7 @@
                 </a:solidFill>
                 <a:latin typeface="Inter"/>
               </a:rPr>
-              <a:t>Joost van Dijk</a:t>
+              <a:t>Kasper Hald</a:t>
             </a:r>
           </a:p>
         </p:txBody>
@@ -5433,7 +5431,7 @@
                 </a:solidFill>
                 <a:latin typeface="Inter"/>
               </a:rPr>
-              <a:t>Developer Advocate, Yubico</a:t>
+              <a:t>Freelance Consultant, ApplSec Consult</a:t>
             </a:r>
           </a:p>
         </p:txBody>
@@ -5468,7 +5466,7 @@
                 </a:solidFill>
                 <a:latin typeface="Inter"/>
               </a:rPr>
-              <a:t>Joost is a Developer Advocate at Yubico and a security and privacy professional with deep expertise in federated single sign-on, multi-factor authentication, FIDO, passkeys, PKI, TLS, and hardware security.</a:t>
+              <a:t>With an educational background in quantum theory and 20+ years within application security, this topic is where Kasper's past and present meet.</a:t>
             </a:r>
           </a:p>
         </p:txBody>
@@ -5503,7 +5501,7 @@
                 </a:solidFill>
                 <a:latin typeface="JetBrains Mono"/>
               </a:rPr>
-              <a:t>linkedin.com/in/joostd</a:t>
+              <a:t>linkedin.com/in/kasper-hald-6622623</a:t>
             </a:r>
           </a:p>
         </p:txBody>
@@ -5649,442 +5647,7 @@
         <p:spPr>
           <a:xfrm>
             <a:off x="548640" y="457200"/>
-            <a:ext cx="617838" cy="457200"/>
-          </a:xfrm>
-          <a:prstGeom prst="rect">
-            <a:avLst/>
-          </a:prstGeom>
-        </p:spPr>
-      </p:pic>
-      <p:sp>
-        <p:nvSpPr>
-          <p:cNvPr id="4" name="Rounded Rectangle 3"/>
-          <p:cNvSpPr/>
-          <p:nvPr/>
-        </p:nvSpPr>
-        <p:spPr>
-          <a:xfrm>
-            <a:off x="548640" y="1463040"/>
-            <a:ext cx="3840480" cy="4389120"/>
-          </a:xfrm>
-          <a:prstGeom prst="roundRect">
-            <a:avLst>
-              <a:gd name="adj" fmla="val 4000"/>
-            </a:avLst>
-          </a:prstGeom>
-          <a:solidFill>
-            <a:srgbClr val="1A1A25"/>
-          </a:solidFill>
-          <a:ln>
-            <a:noFill/>
-          </a:ln>
-        </p:spPr>
-        <p:style>
-          <a:lnRef idx="1">
-            <a:schemeClr val="accent1"/>
-          </a:lnRef>
-          <a:fillRef idx="3">
-            <a:schemeClr val="accent1"/>
-          </a:fillRef>
-          <a:effectRef idx="2">
-            <a:schemeClr val="accent1"/>
-          </a:effectRef>
-          <a:fontRef idx="minor">
-            <a:schemeClr val="lt1"/>
-          </a:fontRef>
-        </p:style>
-        <p:txBody>
-          <a:bodyPr rtlCol="0" anchor="ctr"/>
-          <a:lstStyle/>
-          <a:p>
-            <a:pPr algn="ctr"/>
-          </a:p>
-        </p:txBody>
-      </p:sp>
-      <p:pic>
-        <p:nvPicPr>
-          <p:cNvPr id="5" name="Picture 4" descr="image.jpg"/>
-          <p:cNvPicPr>
-            <a:picLocks noChangeAspect="1"/>
-          </p:cNvPicPr>
-          <p:nvPr/>
-        </p:nvPicPr>
-        <p:blipFill>
-          <a:blip r:embed="rId4"/>
-          <a:stretch>
-            <a:fillRect/>
-          </a:stretch>
-        </p:blipFill>
-        <p:spPr>
-          <a:xfrm>
-            <a:off x="914400" y="2103120"/>
-            <a:ext cx="3108960" cy="3108960"/>
-          </a:xfrm>
-          <a:prstGeom prst="rect">
-            <a:avLst/>
-          </a:prstGeom>
-        </p:spPr>
-      </p:pic>
-      <p:sp>
-        <p:nvSpPr>
-          <p:cNvPr id="6" name="Rectangle 5"/>
-          <p:cNvSpPr/>
-          <p:nvPr/>
-        </p:nvSpPr>
-        <p:spPr>
-          <a:xfrm>
-            <a:off x="4754880" y="1371600"/>
-            <a:ext cx="640080" cy="38100"/>
-          </a:xfrm>
-          <a:prstGeom prst="rect">
-            <a:avLst/>
-          </a:prstGeom>
-          <a:solidFill>
-            <a:srgbClr val="4AB8D2"/>
-          </a:solidFill>
-          <a:ln>
-            <a:noFill/>
-          </a:ln>
-        </p:spPr>
-        <p:style>
-          <a:lnRef idx="1">
-            <a:schemeClr val="accent1"/>
-          </a:lnRef>
-          <a:fillRef idx="3">
-            <a:schemeClr val="accent1"/>
-          </a:fillRef>
-          <a:effectRef idx="2">
-            <a:schemeClr val="accent1"/>
-          </a:effectRef>
-          <a:fontRef idx="minor">
-            <a:schemeClr val="lt1"/>
-          </a:fontRef>
-        </p:style>
-        <p:txBody>
-          <a:bodyPr rtlCol="0" anchor="ctr"/>
-          <a:lstStyle/>
-          <a:p>
-            <a:pPr algn="ctr"/>
-          </a:p>
-        </p:txBody>
-      </p:sp>
-      <p:sp>
-        <p:nvSpPr>
-          <p:cNvPr id="7" name="TextBox 6"/>
-          <p:cNvSpPr txBox="1"/>
-          <p:nvPr/>
-        </p:nvSpPr>
-        <p:spPr>
-          <a:xfrm>
-            <a:off x="4754880" y="1508760"/>
-            <a:ext cx="6858000" cy="365760"/>
-          </a:xfrm>
-          <a:prstGeom prst="rect">
-            <a:avLst/>
-          </a:prstGeom>
-          <a:noFill/>
-        </p:spPr>
-        <p:txBody>
-          <a:bodyPr wrap="square" lIns="0" rIns="0" tIns="0" bIns="0" anchor="t">
-            <a:spAutoFit/>
-          </a:bodyPr>
-          <a:lstStyle/>
-          <a:p>
-            <a:pPr algn="l"/>
-            <a:r>
-              <a:rPr sz="1400" b="1">
-                <a:solidFill>
-                  <a:srgbClr val="4AB8D2"/>
-                </a:solidFill>
-                <a:latin typeface="JetBrains Mono"/>
-              </a:rPr>
-              <a:t>SPEAKER</a:t>
-            </a:r>
-          </a:p>
-        </p:txBody>
-      </p:sp>
-      <p:sp>
-        <p:nvSpPr>
-          <p:cNvPr id="8" name="TextBox 7"/>
-          <p:cNvSpPr txBox="1"/>
-          <p:nvPr/>
-        </p:nvSpPr>
-        <p:spPr>
-          <a:xfrm>
-            <a:off x="4754880" y="1920240"/>
-            <a:ext cx="6858000" cy="822960"/>
-          </a:xfrm>
-          <a:prstGeom prst="rect">
-            <a:avLst/>
-          </a:prstGeom>
-          <a:noFill/>
-        </p:spPr>
-        <p:txBody>
-          <a:bodyPr wrap="square" lIns="0" rIns="0" tIns="0" bIns="0" anchor="t">
-            <a:spAutoFit/>
-          </a:bodyPr>
-          <a:lstStyle/>
-          <a:p>
-            <a:pPr algn="l"/>
-            <a:r>
-              <a:rPr sz="4000" b="1">
-                <a:solidFill>
-                  <a:srgbClr val="E8E8ED"/>
-                </a:solidFill>
-                <a:latin typeface="Inter"/>
-              </a:rPr>
-              <a:t>Kasper Hald</a:t>
-            </a:r>
-          </a:p>
-        </p:txBody>
-      </p:sp>
-      <p:sp>
-        <p:nvSpPr>
-          <p:cNvPr id="9" name="TextBox 8"/>
-          <p:cNvSpPr txBox="1"/>
-          <p:nvPr/>
-        </p:nvSpPr>
-        <p:spPr>
-          <a:xfrm>
-            <a:off x="4754880" y="2788920"/>
-            <a:ext cx="6858000" cy="457200"/>
-          </a:xfrm>
-          <a:prstGeom prst="rect">
-            <a:avLst/>
-          </a:prstGeom>
-          <a:noFill/>
-        </p:spPr>
-        <p:txBody>
-          <a:bodyPr wrap="square" lIns="0" rIns="0" tIns="0" bIns="0" anchor="t">
-            <a:spAutoFit/>
-          </a:bodyPr>
-          <a:lstStyle/>
-          <a:p>
-            <a:pPr algn="l"/>
-            <a:r>
-              <a:rPr sz="2000" b="0">
-                <a:solidFill>
-                  <a:srgbClr val="6DD0E7"/>
-                </a:solidFill>
-                <a:latin typeface="Inter"/>
-              </a:rPr>
-              <a:t>Freelance Consultant, ApplSec Consult</a:t>
-            </a:r>
-          </a:p>
-        </p:txBody>
-      </p:sp>
-      <p:sp>
-        <p:nvSpPr>
-          <p:cNvPr id="10" name="TextBox 9"/>
-          <p:cNvSpPr txBox="1"/>
-          <p:nvPr/>
-        </p:nvSpPr>
-        <p:spPr>
-          <a:xfrm>
-            <a:off x="4754880" y="3474720"/>
-            <a:ext cx="6858000" cy="2103120"/>
-          </a:xfrm>
-          <a:prstGeom prst="rect">
-            <a:avLst/>
-          </a:prstGeom>
-          <a:noFill/>
-        </p:spPr>
-        <p:txBody>
-          <a:bodyPr wrap="square" lIns="0" rIns="0" tIns="0" bIns="0" anchor="t">
-            <a:spAutoFit/>
-          </a:bodyPr>
-          <a:lstStyle/>
-          <a:p>
-            <a:pPr algn="l"/>
-            <a:r>
-              <a:rPr sz="1600" b="0">
-                <a:solidFill>
-                  <a:srgbClr val="8888A0"/>
-                </a:solidFill>
-                <a:latin typeface="Inter"/>
-              </a:rPr>
-              <a:t>With an educational background in quantum theory and 20+ years within application security, this topic is where Kasper's past and present meet.</a:t>
-            </a:r>
-          </a:p>
-        </p:txBody>
-      </p:sp>
-      <p:sp>
-        <p:nvSpPr>
-          <p:cNvPr id="11" name="TextBox 10"/>
-          <p:cNvSpPr txBox="1"/>
-          <p:nvPr/>
-        </p:nvSpPr>
-        <p:spPr>
-          <a:xfrm>
-            <a:off x="4754880" y="5669280"/>
-            <a:ext cx="6858000" cy="365760"/>
-          </a:xfrm>
-          <a:prstGeom prst="rect">
-            <a:avLst/>
-          </a:prstGeom>
-          <a:noFill/>
-        </p:spPr>
-        <p:txBody>
-          <a:bodyPr wrap="square" lIns="0" rIns="0" tIns="0" bIns="0" anchor="t">
-            <a:spAutoFit/>
-          </a:bodyPr>
-          <a:lstStyle/>
-          <a:p>
-            <a:pPr algn="l"/>
-            <a:r>
-              <a:rPr sz="1400" b="0">
-                <a:solidFill>
-                  <a:srgbClr val="4AB8D2"/>
-                </a:solidFill>
-                <a:latin typeface="JetBrains Mono"/>
-              </a:rPr>
-              <a:t>linkedin.com/in/kasper-hald-6622623</a:t>
-            </a:r>
-          </a:p>
-        </p:txBody>
-      </p:sp>
-      <p:sp>
-        <p:nvSpPr>
-          <p:cNvPr id="12" name="TextBox 11"/>
-          <p:cNvSpPr txBox="1"/>
-          <p:nvPr/>
-        </p:nvSpPr>
-        <p:spPr>
-          <a:xfrm>
-            <a:off x="548640" y="6446520"/>
-            <a:ext cx="7315200" cy="274320"/>
-          </a:xfrm>
-          <a:prstGeom prst="rect">
-            <a:avLst/>
-          </a:prstGeom>
-          <a:noFill/>
-        </p:spPr>
-        <p:txBody>
-          <a:bodyPr wrap="square" lIns="0" rIns="0" tIns="0" bIns="0" anchor="t">
-            <a:spAutoFit/>
-          </a:bodyPr>
-          <a:lstStyle/>
-          <a:p>
-            <a:pPr algn="l"/>
-            <a:r>
-              <a:rPr sz="1000" b="0">
-                <a:solidFill>
-                  <a:srgbClr val="8888A0"/>
-                </a:solidFill>
-                <a:latin typeface="JetBrains Mono"/>
-              </a:rPr>
-              <a:t>BSides Aarhus 2026  ·  June 20  ·  INCUBA Next, Aarhus</a:t>
-            </a:r>
-          </a:p>
-        </p:txBody>
-      </p:sp>
-      <p:sp>
-        <p:nvSpPr>
-          <p:cNvPr id="13" name="TextBox 12"/>
-          <p:cNvSpPr txBox="1"/>
-          <p:nvPr/>
-        </p:nvSpPr>
-        <p:spPr>
-          <a:xfrm>
-            <a:off x="10515600" y="6446520"/>
-            <a:ext cx="1188720" cy="274320"/>
-          </a:xfrm>
-          <a:prstGeom prst="rect">
-            <a:avLst/>
-          </a:prstGeom>
-          <a:noFill/>
-        </p:spPr>
-        <p:txBody>
-          <a:bodyPr wrap="square" lIns="0" rIns="0" tIns="0" bIns="0" anchor="t">
-            <a:spAutoFit/>
-          </a:bodyPr>
-          <a:lstStyle/>
-          <a:p>
-            <a:pPr algn="r"/>
-            <a:r>
-              <a:rPr sz="1000" b="0">
-                <a:solidFill>
-                  <a:srgbClr val="8888A0"/>
-                </a:solidFill>
-                <a:latin typeface="JetBrains Mono"/>
-              </a:rPr>
-              <a:t>Speaker</a:t>
-            </a:r>
-          </a:p>
-        </p:txBody>
-      </p:sp>
-    </p:spTree>
-  </p:cSld>
-  <p:clrMapOvr>
-    <a:masterClrMapping/>
-  </p:clrMapOvr>
-  <mc:AlternateContent xmlns:mc="http://schemas.openxmlformats.org/markup-compatibility/2006">
-    <mc:Choice xmlns:p14="http://schemas.microsoft.com/office/powerpoint/2010/main" Requires="p14">
-      <p:transition spd="med" p14:dur="700">
-        <p:fade/>
-      </p:transition>
-    </mc:Choice>
-    <mc:Fallback>
-      <p:transition spd="med">
-        <p:fade/>
-      </p:transition>
-    </mc:Fallback>
-  </mc:AlternateContent>
-</p:sld>
-</file>
-
-<file path=ppt/slides/slide16.xml><?xml version="1.0" encoding="utf-8"?>
-<p:sld xmlns:a="http://schemas.openxmlformats.org/drawingml/2006/main" xmlns:p="http://schemas.openxmlformats.org/presentationml/2006/main" xmlns:r="http://schemas.openxmlformats.org/officeDocument/2006/relationships">
-  <p:cSld>
-    <p:spTree>
-      <p:nvGrpSpPr>
-        <p:cNvPr id="1" name=""/>
-        <p:cNvGrpSpPr/>
-        <p:nvPr/>
-      </p:nvGrpSpPr>
-      <p:grpSpPr/>
-      <p:pic>
-        <p:nvPicPr>
-          <p:cNvPr id="2" name="Picture 1" descr="_bg.png"/>
-          <p:cNvPicPr>
-            <a:picLocks noChangeAspect="1"/>
-          </p:cNvPicPr>
-          <p:nvPr/>
-        </p:nvPicPr>
-        <p:blipFill>
-          <a:blip r:embed="rId2"/>
-          <a:stretch>
-            <a:fillRect/>
-          </a:stretch>
-        </p:blipFill>
-        <p:spPr>
-          <a:xfrm>
-            <a:off x="0" y="0"/>
-            <a:ext cx="12191695" cy="6858000"/>
-          </a:xfrm>
-          <a:prstGeom prst="rect">
-            <a:avLst/>
-          </a:prstGeom>
-        </p:spPr>
-      </p:pic>
-      <p:pic>
-        <p:nvPicPr>
-          <p:cNvPr id="3" name="Picture 2" descr="logo.png"/>
-          <p:cNvPicPr>
-            <a:picLocks noChangeAspect="1"/>
-          </p:cNvPicPr>
-          <p:nvPr/>
-        </p:nvPicPr>
-        <p:blipFill>
-          <a:blip r:embed="rId3"/>
-          <a:stretch>
-            <a:fillRect/>
-          </a:stretch>
-        </p:blipFill>
-        <p:spPr>
-          <a:xfrm>
-            <a:off x="548640" y="457200"/>
-            <a:ext cx="617838" cy="457200"/>
+            <a:ext cx="889686" cy="658368"/>
           </a:xfrm>
           <a:prstGeom prst="rect">
             <a:avLst/>
@@ -6519,7 +6082,7 @@
         <p:spPr>
           <a:xfrm>
             <a:off x="548640" y="320040"/>
-            <a:ext cx="617838" cy="457200"/>
+            <a:ext cx="889686" cy="658368"/>
           </a:xfrm>
           <a:prstGeom prst="rect">
             <a:avLst/>
@@ -7030,7 +6593,7 @@
                 </a:solidFill>
                 <a:latin typeface="Inter"/>
               </a:rPr>
-              <a:t>Emerging Frontiers: Ransomware Attacks in AI Systems</a:t>
+              <a:t>tba</a:t>
             </a:r>
           </a:p>
           <a:p>
@@ -7042,7 +6605,7 @@
                 </a:solidFill>
                 <a:latin typeface="JetBrains Mono"/>
               </a:rPr>
-              <a:t>Behnaz Karimi</a:t>
+              <a:t/>
             </a:r>
           </a:p>
         </p:txBody>
@@ -8198,7 +7761,7 @@
         <p:spPr>
           <a:xfrm>
             <a:off x="548640" y="457200"/>
-            <a:ext cx="617838" cy="457200"/>
+            <a:ext cx="889686" cy="658368"/>
           </a:xfrm>
           <a:prstGeom prst="rect">
             <a:avLst/>
@@ -8547,7 +8110,7 @@
         <p:spPr>
           <a:xfrm>
             <a:off x="548640" y="457200"/>
-            <a:ext cx="617838" cy="457200"/>
+            <a:ext cx="889686" cy="658368"/>
           </a:xfrm>
           <a:prstGeom prst="rect">
             <a:avLst/>
@@ -8993,7 +8556,7 @@
         <p:spPr>
           <a:xfrm>
             <a:off x="548640" y="320040"/>
-            <a:ext cx="617838" cy="457200"/>
+            <a:ext cx="889686" cy="658368"/>
           </a:xfrm>
           <a:prstGeom prst="rect">
             <a:avLst/>
@@ -10050,7 +9613,7 @@
         <p:spPr>
           <a:xfrm>
             <a:off x="548640" y="457200"/>
-            <a:ext cx="617838" cy="457200"/>
+            <a:ext cx="889686" cy="658368"/>
           </a:xfrm>
           <a:prstGeom prst="rect">
             <a:avLst/>
@@ -10234,7 +9797,7 @@
                 </a:solidFill>
                 <a:latin typeface="Inter"/>
               </a:rPr>
-              <a:t>Behnaz Karimi</a:t>
+              <a:t>Martin Sohn Christensen</a:t>
             </a:r>
           </a:p>
         </p:txBody>
@@ -10269,7 +9832,7 @@
                 </a:solidFill>
                 <a:latin typeface="Inter"/>
               </a:rPr>
-              <a:t>Co-Lead / Leader AI Red Teaming OWASP AI Exchange and Founder RAID-AI Framework</a:t>
+              <a:t>Security Researcher, SpecterOps</a:t>
             </a:r>
           </a:p>
         </p:txBody>
@@ -10304,7 +9867,7 @@
                 </a:solidFill>
                 <a:latin typeface="Inter"/>
               </a:rPr>
-              <a:t>Behnaz is an AI Security Researcher and the Founder/Creator of the RAID-AI Framework. She is also Co-Author, Co-Lead, and Leader of AI Red Teaming at OWASP AI Exchange, where she actively contributes to advancing security practices for AI systems.</a:t>
+              <a:t>Martin is a Security Researcher at SpecterOps in Copenhagen, specializing in Microsoft technologies with expertise in Active Directory, identity attack paths, and secure system configuration. His perspective on security risks and challenges is shaped by a background spanning system administration, an information security degree, and information security consultancy. He is a frequent contributor to the community through online engagement and talks.</a:t>
             </a:r>
           </a:p>
         </p:txBody>
@@ -10339,7 +9902,7 @@
                 </a:solidFill>
                 <a:latin typeface="JetBrains Mono"/>
               </a:rPr>
-              <a:t>linkedin.com/in/behnaz-karimi-behi  ·  substack.com/@behnazkarimi</a:t>
+              <a:t>linkedin.com/in/martinsohn  ·  martinsohn.dk</a:t>
             </a:r>
           </a:p>
         </p:txBody>
@@ -10485,7 +10048,7 @@
         <p:spPr>
           <a:xfrm>
             <a:off x="548640" y="457200"/>
-            <a:ext cx="617838" cy="457200"/>
+            <a:ext cx="889686" cy="658368"/>
           </a:xfrm>
           <a:prstGeom prst="rect">
             <a:avLst/>
@@ -10669,7 +10232,7 @@
                 </a:solidFill>
                 <a:latin typeface="Inter"/>
               </a:rPr>
-              <a:t>Martin Sohn Christensen</a:t>
+              <a:t>Marvin Ngoma</a:t>
             </a:r>
           </a:p>
         </p:txBody>
@@ -10704,7 +10267,7 @@
                 </a:solidFill>
                 <a:latin typeface="Inter"/>
               </a:rPr>
-              <a:t>Security Researcher, SpecterOps</a:t>
+              <a:t>Principal Security Architect, Security Evangelist, Elastic</a:t>
             </a:r>
           </a:p>
         </p:txBody>
@@ -10739,7 +10302,7 @@
                 </a:solidFill>
                 <a:latin typeface="Inter"/>
               </a:rPr>
-              <a:t>Martin is a Security Researcher at SpecterOps in Copenhagen, specializing in Microsoft technologies with expertise in Active Directory, identity attack paths, and secure system configuration. His perspective on security risks and challenges is shaped by a background spanning system administration, an information security degree, and information security consultancy. He is a frequent contributor to the community through online engagement and talks.</a:t>
+              <a:t>Marvin is a Principal Security Architect and Security Evangelist at Elastic, and a seasoned consultant with a strong passion for helping organizations succeed in their cybersecurity programs. He has led many projects in both the private and public sectors — architecting and building Security Operations and Intelligence capabilities, and unifying tools, processes, and people. Before Elastic, he was a security consultant at IBM and the primary SME for QRadar in the Nordics.</a:t>
             </a:r>
           </a:p>
         </p:txBody>
@@ -10774,7 +10337,7 @@
                 </a:solidFill>
                 <a:latin typeface="JetBrains Mono"/>
               </a:rPr>
-              <a:t>linkedin.com/in/martinsohn  ·  martinsohn.dk</a:t>
+              <a:t>linkedin.com/in/tyolani  ·  www.elastic.co/blog/author/marvin-ngoma</a:t>
             </a:r>
           </a:p>
         </p:txBody>
@@ -10920,7 +10483,7 @@
         <p:spPr>
           <a:xfrm>
             <a:off x="548640" y="457200"/>
-            <a:ext cx="617838" cy="457200"/>
+            <a:ext cx="889686" cy="658368"/>
           </a:xfrm>
           <a:prstGeom prst="rect">
             <a:avLst/>
@@ -11104,7 +10667,7 @@
                 </a:solidFill>
                 <a:latin typeface="Inter"/>
               </a:rPr>
-              <a:t>Marvin Ngoma</a:t>
+              <a:t>Mikkel Ole Rømer</a:t>
             </a:r>
           </a:p>
         </p:txBody>
@@ -11139,7 +10702,7 @@
                 </a:solidFill>
                 <a:latin typeface="Inter"/>
               </a:rPr>
-              <a:t>Principal Security Architect, Security Evangelist, Elastic</a:t>
+              <a:t>Head of Offensive Security, Truesec</a:t>
             </a:r>
           </a:p>
         </p:txBody>
@@ -11174,7 +10737,7 @@
                 </a:solidFill>
                 <a:latin typeface="Inter"/>
               </a:rPr>
-              <a:t>Marvin is a Principal Security Architect and Security Evangelist at Elastic, and a seasoned consultant with a strong passion for helping organizations succeed in their cybersecurity programs. He has led many projects in both the private and public sectors — architecting and building Security Operations and Intelligence capabilities, and unifying tools, processes, and people. Before Elastic, he was a security consultant at IBM and the primary SME for QRadar in the Nordics.</a:t>
+              <a:t>Cyber Security Expert - I am mainly engaged with adversary simulation for breach prevention. This experience includes penetration testing and adversary emulation within highly complex infrastructures of some of the largest national and international companies. Besides offensive cyber engagements I have led and designed thorough security analysis exercises of enterprise applications, including review and guidance within secure development practices.</a:t>
             </a:r>
           </a:p>
         </p:txBody>
@@ -11209,7 +10772,7 @@
                 </a:solidFill>
                 <a:latin typeface="JetBrains Mono"/>
               </a:rPr>
-              <a:t>linkedin.com/in/tyolani  ·  www.elastic.co/blog/author/marvin-ngoma</a:t>
+              <a:t>linkedin.com/in/mikkel-r%C3%B8mer  ·  sessionize.com/mikkel-ole-romer</a:t>
             </a:r>
           </a:p>
         </p:txBody>

</xml_diff>

<commit_message>
feat: update sponsor details for Baldur Security and add logo
</commit_message>
<xml_diff>
--- a/Plans/template-output/bsides-aarhus-2026-template.pptx
+++ b/Plans/template-output/bsides-aarhus-2026-template.pptx
@@ -20,6 +20,7 @@
     <p:sldId id="268" r:id="rId19"/>
     <p:sldId id="269" r:id="rId20"/>
     <p:sldId id="270" r:id="rId21"/>
+    <p:sldId id="271" r:id="rId22"/>
   </p:sldIdLst>
   <p:sldSz cx="12191695" cy="6858000" type="screen4x3"/>
   <p:notesSz cx="6858000" cy="9144000"/>
@@ -121,7 +122,7 @@
   <p:extLst>
     <p:ext uri="{521415D9-36F7-43E2-AB2F-B90AF26B5E84}">
       <p14:sectionLst xmlns:p14="http://schemas.microsoft.com/office/powerpoint/2010/main">
-        <p14:section name="Template" id="{66F203C2-021A-4CF0-8F42-517E208A9591}">
+        <p14:section name="Template" id="{D38355C2-0C5B-4B4C-973F-3761CC3B4750}">
           <p14:sldIdLst>
             <p14:sldId id="256"/>
             <p14:sldId id="257"/>
@@ -131,21 +132,22 @@
             <p14:sldId id="261"/>
           </p14:sldIdLst>
         </p14:section>
-        <p14:section name="Track 1" id="{735B71DC-E450-4C2F-84C0-9460D21BD227}">
+        <p14:section name="Track 1" id="{4A6771C1-5239-47EE-A568-A53946C6913C}">
           <p14:sldIdLst>
             <p14:sldId id="262"/>
             <p14:sldId id="263"/>
             <p14:sldId id="264"/>
             <p14:sldId id="265"/>
+            <p14:sldId id="266"/>
           </p14:sldIdLst>
         </p14:section>
-        <p14:section name="Track 2" id="{029481B8-7A7B-4E8F-9EA7-B1C93A0C1F19}">
+        <p14:section name="Track 2" id="{A7297D3A-4D83-493F-A7D2-5AA96433FBAE}">
           <p14:sldIdLst>
-            <p14:sldId id="266"/>
             <p14:sldId id="267"/>
             <p14:sldId id="268"/>
             <p14:sldId id="269"/>
             <p14:sldId id="270"/>
+            <p14:sldId id="271"/>
           </p14:sldIdLst>
         </p14:section>
       </p14:sectionLst>
@@ -3656,7 +3658,7 @@
                 </a:solidFill>
                 <a:latin typeface="Inter"/>
               </a:rPr>
-              <a:t>Morten von Seelen</a:t>
+              <a:t>Mikkel Ole Rømer</a:t>
             </a:r>
           </a:p>
         </p:txBody>
@@ -3691,7 +3693,7 @@
                 </a:solidFill>
                 <a:latin typeface="Inter"/>
               </a:rPr>
-              <a:t>Vice President, Truesec</a:t>
+              <a:t>Head of Offensive Security, Truesec</a:t>
             </a:r>
           </a:p>
         </p:txBody>
@@ -3726,7 +3728,7 @@
                 </a:solidFill>
                 <a:latin typeface="Inter"/>
               </a:rPr>
-              <a:t>Morten is Vice President at Truesec in Aarhus and builds cool companies. His work focuses on turning outside-in signals about real organizations into actionable risk insight at national scale.</a:t>
+              <a:t>Cyber Security Expert - I am mainly engaged with adversary simulation for breach prevention. This experience includes penetration testing and adversary emulation within highly complex infrastructures of some of the largest national and international companies. Besides offensive cyber engagements I have led and designed thorough security analysis exercises of enterprise applications, including review and guidance within secure development practices.</a:t>
             </a:r>
           </a:p>
         </p:txBody>
@@ -3761,7 +3763,7 @@
                 </a:solidFill>
                 <a:latin typeface="JetBrains Mono"/>
               </a:rPr>
-              <a:t>linkedin.com/in/vonseelen  ·  tinyurl.com/MvSeeBlog</a:t>
+              <a:t>linkedin.com/in/mikkel-r%C3%B8mer  ·  sessionize.com/mikkel-ole-romer</a:t>
             </a:r>
           </a:p>
         </p:txBody>
@@ -4091,7 +4093,7 @@
                 </a:solidFill>
                 <a:latin typeface="Inter"/>
               </a:rPr>
-              <a:t>Bence Soóki-Tóth</a:t>
+              <a:t>Morten von Seelen</a:t>
             </a:r>
           </a:p>
         </p:txBody>
@@ -4126,7 +4128,7 @@
                 </a:solidFill>
                 <a:latin typeface="Inter"/>
               </a:rPr>
-              <a:t>Master's Student, Aarhus University</a:t>
+              <a:t>Vice President, Truesec</a:t>
             </a:r>
           </a:p>
         </p:txBody>
@@ -4161,7 +4163,7 @@
                 </a:solidFill>
                 <a:latin typeface="Inter"/>
               </a:rPr>
-              <a:t>Bence is a Master's student at Aarhus University and a research assistant at Eötvös Loránd University, working at the intersection of cryptography, game theory, and consensus protocols.</a:t>
+              <a:t>Morten is Vice President at Truesec in Aarhus and builds cool companies. His work focuses on turning outside-in signals about real organizations into actionable risk insight at national scale.</a:t>
             </a:r>
           </a:p>
         </p:txBody>
@@ -4196,7 +4198,7 @@
                 </a:solidFill>
                 <a:latin typeface="JetBrains Mono"/>
               </a:rPr>
-              <a:t>linkedin.com/in/stbence  ·  0xsooki.github.io</a:t>
+              <a:t>linkedin.com/in/vonseelen  ·  tinyurl.com/MvSeeBlog</a:t>
             </a:r>
           </a:p>
         </p:txBody>
@@ -4526,7 +4528,7 @@
                 </a:solidFill>
                 <a:latin typeface="Inter"/>
               </a:rPr>
-              <a:t>Eleni Ioakeim</a:t>
+              <a:t>Bence Soóki-Tóth</a:t>
             </a:r>
           </a:p>
         </p:txBody>
@@ -4561,7 +4563,7 @@
                 </a:solidFill>
                 <a:latin typeface="Inter"/>
               </a:rPr>
-              <a:t>OT Threat Analyst, Truesec</a:t>
+              <a:t>Master's Student, Aarhus University</a:t>
             </a:r>
           </a:p>
         </p:txBody>
@@ -4596,7 +4598,7 @@
                 </a:solidFill>
                 <a:latin typeface="Inter"/>
               </a:rPr>
-              <a:t>Eleni is an OT Threat Analyst at Truesec SOC in Copenhagen, with expertise in OT network security monitoring. Her work contributes to improving SOC processes and detection capabilities for ICS environments.</a:t>
+              <a:t>Bence is a Master's student at Aarhus University and a research assistant at Eötvös Loránd University, working at the intersection of cryptography, game theory, and consensus protocols.</a:t>
             </a:r>
           </a:p>
         </p:txBody>
@@ -4631,7 +4633,7 @@
                 </a:solidFill>
                 <a:latin typeface="JetBrains Mono"/>
               </a:rPr>
-              <a:t>linkedin.com/in/eleni-ioakeim-9bb262aa</a:t>
+              <a:t>linkedin.com/in/stbence  ·  0xsooki.github.io</a:t>
             </a:r>
           </a:p>
         </p:txBody>
@@ -4961,7 +4963,7 @@
                 </a:solidFill>
                 <a:latin typeface="Inter"/>
               </a:rPr>
-              <a:t>Joost van Dijk</a:t>
+              <a:t>Eleni Ioakeim</a:t>
             </a:r>
           </a:p>
         </p:txBody>
@@ -4996,7 +4998,7 @@
                 </a:solidFill>
                 <a:latin typeface="Inter"/>
               </a:rPr>
-              <a:t>Developer Advocate, Yubico</a:t>
+              <a:t>OT Threat Analyst, Truesec</a:t>
             </a:r>
           </a:p>
         </p:txBody>
@@ -5031,7 +5033,7 @@
                 </a:solidFill>
                 <a:latin typeface="Inter"/>
               </a:rPr>
-              <a:t>Joost is a Developer Advocate at Yubico and a security and privacy professional with deep expertise in federated single sign-on, multi-factor authentication, FIDO, passkeys, PKI, TLS, and hardware security.</a:t>
+              <a:t>Eleni is an OT Threat Analyst at Truesec SOC in Copenhagen, with expertise in OT network security monitoring. Her work contributes to improving SOC processes and detection capabilities for ICS environments.</a:t>
             </a:r>
           </a:p>
         </p:txBody>
@@ -5066,7 +5068,7 @@
                 </a:solidFill>
                 <a:latin typeface="JetBrains Mono"/>
               </a:rPr>
-              <a:t>linkedin.com/in/joostd</a:t>
+              <a:t>linkedin.com/in/eleni-ioakeim-9bb262aa</a:t>
             </a:r>
           </a:p>
         </p:txBody>
@@ -5396,7 +5398,7 @@
                 </a:solidFill>
                 <a:latin typeface="Inter"/>
               </a:rPr>
-              <a:t>Kasper Hald</a:t>
+              <a:t>Joost van Dijk</a:t>
             </a:r>
           </a:p>
         </p:txBody>
@@ -5431,7 +5433,7 @@
                 </a:solidFill>
                 <a:latin typeface="Inter"/>
               </a:rPr>
-              <a:t>Freelance Consultant, ApplSec Consult</a:t>
+              <a:t>Developer Advocate, Yubico</a:t>
             </a:r>
           </a:p>
         </p:txBody>
@@ -5466,7 +5468,7 @@
                 </a:solidFill>
                 <a:latin typeface="Inter"/>
               </a:rPr>
-              <a:t>With an educational background in quantum theory and 20+ years within application security, this topic is where Kasper's past and present meet.</a:t>
+              <a:t>Joost is a Developer Advocate at Yubico and a security and privacy professional with deep expertise in federated single sign-on, multi-factor authentication, FIDO, passkeys, PKI, TLS, and hardware security.</a:t>
             </a:r>
           </a:p>
         </p:txBody>
@@ -5501,7 +5503,7 @@
                 </a:solidFill>
                 <a:latin typeface="JetBrains Mono"/>
               </a:rPr>
-              <a:t>linkedin.com/in/kasper-hald-6622623</a:t>
+              <a:t>linkedin.com/in/joostd</a:t>
             </a:r>
           </a:p>
         </p:txBody>
@@ -5831,6 +5833,441 @@
                 </a:solidFill>
                 <a:latin typeface="Inter"/>
               </a:rPr>
+              <a:t>Kasper Hald</a:t>
+            </a:r>
+          </a:p>
+        </p:txBody>
+      </p:sp>
+      <p:sp>
+        <p:nvSpPr>
+          <p:cNvPr id="9" name="TextBox 8"/>
+          <p:cNvSpPr txBox="1"/>
+          <p:nvPr/>
+        </p:nvSpPr>
+        <p:spPr>
+          <a:xfrm>
+            <a:off x="4754880" y="2788920"/>
+            <a:ext cx="6858000" cy="457200"/>
+          </a:xfrm>
+          <a:prstGeom prst="rect">
+            <a:avLst/>
+          </a:prstGeom>
+          <a:noFill/>
+        </p:spPr>
+        <p:txBody>
+          <a:bodyPr wrap="square" lIns="0" rIns="0" tIns="0" bIns="0" anchor="t">
+            <a:spAutoFit/>
+          </a:bodyPr>
+          <a:lstStyle/>
+          <a:p>
+            <a:pPr algn="l"/>
+            <a:r>
+              <a:rPr sz="2000" b="0">
+                <a:solidFill>
+                  <a:srgbClr val="6DD0E7"/>
+                </a:solidFill>
+                <a:latin typeface="Inter"/>
+              </a:rPr>
+              <a:t>Freelance Consultant, ApplSec Consult</a:t>
+            </a:r>
+          </a:p>
+        </p:txBody>
+      </p:sp>
+      <p:sp>
+        <p:nvSpPr>
+          <p:cNvPr id="10" name="TextBox 9"/>
+          <p:cNvSpPr txBox="1"/>
+          <p:nvPr/>
+        </p:nvSpPr>
+        <p:spPr>
+          <a:xfrm>
+            <a:off x="4754880" y="3474720"/>
+            <a:ext cx="6858000" cy="2103120"/>
+          </a:xfrm>
+          <a:prstGeom prst="rect">
+            <a:avLst/>
+          </a:prstGeom>
+          <a:noFill/>
+        </p:spPr>
+        <p:txBody>
+          <a:bodyPr wrap="square" lIns="0" rIns="0" tIns="0" bIns="0" anchor="t">
+            <a:spAutoFit/>
+          </a:bodyPr>
+          <a:lstStyle/>
+          <a:p>
+            <a:pPr algn="l"/>
+            <a:r>
+              <a:rPr sz="1600" b="0">
+                <a:solidFill>
+                  <a:srgbClr val="8888A0"/>
+                </a:solidFill>
+                <a:latin typeface="Inter"/>
+              </a:rPr>
+              <a:t>With an educational background in quantum theory and 20+ years within application security, this topic is where Kasper's past and present meet.</a:t>
+            </a:r>
+          </a:p>
+        </p:txBody>
+      </p:sp>
+      <p:sp>
+        <p:nvSpPr>
+          <p:cNvPr id="11" name="TextBox 10"/>
+          <p:cNvSpPr txBox="1"/>
+          <p:nvPr/>
+        </p:nvSpPr>
+        <p:spPr>
+          <a:xfrm>
+            <a:off x="4754880" y="5669280"/>
+            <a:ext cx="6858000" cy="365760"/>
+          </a:xfrm>
+          <a:prstGeom prst="rect">
+            <a:avLst/>
+          </a:prstGeom>
+          <a:noFill/>
+        </p:spPr>
+        <p:txBody>
+          <a:bodyPr wrap="square" lIns="0" rIns="0" tIns="0" bIns="0" anchor="t">
+            <a:spAutoFit/>
+          </a:bodyPr>
+          <a:lstStyle/>
+          <a:p>
+            <a:pPr algn="l"/>
+            <a:r>
+              <a:rPr sz="1400" b="0">
+                <a:solidFill>
+                  <a:srgbClr val="4AB8D2"/>
+                </a:solidFill>
+                <a:latin typeface="JetBrains Mono"/>
+              </a:rPr>
+              <a:t>linkedin.com/in/kasper-hald-6622623</a:t>
+            </a:r>
+          </a:p>
+        </p:txBody>
+      </p:sp>
+      <p:sp>
+        <p:nvSpPr>
+          <p:cNvPr id="12" name="TextBox 11"/>
+          <p:cNvSpPr txBox="1"/>
+          <p:nvPr/>
+        </p:nvSpPr>
+        <p:spPr>
+          <a:xfrm>
+            <a:off x="548640" y="6446520"/>
+            <a:ext cx="7315200" cy="274320"/>
+          </a:xfrm>
+          <a:prstGeom prst="rect">
+            <a:avLst/>
+          </a:prstGeom>
+          <a:noFill/>
+        </p:spPr>
+        <p:txBody>
+          <a:bodyPr wrap="square" lIns="0" rIns="0" tIns="0" bIns="0" anchor="t">
+            <a:spAutoFit/>
+          </a:bodyPr>
+          <a:lstStyle/>
+          <a:p>
+            <a:pPr algn="l"/>
+            <a:r>
+              <a:rPr sz="1000" b="0">
+                <a:solidFill>
+                  <a:srgbClr val="8888A0"/>
+                </a:solidFill>
+                <a:latin typeface="JetBrains Mono"/>
+              </a:rPr>
+              <a:t>BSides Aarhus 2026  ·  June 20  ·  INCUBA Next, Aarhus</a:t>
+            </a:r>
+          </a:p>
+        </p:txBody>
+      </p:sp>
+      <p:sp>
+        <p:nvSpPr>
+          <p:cNvPr id="13" name="TextBox 12"/>
+          <p:cNvSpPr txBox="1"/>
+          <p:nvPr/>
+        </p:nvSpPr>
+        <p:spPr>
+          <a:xfrm>
+            <a:off x="10515600" y="6446520"/>
+            <a:ext cx="1188720" cy="274320"/>
+          </a:xfrm>
+          <a:prstGeom prst="rect">
+            <a:avLst/>
+          </a:prstGeom>
+          <a:noFill/>
+        </p:spPr>
+        <p:txBody>
+          <a:bodyPr wrap="square" lIns="0" rIns="0" tIns="0" bIns="0" anchor="t">
+            <a:spAutoFit/>
+          </a:bodyPr>
+          <a:lstStyle/>
+          <a:p>
+            <a:pPr algn="r"/>
+            <a:r>
+              <a:rPr sz="1000" b="0">
+                <a:solidFill>
+                  <a:srgbClr val="8888A0"/>
+                </a:solidFill>
+                <a:latin typeface="JetBrains Mono"/>
+              </a:rPr>
+              <a:t>Speaker</a:t>
+            </a:r>
+          </a:p>
+        </p:txBody>
+      </p:sp>
+    </p:spTree>
+  </p:cSld>
+  <p:clrMapOvr>
+    <a:masterClrMapping/>
+  </p:clrMapOvr>
+  <mc:AlternateContent xmlns:mc="http://schemas.openxmlformats.org/markup-compatibility/2006">
+    <mc:Choice xmlns:p14="http://schemas.microsoft.com/office/powerpoint/2010/main" Requires="p14">
+      <p:transition spd="med" p14:dur="700">
+        <p:fade/>
+      </p:transition>
+    </mc:Choice>
+    <mc:Fallback>
+      <p:transition spd="med">
+        <p:fade/>
+      </p:transition>
+    </mc:Fallback>
+  </mc:AlternateContent>
+</p:sld>
+</file>
+
+<file path=ppt/slides/slide16.xml><?xml version="1.0" encoding="utf-8"?>
+<p:sld xmlns:a="http://schemas.openxmlformats.org/drawingml/2006/main" xmlns:p="http://schemas.openxmlformats.org/presentationml/2006/main" xmlns:r="http://schemas.openxmlformats.org/officeDocument/2006/relationships">
+  <p:cSld>
+    <p:spTree>
+      <p:nvGrpSpPr>
+        <p:cNvPr id="1" name=""/>
+        <p:cNvGrpSpPr/>
+        <p:nvPr/>
+      </p:nvGrpSpPr>
+      <p:grpSpPr/>
+      <p:pic>
+        <p:nvPicPr>
+          <p:cNvPr id="2" name="Picture 1" descr="_bg.png"/>
+          <p:cNvPicPr>
+            <a:picLocks noChangeAspect="1"/>
+          </p:cNvPicPr>
+          <p:nvPr/>
+        </p:nvPicPr>
+        <p:blipFill>
+          <a:blip r:embed="rId2"/>
+          <a:stretch>
+            <a:fillRect/>
+          </a:stretch>
+        </p:blipFill>
+        <p:spPr>
+          <a:xfrm>
+            <a:off x="0" y="0"/>
+            <a:ext cx="12191695" cy="6858000"/>
+          </a:xfrm>
+          <a:prstGeom prst="rect">
+            <a:avLst/>
+          </a:prstGeom>
+        </p:spPr>
+      </p:pic>
+      <p:pic>
+        <p:nvPicPr>
+          <p:cNvPr id="3" name="Picture 2" descr="logo.png"/>
+          <p:cNvPicPr>
+            <a:picLocks noChangeAspect="1"/>
+          </p:cNvPicPr>
+          <p:nvPr/>
+        </p:nvPicPr>
+        <p:blipFill>
+          <a:blip r:embed="rId3"/>
+          <a:stretch>
+            <a:fillRect/>
+          </a:stretch>
+        </p:blipFill>
+        <p:spPr>
+          <a:xfrm>
+            <a:off x="548640" y="457200"/>
+            <a:ext cx="889686" cy="658368"/>
+          </a:xfrm>
+          <a:prstGeom prst="rect">
+            <a:avLst/>
+          </a:prstGeom>
+        </p:spPr>
+      </p:pic>
+      <p:sp>
+        <p:nvSpPr>
+          <p:cNvPr id="4" name="Rounded Rectangle 3"/>
+          <p:cNvSpPr/>
+          <p:nvPr/>
+        </p:nvSpPr>
+        <p:spPr>
+          <a:xfrm>
+            <a:off x="548640" y="1463040"/>
+            <a:ext cx="3840480" cy="4389120"/>
+          </a:xfrm>
+          <a:prstGeom prst="roundRect">
+            <a:avLst>
+              <a:gd name="adj" fmla="val 4000"/>
+            </a:avLst>
+          </a:prstGeom>
+          <a:solidFill>
+            <a:srgbClr val="1A1A25"/>
+          </a:solidFill>
+          <a:ln>
+            <a:noFill/>
+          </a:ln>
+        </p:spPr>
+        <p:style>
+          <a:lnRef idx="1">
+            <a:schemeClr val="accent1"/>
+          </a:lnRef>
+          <a:fillRef idx="3">
+            <a:schemeClr val="accent1"/>
+          </a:fillRef>
+          <a:effectRef idx="2">
+            <a:schemeClr val="accent1"/>
+          </a:effectRef>
+          <a:fontRef idx="minor">
+            <a:schemeClr val="lt1"/>
+          </a:fontRef>
+        </p:style>
+        <p:txBody>
+          <a:bodyPr rtlCol="0" anchor="ctr"/>
+          <a:lstStyle/>
+          <a:p>
+            <a:pPr algn="ctr"/>
+          </a:p>
+        </p:txBody>
+      </p:sp>
+      <p:pic>
+        <p:nvPicPr>
+          <p:cNvPr id="5" name="Picture 4" descr="image.jpg"/>
+          <p:cNvPicPr>
+            <a:picLocks noChangeAspect="1"/>
+          </p:cNvPicPr>
+          <p:nvPr/>
+        </p:nvPicPr>
+        <p:blipFill>
+          <a:blip r:embed="rId4"/>
+          <a:stretch>
+            <a:fillRect/>
+          </a:stretch>
+        </p:blipFill>
+        <p:spPr>
+          <a:xfrm>
+            <a:off x="914400" y="2103120"/>
+            <a:ext cx="3108960" cy="3108960"/>
+          </a:xfrm>
+          <a:prstGeom prst="rect">
+            <a:avLst/>
+          </a:prstGeom>
+        </p:spPr>
+      </p:pic>
+      <p:sp>
+        <p:nvSpPr>
+          <p:cNvPr id="6" name="Rectangle 5"/>
+          <p:cNvSpPr/>
+          <p:nvPr/>
+        </p:nvSpPr>
+        <p:spPr>
+          <a:xfrm>
+            <a:off x="4754880" y="1371600"/>
+            <a:ext cx="640080" cy="38100"/>
+          </a:xfrm>
+          <a:prstGeom prst="rect">
+            <a:avLst/>
+          </a:prstGeom>
+          <a:solidFill>
+            <a:srgbClr val="4AB8D2"/>
+          </a:solidFill>
+          <a:ln>
+            <a:noFill/>
+          </a:ln>
+        </p:spPr>
+        <p:style>
+          <a:lnRef idx="1">
+            <a:schemeClr val="accent1"/>
+          </a:lnRef>
+          <a:fillRef idx="3">
+            <a:schemeClr val="accent1"/>
+          </a:fillRef>
+          <a:effectRef idx="2">
+            <a:schemeClr val="accent1"/>
+          </a:effectRef>
+          <a:fontRef idx="minor">
+            <a:schemeClr val="lt1"/>
+          </a:fontRef>
+        </p:style>
+        <p:txBody>
+          <a:bodyPr rtlCol="0" anchor="ctr"/>
+          <a:lstStyle/>
+          <a:p>
+            <a:pPr algn="ctr"/>
+          </a:p>
+        </p:txBody>
+      </p:sp>
+      <p:sp>
+        <p:nvSpPr>
+          <p:cNvPr id="7" name="TextBox 6"/>
+          <p:cNvSpPr txBox="1"/>
+          <p:nvPr/>
+        </p:nvSpPr>
+        <p:spPr>
+          <a:xfrm>
+            <a:off x="4754880" y="1508760"/>
+            <a:ext cx="6858000" cy="365760"/>
+          </a:xfrm>
+          <a:prstGeom prst="rect">
+            <a:avLst/>
+          </a:prstGeom>
+          <a:noFill/>
+        </p:spPr>
+        <p:txBody>
+          <a:bodyPr wrap="square" lIns="0" rIns="0" tIns="0" bIns="0" anchor="t">
+            <a:spAutoFit/>
+          </a:bodyPr>
+          <a:lstStyle/>
+          <a:p>
+            <a:pPr algn="l"/>
+            <a:r>
+              <a:rPr sz="1400" b="1">
+                <a:solidFill>
+                  <a:srgbClr val="4AB8D2"/>
+                </a:solidFill>
+                <a:latin typeface="JetBrains Mono"/>
+              </a:rPr>
+              <a:t>SPEAKER</a:t>
+            </a:r>
+          </a:p>
+        </p:txBody>
+      </p:sp>
+      <p:sp>
+        <p:nvSpPr>
+          <p:cNvPr id="8" name="TextBox 7"/>
+          <p:cNvSpPr txBox="1"/>
+          <p:nvPr/>
+        </p:nvSpPr>
+        <p:spPr>
+          <a:xfrm>
+            <a:off x="4754880" y="1920240"/>
+            <a:ext cx="6858000" cy="822960"/>
+          </a:xfrm>
+          <a:prstGeom prst="rect">
+            <a:avLst/>
+          </a:prstGeom>
+          <a:noFill/>
+        </p:spPr>
+        <p:txBody>
+          <a:bodyPr wrap="square" lIns="0" rIns="0" tIns="0" bIns="0" anchor="t">
+            <a:spAutoFit/>
+          </a:bodyPr>
+          <a:lstStyle/>
+          <a:p>
+            <a:pPr algn="l"/>
+            <a:r>
+              <a:rPr sz="4000" b="1">
+                <a:solidFill>
+                  <a:srgbClr val="E8E8ED"/>
+                </a:solidFill>
+                <a:latin typeface="Inter"/>
+              </a:rPr>
               <a:t>Tom Kern</a:t>
             </a:r>
           </a:p>
@@ -6523,7 +6960,7 @@
                 </a:solidFill>
                 <a:latin typeface="Inter"/>
               </a:rPr>
-              <a:t>Breakfast and network</a:t>
+              <a:t>Breakfast</a:t>
             </a:r>
           </a:p>
         </p:txBody>
@@ -6593,7 +7030,7 @@
                 </a:solidFill>
                 <a:latin typeface="Inter"/>
               </a:rPr>
-              <a:t>tba</a:t>
+              <a:t>To Be Announced</a:t>
             </a:r>
           </a:p>
           <a:p>
@@ -6605,7 +7042,7 @@
                 </a:solidFill>
                 <a:latin typeface="JetBrains Mono"/>
               </a:rPr>
-              <a:t/>
+              <a:t>Klaus Agnoletti</a:t>
             </a:r>
           </a:p>
         </p:txBody>
@@ -8992,7 +9429,7 @@
       </p:sp>
       <p:pic>
         <p:nvPicPr>
-          <p:cNvPr id="15" name="Picture 14" descr="tech-hub-aarhus.png"/>
+          <p:cNvPr id="15" name="Picture 14" descr="_sponsor_baldur_security_final.png"/>
           <p:cNvPicPr>
             <a:picLocks noChangeAspect="1"/>
           </p:cNvPicPr>
@@ -9006,8 +9443,8 @@
         </p:blipFill>
         <p:spPr>
           <a:xfrm>
-            <a:off x="3317316" y="3438144"/>
-            <a:ext cx="1487981" cy="521207"/>
+            <a:off x="2627551" y="3438144"/>
+            <a:ext cx="2867512" cy="521207"/>
           </a:xfrm>
           <a:prstGeom prst="rect">
             <a:avLst/>
@@ -9177,7 +9614,7 @@
         </p:nvSpPr>
         <p:spPr>
           <a:xfrm>
-            <a:off x="4267047" y="4471416"/>
+            <a:off x="2232507" y="4471416"/>
             <a:ext cx="3657600" cy="740664"/>
           </a:xfrm>
           <a:prstGeom prst="roundRect">
@@ -9221,7 +9658,7 @@
       </p:sp>
       <p:pic>
         <p:nvPicPr>
-          <p:cNvPr id="21" name="Picture 20" descr="Danske BankLogo White RGB.png"/>
+          <p:cNvPr id="21" name="Picture 20" descr="tech-hub-aarhus.png"/>
           <p:cNvPicPr>
             <a:picLocks noChangeAspect="1"/>
           </p:cNvPicPr>
@@ -9235,8 +9672,8 @@
         </p:blipFill>
         <p:spPr>
           <a:xfrm>
-            <a:off x="4376775" y="4665768"/>
-            <a:ext cx="3438144" cy="351958"/>
+            <a:off x="3317316" y="4581144"/>
+            <a:ext cx="1487981" cy="521207"/>
           </a:xfrm>
           <a:prstGeom prst="rect">
             <a:avLst/>
@@ -9245,48 +9682,13 @@
       </p:pic>
       <p:sp>
         <p:nvSpPr>
-          <p:cNvPr id="22" name="TextBox 21"/>
-          <p:cNvSpPr txBox="1"/>
-          <p:nvPr/>
-        </p:nvSpPr>
-        <p:spPr>
-          <a:xfrm>
-            <a:off x="548640" y="5303520"/>
-            <a:ext cx="11094415" cy="256032"/>
-          </a:xfrm>
-          <a:prstGeom prst="rect">
-            <a:avLst/>
-          </a:prstGeom>
-          <a:noFill/>
-        </p:spPr>
-        <p:txBody>
-          <a:bodyPr wrap="square" lIns="0" rIns="0" tIns="0" bIns="0" anchor="t">
-            <a:spAutoFit/>
-          </a:bodyPr>
-          <a:lstStyle/>
-          <a:p>
-            <a:pPr algn="ctr"/>
-            <a:r>
-              <a:rPr sz="1200" b="1">
-                <a:solidFill>
-                  <a:srgbClr val="4AB8D2"/>
-                </a:solidFill>
-                <a:latin typeface="JetBrains Mono"/>
-              </a:rPr>
-              <a:t>VENUE SPONSORS</a:t>
-            </a:r>
-          </a:p>
-        </p:txBody>
-      </p:sp>
-      <p:sp>
-        <p:nvSpPr>
-          <p:cNvPr id="23" name="Rounded Rectangle 22"/>
+          <p:cNvPr id="22" name="Rounded Rectangle 21"/>
           <p:cNvSpPr/>
           <p:nvPr/>
         </p:nvSpPr>
         <p:spPr>
           <a:xfrm>
-            <a:off x="2232507" y="5614416"/>
+            <a:off x="6301587" y="4471416"/>
             <a:ext cx="3657600" cy="740664"/>
           </a:xfrm>
           <a:prstGeom prst="roundRect">
@@ -9328,55 +9730,9 @@
           </a:p>
         </p:txBody>
       </p:sp>
-      <p:sp>
-        <p:nvSpPr>
-          <p:cNvPr id="24" name="Rounded Rectangle 23"/>
-          <p:cNvSpPr/>
-          <p:nvPr/>
-        </p:nvSpPr>
-        <p:spPr>
-          <a:xfrm>
-            <a:off x="2305659" y="5687568"/>
-            <a:ext cx="3511296" cy="594359"/>
-          </a:xfrm>
-          <a:prstGeom prst="roundRect">
-            <a:avLst>
-              <a:gd name="adj" fmla="val 8000"/>
-            </a:avLst>
-          </a:prstGeom>
-          <a:solidFill>
-            <a:srgbClr val="FFFFFF"/>
-          </a:solidFill>
-          <a:ln>
-            <a:noFill/>
-          </a:ln>
-          <a:effectLst/>
-        </p:spPr>
-        <p:style>
-          <a:lnRef idx="1">
-            <a:schemeClr val="accent1"/>
-          </a:lnRef>
-          <a:fillRef idx="3">
-            <a:schemeClr val="accent1"/>
-          </a:fillRef>
-          <a:effectRef idx="2">
-            <a:schemeClr val="accent1"/>
-          </a:effectRef>
-          <a:fontRef idx="minor">
-            <a:schemeClr val="lt1"/>
-          </a:fontRef>
-        </p:style>
-        <p:txBody>
-          <a:bodyPr rtlCol="0" anchor="ctr"/>
-          <a:lstStyle/>
-          <a:p>
-            <a:pPr algn="ctr"/>
-          </a:p>
-        </p:txBody>
-      </p:sp>
       <p:pic>
         <p:nvPicPr>
-          <p:cNvPr id="25" name="Picture 24" descr="_sponsor_incuba-logo.png"/>
+          <p:cNvPr id="23" name="Picture 22" descr="Danske BankLogo White RGB.png"/>
           <p:cNvPicPr>
             <a:picLocks noChangeAspect="1"/>
           </p:cNvPicPr>
@@ -9390,8 +9746,8 @@
         </p:blipFill>
         <p:spPr>
           <a:xfrm>
-            <a:off x="3243011" y="5724144"/>
-            <a:ext cx="1636593" cy="521207"/>
+            <a:off x="6411315" y="4665768"/>
+            <a:ext cx="3438144" cy="351958"/>
           </a:xfrm>
           <a:prstGeom prst="rect">
             <a:avLst/>
@@ -9400,13 +9756,48 @@
       </p:pic>
       <p:sp>
         <p:nvSpPr>
-          <p:cNvPr id="26" name="Rounded Rectangle 25"/>
+          <p:cNvPr id="24" name="TextBox 23"/>
+          <p:cNvSpPr txBox="1"/>
+          <p:nvPr/>
+        </p:nvSpPr>
+        <p:spPr>
+          <a:xfrm>
+            <a:off x="548640" y="5303520"/>
+            <a:ext cx="11094415" cy="256032"/>
+          </a:xfrm>
+          <a:prstGeom prst="rect">
+            <a:avLst/>
+          </a:prstGeom>
+          <a:noFill/>
+        </p:spPr>
+        <p:txBody>
+          <a:bodyPr wrap="square" lIns="0" rIns="0" tIns="0" bIns="0" anchor="t">
+            <a:spAutoFit/>
+          </a:bodyPr>
+          <a:lstStyle/>
+          <a:p>
+            <a:pPr algn="ctr"/>
+            <a:r>
+              <a:rPr sz="1200" b="1">
+                <a:solidFill>
+                  <a:srgbClr val="4AB8D2"/>
+                </a:solidFill>
+                <a:latin typeface="JetBrains Mono"/>
+              </a:rPr>
+              <a:t>VENUE SPONSORS</a:t>
+            </a:r>
+          </a:p>
+        </p:txBody>
+      </p:sp>
+      <p:sp>
+        <p:nvSpPr>
+          <p:cNvPr id="25" name="Rounded Rectangle 24"/>
           <p:cNvSpPr/>
           <p:nvPr/>
         </p:nvSpPr>
         <p:spPr>
           <a:xfrm>
-            <a:off x="6301587" y="5614416"/>
+            <a:off x="2232507" y="5614416"/>
             <a:ext cx="3657600" cy="740664"/>
           </a:xfrm>
           <a:prstGeom prst="roundRect">
@@ -9448,9 +9839,55 @@
           </a:p>
         </p:txBody>
       </p:sp>
+      <p:sp>
+        <p:nvSpPr>
+          <p:cNvPr id="26" name="Rounded Rectangle 25"/>
+          <p:cNvSpPr/>
+          <p:nvPr/>
+        </p:nvSpPr>
+        <p:spPr>
+          <a:xfrm>
+            <a:off x="2305659" y="5687568"/>
+            <a:ext cx="3511296" cy="594359"/>
+          </a:xfrm>
+          <a:prstGeom prst="roundRect">
+            <a:avLst>
+              <a:gd name="adj" fmla="val 8000"/>
+            </a:avLst>
+          </a:prstGeom>
+          <a:solidFill>
+            <a:srgbClr val="FFFFFF"/>
+          </a:solidFill>
+          <a:ln>
+            <a:noFill/>
+          </a:ln>
+          <a:effectLst/>
+        </p:spPr>
+        <p:style>
+          <a:lnRef idx="1">
+            <a:schemeClr val="accent1"/>
+          </a:lnRef>
+          <a:fillRef idx="3">
+            <a:schemeClr val="accent1"/>
+          </a:fillRef>
+          <a:effectRef idx="2">
+            <a:schemeClr val="accent1"/>
+          </a:effectRef>
+          <a:fontRef idx="minor">
+            <a:schemeClr val="lt1"/>
+          </a:fontRef>
+        </p:style>
+        <p:txBody>
+          <a:bodyPr rtlCol="0" anchor="ctr"/>
+          <a:lstStyle/>
+          <a:p>
+            <a:pPr algn="ctr"/>
+          </a:p>
+        </p:txBody>
+      </p:sp>
       <p:pic>
         <p:nvPicPr>
-          <p:cNvPr id="27" name="Picture 26" descr="aulogo_uk_var2_white.png"/>
+          <p:cNvPr id="27" name="Picture 26" descr="_sponsor_incuba-logo.png"/>
           <p:cNvPicPr>
             <a:picLocks noChangeAspect="1"/>
           </p:cNvPicPr>
@@ -9464,6 +9901,80 @@
         </p:blipFill>
         <p:spPr>
           <a:xfrm>
+            <a:off x="3243011" y="5724144"/>
+            <a:ext cx="1636593" cy="521207"/>
+          </a:xfrm>
+          <a:prstGeom prst="rect">
+            <a:avLst/>
+          </a:prstGeom>
+        </p:spPr>
+      </p:pic>
+      <p:sp>
+        <p:nvSpPr>
+          <p:cNvPr id="28" name="Rounded Rectangle 27"/>
+          <p:cNvSpPr/>
+          <p:nvPr/>
+        </p:nvSpPr>
+        <p:spPr>
+          <a:xfrm>
+            <a:off x="6301587" y="5614416"/>
+            <a:ext cx="3657600" cy="740664"/>
+          </a:xfrm>
+          <a:prstGeom prst="roundRect">
+            <a:avLst>
+              <a:gd name="adj" fmla="val 8000"/>
+            </a:avLst>
+          </a:prstGeom>
+          <a:solidFill>
+            <a:srgbClr val="1A1A25">
+              <a:alpha val="12000"/>
+            </a:srgbClr>
+          </a:solidFill>
+          <a:ln w="9525">
+            <a:solidFill>
+              <a:srgbClr val="2A2A3A"/>
+            </a:solidFill>
+          </a:ln>
+          <a:effectLst/>
+        </p:spPr>
+        <p:style>
+          <a:lnRef idx="1">
+            <a:schemeClr val="accent1"/>
+          </a:lnRef>
+          <a:fillRef idx="3">
+            <a:schemeClr val="accent1"/>
+          </a:fillRef>
+          <a:effectRef idx="2">
+            <a:schemeClr val="accent1"/>
+          </a:effectRef>
+          <a:fontRef idx="minor">
+            <a:schemeClr val="lt1"/>
+          </a:fontRef>
+        </p:style>
+        <p:txBody>
+          <a:bodyPr rtlCol="0" anchor="ctr"/>
+          <a:lstStyle/>
+          <a:p>
+            <a:pPr algn="ctr"/>
+          </a:p>
+        </p:txBody>
+      </p:sp>
+      <p:pic>
+        <p:nvPicPr>
+          <p:cNvPr id="29" name="Picture 28" descr="aulogo_uk_var2_white.png"/>
+          <p:cNvPicPr>
+            <a:picLocks noChangeAspect="1"/>
+          </p:cNvPicPr>
+          <p:nvPr/>
+        </p:nvPicPr>
+        <p:blipFill>
+          <a:blip r:embed="rId11"/>
+          <a:stretch>
+            <a:fillRect/>
+          </a:stretch>
+        </p:blipFill>
+        <p:spPr>
+          <a:xfrm>
             <a:off x="6897998" y="5724144"/>
             <a:ext cx="2464778" cy="521207"/>
           </a:xfrm>
@@ -9474,7 +9985,7 @@
       </p:pic>
       <p:sp>
         <p:nvSpPr>
-          <p:cNvPr id="28" name="TextBox 27"/>
+          <p:cNvPr id="30" name="TextBox 29"/>
           <p:cNvSpPr txBox="1"/>
           <p:nvPr/>
         </p:nvSpPr>
@@ -9509,7 +10020,7 @@
       </p:sp>
       <p:sp>
         <p:nvSpPr>
-          <p:cNvPr id="29" name="TextBox 28"/>
+          <p:cNvPr id="31" name="TextBox 30"/>
           <p:cNvSpPr txBox="1"/>
           <p:nvPr/>
         </p:nvSpPr>
@@ -9797,7 +10308,7 @@
                 </a:solidFill>
                 <a:latin typeface="Inter"/>
               </a:rPr>
-              <a:t>Martin Sohn Christensen</a:t>
+              <a:t>Klaus Agnoletti</a:t>
             </a:r>
           </a:p>
         </p:txBody>
@@ -9832,7 +10343,7 @@
                 </a:solidFill>
                 <a:latin typeface="Inter"/>
               </a:rPr>
-              <a:t>Security Researcher, SpecterOps</a:t>
+              <a:t>Storytelling Cyber Security Advisor, Relations Security</a:t>
             </a:r>
           </a:p>
         </p:txBody>
@@ -9867,7 +10378,7 @@
                 </a:solidFill>
                 <a:latin typeface="Inter"/>
               </a:rPr>
-              <a:t>Martin is a Security Researcher at SpecterOps in Copenhagen, specializing in Microsoft technologies with expertise in Active Directory, identity attack paths, and secure system configuration. His perspective on security risks and challenges is shaped by a background spanning system administration, an information security degree, and information security consultancy. He is a frequent contributor to the community through online engagement and talks.</a:t>
+              <a:t>Klaus Agnoletti has been an all-round infosec professional since 2004. He co-founded BSides København in 2019. Recently he started out as an infosec freelancer focusing on storytelling in marketing, employer branding, game-based learning or wherever new ideas bring him.</a:t>
             </a:r>
           </a:p>
         </p:txBody>
@@ -9902,7 +10413,7 @@
                 </a:solidFill>
                 <a:latin typeface="JetBrains Mono"/>
               </a:rPr>
-              <a:t>linkedin.com/in/martinsohn  ·  martinsohn.dk</a:t>
+              <a:t>linkedin.com/in/agnoletti</a:t>
             </a:r>
           </a:p>
         </p:txBody>
@@ -10232,7 +10743,7 @@
                 </a:solidFill>
                 <a:latin typeface="Inter"/>
               </a:rPr>
-              <a:t>Marvin Ngoma</a:t>
+              <a:t>Martin Sohn Christensen</a:t>
             </a:r>
           </a:p>
         </p:txBody>
@@ -10267,7 +10778,7 @@
                 </a:solidFill>
                 <a:latin typeface="Inter"/>
               </a:rPr>
-              <a:t>Principal Security Architect, Security Evangelist, Elastic</a:t>
+              <a:t>Security Researcher, SpecterOps</a:t>
             </a:r>
           </a:p>
         </p:txBody>
@@ -10302,7 +10813,7 @@
                 </a:solidFill>
                 <a:latin typeface="Inter"/>
               </a:rPr>
-              <a:t>Marvin is a Principal Security Architect and Security Evangelist at Elastic, and a seasoned consultant with a strong passion for helping organizations succeed in their cybersecurity programs. He has led many projects in both the private and public sectors — architecting and building Security Operations and Intelligence capabilities, and unifying tools, processes, and people. Before Elastic, he was a security consultant at IBM and the primary SME for QRadar in the Nordics.</a:t>
+              <a:t>Martin is a Security Researcher at SpecterOps in Copenhagen, specializing in Microsoft technologies with expertise in Active Directory, identity attack paths, and secure system configuration. His perspective on security risks and challenges is shaped by a background spanning system administration, an information security degree, and information security consultancy. He is a frequent contributor to the community through online engagement and talks.</a:t>
             </a:r>
           </a:p>
         </p:txBody>
@@ -10337,7 +10848,7 @@
                 </a:solidFill>
                 <a:latin typeface="JetBrains Mono"/>
               </a:rPr>
-              <a:t>linkedin.com/in/tyolani  ·  www.elastic.co/blog/author/marvin-ngoma</a:t>
+              <a:t>linkedin.com/in/martinsohn  ·  martinsohn.dk</a:t>
             </a:r>
           </a:p>
         </p:txBody>
@@ -10667,7 +11178,7 @@
                 </a:solidFill>
                 <a:latin typeface="Inter"/>
               </a:rPr>
-              <a:t>Mikkel Ole Rømer</a:t>
+              <a:t>Marvin Ngoma</a:t>
             </a:r>
           </a:p>
         </p:txBody>
@@ -10702,7 +11213,7 @@
                 </a:solidFill>
                 <a:latin typeface="Inter"/>
               </a:rPr>
-              <a:t>Head of Offensive Security, Truesec</a:t>
+              <a:t>Principal Security Architect, Security Evangelist, Elastic</a:t>
             </a:r>
           </a:p>
         </p:txBody>
@@ -10737,7 +11248,7 @@
                 </a:solidFill>
                 <a:latin typeface="Inter"/>
               </a:rPr>
-              <a:t>Cyber Security Expert - I am mainly engaged with adversary simulation for breach prevention. This experience includes penetration testing and adversary emulation within highly complex infrastructures of some of the largest national and international companies. Besides offensive cyber engagements I have led and designed thorough security analysis exercises of enterprise applications, including review and guidance within secure development practices.</a:t>
+              <a:t>Marvin is a Principal Security Architect and Security Evangelist at Elastic, and a seasoned consultant with a strong passion for helping organizations succeed in their cybersecurity programs. He has led many projects in both the private and public sectors — architecting and building Security Operations and Intelligence capabilities, and unifying tools, processes, and people. Before Elastic, he was a security consultant at IBM and the primary SME for QRadar in the Nordics.</a:t>
             </a:r>
           </a:p>
         </p:txBody>
@@ -10772,7 +11283,7 @@
                 </a:solidFill>
                 <a:latin typeface="JetBrains Mono"/>
               </a:rPr>
-              <a:t>linkedin.com/in/mikkel-r%C3%B8mer  ·  sessionize.com/mikkel-ole-romer</a:t>
+              <a:t>linkedin.com/in/tyolani  ·  www.elastic.co/blog/author/marvin-ngoma</a:t>
             </a:r>
           </a:p>
         </p:txBody>

</xml_diff>

<commit_message>
feat: replace 'To Be Announced' session with 'Side Quest: Whodunit?' and update schedule
</commit_message>
<xml_diff>
--- a/Plans/template-output/bsides-aarhus-2026-template.pptx
+++ b/Plans/template-output/bsides-aarhus-2026-template.pptx
@@ -122,7 +122,7 @@
   <p:extLst>
     <p:ext uri="{521415D9-36F7-43E2-AB2F-B90AF26B5E84}">
       <p14:sectionLst xmlns:p14="http://schemas.microsoft.com/office/powerpoint/2010/main">
-        <p14:section name="Template" id="{D38355C2-0C5B-4B4C-973F-3761CC3B4750}">
+        <p14:section name="Template" id="{41EA1A9D-ED10-42BF-B56B-194336BEC4BC}">
           <p14:sldIdLst>
             <p14:sldId id="256"/>
             <p14:sldId id="257"/>
@@ -132,7 +132,7 @@
             <p14:sldId id="261"/>
           </p14:sldIdLst>
         </p14:section>
-        <p14:section name="Track 1" id="{4A6771C1-5239-47EE-A568-A53946C6913C}">
+        <p14:section name="Track 1" id="{AA4AB062-3D0D-44B7-B88D-17DC1EAC6A94}">
           <p14:sldIdLst>
             <p14:sldId id="262"/>
             <p14:sldId id="263"/>
@@ -141,7 +141,7 @@
             <p14:sldId id="266"/>
           </p14:sldIdLst>
         </p14:section>
-        <p14:section name="Track 2" id="{A7297D3A-4D83-493F-A7D2-5AA96433FBAE}">
+        <p14:section name="Track 2" id="{7EE57DA3-E14F-4E34-AF91-5C43F212F52B}">
           <p14:sldIdLst>
             <p14:sldId id="267"/>
             <p14:sldId id="268"/>
@@ -7616,7 +7616,7 @@
                 </a:solidFill>
                 <a:latin typeface="Inter"/>
               </a:rPr>
-              <a:t>To Be Announced</a:t>
+              <a:t>Side Quest: "Whodunit?" – Unintentional System Compromise</a:t>
             </a:r>
           </a:p>
           <a:p>

</xml_diff>

<commit_message>
feat: update presentation template for BSides Aarhus 2026
</commit_message>
<xml_diff>
--- a/Plans/template-output/bsides-aarhus-2026-template.pptx
+++ b/Plans/template-output/bsides-aarhus-2026-template.pptx
@@ -122,7 +122,7 @@
   <p:extLst>
     <p:ext uri="{521415D9-36F7-43E2-AB2F-B90AF26B5E84}">
       <p14:sectionLst xmlns:p14="http://schemas.microsoft.com/office/powerpoint/2010/main">
-        <p14:section name="Template" id="{41EA1A9D-ED10-42BF-B56B-194336BEC4BC}">
+        <p14:section name="Template" id="{44274776-E444-497D-8093-9ADD83877634}">
           <p14:sldIdLst>
             <p14:sldId id="256"/>
             <p14:sldId id="257"/>
@@ -132,7 +132,7 @@
             <p14:sldId id="261"/>
           </p14:sldIdLst>
         </p14:section>
-        <p14:section name="Track 1" id="{AA4AB062-3D0D-44B7-B88D-17DC1EAC6A94}">
+        <p14:section name="Track 1" id="{D6E25622-1309-4B1B-AD2B-3951AB5E4B75}">
           <p14:sldIdLst>
             <p14:sldId id="262"/>
             <p14:sldId id="263"/>
@@ -141,7 +141,7 @@
             <p14:sldId id="266"/>
           </p14:sldIdLst>
         </p14:section>
-        <p14:section name="Track 2" id="{7EE57DA3-E14F-4E34-AF91-5C43F212F52B}">
+        <p14:section name="Track 2" id="{0F28A2EF-DB5C-4B2A-9878-AE6DDE1AD321}">
           <p14:sldIdLst>
             <p14:sldId id="267"/>
             <p14:sldId id="268"/>
@@ -7030,7 +7030,7 @@
                 </a:solidFill>
                 <a:latin typeface="Inter"/>
               </a:rPr>
-              <a:t>To Be Announced</a:t>
+              <a:t>Malware &amp; Monsters: Contain It Before It Evolves</a:t>
             </a:r>
           </a:p>
           <a:p>

</xml_diff>

<commit_message>
feat: enhance sponsor display logic in PowerPoint template for BSides Aarhus 2026
</commit_message>
<xml_diff>
--- a/Plans/template-output/bsides-aarhus-2026-template.pptx
+++ b/Plans/template-output/bsides-aarhus-2026-template.pptx
@@ -122,7 +122,7 @@
   <p:extLst>
     <p:ext uri="{521415D9-36F7-43E2-AB2F-B90AF26B5E84}">
       <p14:sectionLst xmlns:p14="http://schemas.microsoft.com/office/powerpoint/2010/main">
-        <p14:section name="Template" id="{44274776-E444-497D-8093-9ADD83877634}">
+        <p14:section name="Template" id="{F3892AFA-D0B0-4259-BAD2-4EE0E6F2F379}">
           <p14:sldIdLst>
             <p14:sldId id="256"/>
             <p14:sldId id="257"/>
@@ -132,7 +132,7 @@
             <p14:sldId id="261"/>
           </p14:sldIdLst>
         </p14:section>
-        <p14:section name="Track 1" id="{D6E25622-1309-4B1B-AD2B-3951AB5E4B75}">
+        <p14:section name="Track 1" id="{92A063FE-BEEE-4545-930E-75C7279B279B}">
           <p14:sldIdLst>
             <p14:sldId id="262"/>
             <p14:sldId id="263"/>
@@ -141,7 +141,7 @@
             <p14:sldId id="266"/>
           </p14:sldIdLst>
         </p14:section>
-        <p14:section name="Track 2" id="{0F28A2EF-DB5C-4B2A-9878-AE6DDE1AD321}">
+        <p14:section name="Track 2" id="{FC1A6C1F-C9E6-4F1D-880E-9DD72121416C}">
           <p14:sldIdLst>
             <p14:sldId id="267"/>
             <p14:sldId id="268"/>
@@ -9080,93 +9080,23 @@
       </p:sp>
       <p:sp>
         <p:nvSpPr>
-          <p:cNvPr id="6" name="TextBox 5"/>
-          <p:cNvSpPr txBox="1"/>
-          <p:nvPr/>
-        </p:nvSpPr>
-        <p:spPr>
-          <a:xfrm>
-            <a:off x="548640" y="1737360"/>
-            <a:ext cx="10972800" cy="320040"/>
-          </a:xfrm>
-          <a:prstGeom prst="rect">
-            <a:avLst/>
-          </a:prstGeom>
-          <a:noFill/>
-        </p:spPr>
-        <p:txBody>
-          <a:bodyPr wrap="square" lIns="0" rIns="0" tIns="0" bIns="0" anchor="t">
-            <a:spAutoFit/>
-          </a:bodyPr>
-          <a:lstStyle/>
-          <a:p>
-            <a:pPr algn="l"/>
-            <a:r>
-              <a:rPr sz="1100" b="0">
-                <a:solidFill>
-                  <a:srgbClr val="8888A0"/>
-                </a:solidFill>
-                <a:latin typeface="JetBrains Mono"/>
-              </a:rPr>
-              <a:t>BSides Aarhus 2026 is made possible by</a:t>
-            </a:r>
-          </a:p>
-        </p:txBody>
-      </p:sp>
-      <p:sp>
-        <p:nvSpPr>
-          <p:cNvPr id="7" name="TextBox 6"/>
-          <p:cNvSpPr txBox="1"/>
-          <p:nvPr/>
-        </p:nvSpPr>
-        <p:spPr>
-          <a:xfrm>
-            <a:off x="548640" y="1874519"/>
-            <a:ext cx="11094415" cy="256032"/>
-          </a:xfrm>
-          <a:prstGeom prst="rect">
-            <a:avLst/>
-          </a:prstGeom>
-          <a:noFill/>
-        </p:spPr>
-        <p:txBody>
-          <a:bodyPr wrap="square" lIns="0" rIns="0" tIns="0" bIns="0" anchor="t">
-            <a:spAutoFit/>
-          </a:bodyPr>
-          <a:lstStyle/>
-          <a:p>
-            <a:pPr algn="ctr"/>
-            <a:r>
-              <a:rPr sz="1200" b="1">
-                <a:solidFill>
-                  <a:srgbClr val="4AB8D2"/>
-                </a:solidFill>
-                <a:latin typeface="JetBrains Mono"/>
-              </a:rPr>
-              <a:t>COMMUNITY PARTNERS</a:t>
-            </a:r>
-          </a:p>
-        </p:txBody>
-      </p:sp>
-      <p:sp>
-        <p:nvSpPr>
-          <p:cNvPr id="8" name="Rounded Rectangle 7"/>
+          <p:cNvPr id="6" name="Rounded Rectangle 5"/>
           <p:cNvSpPr/>
           <p:nvPr/>
         </p:nvSpPr>
         <p:spPr>
           <a:xfrm>
-            <a:off x="2232507" y="2185416"/>
-            <a:ext cx="3657600" cy="740664"/>
+            <a:off x="374904" y="1728215"/>
+            <a:ext cx="9367083" cy="1188720"/>
           </a:xfrm>
           <a:prstGeom prst="roundRect">
             <a:avLst>
-              <a:gd name="adj" fmla="val 8000"/>
+              <a:gd name="adj" fmla="val 10000"/>
             </a:avLst>
           </a:prstGeom>
           <a:solidFill>
             <a:srgbClr val="1A1A25">
-              <a:alpha val="12000"/>
+              <a:alpha val="15000"/>
             </a:srgbClr>
           </a:solidFill>
           <a:ln w="9525">
@@ -9198,55 +9128,9 @@
           </a:p>
         </p:txBody>
       </p:sp>
-      <p:sp>
-        <p:nvSpPr>
-          <p:cNvPr id="9" name="Rounded Rectangle 8"/>
-          <p:cNvSpPr/>
-          <p:nvPr/>
-        </p:nvSpPr>
-        <p:spPr>
-          <a:xfrm>
-            <a:off x="2305659" y="2258568"/>
-            <a:ext cx="3511296" cy="594359"/>
-          </a:xfrm>
-          <a:prstGeom prst="roundRect">
-            <a:avLst>
-              <a:gd name="adj" fmla="val 8000"/>
-            </a:avLst>
-          </a:prstGeom>
-          <a:solidFill>
-            <a:srgbClr val="FFFFFF"/>
-          </a:solidFill>
-          <a:ln>
-            <a:noFill/>
-          </a:ln>
-          <a:effectLst/>
-        </p:spPr>
-        <p:style>
-          <a:lnRef idx="1">
-            <a:schemeClr val="accent1"/>
-          </a:lnRef>
-          <a:fillRef idx="3">
-            <a:schemeClr val="accent1"/>
-          </a:fillRef>
-          <a:effectRef idx="2">
-            <a:schemeClr val="accent1"/>
-          </a:effectRef>
-          <a:fontRef idx="minor">
-            <a:schemeClr val="lt1"/>
-          </a:fontRef>
-        </p:style>
-        <p:txBody>
-          <a:bodyPr rtlCol="0" anchor="ctr"/>
-          <a:lstStyle/>
-          <a:p>
-            <a:pPr algn="ctr"/>
-          </a:p>
-        </p:txBody>
-      </p:sp>
       <p:pic>
         <p:nvPicPr>
-          <p:cNvPr id="10" name="Picture 9" descr="AarhusKommuneErhverv_Logo.png"/>
+          <p:cNvPr id="7" name="Picture 6" descr="Danske BankLogo White RGB.png"/>
           <p:cNvPicPr>
             <a:picLocks noChangeAspect="1"/>
           </p:cNvPicPr>
@@ -9260,8 +9144,8 @@
         </p:blipFill>
         <p:spPr>
           <a:xfrm>
-            <a:off x="3540099" y="2295144"/>
-            <a:ext cx="1042415" cy="521207"/>
+            <a:off x="502920" y="1856231"/>
+            <a:ext cx="9111051" cy="932688"/>
           </a:xfrm>
           <a:prstGeom prst="rect">
             <a:avLst/>
@@ -9270,23 +9154,23 @@
       </p:pic>
       <p:sp>
         <p:nvSpPr>
-          <p:cNvPr id="11" name="Rounded Rectangle 10"/>
+          <p:cNvPr id="8" name="Rounded Rectangle 7"/>
           <p:cNvSpPr/>
           <p:nvPr/>
         </p:nvSpPr>
         <p:spPr>
           <a:xfrm>
-            <a:off x="6301587" y="2185416"/>
-            <a:ext cx="3657600" cy="740664"/>
+            <a:off x="10022639" y="1728215"/>
+            <a:ext cx="1791408" cy="1188720"/>
           </a:xfrm>
           <a:prstGeom prst="roundRect">
             <a:avLst>
-              <a:gd name="adj" fmla="val 8000"/>
+              <a:gd name="adj" fmla="val 10000"/>
             </a:avLst>
           </a:prstGeom>
           <a:solidFill>
             <a:srgbClr val="1A1A25">
-              <a:alpha val="12000"/>
+              <a:alpha val="15000"/>
             </a:srgbClr>
           </a:solidFill>
           <a:ln w="9525">
@@ -9318,9 +9202,55 @@
           </a:p>
         </p:txBody>
       </p:sp>
+      <p:sp>
+        <p:nvSpPr>
+          <p:cNvPr id="9" name="Rounded Rectangle 8"/>
+          <p:cNvSpPr/>
+          <p:nvPr/>
+        </p:nvSpPr>
+        <p:spPr>
+          <a:xfrm>
+            <a:off x="10095791" y="1801367"/>
+            <a:ext cx="1645104" cy="1042416"/>
+          </a:xfrm>
+          <a:prstGeom prst="roundRect">
+            <a:avLst>
+              <a:gd name="adj" fmla="val 10000"/>
+            </a:avLst>
+          </a:prstGeom>
+          <a:solidFill>
+            <a:srgbClr val="FFFFFF"/>
+          </a:solidFill>
+          <a:ln>
+            <a:noFill/>
+          </a:ln>
+          <a:effectLst/>
+        </p:spPr>
+        <p:style>
+          <a:lnRef idx="1">
+            <a:schemeClr val="accent1"/>
+          </a:lnRef>
+          <a:fillRef idx="3">
+            <a:schemeClr val="accent1"/>
+          </a:fillRef>
+          <a:effectRef idx="2">
+            <a:schemeClr val="accent1"/>
+          </a:effectRef>
+          <a:fontRef idx="minor">
+            <a:schemeClr val="lt1"/>
+          </a:fontRef>
+        </p:style>
+        <p:txBody>
+          <a:bodyPr rtlCol="0" anchor="ctr"/>
+          <a:lstStyle/>
+          <a:p>
+            <a:pPr algn="ctr"/>
+          </a:p>
+        </p:txBody>
+      </p:sp>
       <p:pic>
         <p:nvPicPr>
-          <p:cNvPr id="12" name="Picture 11" descr="Truesec-Logo-Large-White.png"/>
+          <p:cNvPr id="10" name="Picture 9" descr="sticker-mule.png"/>
           <p:cNvPicPr>
             <a:picLocks noChangeAspect="1"/>
           </p:cNvPicPr>
@@ -9334,8 +9264,8 @@
         </p:blipFill>
         <p:spPr>
           <a:xfrm>
-            <a:off x="6421243" y="2295144"/>
-            <a:ext cx="3418287" cy="521207"/>
+            <a:off x="10150655" y="1856231"/>
+            <a:ext cx="1535376" cy="932688"/>
           </a:xfrm>
           <a:prstGeom prst="rect">
             <a:avLst/>
@@ -9344,58 +9274,23 @@
       </p:pic>
       <p:sp>
         <p:nvSpPr>
-          <p:cNvPr id="13" name="TextBox 12"/>
-          <p:cNvSpPr txBox="1"/>
-          <p:nvPr/>
-        </p:nvSpPr>
-        <p:spPr>
-          <a:xfrm>
-            <a:off x="548640" y="3017520"/>
-            <a:ext cx="11094415" cy="256032"/>
-          </a:xfrm>
-          <a:prstGeom prst="rect">
-            <a:avLst/>
-          </a:prstGeom>
-          <a:noFill/>
-        </p:spPr>
-        <p:txBody>
-          <a:bodyPr wrap="square" lIns="0" rIns="0" tIns="0" bIns="0" anchor="t">
-            <a:spAutoFit/>
-          </a:bodyPr>
-          <a:lstStyle/>
-          <a:p>
-            <a:pPr algn="ctr"/>
-            <a:r>
-              <a:rPr sz="1200" b="1">
-                <a:solidFill>
-                  <a:srgbClr val="4AB8D2"/>
-                </a:solidFill>
-                <a:latin typeface="JetBrains Mono"/>
-              </a:rPr>
-              <a:t>COMMUNITY FRIENDS</a:t>
-            </a:r>
-          </a:p>
-        </p:txBody>
-      </p:sp>
-      <p:sp>
-        <p:nvSpPr>
-          <p:cNvPr id="14" name="Rounded Rectangle 13"/>
+          <p:cNvPr id="11" name="Rounded Rectangle 10"/>
           <p:cNvSpPr/>
           <p:nvPr/>
         </p:nvSpPr>
         <p:spPr>
           <a:xfrm>
-            <a:off x="2232507" y="3328416"/>
-            <a:ext cx="3657600" cy="740664"/>
+            <a:off x="374904" y="2935223"/>
+            <a:ext cx="6438198" cy="1188720"/>
           </a:xfrm>
           <a:prstGeom prst="roundRect">
             <a:avLst>
-              <a:gd name="adj" fmla="val 8000"/>
+              <a:gd name="adj" fmla="val 10000"/>
             </a:avLst>
           </a:prstGeom>
           <a:solidFill>
             <a:srgbClr val="1A1A25">
-              <a:alpha val="12000"/>
+              <a:alpha val="15000"/>
             </a:srgbClr>
           </a:solidFill>
           <a:ln w="9525">
@@ -9429,7 +9324,7 @@
       </p:sp>
       <p:pic>
         <p:nvPicPr>
-          <p:cNvPr id="15" name="Picture 14" descr="_sponsor_baldur_security_final.png"/>
+          <p:cNvPr id="12" name="Picture 11" descr="_sponsor_Semgrep-logo--white.png"/>
           <p:cNvPicPr>
             <a:picLocks noChangeAspect="1"/>
           </p:cNvPicPr>
@@ -9443,8 +9338,8 @@
         </p:blipFill>
         <p:spPr>
           <a:xfrm>
-            <a:off x="2627551" y="3438144"/>
-            <a:ext cx="2867512" cy="521207"/>
+            <a:off x="502920" y="3063239"/>
+            <a:ext cx="6182166" cy="932688"/>
           </a:xfrm>
           <a:prstGeom prst="rect">
             <a:avLst/>
@@ -9453,23 +9348,23 @@
       </p:pic>
       <p:sp>
         <p:nvSpPr>
-          <p:cNvPr id="16" name="Rounded Rectangle 15"/>
+          <p:cNvPr id="13" name="Rounded Rectangle 12"/>
           <p:cNvSpPr/>
           <p:nvPr/>
         </p:nvSpPr>
         <p:spPr>
           <a:xfrm>
-            <a:off x="6301587" y="3328416"/>
-            <a:ext cx="3657600" cy="740664"/>
+            <a:off x="7147360" y="2935223"/>
+            <a:ext cx="4666687" cy="1188720"/>
           </a:xfrm>
           <a:prstGeom prst="roundRect">
             <a:avLst>
-              <a:gd name="adj" fmla="val 8000"/>
+              <a:gd name="adj" fmla="val 10000"/>
             </a:avLst>
           </a:prstGeom>
           <a:solidFill>
             <a:srgbClr val="1A1A25">
-              <a:alpha val="12000"/>
+              <a:alpha val="15000"/>
             </a:srgbClr>
           </a:solidFill>
           <a:ln w="9525">
@@ -9501,55 +9396,9 @@
           </a:p>
         </p:txBody>
       </p:sp>
-      <p:sp>
-        <p:nvSpPr>
-          <p:cNvPr id="17" name="Rounded Rectangle 16"/>
-          <p:cNvSpPr/>
-          <p:nvPr/>
-        </p:nvSpPr>
-        <p:spPr>
-          <a:xfrm>
-            <a:off x="6374739" y="3401568"/>
-            <a:ext cx="3511296" cy="594359"/>
-          </a:xfrm>
-          <a:prstGeom prst="roundRect">
-            <a:avLst>
-              <a:gd name="adj" fmla="val 8000"/>
-            </a:avLst>
-          </a:prstGeom>
-          <a:solidFill>
-            <a:srgbClr val="FFFFFF"/>
-          </a:solidFill>
-          <a:ln>
-            <a:noFill/>
-          </a:ln>
-          <a:effectLst/>
-        </p:spPr>
-        <p:style>
-          <a:lnRef idx="1">
-            <a:schemeClr val="accent1"/>
-          </a:lnRef>
-          <a:fillRef idx="3">
-            <a:schemeClr val="accent1"/>
-          </a:fillRef>
-          <a:effectRef idx="2">
-            <a:schemeClr val="accent1"/>
-          </a:effectRef>
-          <a:fontRef idx="minor">
-            <a:schemeClr val="lt1"/>
-          </a:fontRef>
-        </p:style>
-        <p:txBody>
-          <a:bodyPr rtlCol="0" anchor="ctr"/>
-          <a:lstStyle/>
-          <a:p>
-            <a:pPr algn="ctr"/>
-          </a:p>
-        </p:txBody>
-      </p:sp>
       <p:pic>
         <p:nvPicPr>
-          <p:cNvPr id="18" name="Picture 17" descr="sticker-mule.png"/>
+          <p:cNvPr id="14" name="Picture 13" descr="aulogo_uk_var2_white.png"/>
           <p:cNvPicPr>
             <a:picLocks noChangeAspect="1"/>
           </p:cNvPicPr>
@@ -9563,8 +9412,8 @@
         </p:blipFill>
         <p:spPr>
           <a:xfrm>
-            <a:off x="7701385" y="3438144"/>
-            <a:ext cx="858004" cy="521207"/>
+            <a:off x="7275376" y="3063239"/>
+            <a:ext cx="4410655" cy="932688"/>
           </a:xfrm>
           <a:prstGeom prst="rect">
             <a:avLst/>
@@ -9573,58 +9422,23 @@
       </p:pic>
       <p:sp>
         <p:nvSpPr>
-          <p:cNvPr id="19" name="TextBox 18"/>
-          <p:cNvSpPr txBox="1"/>
-          <p:nvPr/>
-        </p:nvSpPr>
-        <p:spPr>
-          <a:xfrm>
-            <a:off x="548640" y="4160520"/>
-            <a:ext cx="11094415" cy="256032"/>
-          </a:xfrm>
-          <a:prstGeom prst="rect">
-            <a:avLst/>
-          </a:prstGeom>
-          <a:noFill/>
-        </p:spPr>
-        <p:txBody>
-          <a:bodyPr wrap="square" lIns="0" rIns="0" tIns="0" bIns="0" anchor="t">
-            <a:spAutoFit/>
-          </a:bodyPr>
-          <a:lstStyle/>
-          <a:p>
-            <a:pPr algn="ctr"/>
-            <a:r>
-              <a:rPr sz="1200" b="1">
-                <a:solidFill>
-                  <a:srgbClr val="4AB8D2"/>
-                </a:solidFill>
-                <a:latin typeface="JetBrains Mono"/>
-              </a:rPr>
-              <a:t>COMMUNITY STUDENT FRIENDS</a:t>
-            </a:r>
-          </a:p>
-        </p:txBody>
-      </p:sp>
-      <p:sp>
-        <p:nvSpPr>
-          <p:cNvPr id="20" name="Rounded Rectangle 19"/>
+          <p:cNvPr id="15" name="Rounded Rectangle 14"/>
           <p:cNvSpPr/>
           <p:nvPr/>
         </p:nvSpPr>
         <p:spPr>
           <a:xfrm>
-            <a:off x="2232507" y="4471416"/>
-            <a:ext cx="3657600" cy="740664"/>
+            <a:off x="1279080" y="4142232"/>
+            <a:ext cx="6372967" cy="1188720"/>
           </a:xfrm>
           <a:prstGeom prst="roundRect">
             <a:avLst>
-              <a:gd name="adj" fmla="val 8000"/>
+              <a:gd name="adj" fmla="val 10000"/>
             </a:avLst>
           </a:prstGeom>
           <a:solidFill>
             <a:srgbClr val="1A1A25">
-              <a:alpha val="12000"/>
+              <a:alpha val="15000"/>
             </a:srgbClr>
           </a:solidFill>
           <a:ln w="9525">
@@ -9658,7 +9472,7 @@
       </p:sp>
       <p:pic>
         <p:nvPicPr>
-          <p:cNvPr id="21" name="Picture 20" descr="tech-hub-aarhus.png"/>
+          <p:cNvPr id="16" name="Picture 15" descr="Truesec-Logo-Large-White.png"/>
           <p:cNvPicPr>
             <a:picLocks noChangeAspect="1"/>
           </p:cNvPicPr>
@@ -9672,8 +9486,8 @@
         </p:blipFill>
         <p:spPr>
           <a:xfrm>
-            <a:off x="3317316" y="4581144"/>
-            <a:ext cx="1487981" cy="521207"/>
+            <a:off x="1407096" y="4270248"/>
+            <a:ext cx="6116935" cy="932688"/>
           </a:xfrm>
           <a:prstGeom prst="rect">
             <a:avLst/>
@@ -9682,23 +9496,23 @@
       </p:pic>
       <p:sp>
         <p:nvSpPr>
-          <p:cNvPr id="22" name="Rounded Rectangle 21"/>
+          <p:cNvPr id="17" name="Rounded Rectangle 16"/>
           <p:cNvSpPr/>
           <p:nvPr/>
         </p:nvSpPr>
         <p:spPr>
           <a:xfrm>
-            <a:off x="6301587" y="4471416"/>
-            <a:ext cx="3657600" cy="740664"/>
+            <a:off x="7725199" y="4142232"/>
+            <a:ext cx="3184672" cy="1188720"/>
           </a:xfrm>
           <a:prstGeom prst="roundRect">
             <a:avLst>
-              <a:gd name="adj" fmla="val 8000"/>
+              <a:gd name="adj" fmla="val 10000"/>
             </a:avLst>
           </a:prstGeom>
           <a:solidFill>
             <a:srgbClr val="1A1A25">
-              <a:alpha val="12000"/>
+              <a:alpha val="15000"/>
             </a:srgbClr>
           </a:solidFill>
           <a:ln w="9525">
@@ -9730,9 +9544,55 @@
           </a:p>
         </p:txBody>
       </p:sp>
+      <p:sp>
+        <p:nvSpPr>
+          <p:cNvPr id="18" name="Rounded Rectangle 17"/>
+          <p:cNvSpPr/>
+          <p:nvPr/>
+        </p:nvSpPr>
+        <p:spPr>
+          <a:xfrm>
+            <a:off x="7798351" y="4215384"/>
+            <a:ext cx="3038368" cy="1042416"/>
+          </a:xfrm>
+          <a:prstGeom prst="roundRect">
+            <a:avLst>
+              <a:gd name="adj" fmla="val 10000"/>
+            </a:avLst>
+          </a:prstGeom>
+          <a:solidFill>
+            <a:srgbClr val="FFFFFF"/>
+          </a:solidFill>
+          <a:ln>
+            <a:noFill/>
+          </a:ln>
+          <a:effectLst/>
+        </p:spPr>
+        <p:style>
+          <a:lnRef idx="1">
+            <a:schemeClr val="accent1"/>
+          </a:lnRef>
+          <a:fillRef idx="3">
+            <a:schemeClr val="accent1"/>
+          </a:fillRef>
+          <a:effectRef idx="2">
+            <a:schemeClr val="accent1"/>
+          </a:effectRef>
+          <a:fontRef idx="minor">
+            <a:schemeClr val="lt1"/>
+          </a:fontRef>
+        </p:style>
+        <p:txBody>
+          <a:bodyPr rtlCol="0" anchor="ctr"/>
+          <a:lstStyle/>
+          <a:p>
+            <a:pPr algn="ctr"/>
+          </a:p>
+        </p:txBody>
+      </p:sp>
       <p:pic>
         <p:nvPicPr>
-          <p:cNvPr id="23" name="Picture 22" descr="Danske BankLogo White RGB.png"/>
+          <p:cNvPr id="19" name="Picture 18" descr="_sponsor_incuba-logo.png"/>
           <p:cNvPicPr>
             <a:picLocks noChangeAspect="1"/>
           </p:cNvPicPr>
@@ -9746,8 +9606,8 @@
         </p:blipFill>
         <p:spPr>
           <a:xfrm>
-            <a:off x="6411315" y="4665768"/>
-            <a:ext cx="3438144" cy="351958"/>
+            <a:off x="7853215" y="4270248"/>
+            <a:ext cx="2928640" cy="932688"/>
           </a:xfrm>
           <a:prstGeom prst="rect">
             <a:avLst/>
@@ -9756,58 +9616,23 @@
       </p:pic>
       <p:sp>
         <p:nvSpPr>
-          <p:cNvPr id="24" name="TextBox 23"/>
-          <p:cNvSpPr txBox="1"/>
-          <p:nvPr/>
-        </p:nvSpPr>
-        <p:spPr>
-          <a:xfrm>
-            <a:off x="548640" y="5303520"/>
-            <a:ext cx="11094415" cy="256032"/>
-          </a:xfrm>
-          <a:prstGeom prst="rect">
-            <a:avLst/>
-          </a:prstGeom>
-          <a:noFill/>
-        </p:spPr>
-        <p:txBody>
-          <a:bodyPr wrap="square" lIns="0" rIns="0" tIns="0" bIns="0" anchor="t">
-            <a:spAutoFit/>
-          </a:bodyPr>
-          <a:lstStyle/>
-          <a:p>
-            <a:pPr algn="ctr"/>
-            <a:r>
-              <a:rPr sz="1200" b="1">
-                <a:solidFill>
-                  <a:srgbClr val="4AB8D2"/>
-                </a:solidFill>
-                <a:latin typeface="JetBrains Mono"/>
-              </a:rPr>
-              <a:t>VENUE SPONSORS</a:t>
-            </a:r>
-          </a:p>
-        </p:txBody>
-      </p:sp>
-      <p:sp>
-        <p:nvSpPr>
-          <p:cNvPr id="25" name="Rounded Rectangle 24"/>
+          <p:cNvPr id="20" name="Rounded Rectangle 19"/>
           <p:cNvSpPr/>
           <p:nvPr/>
         </p:nvSpPr>
         <p:spPr>
           <a:xfrm>
-            <a:off x="2232507" y="5614416"/>
-            <a:ext cx="3657600" cy="740664"/>
+            <a:off x="374904" y="5349240"/>
+            <a:ext cx="5387370" cy="1188720"/>
           </a:xfrm>
           <a:prstGeom prst="roundRect">
             <a:avLst>
-              <a:gd name="adj" fmla="val 8000"/>
+              <a:gd name="adj" fmla="val 10000"/>
             </a:avLst>
           </a:prstGeom>
           <a:solidFill>
             <a:srgbClr val="1A1A25">
-              <a:alpha val="12000"/>
+              <a:alpha val="15000"/>
             </a:srgbClr>
           </a:solidFill>
           <a:ln w="9525">
@@ -9839,55 +9664,9 @@
           </a:p>
         </p:txBody>
       </p:sp>
-      <p:sp>
-        <p:nvSpPr>
-          <p:cNvPr id="26" name="Rounded Rectangle 25"/>
-          <p:cNvSpPr/>
-          <p:nvPr/>
-        </p:nvSpPr>
-        <p:spPr>
-          <a:xfrm>
-            <a:off x="2305659" y="5687568"/>
-            <a:ext cx="3511296" cy="594359"/>
-          </a:xfrm>
-          <a:prstGeom prst="roundRect">
-            <a:avLst>
-              <a:gd name="adj" fmla="val 8000"/>
-            </a:avLst>
-          </a:prstGeom>
-          <a:solidFill>
-            <a:srgbClr val="FFFFFF"/>
-          </a:solidFill>
-          <a:ln>
-            <a:noFill/>
-          </a:ln>
-          <a:effectLst/>
-        </p:spPr>
-        <p:style>
-          <a:lnRef idx="1">
-            <a:schemeClr val="accent1"/>
-          </a:lnRef>
-          <a:fillRef idx="3">
-            <a:schemeClr val="accent1"/>
-          </a:fillRef>
-          <a:effectRef idx="2">
-            <a:schemeClr val="accent1"/>
-          </a:effectRef>
-          <a:fontRef idx="minor">
-            <a:schemeClr val="lt1"/>
-          </a:fontRef>
-        </p:style>
-        <p:txBody>
-          <a:bodyPr rtlCol="0" anchor="ctr"/>
-          <a:lstStyle/>
-          <a:p>
-            <a:pPr algn="ctr"/>
-          </a:p>
-        </p:txBody>
-      </p:sp>
       <p:pic>
         <p:nvPicPr>
-          <p:cNvPr id="27" name="Picture 26" descr="_sponsor_incuba-logo.png"/>
+          <p:cNvPr id="21" name="Picture 20" descr="_sponsor_baldur_security_final.png"/>
           <p:cNvPicPr>
             <a:picLocks noChangeAspect="1"/>
           </p:cNvPicPr>
@@ -9901,8 +9680,8 @@
         </p:blipFill>
         <p:spPr>
           <a:xfrm>
-            <a:off x="3243011" y="5724144"/>
-            <a:ext cx="1636593" cy="521207"/>
+            <a:off x="502920" y="5477256"/>
+            <a:ext cx="5131338" cy="932688"/>
           </a:xfrm>
           <a:prstGeom prst="rect">
             <a:avLst/>
@@ -9911,23 +9690,23 @@
       </p:pic>
       <p:sp>
         <p:nvSpPr>
-          <p:cNvPr id="28" name="Rounded Rectangle 27"/>
+          <p:cNvPr id="22" name="Rounded Rectangle 21"/>
           <p:cNvSpPr/>
           <p:nvPr/>
         </p:nvSpPr>
         <p:spPr>
           <a:xfrm>
-            <a:off x="6301587" y="5614416"/>
-            <a:ext cx="3657600" cy="740664"/>
+            <a:off x="6268089" y="5349240"/>
+            <a:ext cx="2918735" cy="1188720"/>
           </a:xfrm>
           <a:prstGeom prst="roundRect">
             <a:avLst>
-              <a:gd name="adj" fmla="val 8000"/>
+              <a:gd name="adj" fmla="val 10000"/>
             </a:avLst>
           </a:prstGeom>
           <a:solidFill>
             <a:srgbClr val="1A1A25">
-              <a:alpha val="12000"/>
+              <a:alpha val="15000"/>
             </a:srgbClr>
           </a:solidFill>
           <a:ln w="9525">
@@ -9961,7 +9740,7 @@
       </p:sp>
       <p:pic>
         <p:nvPicPr>
-          <p:cNvPr id="29" name="Picture 28" descr="aulogo_uk_var2_white.png"/>
+          <p:cNvPr id="23" name="Picture 22" descr="tech-hub-aarhus.png"/>
           <p:cNvPicPr>
             <a:picLocks noChangeAspect="1"/>
           </p:cNvPicPr>
@@ -9975,8 +9754,8 @@
         </p:blipFill>
         <p:spPr>
           <a:xfrm>
-            <a:off x="6897998" y="5724144"/>
-            <a:ext cx="2464778" cy="521207"/>
+            <a:off x="6396105" y="5477256"/>
+            <a:ext cx="2662703" cy="932688"/>
           </a:xfrm>
           <a:prstGeom prst="rect">
             <a:avLst/>
@@ -9985,7 +9764,127 @@
       </p:pic>
       <p:sp>
         <p:nvSpPr>
-          <p:cNvPr id="30" name="TextBox 29"/>
+          <p:cNvPr id="24" name="Rounded Rectangle 23"/>
+          <p:cNvSpPr/>
+          <p:nvPr/>
+        </p:nvSpPr>
+        <p:spPr>
+          <a:xfrm>
+            <a:off x="9692639" y="5349240"/>
+            <a:ext cx="2121408" cy="1188720"/>
+          </a:xfrm>
+          <a:prstGeom prst="roundRect">
+            <a:avLst>
+              <a:gd name="adj" fmla="val 10000"/>
+            </a:avLst>
+          </a:prstGeom>
+          <a:solidFill>
+            <a:srgbClr val="1A1A25">
+              <a:alpha val="15000"/>
+            </a:srgbClr>
+          </a:solidFill>
+          <a:ln w="9525">
+            <a:solidFill>
+              <a:srgbClr val="2A2A3A"/>
+            </a:solidFill>
+          </a:ln>
+          <a:effectLst/>
+        </p:spPr>
+        <p:style>
+          <a:lnRef idx="1">
+            <a:schemeClr val="accent1"/>
+          </a:lnRef>
+          <a:fillRef idx="3">
+            <a:schemeClr val="accent1"/>
+          </a:fillRef>
+          <a:effectRef idx="2">
+            <a:schemeClr val="accent1"/>
+          </a:effectRef>
+          <a:fontRef idx="minor">
+            <a:schemeClr val="lt1"/>
+          </a:fontRef>
+        </p:style>
+        <p:txBody>
+          <a:bodyPr rtlCol="0" anchor="ctr"/>
+          <a:lstStyle/>
+          <a:p>
+            <a:pPr algn="ctr"/>
+          </a:p>
+        </p:txBody>
+      </p:sp>
+      <p:sp>
+        <p:nvSpPr>
+          <p:cNvPr id="25" name="Rounded Rectangle 24"/>
+          <p:cNvSpPr/>
+          <p:nvPr/>
+        </p:nvSpPr>
+        <p:spPr>
+          <a:xfrm>
+            <a:off x="9765791" y="5422392"/>
+            <a:ext cx="1975104" cy="1042416"/>
+          </a:xfrm>
+          <a:prstGeom prst="roundRect">
+            <a:avLst>
+              <a:gd name="adj" fmla="val 10000"/>
+            </a:avLst>
+          </a:prstGeom>
+          <a:solidFill>
+            <a:srgbClr val="FFFFFF"/>
+          </a:solidFill>
+          <a:ln>
+            <a:noFill/>
+          </a:ln>
+          <a:effectLst/>
+        </p:spPr>
+        <p:style>
+          <a:lnRef idx="1">
+            <a:schemeClr val="accent1"/>
+          </a:lnRef>
+          <a:fillRef idx="3">
+            <a:schemeClr val="accent1"/>
+          </a:fillRef>
+          <a:effectRef idx="2">
+            <a:schemeClr val="accent1"/>
+          </a:effectRef>
+          <a:fontRef idx="minor">
+            <a:schemeClr val="lt1"/>
+          </a:fontRef>
+        </p:style>
+        <p:txBody>
+          <a:bodyPr rtlCol="0" anchor="ctr"/>
+          <a:lstStyle/>
+          <a:p>
+            <a:pPr algn="ctr"/>
+          </a:p>
+        </p:txBody>
+      </p:sp>
+      <p:pic>
+        <p:nvPicPr>
+          <p:cNvPr id="26" name="Picture 25" descr="AarhusKommuneErhverv_Logo.png"/>
+          <p:cNvPicPr>
+            <a:picLocks noChangeAspect="1"/>
+          </p:cNvPicPr>
+          <p:nvPr/>
+        </p:nvPicPr>
+        <p:blipFill>
+          <a:blip r:embed="rId12"/>
+          <a:stretch>
+            <a:fillRect/>
+          </a:stretch>
+        </p:blipFill>
+        <p:spPr>
+          <a:xfrm>
+            <a:off x="9820655" y="5477256"/>
+            <a:ext cx="1865376" cy="932688"/>
+          </a:xfrm>
+          <a:prstGeom prst="rect">
+            <a:avLst/>
+          </a:prstGeom>
+        </p:spPr>
+      </p:pic>
+      <p:sp>
+        <p:nvSpPr>
+          <p:cNvPr id="27" name="TextBox 26"/>
           <p:cNvSpPr txBox="1"/>
           <p:nvPr/>
         </p:nvSpPr>
@@ -10020,7 +9919,7 @@
       </p:sp>
       <p:sp>
         <p:nvSpPr>
-          <p:cNvPr id="31" name="TextBox 30"/>
+          <p:cNvPr id="28" name="TextBox 27"/>
           <p:cNvSpPr txBox="1"/>
           <p:nvPr/>
         </p:nvSpPr>

</xml_diff>

<commit_message>
feat: add slides section to session details and include WebAuthn presentation slides
</commit_message>
<xml_diff>
--- a/Plans/template-output/bsides-aarhus-2026-template.pptx
+++ b/Plans/template-output/bsides-aarhus-2026-template.pptx
@@ -5,24 +5,24 @@
     <p:sldMasterId id="2147483648" r:id="rId1"/>
   </p:sldMasterIdLst>
   <p:sldIdLst>
-    <p:sldId id="256" r:id="rId7"/>
-    <p:sldId id="257" r:id="rId8"/>
-    <p:sldId id="258" r:id="rId9"/>
-    <p:sldId id="259" r:id="rId10"/>
-    <p:sldId id="260" r:id="rId11"/>
-    <p:sldId id="261" r:id="rId12"/>
-    <p:sldId id="262" r:id="rId13"/>
-    <p:sldId id="263" r:id="rId14"/>
-    <p:sldId id="264" r:id="rId15"/>
-    <p:sldId id="265" r:id="rId16"/>
-    <p:sldId id="266" r:id="rId17"/>
-    <p:sldId id="267" r:id="rId18"/>
-    <p:sldId id="268" r:id="rId19"/>
-    <p:sldId id="269" r:id="rId20"/>
-    <p:sldId id="270" r:id="rId21"/>
-    <p:sldId id="271" r:id="rId22"/>
+    <p:sldId id="256" r:id="rId2"/>
+    <p:sldId id="257" r:id="rId3"/>
+    <p:sldId id="258" r:id="rId4"/>
+    <p:sldId id="259" r:id="rId5"/>
+    <p:sldId id="260" r:id="rId6"/>
+    <p:sldId id="261" r:id="rId7"/>
+    <p:sldId id="262" r:id="rId8"/>
+    <p:sldId id="263" r:id="rId9"/>
+    <p:sldId id="264" r:id="rId10"/>
+    <p:sldId id="265" r:id="rId11"/>
+    <p:sldId id="266" r:id="rId12"/>
+    <p:sldId id="267" r:id="rId13"/>
+    <p:sldId id="268" r:id="rId14"/>
+    <p:sldId id="269" r:id="rId15"/>
+    <p:sldId id="270" r:id="rId16"/>
+    <p:sldId id="271" r:id="rId17"/>
   </p:sldIdLst>
-  <p:sldSz cx="12191695" cy="6858000" type="screen4x3"/>
+  <p:sldSz cx="12192000" cy="6858000"/>
   <p:notesSz cx="6858000" cy="9144000"/>
   <p:defaultTextStyle>
     <a:defPPr>
@@ -152,6 +152,20 @@
         </p14:section>
       </p14:sectionLst>
     </p:ext>
+    <p:ext uri="{EFAFB233-063F-42B5-8137-9DF3F51BA10A}">
+      <p15:sldGuideLst xmlns:p15="http://schemas.microsoft.com/office/powerpoint/2012/main">
+        <p15:guide id="1" orient="horz" pos="2160">
+          <p15:clr>
+            <a:srgbClr val="A4A3A4"/>
+          </p15:clr>
+        </p15:guide>
+        <p15:guide id="2" pos="2880">
+          <p15:clr>
+            <a:srgbClr val="A4A3A4"/>
+          </p15:clr>
+        </p15:guide>
+      </p15:sldGuideLst>
+    </p:ext>
   </p:extLst>
 </p:presentation>
 </file>
@@ -194,10 +208,9 @@
           <a:lstStyle/>
           <a:p>
             <a:r>
-              <a:rPr lang="en-US" smtClean="0"/>
+              <a:rPr lang="en-US"/>
               <a:t>Click to edit Master title style</a:t>
             </a:r>
-            <a:endParaRPr lang="en-US"/>
           </a:p>
         </p:txBody>
       </p:sp>
@@ -313,10 +326,9 @@
           </a:lstStyle>
           <a:p>
             <a:r>
-              <a:rPr lang="en-US" smtClean="0"/>
+              <a:rPr lang="en-US"/>
               <a:t>Click to edit Master subtitle style</a:t>
             </a:r>
-            <a:endParaRPr lang="en-US"/>
           </a:p>
         </p:txBody>
       </p:sp>
@@ -337,7 +349,7 @@
           <a:p>
             <a:fld id="{5BCAD085-E8A6-8845-BD4E-CB4CCA059FC4}" type="datetimeFigureOut">
               <a:rPr lang="en-US" smtClean="0"/>
-              <a:t>1/27/13</a:t>
+              <a:t>6/19/26</a:t>
             </a:fld>
             <a:endParaRPr lang="en-US"/>
           </a:p>
@@ -379,7 +391,7 @@
           <a:p>
             <a:fld id="{C1FF6DA9-008F-8B48-92A6-B652298478BF}" type="slidenum">
               <a:rPr lang="en-US" smtClean="0"/>
-              <a:t>‹#›</a:t>
+              <a:t>‹nr.›</a:t>
             </a:fld>
             <a:endParaRPr lang="en-US"/>
           </a:p>
@@ -431,10 +443,9 @@
           <a:lstStyle/>
           <a:p>
             <a:r>
-              <a:rPr lang="en-US" smtClean="0"/>
+              <a:rPr lang="en-US"/>
               <a:t>Click to edit Master title style</a:t>
             </a:r>
-            <a:endParaRPr lang="en-US"/>
           </a:p>
         </p:txBody>
       </p:sp>
@@ -455,38 +466,37 @@
           <a:p>
             <a:pPr lvl="0"/>
             <a:r>
-              <a:rPr lang="en-US" smtClean="0"/>
+              <a:rPr lang="en-US"/>
               <a:t>Click to edit Master text styles</a:t>
             </a:r>
           </a:p>
           <a:p>
             <a:pPr lvl="1"/>
             <a:r>
-              <a:rPr lang="en-US" smtClean="0"/>
+              <a:rPr lang="en-US"/>
               <a:t>Second level</a:t>
             </a:r>
           </a:p>
           <a:p>
             <a:pPr lvl="2"/>
             <a:r>
-              <a:rPr lang="en-US" smtClean="0"/>
+              <a:rPr lang="en-US"/>
               <a:t>Third level</a:t>
             </a:r>
           </a:p>
           <a:p>
             <a:pPr lvl="3"/>
             <a:r>
-              <a:rPr lang="en-US" smtClean="0"/>
+              <a:rPr lang="en-US"/>
               <a:t>Fourth level</a:t>
             </a:r>
           </a:p>
           <a:p>
             <a:pPr lvl="4"/>
             <a:r>
-              <a:rPr lang="en-US" smtClean="0"/>
+              <a:rPr lang="en-US"/>
               <a:t>Fifth level</a:t>
             </a:r>
-            <a:endParaRPr lang="en-US"/>
           </a:p>
         </p:txBody>
       </p:sp>
@@ -507,7 +517,7 @@
           <a:p>
             <a:fld id="{5BCAD085-E8A6-8845-BD4E-CB4CCA059FC4}" type="datetimeFigureOut">
               <a:rPr lang="en-US" smtClean="0"/>
-              <a:t>1/27/13</a:t>
+              <a:t>6/19/26</a:t>
             </a:fld>
             <a:endParaRPr lang="en-US"/>
           </a:p>
@@ -549,7 +559,7 @@
           <a:p>
             <a:fld id="{C1FF6DA9-008F-8B48-92A6-B652298478BF}" type="slidenum">
               <a:rPr lang="en-US" smtClean="0"/>
-              <a:t>‹#›</a:t>
+              <a:t>‹nr.›</a:t>
             </a:fld>
             <a:endParaRPr lang="en-US"/>
           </a:p>
@@ -606,10 +616,9 @@
           <a:lstStyle/>
           <a:p>
             <a:r>
-              <a:rPr lang="en-US" smtClean="0"/>
+              <a:rPr lang="en-US"/>
               <a:t>Click to edit Master title style</a:t>
             </a:r>
-            <a:endParaRPr lang="en-US"/>
           </a:p>
         </p:txBody>
       </p:sp>
@@ -635,38 +644,37 @@
           <a:p>
             <a:pPr lvl="0"/>
             <a:r>
-              <a:rPr lang="en-US" smtClean="0"/>
+              <a:rPr lang="en-US"/>
               <a:t>Click to edit Master text styles</a:t>
             </a:r>
           </a:p>
           <a:p>
             <a:pPr lvl="1"/>
             <a:r>
-              <a:rPr lang="en-US" smtClean="0"/>
+              <a:rPr lang="en-US"/>
               <a:t>Second level</a:t>
             </a:r>
           </a:p>
           <a:p>
             <a:pPr lvl="2"/>
             <a:r>
-              <a:rPr lang="en-US" smtClean="0"/>
+              <a:rPr lang="en-US"/>
               <a:t>Third level</a:t>
             </a:r>
           </a:p>
           <a:p>
             <a:pPr lvl="3"/>
             <a:r>
-              <a:rPr lang="en-US" smtClean="0"/>
+              <a:rPr lang="en-US"/>
               <a:t>Fourth level</a:t>
             </a:r>
           </a:p>
           <a:p>
             <a:pPr lvl="4"/>
             <a:r>
-              <a:rPr lang="en-US" smtClean="0"/>
+              <a:rPr lang="en-US"/>
               <a:t>Fifth level</a:t>
             </a:r>
-            <a:endParaRPr lang="en-US"/>
           </a:p>
         </p:txBody>
       </p:sp>
@@ -687,7 +695,7 @@
           <a:p>
             <a:fld id="{5BCAD085-E8A6-8845-BD4E-CB4CCA059FC4}" type="datetimeFigureOut">
               <a:rPr lang="en-US" smtClean="0"/>
-              <a:t>1/27/13</a:t>
+              <a:t>6/19/26</a:t>
             </a:fld>
             <a:endParaRPr lang="en-US"/>
           </a:p>
@@ -729,7 +737,7 @@
           <a:p>
             <a:fld id="{C1FF6DA9-008F-8B48-92A6-B652298478BF}" type="slidenum">
               <a:rPr lang="en-US" smtClean="0"/>
-              <a:t>‹#›</a:t>
+              <a:t>‹nr.›</a:t>
             </a:fld>
             <a:endParaRPr lang="en-US"/>
           </a:p>
@@ -781,10 +789,9 @@
           <a:lstStyle/>
           <a:p>
             <a:r>
-              <a:rPr lang="en-US" smtClean="0"/>
+              <a:rPr lang="en-US"/>
               <a:t>Click to edit Master title style</a:t>
             </a:r>
-            <a:endParaRPr lang="en-US"/>
           </a:p>
         </p:txBody>
       </p:sp>
@@ -805,38 +812,37 @@
           <a:p>
             <a:pPr lvl="0"/>
             <a:r>
-              <a:rPr lang="en-US" smtClean="0"/>
+              <a:rPr lang="en-US"/>
               <a:t>Click to edit Master text styles</a:t>
             </a:r>
           </a:p>
           <a:p>
             <a:pPr lvl="1"/>
             <a:r>
-              <a:rPr lang="en-US" smtClean="0"/>
+              <a:rPr lang="en-US"/>
               <a:t>Second level</a:t>
             </a:r>
           </a:p>
           <a:p>
             <a:pPr lvl="2"/>
             <a:r>
-              <a:rPr lang="en-US" smtClean="0"/>
+              <a:rPr lang="en-US"/>
               <a:t>Third level</a:t>
             </a:r>
           </a:p>
           <a:p>
             <a:pPr lvl="3"/>
             <a:r>
-              <a:rPr lang="en-US" smtClean="0"/>
+              <a:rPr lang="en-US"/>
               <a:t>Fourth level</a:t>
             </a:r>
           </a:p>
           <a:p>
             <a:pPr lvl="4"/>
             <a:r>
-              <a:rPr lang="en-US" smtClean="0"/>
+              <a:rPr lang="en-US"/>
               <a:t>Fifth level</a:t>
             </a:r>
-            <a:endParaRPr lang="en-US"/>
           </a:p>
         </p:txBody>
       </p:sp>
@@ -857,7 +863,7 @@
           <a:p>
             <a:fld id="{5BCAD085-E8A6-8845-BD4E-CB4CCA059FC4}" type="datetimeFigureOut">
               <a:rPr lang="en-US" smtClean="0"/>
-              <a:t>1/27/13</a:t>
+              <a:t>6/19/26</a:t>
             </a:fld>
             <a:endParaRPr lang="en-US"/>
           </a:p>
@@ -899,7 +905,7 @@
           <a:p>
             <a:fld id="{C1FF6DA9-008F-8B48-92A6-B652298478BF}" type="slidenum">
               <a:rPr lang="en-US" smtClean="0"/>
-              <a:t>‹#›</a:t>
+              <a:t>‹nr.›</a:t>
             </a:fld>
             <a:endParaRPr lang="en-US"/>
           </a:p>
@@ -960,10 +966,9 @@
           </a:lstStyle>
           <a:p>
             <a:r>
-              <a:rPr lang="en-US" smtClean="0"/>
+              <a:rPr lang="en-US"/>
               <a:t>Click to edit Master title style</a:t>
             </a:r>
-            <a:endParaRPr lang="en-US"/>
           </a:p>
         </p:txBody>
       </p:sp>
@@ -1080,7 +1085,7 @@
           <a:p>
             <a:pPr lvl="0"/>
             <a:r>
-              <a:rPr lang="en-US" smtClean="0"/>
+              <a:rPr lang="en-US"/>
               <a:t>Click to edit Master text styles</a:t>
             </a:r>
           </a:p>
@@ -1103,7 +1108,7 @@
           <a:p>
             <a:fld id="{5BCAD085-E8A6-8845-BD4E-CB4CCA059FC4}" type="datetimeFigureOut">
               <a:rPr lang="en-US" smtClean="0"/>
-              <a:t>1/27/13</a:t>
+              <a:t>6/19/26</a:t>
             </a:fld>
             <a:endParaRPr lang="en-US"/>
           </a:p>
@@ -1145,7 +1150,7 @@
           <a:p>
             <a:fld id="{C1FF6DA9-008F-8B48-92A6-B652298478BF}" type="slidenum">
               <a:rPr lang="en-US" smtClean="0"/>
-              <a:t>‹#›</a:t>
+              <a:t>‹nr.›</a:t>
             </a:fld>
             <a:endParaRPr lang="en-US"/>
           </a:p>
@@ -1197,10 +1202,9 @@
           <a:lstStyle/>
           <a:p>
             <a:r>
-              <a:rPr lang="en-US" smtClean="0"/>
+              <a:rPr lang="en-US"/>
               <a:t>Click to edit Master title style</a:t>
             </a:r>
-            <a:endParaRPr lang="en-US"/>
           </a:p>
         </p:txBody>
       </p:sp>
@@ -1254,38 +1258,37 @@
           <a:p>
             <a:pPr lvl="0"/>
             <a:r>
-              <a:rPr lang="en-US" smtClean="0"/>
+              <a:rPr lang="en-US"/>
               <a:t>Click to edit Master text styles</a:t>
             </a:r>
           </a:p>
           <a:p>
             <a:pPr lvl="1"/>
             <a:r>
-              <a:rPr lang="en-US" smtClean="0"/>
+              <a:rPr lang="en-US"/>
               <a:t>Second level</a:t>
             </a:r>
           </a:p>
           <a:p>
             <a:pPr lvl="2"/>
             <a:r>
-              <a:rPr lang="en-US" smtClean="0"/>
+              <a:rPr lang="en-US"/>
               <a:t>Third level</a:t>
             </a:r>
           </a:p>
           <a:p>
             <a:pPr lvl="3"/>
             <a:r>
-              <a:rPr lang="en-US" smtClean="0"/>
+              <a:rPr lang="en-US"/>
               <a:t>Fourth level</a:t>
             </a:r>
           </a:p>
           <a:p>
             <a:pPr lvl="4"/>
             <a:r>
-              <a:rPr lang="en-US" smtClean="0"/>
+              <a:rPr lang="en-US"/>
               <a:t>Fifth level</a:t>
             </a:r>
-            <a:endParaRPr lang="en-US"/>
           </a:p>
         </p:txBody>
       </p:sp>
@@ -1339,38 +1342,37 @@
           <a:p>
             <a:pPr lvl="0"/>
             <a:r>
-              <a:rPr lang="en-US" smtClean="0"/>
+              <a:rPr lang="en-US"/>
               <a:t>Click to edit Master text styles</a:t>
             </a:r>
           </a:p>
           <a:p>
             <a:pPr lvl="1"/>
             <a:r>
-              <a:rPr lang="en-US" smtClean="0"/>
+              <a:rPr lang="en-US"/>
               <a:t>Second level</a:t>
             </a:r>
           </a:p>
           <a:p>
             <a:pPr lvl="2"/>
             <a:r>
-              <a:rPr lang="en-US" smtClean="0"/>
+              <a:rPr lang="en-US"/>
               <a:t>Third level</a:t>
             </a:r>
           </a:p>
           <a:p>
             <a:pPr lvl="3"/>
             <a:r>
-              <a:rPr lang="en-US" smtClean="0"/>
+              <a:rPr lang="en-US"/>
               <a:t>Fourth level</a:t>
             </a:r>
           </a:p>
           <a:p>
             <a:pPr lvl="4"/>
             <a:r>
-              <a:rPr lang="en-US" smtClean="0"/>
+              <a:rPr lang="en-US"/>
               <a:t>Fifth level</a:t>
             </a:r>
-            <a:endParaRPr lang="en-US"/>
           </a:p>
         </p:txBody>
       </p:sp>
@@ -1391,7 +1393,7 @@
           <a:p>
             <a:fld id="{5BCAD085-E8A6-8845-BD4E-CB4CCA059FC4}" type="datetimeFigureOut">
               <a:rPr lang="en-US" smtClean="0"/>
-              <a:t>1/27/13</a:t>
+              <a:t>6/19/26</a:t>
             </a:fld>
             <a:endParaRPr lang="en-US"/>
           </a:p>
@@ -1433,7 +1435,7 @@
           <a:p>
             <a:fld id="{C1FF6DA9-008F-8B48-92A6-B652298478BF}" type="slidenum">
               <a:rPr lang="en-US" smtClean="0"/>
-              <a:t>‹#›</a:t>
+              <a:t>‹nr.›</a:t>
             </a:fld>
             <a:endParaRPr lang="en-US"/>
           </a:p>
@@ -1489,10 +1491,9 @@
           </a:lstStyle>
           <a:p>
             <a:r>
-              <a:rPr lang="en-US" smtClean="0"/>
+              <a:rPr lang="en-US"/>
               <a:t>Click to edit Master title style</a:t>
             </a:r>
-            <a:endParaRPr lang="en-US"/>
           </a:p>
         </p:txBody>
       </p:sp>
@@ -1555,7 +1556,7 @@
           <a:p>
             <a:pPr lvl="0"/>
             <a:r>
-              <a:rPr lang="en-US" smtClean="0"/>
+              <a:rPr lang="en-US"/>
               <a:t>Click to edit Master text styles</a:t>
             </a:r>
           </a:p>
@@ -1611,38 +1612,37 @@
           <a:p>
             <a:pPr lvl="0"/>
             <a:r>
-              <a:rPr lang="en-US" smtClean="0"/>
+              <a:rPr lang="en-US"/>
               <a:t>Click to edit Master text styles</a:t>
             </a:r>
           </a:p>
           <a:p>
             <a:pPr lvl="1"/>
             <a:r>
-              <a:rPr lang="en-US" smtClean="0"/>
+              <a:rPr lang="en-US"/>
               <a:t>Second level</a:t>
             </a:r>
           </a:p>
           <a:p>
             <a:pPr lvl="2"/>
             <a:r>
-              <a:rPr lang="en-US" smtClean="0"/>
+              <a:rPr lang="en-US"/>
               <a:t>Third level</a:t>
             </a:r>
           </a:p>
           <a:p>
             <a:pPr lvl="3"/>
             <a:r>
-              <a:rPr lang="en-US" smtClean="0"/>
+              <a:rPr lang="en-US"/>
               <a:t>Fourth level</a:t>
             </a:r>
           </a:p>
           <a:p>
             <a:pPr lvl="4"/>
             <a:r>
-              <a:rPr lang="en-US" smtClean="0"/>
+              <a:rPr lang="en-US"/>
               <a:t>Fifth level</a:t>
             </a:r>
-            <a:endParaRPr lang="en-US"/>
           </a:p>
         </p:txBody>
       </p:sp>
@@ -1705,7 +1705,7 @@
           <a:p>
             <a:pPr lvl="0"/>
             <a:r>
-              <a:rPr lang="en-US" smtClean="0"/>
+              <a:rPr lang="en-US"/>
               <a:t>Click to edit Master text styles</a:t>
             </a:r>
           </a:p>
@@ -1761,38 +1761,37 @@
           <a:p>
             <a:pPr lvl="0"/>
             <a:r>
-              <a:rPr lang="en-US" smtClean="0"/>
+              <a:rPr lang="en-US"/>
               <a:t>Click to edit Master text styles</a:t>
             </a:r>
           </a:p>
           <a:p>
             <a:pPr lvl="1"/>
             <a:r>
-              <a:rPr lang="en-US" smtClean="0"/>
+              <a:rPr lang="en-US"/>
               <a:t>Second level</a:t>
             </a:r>
           </a:p>
           <a:p>
             <a:pPr lvl="2"/>
             <a:r>
-              <a:rPr lang="en-US" smtClean="0"/>
+              <a:rPr lang="en-US"/>
               <a:t>Third level</a:t>
             </a:r>
           </a:p>
           <a:p>
             <a:pPr lvl="3"/>
             <a:r>
-              <a:rPr lang="en-US" smtClean="0"/>
+              <a:rPr lang="en-US"/>
               <a:t>Fourth level</a:t>
             </a:r>
           </a:p>
           <a:p>
             <a:pPr lvl="4"/>
             <a:r>
-              <a:rPr lang="en-US" smtClean="0"/>
+              <a:rPr lang="en-US"/>
               <a:t>Fifth level</a:t>
             </a:r>
-            <a:endParaRPr lang="en-US"/>
           </a:p>
         </p:txBody>
       </p:sp>
@@ -1813,7 +1812,7 @@
           <a:p>
             <a:fld id="{5BCAD085-E8A6-8845-BD4E-CB4CCA059FC4}" type="datetimeFigureOut">
               <a:rPr lang="en-US" smtClean="0"/>
-              <a:t>1/27/13</a:t>
+              <a:t>6/19/26</a:t>
             </a:fld>
             <a:endParaRPr lang="en-US"/>
           </a:p>
@@ -1855,7 +1854,7 @@
           <a:p>
             <a:fld id="{C1FF6DA9-008F-8B48-92A6-B652298478BF}" type="slidenum">
               <a:rPr lang="en-US" smtClean="0"/>
-              <a:t>‹#›</a:t>
+              <a:t>‹nr.›</a:t>
             </a:fld>
             <a:endParaRPr lang="en-US"/>
           </a:p>
@@ -1907,10 +1906,9 @@
           <a:lstStyle/>
           <a:p>
             <a:r>
-              <a:rPr lang="en-US" smtClean="0"/>
+              <a:rPr lang="en-US"/>
               <a:t>Click to edit Master title style</a:t>
             </a:r>
-            <a:endParaRPr lang="en-US"/>
           </a:p>
         </p:txBody>
       </p:sp>
@@ -1931,7 +1929,7 @@
           <a:p>
             <a:fld id="{5BCAD085-E8A6-8845-BD4E-CB4CCA059FC4}" type="datetimeFigureOut">
               <a:rPr lang="en-US" smtClean="0"/>
-              <a:t>1/27/13</a:t>
+              <a:t>6/19/26</a:t>
             </a:fld>
             <a:endParaRPr lang="en-US"/>
           </a:p>
@@ -1973,7 +1971,7 @@
           <a:p>
             <a:fld id="{C1FF6DA9-008F-8B48-92A6-B652298478BF}" type="slidenum">
               <a:rPr lang="en-US" smtClean="0"/>
-              <a:t>‹#›</a:t>
+              <a:t>‹nr.›</a:t>
             </a:fld>
             <a:endParaRPr lang="en-US"/>
           </a:p>
@@ -2026,7 +2024,7 @@
           <a:p>
             <a:fld id="{5BCAD085-E8A6-8845-BD4E-CB4CCA059FC4}" type="datetimeFigureOut">
               <a:rPr lang="en-US" smtClean="0"/>
-              <a:t>1/27/13</a:t>
+              <a:t>6/19/26</a:t>
             </a:fld>
             <a:endParaRPr lang="en-US"/>
           </a:p>
@@ -2068,7 +2066,7 @@
           <a:p>
             <a:fld id="{C1FF6DA9-008F-8B48-92A6-B652298478BF}" type="slidenum">
               <a:rPr lang="en-US" smtClean="0"/>
-              <a:t>‹#›</a:t>
+              <a:t>‹nr.›</a:t>
             </a:fld>
             <a:endParaRPr lang="en-US"/>
           </a:p>
@@ -2129,10 +2127,9 @@
           </a:lstStyle>
           <a:p>
             <a:r>
-              <a:rPr lang="en-US" smtClean="0"/>
+              <a:rPr lang="en-US"/>
               <a:t>Click to edit Master title style</a:t>
             </a:r>
-            <a:endParaRPr lang="en-US"/>
           </a:p>
         </p:txBody>
       </p:sp>
@@ -2186,38 +2183,37 @@
           <a:p>
             <a:pPr lvl="0"/>
             <a:r>
-              <a:rPr lang="en-US" smtClean="0"/>
+              <a:rPr lang="en-US"/>
               <a:t>Click to edit Master text styles</a:t>
             </a:r>
           </a:p>
           <a:p>
             <a:pPr lvl="1"/>
             <a:r>
-              <a:rPr lang="en-US" smtClean="0"/>
+              <a:rPr lang="en-US"/>
               <a:t>Second level</a:t>
             </a:r>
           </a:p>
           <a:p>
             <a:pPr lvl="2"/>
             <a:r>
-              <a:rPr lang="en-US" smtClean="0"/>
+              <a:rPr lang="en-US"/>
               <a:t>Third level</a:t>
             </a:r>
           </a:p>
           <a:p>
             <a:pPr lvl="3"/>
             <a:r>
-              <a:rPr lang="en-US" smtClean="0"/>
+              <a:rPr lang="en-US"/>
               <a:t>Fourth level</a:t>
             </a:r>
           </a:p>
           <a:p>
             <a:pPr lvl="4"/>
             <a:r>
-              <a:rPr lang="en-US" smtClean="0"/>
+              <a:rPr lang="en-US"/>
               <a:t>Fifth level</a:t>
             </a:r>
-            <a:endParaRPr lang="en-US"/>
           </a:p>
         </p:txBody>
       </p:sp>
@@ -2280,7 +2276,7 @@
           <a:p>
             <a:pPr lvl="0"/>
             <a:r>
-              <a:rPr lang="en-US" smtClean="0"/>
+              <a:rPr lang="en-US"/>
               <a:t>Click to edit Master text styles</a:t>
             </a:r>
           </a:p>
@@ -2303,7 +2299,7 @@
           <a:p>
             <a:fld id="{5BCAD085-E8A6-8845-BD4E-CB4CCA059FC4}" type="datetimeFigureOut">
               <a:rPr lang="en-US" smtClean="0"/>
-              <a:t>1/27/13</a:t>
+              <a:t>6/19/26</a:t>
             </a:fld>
             <a:endParaRPr lang="en-US"/>
           </a:p>
@@ -2345,7 +2341,7 @@
           <a:p>
             <a:fld id="{C1FF6DA9-008F-8B48-92A6-B652298478BF}" type="slidenum">
               <a:rPr lang="en-US" smtClean="0"/>
-              <a:t>‹#›</a:t>
+              <a:t>‹nr.›</a:t>
             </a:fld>
             <a:endParaRPr lang="en-US"/>
           </a:p>
@@ -2406,10 +2402,9 @@
           </a:lstStyle>
           <a:p>
             <a:r>
-              <a:rPr lang="en-US" smtClean="0"/>
+              <a:rPr lang="en-US"/>
               <a:t>Click to edit Master title style</a:t>
             </a:r>
-            <a:endParaRPr lang="en-US"/>
           </a:p>
         </p:txBody>
       </p:sp>
@@ -2533,7 +2528,7 @@
           <a:p>
             <a:pPr lvl="0"/>
             <a:r>
-              <a:rPr lang="en-US" smtClean="0"/>
+              <a:rPr lang="en-US"/>
               <a:t>Click to edit Master text styles</a:t>
             </a:r>
           </a:p>
@@ -2556,7 +2551,7 @@
           <a:p>
             <a:fld id="{5BCAD085-E8A6-8845-BD4E-CB4CCA059FC4}" type="datetimeFigureOut">
               <a:rPr lang="en-US" smtClean="0"/>
-              <a:t>1/27/13</a:t>
+              <a:t>6/19/26</a:t>
             </a:fld>
             <a:endParaRPr lang="en-US"/>
           </a:p>
@@ -2598,7 +2593,7 @@
           <a:p>
             <a:fld id="{C1FF6DA9-008F-8B48-92A6-B652298478BF}" type="slidenum">
               <a:rPr lang="en-US" smtClean="0"/>
-              <a:t>‹#›</a:t>
+              <a:t>‹nr.›</a:t>
             </a:fld>
             <a:endParaRPr lang="en-US"/>
           </a:p>
@@ -2665,10 +2660,9 @@
           <a:lstStyle/>
           <a:p>
             <a:r>
-              <a:rPr lang="en-US" smtClean="0"/>
+              <a:rPr lang="en-US"/>
               <a:t>Click to edit Master title style</a:t>
             </a:r>
-            <a:endParaRPr lang="en-US"/>
           </a:p>
         </p:txBody>
       </p:sp>
@@ -2699,38 +2693,37 @@
           <a:p>
             <a:pPr lvl="0"/>
             <a:r>
-              <a:rPr lang="en-US" smtClean="0"/>
+              <a:rPr lang="en-US"/>
               <a:t>Click to edit Master text styles</a:t>
             </a:r>
           </a:p>
           <a:p>
             <a:pPr lvl="1"/>
             <a:r>
-              <a:rPr lang="en-US" smtClean="0"/>
+              <a:rPr lang="en-US"/>
               <a:t>Second level</a:t>
             </a:r>
           </a:p>
           <a:p>
             <a:pPr lvl="2"/>
             <a:r>
-              <a:rPr lang="en-US" smtClean="0"/>
+              <a:rPr lang="en-US"/>
               <a:t>Third level</a:t>
             </a:r>
           </a:p>
           <a:p>
             <a:pPr lvl="3"/>
             <a:r>
-              <a:rPr lang="en-US" smtClean="0"/>
+              <a:rPr lang="en-US"/>
               <a:t>Fourth level</a:t>
             </a:r>
           </a:p>
           <a:p>
             <a:pPr lvl="4"/>
             <a:r>
-              <a:rPr lang="en-US" smtClean="0"/>
+              <a:rPr lang="en-US"/>
               <a:t>Fifth level</a:t>
             </a:r>
-            <a:endParaRPr lang="en-US"/>
           </a:p>
         </p:txBody>
       </p:sp>
@@ -2769,7 +2762,7 @@
           <a:p>
             <a:fld id="{5BCAD085-E8A6-8845-BD4E-CB4CCA059FC4}" type="datetimeFigureOut">
               <a:rPr lang="en-US" smtClean="0"/>
-              <a:t>1/27/13</a:t>
+              <a:t>6/19/26</a:t>
             </a:fld>
             <a:endParaRPr lang="en-US"/>
           </a:p>
@@ -2847,7 +2840,7 @@
           <a:p>
             <a:fld id="{C1FF6DA9-008F-8B48-92A6-B652298478BF}" type="slidenum">
               <a:rPr lang="en-US" smtClean="0"/>
-              <a:t>‹#›</a:t>
+              <a:t>‹nr.›</a:t>
             </a:fld>
             <a:endParaRPr lang="en-US"/>
           </a:p>
@@ -3128,7 +3121,7 @@
 </file>
 
 <file path=ppt/slides/slide1.xml><?xml version="1.0" encoding="utf-8"?>
-<p:sld xmlns:a="http://schemas.openxmlformats.org/drawingml/2006/main" xmlns:p="http://schemas.openxmlformats.org/presentationml/2006/main" xmlns:r="http://schemas.openxmlformats.org/officeDocument/2006/relationships">
+<p:sld xmlns:a="http://schemas.openxmlformats.org/drawingml/2006/main" xmlns:r="http://schemas.openxmlformats.org/officeDocument/2006/relationships" xmlns:p="http://schemas.openxmlformats.org/presentationml/2006/main">
   <p:cSld>
     <p:spTree>
       <p:nvGrpSpPr>
@@ -3136,7 +3129,14 @@
         <p:cNvGrpSpPr/>
         <p:nvPr/>
       </p:nvGrpSpPr>
-      <p:grpSpPr/>
+      <p:grpSpPr>
+        <a:xfrm>
+          <a:off x="0" y="0"/>
+          <a:ext cx="0" cy="0"/>
+          <a:chOff x="0" y="0"/>
+          <a:chExt cx="0" cy="0"/>
+        </a:xfrm>
+      </p:grpSpPr>
       <p:pic>
         <p:nvPicPr>
           <p:cNvPr id="2" name="Picture 1" descr="_bg.png"/>
@@ -3177,8 +3177,8 @@
         </p:blipFill>
         <p:spPr>
           <a:xfrm>
-            <a:off x="548640" y="502920"/>
-            <a:ext cx="1235676" cy="914400"/>
+            <a:off x="548639" y="502919"/>
+            <a:ext cx="2267613" cy="1678033"/>
           </a:xfrm>
           <a:prstGeom prst="rect">
             <a:avLst/>
@@ -3193,7 +3193,7 @@
         </p:nvSpPr>
         <p:spPr>
           <a:xfrm>
-            <a:off x="548640" y="2011680"/>
+            <a:off x="548639" y="2971800"/>
             <a:ext cx="10972800" cy="457200"/>
           </a:xfrm>
           <a:prstGeom prst="rect">
@@ -3202,14 +3202,14 @@
           <a:noFill/>
         </p:spPr>
         <p:txBody>
-          <a:bodyPr wrap="square" lIns="0" rIns="0" tIns="0" bIns="0" anchor="t">
+          <a:bodyPr wrap="square" lIns="0" tIns="0" rIns="0" bIns="0" anchor="t">
             <a:spAutoFit/>
           </a:bodyPr>
           <a:lstStyle/>
           <a:p>
             <a:pPr algn="l"/>
             <a:r>
-              <a:rPr sz="1400" b="1">
+              <a:rPr sz="1400" b="1" dirty="0">
                 <a:solidFill>
                   <a:srgbClr val="4AB8D2"/>
                 </a:solidFill>
@@ -3228,7 +3228,7 @@
         </p:nvSpPr>
         <p:spPr>
           <a:xfrm>
-            <a:off x="548640" y="2468880"/>
+            <a:off x="548639" y="3518263"/>
             <a:ext cx="10972800" cy="1463040"/>
           </a:xfrm>
           <a:prstGeom prst="rect">
@@ -3237,90 +3237,29 @@
           <a:noFill/>
         </p:spPr>
         <p:txBody>
-          <a:bodyPr wrap="square" lIns="0" rIns="0" tIns="0" bIns="0" anchor="t">
+          <a:bodyPr wrap="square" lIns="0" tIns="0" rIns="0" bIns="0" anchor="t">
             <a:spAutoFit/>
           </a:bodyPr>
           <a:lstStyle/>
           <a:p>
             <a:pPr algn="l"/>
             <a:r>
-              <a:rPr sz="7200" b="1">
+              <a:rPr sz="7200" b="1" dirty="0" err="1">
                 <a:solidFill>
                   <a:srgbClr val="E8E8ED"/>
                 </a:solidFill>
                 <a:latin typeface="Inter"/>
               </a:rPr>
-              <a:t>BSides Aarhus 2026</a:t>
-            </a:r>
-          </a:p>
-        </p:txBody>
-      </p:sp>
-      <p:sp>
-        <p:nvSpPr>
-          <p:cNvPr id="6" name="TextBox 5"/>
-          <p:cNvSpPr txBox="1"/>
-          <p:nvPr/>
-        </p:nvSpPr>
-        <p:spPr>
-          <a:xfrm>
-            <a:off x="548640" y="4206240"/>
-            <a:ext cx="10972800" cy="548640"/>
-          </a:xfrm>
-          <a:prstGeom prst="rect">
-            <a:avLst/>
-          </a:prstGeom>
-          <a:noFill/>
-        </p:spPr>
-        <p:txBody>
-          <a:bodyPr wrap="square" lIns="0" rIns="0" tIns="0" bIns="0" anchor="t">
-            <a:spAutoFit/>
-          </a:bodyPr>
-          <a:lstStyle/>
-          <a:p>
-            <a:pPr algn="l"/>
-            <a:r>
-              <a:rPr sz="3200" b="0">
-                <a:solidFill>
-                  <a:srgbClr val="6DD0E7"/>
+              <a:t>BSides</a:t>
+            </a:r>
+            <a:r>
+              <a:rPr sz="7200" b="1" dirty="0">
+                <a:solidFill>
+                  <a:srgbClr val="E8E8ED"/>
                 </a:solidFill>
                 <a:latin typeface="Inter"/>
               </a:rPr>
-              <a:t>Talk title goes here</a:t>
-            </a:r>
-          </a:p>
-        </p:txBody>
-      </p:sp>
-      <p:sp>
-        <p:nvSpPr>
-          <p:cNvPr id="7" name="TextBox 6"/>
-          <p:cNvSpPr txBox="1"/>
-          <p:nvPr/>
-        </p:nvSpPr>
-        <p:spPr>
-          <a:xfrm>
-            <a:off x="548640" y="4937760"/>
-            <a:ext cx="10972800" cy="411480"/>
-          </a:xfrm>
-          <a:prstGeom prst="rect">
-            <a:avLst/>
-          </a:prstGeom>
-          <a:noFill/>
-        </p:spPr>
-        <p:txBody>
-          <a:bodyPr wrap="square" lIns="0" rIns="0" tIns="0" bIns="0" anchor="t">
-            <a:spAutoFit/>
-          </a:bodyPr>
-          <a:lstStyle/>
-          <a:p>
-            <a:pPr algn="l"/>
-            <a:r>
-              <a:rPr sz="2000" b="0">
-                <a:solidFill>
-                  <a:srgbClr val="8888A0"/>
-                </a:solidFill>
-                <a:latin typeface="Inter"/>
-              </a:rPr>
-              <a:t>Speaker Name  ·  Affiliation</a:t>
+              <a:t> Aarhus 2026</a:t>
             </a:r>
           </a:p>
         </p:txBody>
@@ -3365,6 +3304,7 @@
           <a:lstStyle/>
           <a:p>
             <a:pPr algn="ctr"/>
+            <a:endParaRPr/>
           </a:p>
         </p:txBody>
       </p:sp>
@@ -3385,7 +3325,7 @@
           <a:noFill/>
         </p:spPr>
         <p:txBody>
-          <a:bodyPr wrap="square" lIns="0" rIns="0" tIns="0" bIns="0" anchor="t">
+          <a:bodyPr wrap="square" lIns="0" tIns="0" rIns="0" bIns="0" anchor="t">
             <a:spAutoFit/>
           </a:bodyPr>
           <a:lstStyle/>
@@ -3408,13 +3348,13 @@
   <p:clrMapOvr>
     <a:masterClrMapping/>
   </p:clrMapOvr>
-  <mc:AlternateContent xmlns:mc="http://schemas.openxmlformats.org/markup-compatibility/2006">
-    <mc:Choice xmlns:p14="http://schemas.microsoft.com/office/powerpoint/2010/main" Requires="p14">
+  <mc:AlternateContent xmlns:mc="http://schemas.openxmlformats.org/markup-compatibility/2006" xmlns:p14="http://schemas.microsoft.com/office/powerpoint/2010/main">
+    <mc:Choice Requires="p14">
       <p:transition spd="med" p14:dur="700">
         <p:fade/>
       </p:transition>
     </mc:Choice>
-    <mc:Fallback>
+    <mc:Fallback xmlns="">
       <p:transition spd="med">
         <p:fade/>
       </p:transition>
@@ -3424,7 +3364,7 @@
 </file>
 
 <file path=ppt/slides/slide10.xml><?xml version="1.0" encoding="utf-8"?>
-<p:sld xmlns:a="http://schemas.openxmlformats.org/drawingml/2006/main" xmlns:p="http://schemas.openxmlformats.org/presentationml/2006/main" xmlns:r="http://schemas.openxmlformats.org/officeDocument/2006/relationships">
+<p:sld xmlns:a="http://schemas.openxmlformats.org/drawingml/2006/main" xmlns:r="http://schemas.openxmlformats.org/officeDocument/2006/relationships" xmlns:p="http://schemas.openxmlformats.org/presentationml/2006/main">
   <p:cSld>
     <p:spTree>
       <p:nvGrpSpPr>
@@ -3432,7 +3372,14 @@
         <p:cNvGrpSpPr/>
         <p:nvPr/>
       </p:nvGrpSpPr>
-      <p:grpSpPr/>
+      <p:grpSpPr>
+        <a:xfrm>
+          <a:off x="0" y="0"/>
+          <a:ext cx="0" cy="0"/>
+          <a:chOff x="0" y="0"/>
+          <a:chExt cx="0" cy="0"/>
+        </a:xfrm>
+      </p:grpSpPr>
       <p:pic>
         <p:nvPicPr>
           <p:cNvPr id="2" name="Picture 1" descr="_bg.png"/>
@@ -3523,6 +3470,7 @@
           <a:lstStyle/>
           <a:p>
             <a:pPr algn="ctr"/>
+            <a:endParaRPr/>
           </a:p>
         </p:txBody>
       </p:sp>
@@ -3590,6 +3538,7 @@
           <a:lstStyle/>
           <a:p>
             <a:pPr algn="ctr"/>
+            <a:endParaRPr/>
           </a:p>
         </p:txBody>
       </p:sp>
@@ -3610,7 +3559,7 @@
           <a:noFill/>
         </p:spPr>
         <p:txBody>
-          <a:bodyPr wrap="square" lIns="0" rIns="0" tIns="0" bIns="0" anchor="t">
+          <a:bodyPr wrap="square" lIns="0" tIns="0" rIns="0" bIns="0" anchor="t">
             <a:spAutoFit/>
           </a:bodyPr>
           <a:lstStyle/>
@@ -3645,7 +3594,7 @@
           <a:noFill/>
         </p:spPr>
         <p:txBody>
-          <a:bodyPr wrap="square" lIns="0" rIns="0" tIns="0" bIns="0" anchor="t">
+          <a:bodyPr wrap="square" lIns="0" tIns="0" rIns="0" bIns="0" anchor="t">
             <a:spAutoFit/>
           </a:bodyPr>
           <a:lstStyle/>
@@ -3680,7 +3629,7 @@
           <a:noFill/>
         </p:spPr>
         <p:txBody>
-          <a:bodyPr wrap="square" lIns="0" rIns="0" tIns="0" bIns="0" anchor="t">
+          <a:bodyPr wrap="square" lIns="0" tIns="0" rIns="0" bIns="0" anchor="t">
             <a:spAutoFit/>
           </a:bodyPr>
           <a:lstStyle/>
@@ -3715,7 +3664,7 @@
           <a:noFill/>
         </p:spPr>
         <p:txBody>
-          <a:bodyPr wrap="square" lIns="0" rIns="0" tIns="0" bIns="0" anchor="t">
+          <a:bodyPr wrap="square" lIns="0" tIns="0" rIns="0" bIns="0" anchor="t">
             <a:spAutoFit/>
           </a:bodyPr>
           <a:lstStyle/>
@@ -3750,7 +3699,7 @@
           <a:noFill/>
         </p:spPr>
         <p:txBody>
-          <a:bodyPr wrap="square" lIns="0" rIns="0" tIns="0" bIns="0" anchor="t">
+          <a:bodyPr wrap="square" lIns="0" tIns="0" rIns="0" bIns="0" anchor="t">
             <a:spAutoFit/>
           </a:bodyPr>
           <a:lstStyle/>
@@ -3785,7 +3734,7 @@
           <a:noFill/>
         </p:spPr>
         <p:txBody>
-          <a:bodyPr wrap="square" lIns="0" rIns="0" tIns="0" bIns="0" anchor="t">
+          <a:bodyPr wrap="square" lIns="0" tIns="0" rIns="0" bIns="0" anchor="t">
             <a:spAutoFit/>
           </a:bodyPr>
           <a:lstStyle/>
@@ -3820,7 +3769,7 @@
           <a:noFill/>
         </p:spPr>
         <p:txBody>
-          <a:bodyPr wrap="square" lIns="0" rIns="0" tIns="0" bIns="0" anchor="t">
+          <a:bodyPr wrap="square" lIns="0" tIns="0" rIns="0" bIns="0" anchor="t">
             <a:spAutoFit/>
           </a:bodyPr>
           <a:lstStyle/>
@@ -3838,18 +3787,48 @@
           </a:p>
         </p:txBody>
       </p:sp>
+      <p:pic>
+        <p:nvPicPr>
+          <p:cNvPr id="14" name="Billede 13">
+            <a:extLst>
+              <a:ext uri="{FF2B5EF4-FFF2-40B4-BE49-F238E27FC236}">
+                <a16:creationId xmlns:a16="http://schemas.microsoft.com/office/drawing/2014/main" id="{660AF998-D9FF-3F34-770C-25436710065F}"/>
+              </a:ext>
+            </a:extLst>
+          </p:cNvPr>
+          <p:cNvPicPr>
+            <a:picLocks noChangeAspect="1"/>
+          </p:cNvPicPr>
+          <p:nvPr/>
+        </p:nvPicPr>
+        <p:blipFill>
+          <a:blip r:embed="rId5"/>
+          <a:stretch>
+            <a:fillRect/>
+          </a:stretch>
+        </p:blipFill>
+        <p:spPr>
+          <a:xfrm>
+            <a:off x="10412509" y="137160"/>
+            <a:ext cx="1637211" cy="1637211"/>
+          </a:xfrm>
+          <a:prstGeom prst="rect">
+            <a:avLst/>
+          </a:prstGeom>
+        </p:spPr>
+      </p:pic>
     </p:spTree>
   </p:cSld>
   <p:clrMapOvr>
     <a:masterClrMapping/>
   </p:clrMapOvr>
-  <mc:AlternateContent xmlns:mc="http://schemas.openxmlformats.org/markup-compatibility/2006">
-    <mc:Choice xmlns:p14="http://schemas.microsoft.com/office/powerpoint/2010/main" Requires="p14">
+  <mc:AlternateContent xmlns:mc="http://schemas.openxmlformats.org/markup-compatibility/2006" xmlns:p14="http://schemas.microsoft.com/office/powerpoint/2010/main">
+    <mc:Choice Requires="p14">
       <p:transition spd="med" p14:dur="700">
         <p:fade/>
       </p:transition>
     </mc:Choice>
-    <mc:Fallback>
+    <mc:Fallback xmlns="">
       <p:transition spd="med">
         <p:fade/>
       </p:transition>
@@ -3859,7 +3838,7 @@
 </file>
 
 <file path=ppt/slides/slide11.xml><?xml version="1.0" encoding="utf-8"?>
-<p:sld xmlns:a="http://schemas.openxmlformats.org/drawingml/2006/main" xmlns:p="http://schemas.openxmlformats.org/presentationml/2006/main" xmlns:r="http://schemas.openxmlformats.org/officeDocument/2006/relationships">
+<p:sld xmlns:a="http://schemas.openxmlformats.org/drawingml/2006/main" xmlns:r="http://schemas.openxmlformats.org/officeDocument/2006/relationships" xmlns:p="http://schemas.openxmlformats.org/presentationml/2006/main">
   <p:cSld>
     <p:spTree>
       <p:nvGrpSpPr>
@@ -3867,7 +3846,14 @@
         <p:cNvGrpSpPr/>
         <p:nvPr/>
       </p:nvGrpSpPr>
-      <p:grpSpPr/>
+      <p:grpSpPr>
+        <a:xfrm>
+          <a:off x="0" y="0"/>
+          <a:ext cx="0" cy="0"/>
+          <a:chOff x="0" y="0"/>
+          <a:chExt cx="0" cy="0"/>
+        </a:xfrm>
+      </p:grpSpPr>
       <p:pic>
         <p:nvPicPr>
           <p:cNvPr id="2" name="Picture 1" descr="_bg.png"/>
@@ -3958,6 +3944,7 @@
           <a:lstStyle/>
           <a:p>
             <a:pPr algn="ctr"/>
+            <a:endParaRPr/>
           </a:p>
         </p:txBody>
       </p:sp>
@@ -4025,6 +4012,7 @@
           <a:lstStyle/>
           <a:p>
             <a:pPr algn="ctr"/>
+            <a:endParaRPr/>
           </a:p>
         </p:txBody>
       </p:sp>
@@ -4045,7 +4033,7 @@
           <a:noFill/>
         </p:spPr>
         <p:txBody>
-          <a:bodyPr wrap="square" lIns="0" rIns="0" tIns="0" bIns="0" anchor="t">
+          <a:bodyPr wrap="square" lIns="0" tIns="0" rIns="0" bIns="0" anchor="t">
             <a:spAutoFit/>
           </a:bodyPr>
           <a:lstStyle/>
@@ -4080,7 +4068,7 @@
           <a:noFill/>
         </p:spPr>
         <p:txBody>
-          <a:bodyPr wrap="square" lIns="0" rIns="0" tIns="0" bIns="0" anchor="t">
+          <a:bodyPr wrap="square" lIns="0" tIns="0" rIns="0" bIns="0" anchor="t">
             <a:spAutoFit/>
           </a:bodyPr>
           <a:lstStyle/>
@@ -4115,7 +4103,7 @@
           <a:noFill/>
         </p:spPr>
         <p:txBody>
-          <a:bodyPr wrap="square" lIns="0" rIns="0" tIns="0" bIns="0" anchor="t">
+          <a:bodyPr wrap="square" lIns="0" tIns="0" rIns="0" bIns="0" anchor="t">
             <a:spAutoFit/>
           </a:bodyPr>
           <a:lstStyle/>
@@ -4150,7 +4138,7 @@
           <a:noFill/>
         </p:spPr>
         <p:txBody>
-          <a:bodyPr wrap="square" lIns="0" rIns="0" tIns="0" bIns="0" anchor="t">
+          <a:bodyPr wrap="square" lIns="0" tIns="0" rIns="0" bIns="0" anchor="t">
             <a:spAutoFit/>
           </a:bodyPr>
           <a:lstStyle/>
@@ -4185,7 +4173,7 @@
           <a:noFill/>
         </p:spPr>
         <p:txBody>
-          <a:bodyPr wrap="square" lIns="0" rIns="0" tIns="0" bIns="0" anchor="t">
+          <a:bodyPr wrap="square" lIns="0" tIns="0" rIns="0" bIns="0" anchor="t">
             <a:spAutoFit/>
           </a:bodyPr>
           <a:lstStyle/>
@@ -4220,7 +4208,7 @@
           <a:noFill/>
         </p:spPr>
         <p:txBody>
-          <a:bodyPr wrap="square" lIns="0" rIns="0" tIns="0" bIns="0" anchor="t">
+          <a:bodyPr wrap="square" lIns="0" tIns="0" rIns="0" bIns="0" anchor="t">
             <a:spAutoFit/>
           </a:bodyPr>
           <a:lstStyle/>
@@ -4255,7 +4243,7 @@
           <a:noFill/>
         </p:spPr>
         <p:txBody>
-          <a:bodyPr wrap="square" lIns="0" rIns="0" tIns="0" bIns="0" anchor="t">
+          <a:bodyPr wrap="square" lIns="0" tIns="0" rIns="0" bIns="0" anchor="t">
             <a:spAutoFit/>
           </a:bodyPr>
           <a:lstStyle/>
@@ -4273,18 +4261,48 @@
           </a:p>
         </p:txBody>
       </p:sp>
+      <p:pic>
+        <p:nvPicPr>
+          <p:cNvPr id="14" name="Billede 13">
+            <a:extLst>
+              <a:ext uri="{FF2B5EF4-FFF2-40B4-BE49-F238E27FC236}">
+                <a16:creationId xmlns:a16="http://schemas.microsoft.com/office/drawing/2014/main" id="{E1CB9C69-19F0-2CD3-7E44-07B0F581E15B}"/>
+              </a:ext>
+            </a:extLst>
+          </p:cNvPr>
+          <p:cNvPicPr>
+            <a:picLocks noChangeAspect="1"/>
+          </p:cNvPicPr>
+          <p:nvPr/>
+        </p:nvPicPr>
+        <p:blipFill>
+          <a:blip r:embed="rId5"/>
+          <a:stretch>
+            <a:fillRect/>
+          </a:stretch>
+        </p:blipFill>
+        <p:spPr>
+          <a:xfrm>
+            <a:off x="10412509" y="137160"/>
+            <a:ext cx="1637211" cy="1637211"/>
+          </a:xfrm>
+          <a:prstGeom prst="rect">
+            <a:avLst/>
+          </a:prstGeom>
+        </p:spPr>
+      </p:pic>
     </p:spTree>
   </p:cSld>
   <p:clrMapOvr>
     <a:masterClrMapping/>
   </p:clrMapOvr>
-  <mc:AlternateContent xmlns:mc="http://schemas.openxmlformats.org/markup-compatibility/2006">
-    <mc:Choice xmlns:p14="http://schemas.microsoft.com/office/powerpoint/2010/main" Requires="p14">
+  <mc:AlternateContent xmlns:mc="http://schemas.openxmlformats.org/markup-compatibility/2006" xmlns:p14="http://schemas.microsoft.com/office/powerpoint/2010/main">
+    <mc:Choice Requires="p14">
       <p:transition spd="med" p14:dur="700">
         <p:fade/>
       </p:transition>
     </mc:Choice>
-    <mc:Fallback>
+    <mc:Fallback xmlns="">
       <p:transition spd="med">
         <p:fade/>
       </p:transition>
@@ -4294,7 +4312,7 @@
 </file>
 
 <file path=ppt/slides/slide12.xml><?xml version="1.0" encoding="utf-8"?>
-<p:sld xmlns:a="http://schemas.openxmlformats.org/drawingml/2006/main" xmlns:p="http://schemas.openxmlformats.org/presentationml/2006/main" xmlns:r="http://schemas.openxmlformats.org/officeDocument/2006/relationships">
+<p:sld xmlns:a="http://schemas.openxmlformats.org/drawingml/2006/main" xmlns:r="http://schemas.openxmlformats.org/officeDocument/2006/relationships" xmlns:p="http://schemas.openxmlformats.org/presentationml/2006/main">
   <p:cSld>
     <p:spTree>
       <p:nvGrpSpPr>
@@ -4302,7 +4320,14 @@
         <p:cNvGrpSpPr/>
         <p:nvPr/>
       </p:nvGrpSpPr>
-      <p:grpSpPr/>
+      <p:grpSpPr>
+        <a:xfrm>
+          <a:off x="0" y="0"/>
+          <a:ext cx="0" cy="0"/>
+          <a:chOff x="0" y="0"/>
+          <a:chExt cx="0" cy="0"/>
+        </a:xfrm>
+      </p:grpSpPr>
       <p:pic>
         <p:nvPicPr>
           <p:cNvPr id="2" name="Picture 1" descr="_bg.png"/>
@@ -4393,6 +4418,7 @@
           <a:lstStyle/>
           <a:p>
             <a:pPr algn="ctr"/>
+            <a:endParaRPr/>
           </a:p>
         </p:txBody>
       </p:sp>
@@ -4460,6 +4486,7 @@
           <a:lstStyle/>
           <a:p>
             <a:pPr algn="ctr"/>
+            <a:endParaRPr/>
           </a:p>
         </p:txBody>
       </p:sp>
@@ -4480,7 +4507,7 @@
           <a:noFill/>
         </p:spPr>
         <p:txBody>
-          <a:bodyPr wrap="square" lIns="0" rIns="0" tIns="0" bIns="0" anchor="t">
+          <a:bodyPr wrap="square" lIns="0" tIns="0" rIns="0" bIns="0" anchor="t">
             <a:spAutoFit/>
           </a:bodyPr>
           <a:lstStyle/>
@@ -4515,7 +4542,7 @@
           <a:noFill/>
         </p:spPr>
         <p:txBody>
-          <a:bodyPr wrap="square" lIns="0" rIns="0" tIns="0" bIns="0" anchor="t">
+          <a:bodyPr wrap="square" lIns="0" tIns="0" rIns="0" bIns="0" anchor="t">
             <a:spAutoFit/>
           </a:bodyPr>
           <a:lstStyle/>
@@ -4550,7 +4577,7 @@
           <a:noFill/>
         </p:spPr>
         <p:txBody>
-          <a:bodyPr wrap="square" lIns="0" rIns="0" tIns="0" bIns="0" anchor="t">
+          <a:bodyPr wrap="square" lIns="0" tIns="0" rIns="0" bIns="0" anchor="t">
             <a:spAutoFit/>
           </a:bodyPr>
           <a:lstStyle/>
@@ -4585,7 +4612,7 @@
           <a:noFill/>
         </p:spPr>
         <p:txBody>
-          <a:bodyPr wrap="square" lIns="0" rIns="0" tIns="0" bIns="0" anchor="t">
+          <a:bodyPr wrap="square" lIns="0" tIns="0" rIns="0" bIns="0" anchor="t">
             <a:spAutoFit/>
           </a:bodyPr>
           <a:lstStyle/>
@@ -4620,7 +4647,7 @@
           <a:noFill/>
         </p:spPr>
         <p:txBody>
-          <a:bodyPr wrap="square" lIns="0" rIns="0" tIns="0" bIns="0" anchor="t">
+          <a:bodyPr wrap="square" lIns="0" tIns="0" rIns="0" bIns="0" anchor="t">
             <a:spAutoFit/>
           </a:bodyPr>
           <a:lstStyle/>
@@ -4655,7 +4682,7 @@
           <a:noFill/>
         </p:spPr>
         <p:txBody>
-          <a:bodyPr wrap="square" lIns="0" rIns="0" tIns="0" bIns="0" anchor="t">
+          <a:bodyPr wrap="square" lIns="0" tIns="0" rIns="0" bIns="0" anchor="t">
             <a:spAutoFit/>
           </a:bodyPr>
           <a:lstStyle/>
@@ -4690,7 +4717,7 @@
           <a:noFill/>
         </p:spPr>
         <p:txBody>
-          <a:bodyPr wrap="square" lIns="0" rIns="0" tIns="0" bIns="0" anchor="t">
+          <a:bodyPr wrap="square" lIns="0" tIns="0" rIns="0" bIns="0" anchor="t">
             <a:spAutoFit/>
           </a:bodyPr>
           <a:lstStyle/>
@@ -4708,18 +4735,48 @@
           </a:p>
         </p:txBody>
       </p:sp>
+      <p:pic>
+        <p:nvPicPr>
+          <p:cNvPr id="16" name="Billede 15">
+            <a:extLst>
+              <a:ext uri="{FF2B5EF4-FFF2-40B4-BE49-F238E27FC236}">
+                <a16:creationId xmlns:a16="http://schemas.microsoft.com/office/drawing/2014/main" id="{E697856D-9098-6A70-315A-7EC18A8A0C9F}"/>
+              </a:ext>
+            </a:extLst>
+          </p:cNvPr>
+          <p:cNvPicPr>
+            <a:picLocks noChangeAspect="1"/>
+          </p:cNvPicPr>
+          <p:nvPr/>
+        </p:nvPicPr>
+        <p:blipFill>
+          <a:blip r:embed="rId5"/>
+          <a:stretch>
+            <a:fillRect/>
+          </a:stretch>
+        </p:blipFill>
+        <p:spPr>
+          <a:xfrm>
+            <a:off x="10439400" y="175260"/>
+            <a:ext cx="1572662" cy="1572662"/>
+          </a:xfrm>
+          <a:prstGeom prst="rect">
+            <a:avLst/>
+          </a:prstGeom>
+        </p:spPr>
+      </p:pic>
     </p:spTree>
   </p:cSld>
   <p:clrMapOvr>
     <a:masterClrMapping/>
   </p:clrMapOvr>
-  <mc:AlternateContent xmlns:mc="http://schemas.openxmlformats.org/markup-compatibility/2006">
-    <mc:Choice xmlns:p14="http://schemas.microsoft.com/office/powerpoint/2010/main" Requires="p14">
+  <mc:AlternateContent xmlns:mc="http://schemas.openxmlformats.org/markup-compatibility/2006" xmlns:p14="http://schemas.microsoft.com/office/powerpoint/2010/main">
+    <mc:Choice Requires="p14">
       <p:transition spd="med" p14:dur="700">
         <p:fade/>
       </p:transition>
     </mc:Choice>
-    <mc:Fallback>
+    <mc:Fallback xmlns="">
       <p:transition spd="med">
         <p:fade/>
       </p:transition>
@@ -4729,7 +4786,7 @@
 </file>
 
 <file path=ppt/slides/slide13.xml><?xml version="1.0" encoding="utf-8"?>
-<p:sld xmlns:a="http://schemas.openxmlformats.org/drawingml/2006/main" xmlns:p="http://schemas.openxmlformats.org/presentationml/2006/main" xmlns:r="http://schemas.openxmlformats.org/officeDocument/2006/relationships">
+<p:sld xmlns:a="http://schemas.openxmlformats.org/drawingml/2006/main" xmlns:r="http://schemas.openxmlformats.org/officeDocument/2006/relationships" xmlns:p="http://schemas.openxmlformats.org/presentationml/2006/main">
   <p:cSld>
     <p:spTree>
       <p:nvGrpSpPr>
@@ -4737,7 +4794,14 @@
         <p:cNvGrpSpPr/>
         <p:nvPr/>
       </p:nvGrpSpPr>
-      <p:grpSpPr/>
+      <p:grpSpPr>
+        <a:xfrm>
+          <a:off x="0" y="0"/>
+          <a:ext cx="0" cy="0"/>
+          <a:chOff x="0" y="0"/>
+          <a:chExt cx="0" cy="0"/>
+        </a:xfrm>
+      </p:grpSpPr>
       <p:pic>
         <p:nvPicPr>
           <p:cNvPr id="2" name="Picture 1" descr="_bg.png"/>
@@ -4828,6 +4892,7 @@
           <a:lstStyle/>
           <a:p>
             <a:pPr algn="ctr"/>
+            <a:endParaRPr/>
           </a:p>
         </p:txBody>
       </p:sp>
@@ -4895,6 +4960,7 @@
           <a:lstStyle/>
           <a:p>
             <a:pPr algn="ctr"/>
+            <a:endParaRPr/>
           </a:p>
         </p:txBody>
       </p:sp>
@@ -4915,7 +4981,7 @@
           <a:noFill/>
         </p:spPr>
         <p:txBody>
-          <a:bodyPr wrap="square" lIns="0" rIns="0" tIns="0" bIns="0" anchor="t">
+          <a:bodyPr wrap="square" lIns="0" tIns="0" rIns="0" bIns="0" anchor="t">
             <a:spAutoFit/>
           </a:bodyPr>
           <a:lstStyle/>
@@ -4950,7 +5016,7 @@
           <a:noFill/>
         </p:spPr>
         <p:txBody>
-          <a:bodyPr wrap="square" lIns="0" rIns="0" tIns="0" bIns="0" anchor="t">
+          <a:bodyPr wrap="square" lIns="0" tIns="0" rIns="0" bIns="0" anchor="t">
             <a:spAutoFit/>
           </a:bodyPr>
           <a:lstStyle/>
@@ -4985,7 +5051,7 @@
           <a:noFill/>
         </p:spPr>
         <p:txBody>
-          <a:bodyPr wrap="square" lIns="0" rIns="0" tIns="0" bIns="0" anchor="t">
+          <a:bodyPr wrap="square" lIns="0" tIns="0" rIns="0" bIns="0" anchor="t">
             <a:spAutoFit/>
           </a:bodyPr>
           <a:lstStyle/>
@@ -5020,7 +5086,7 @@
           <a:noFill/>
         </p:spPr>
         <p:txBody>
-          <a:bodyPr wrap="square" lIns="0" rIns="0" tIns="0" bIns="0" anchor="t">
+          <a:bodyPr wrap="square" lIns="0" tIns="0" rIns="0" bIns="0" anchor="t">
             <a:spAutoFit/>
           </a:bodyPr>
           <a:lstStyle/>
@@ -5055,7 +5121,7 @@
           <a:noFill/>
         </p:spPr>
         <p:txBody>
-          <a:bodyPr wrap="square" lIns="0" rIns="0" tIns="0" bIns="0" anchor="t">
+          <a:bodyPr wrap="square" lIns="0" tIns="0" rIns="0" bIns="0" anchor="t">
             <a:spAutoFit/>
           </a:bodyPr>
           <a:lstStyle/>
@@ -5090,7 +5156,7 @@
           <a:noFill/>
         </p:spPr>
         <p:txBody>
-          <a:bodyPr wrap="square" lIns="0" rIns="0" tIns="0" bIns="0" anchor="t">
+          <a:bodyPr wrap="square" lIns="0" tIns="0" rIns="0" bIns="0" anchor="t">
             <a:spAutoFit/>
           </a:bodyPr>
           <a:lstStyle/>
@@ -5125,7 +5191,7 @@
           <a:noFill/>
         </p:spPr>
         <p:txBody>
-          <a:bodyPr wrap="square" lIns="0" rIns="0" tIns="0" bIns="0" anchor="t">
+          <a:bodyPr wrap="square" lIns="0" tIns="0" rIns="0" bIns="0" anchor="t">
             <a:spAutoFit/>
           </a:bodyPr>
           <a:lstStyle/>
@@ -5143,18 +5209,48 @@
           </a:p>
         </p:txBody>
       </p:sp>
+      <p:pic>
+        <p:nvPicPr>
+          <p:cNvPr id="14" name="Billede 13">
+            <a:extLst>
+              <a:ext uri="{FF2B5EF4-FFF2-40B4-BE49-F238E27FC236}">
+                <a16:creationId xmlns:a16="http://schemas.microsoft.com/office/drawing/2014/main" id="{9285E749-42C2-CA8D-CB95-180160F4CBDD}"/>
+              </a:ext>
+            </a:extLst>
+          </p:cNvPr>
+          <p:cNvPicPr>
+            <a:picLocks noChangeAspect="1"/>
+          </p:cNvPicPr>
+          <p:nvPr/>
+        </p:nvPicPr>
+        <p:blipFill>
+          <a:blip r:embed="rId5"/>
+          <a:stretch>
+            <a:fillRect/>
+          </a:stretch>
+        </p:blipFill>
+        <p:spPr>
+          <a:xfrm>
+            <a:off x="10439400" y="175260"/>
+            <a:ext cx="1572662" cy="1572662"/>
+          </a:xfrm>
+          <a:prstGeom prst="rect">
+            <a:avLst/>
+          </a:prstGeom>
+        </p:spPr>
+      </p:pic>
     </p:spTree>
   </p:cSld>
   <p:clrMapOvr>
     <a:masterClrMapping/>
   </p:clrMapOvr>
-  <mc:AlternateContent xmlns:mc="http://schemas.openxmlformats.org/markup-compatibility/2006">
-    <mc:Choice xmlns:p14="http://schemas.microsoft.com/office/powerpoint/2010/main" Requires="p14">
+  <mc:AlternateContent xmlns:mc="http://schemas.openxmlformats.org/markup-compatibility/2006" xmlns:p14="http://schemas.microsoft.com/office/powerpoint/2010/main">
+    <mc:Choice Requires="p14">
       <p:transition spd="med" p14:dur="700">
         <p:fade/>
       </p:transition>
     </mc:Choice>
-    <mc:Fallback>
+    <mc:Fallback xmlns="">
       <p:transition spd="med">
         <p:fade/>
       </p:transition>
@@ -5164,7 +5260,7 @@
 </file>
 
 <file path=ppt/slides/slide14.xml><?xml version="1.0" encoding="utf-8"?>
-<p:sld xmlns:a="http://schemas.openxmlformats.org/drawingml/2006/main" xmlns:p="http://schemas.openxmlformats.org/presentationml/2006/main" xmlns:r="http://schemas.openxmlformats.org/officeDocument/2006/relationships">
+<p:sld xmlns:a="http://schemas.openxmlformats.org/drawingml/2006/main" xmlns:r="http://schemas.openxmlformats.org/officeDocument/2006/relationships" xmlns:p="http://schemas.openxmlformats.org/presentationml/2006/main">
   <p:cSld>
     <p:spTree>
       <p:nvGrpSpPr>
@@ -5172,7 +5268,14 @@
         <p:cNvGrpSpPr/>
         <p:nvPr/>
       </p:nvGrpSpPr>
-      <p:grpSpPr/>
+      <p:grpSpPr>
+        <a:xfrm>
+          <a:off x="0" y="0"/>
+          <a:ext cx="0" cy="0"/>
+          <a:chOff x="0" y="0"/>
+          <a:chExt cx="0" cy="0"/>
+        </a:xfrm>
+      </p:grpSpPr>
       <p:pic>
         <p:nvPicPr>
           <p:cNvPr id="2" name="Picture 1" descr="_bg.png"/>
@@ -5263,6 +5366,7 @@
           <a:lstStyle/>
           <a:p>
             <a:pPr algn="ctr"/>
+            <a:endParaRPr/>
           </a:p>
         </p:txBody>
       </p:sp>
@@ -5330,6 +5434,7 @@
           <a:lstStyle/>
           <a:p>
             <a:pPr algn="ctr"/>
+            <a:endParaRPr/>
           </a:p>
         </p:txBody>
       </p:sp>
@@ -5350,7 +5455,7 @@
           <a:noFill/>
         </p:spPr>
         <p:txBody>
-          <a:bodyPr wrap="square" lIns="0" rIns="0" tIns="0" bIns="0" anchor="t">
+          <a:bodyPr wrap="square" lIns="0" tIns="0" rIns="0" bIns="0" anchor="t">
             <a:spAutoFit/>
           </a:bodyPr>
           <a:lstStyle/>
@@ -5385,7 +5490,7 @@
           <a:noFill/>
         </p:spPr>
         <p:txBody>
-          <a:bodyPr wrap="square" lIns="0" rIns="0" tIns="0" bIns="0" anchor="t">
+          <a:bodyPr wrap="square" lIns="0" tIns="0" rIns="0" bIns="0" anchor="t">
             <a:spAutoFit/>
           </a:bodyPr>
           <a:lstStyle/>
@@ -5420,7 +5525,7 @@
           <a:noFill/>
         </p:spPr>
         <p:txBody>
-          <a:bodyPr wrap="square" lIns="0" rIns="0" tIns="0" bIns="0" anchor="t">
+          <a:bodyPr wrap="square" lIns="0" tIns="0" rIns="0" bIns="0" anchor="t">
             <a:spAutoFit/>
           </a:bodyPr>
           <a:lstStyle/>
@@ -5455,7 +5560,7 @@
           <a:noFill/>
         </p:spPr>
         <p:txBody>
-          <a:bodyPr wrap="square" lIns="0" rIns="0" tIns="0" bIns="0" anchor="t">
+          <a:bodyPr wrap="square" lIns="0" tIns="0" rIns="0" bIns="0" anchor="t">
             <a:spAutoFit/>
           </a:bodyPr>
           <a:lstStyle/>
@@ -5490,7 +5595,7 @@
           <a:noFill/>
         </p:spPr>
         <p:txBody>
-          <a:bodyPr wrap="square" lIns="0" rIns="0" tIns="0" bIns="0" anchor="t">
+          <a:bodyPr wrap="square" lIns="0" tIns="0" rIns="0" bIns="0" anchor="t">
             <a:spAutoFit/>
           </a:bodyPr>
           <a:lstStyle/>
@@ -5525,7 +5630,7 @@
           <a:noFill/>
         </p:spPr>
         <p:txBody>
-          <a:bodyPr wrap="square" lIns="0" rIns="0" tIns="0" bIns="0" anchor="t">
+          <a:bodyPr wrap="square" lIns="0" tIns="0" rIns="0" bIns="0" anchor="t">
             <a:spAutoFit/>
           </a:bodyPr>
           <a:lstStyle/>
@@ -5560,7 +5665,7 @@
           <a:noFill/>
         </p:spPr>
         <p:txBody>
-          <a:bodyPr wrap="square" lIns="0" rIns="0" tIns="0" bIns="0" anchor="t">
+          <a:bodyPr wrap="square" lIns="0" tIns="0" rIns="0" bIns="0" anchor="t">
             <a:spAutoFit/>
           </a:bodyPr>
           <a:lstStyle/>
@@ -5578,18 +5683,48 @@
           </a:p>
         </p:txBody>
       </p:sp>
+      <p:pic>
+        <p:nvPicPr>
+          <p:cNvPr id="14" name="Billede 13">
+            <a:extLst>
+              <a:ext uri="{FF2B5EF4-FFF2-40B4-BE49-F238E27FC236}">
+                <a16:creationId xmlns:a16="http://schemas.microsoft.com/office/drawing/2014/main" id="{15625941-D218-408F-012C-652DC3076747}"/>
+              </a:ext>
+            </a:extLst>
+          </p:cNvPr>
+          <p:cNvPicPr>
+            <a:picLocks noChangeAspect="1"/>
+          </p:cNvPicPr>
+          <p:nvPr/>
+        </p:nvPicPr>
+        <p:blipFill>
+          <a:blip r:embed="rId5"/>
+          <a:stretch>
+            <a:fillRect/>
+          </a:stretch>
+        </p:blipFill>
+        <p:spPr>
+          <a:xfrm>
+            <a:off x="10439400" y="175260"/>
+            <a:ext cx="1572662" cy="1572662"/>
+          </a:xfrm>
+          <a:prstGeom prst="rect">
+            <a:avLst/>
+          </a:prstGeom>
+        </p:spPr>
+      </p:pic>
     </p:spTree>
   </p:cSld>
   <p:clrMapOvr>
     <a:masterClrMapping/>
   </p:clrMapOvr>
-  <mc:AlternateContent xmlns:mc="http://schemas.openxmlformats.org/markup-compatibility/2006">
-    <mc:Choice xmlns:p14="http://schemas.microsoft.com/office/powerpoint/2010/main" Requires="p14">
+  <mc:AlternateContent xmlns:mc="http://schemas.openxmlformats.org/markup-compatibility/2006" xmlns:p14="http://schemas.microsoft.com/office/powerpoint/2010/main">
+    <mc:Choice Requires="p14">
       <p:transition spd="med" p14:dur="700">
         <p:fade/>
       </p:transition>
     </mc:Choice>
-    <mc:Fallback>
+    <mc:Fallback xmlns="">
       <p:transition spd="med">
         <p:fade/>
       </p:transition>
@@ -5599,7 +5734,7 @@
 </file>
 
 <file path=ppt/slides/slide15.xml><?xml version="1.0" encoding="utf-8"?>
-<p:sld xmlns:a="http://schemas.openxmlformats.org/drawingml/2006/main" xmlns:p="http://schemas.openxmlformats.org/presentationml/2006/main" xmlns:r="http://schemas.openxmlformats.org/officeDocument/2006/relationships">
+<p:sld xmlns:a="http://schemas.openxmlformats.org/drawingml/2006/main" xmlns:r="http://schemas.openxmlformats.org/officeDocument/2006/relationships" xmlns:p="http://schemas.openxmlformats.org/presentationml/2006/main">
   <p:cSld>
     <p:spTree>
       <p:nvGrpSpPr>
@@ -5607,7 +5742,14 @@
         <p:cNvGrpSpPr/>
         <p:nvPr/>
       </p:nvGrpSpPr>
-      <p:grpSpPr/>
+      <p:grpSpPr>
+        <a:xfrm>
+          <a:off x="0" y="0"/>
+          <a:ext cx="0" cy="0"/>
+          <a:chOff x="0" y="0"/>
+          <a:chExt cx="0" cy="0"/>
+        </a:xfrm>
+      </p:grpSpPr>
       <p:pic>
         <p:nvPicPr>
           <p:cNvPr id="2" name="Picture 1" descr="_bg.png"/>
@@ -5698,6 +5840,7 @@
           <a:lstStyle/>
           <a:p>
             <a:pPr algn="ctr"/>
+            <a:endParaRPr/>
           </a:p>
         </p:txBody>
       </p:sp>
@@ -5765,6 +5908,7 @@
           <a:lstStyle/>
           <a:p>
             <a:pPr algn="ctr"/>
+            <a:endParaRPr/>
           </a:p>
         </p:txBody>
       </p:sp>
@@ -5785,7 +5929,7 @@
           <a:noFill/>
         </p:spPr>
         <p:txBody>
-          <a:bodyPr wrap="square" lIns="0" rIns="0" tIns="0" bIns="0" anchor="t">
+          <a:bodyPr wrap="square" lIns="0" tIns="0" rIns="0" bIns="0" anchor="t">
             <a:spAutoFit/>
           </a:bodyPr>
           <a:lstStyle/>
@@ -5820,7 +5964,7 @@
           <a:noFill/>
         </p:spPr>
         <p:txBody>
-          <a:bodyPr wrap="square" lIns="0" rIns="0" tIns="0" bIns="0" anchor="t">
+          <a:bodyPr wrap="square" lIns="0" tIns="0" rIns="0" bIns="0" anchor="t">
             <a:spAutoFit/>
           </a:bodyPr>
           <a:lstStyle/>
@@ -5855,7 +5999,7 @@
           <a:noFill/>
         </p:spPr>
         <p:txBody>
-          <a:bodyPr wrap="square" lIns="0" rIns="0" tIns="0" bIns="0" anchor="t">
+          <a:bodyPr wrap="square" lIns="0" tIns="0" rIns="0" bIns="0" anchor="t">
             <a:spAutoFit/>
           </a:bodyPr>
           <a:lstStyle/>
@@ -5890,7 +6034,7 @@
           <a:noFill/>
         </p:spPr>
         <p:txBody>
-          <a:bodyPr wrap="square" lIns="0" rIns="0" tIns="0" bIns="0" anchor="t">
+          <a:bodyPr wrap="square" lIns="0" tIns="0" rIns="0" bIns="0" anchor="t">
             <a:spAutoFit/>
           </a:bodyPr>
           <a:lstStyle/>
@@ -5925,7 +6069,7 @@
           <a:noFill/>
         </p:spPr>
         <p:txBody>
-          <a:bodyPr wrap="square" lIns="0" rIns="0" tIns="0" bIns="0" anchor="t">
+          <a:bodyPr wrap="square" lIns="0" tIns="0" rIns="0" bIns="0" anchor="t">
             <a:spAutoFit/>
           </a:bodyPr>
           <a:lstStyle/>
@@ -5960,7 +6104,7 @@
           <a:noFill/>
         </p:spPr>
         <p:txBody>
-          <a:bodyPr wrap="square" lIns="0" rIns="0" tIns="0" bIns="0" anchor="t">
+          <a:bodyPr wrap="square" lIns="0" tIns="0" rIns="0" bIns="0" anchor="t">
             <a:spAutoFit/>
           </a:bodyPr>
           <a:lstStyle/>
@@ -5995,7 +6139,7 @@
           <a:noFill/>
         </p:spPr>
         <p:txBody>
-          <a:bodyPr wrap="square" lIns="0" rIns="0" tIns="0" bIns="0" anchor="t">
+          <a:bodyPr wrap="square" lIns="0" tIns="0" rIns="0" bIns="0" anchor="t">
             <a:spAutoFit/>
           </a:bodyPr>
           <a:lstStyle/>
@@ -6013,18 +6157,48 @@
           </a:p>
         </p:txBody>
       </p:sp>
+      <p:pic>
+        <p:nvPicPr>
+          <p:cNvPr id="14" name="Billede 13">
+            <a:extLst>
+              <a:ext uri="{FF2B5EF4-FFF2-40B4-BE49-F238E27FC236}">
+                <a16:creationId xmlns:a16="http://schemas.microsoft.com/office/drawing/2014/main" id="{9A602209-4DFC-271A-643E-46EFBB5DDC12}"/>
+              </a:ext>
+            </a:extLst>
+          </p:cNvPr>
+          <p:cNvPicPr>
+            <a:picLocks noChangeAspect="1"/>
+          </p:cNvPicPr>
+          <p:nvPr/>
+        </p:nvPicPr>
+        <p:blipFill>
+          <a:blip r:embed="rId5"/>
+          <a:stretch>
+            <a:fillRect/>
+          </a:stretch>
+        </p:blipFill>
+        <p:spPr>
+          <a:xfrm>
+            <a:off x="10439400" y="175260"/>
+            <a:ext cx="1572662" cy="1572662"/>
+          </a:xfrm>
+          <a:prstGeom prst="rect">
+            <a:avLst/>
+          </a:prstGeom>
+        </p:spPr>
+      </p:pic>
     </p:spTree>
   </p:cSld>
   <p:clrMapOvr>
     <a:masterClrMapping/>
   </p:clrMapOvr>
-  <mc:AlternateContent xmlns:mc="http://schemas.openxmlformats.org/markup-compatibility/2006">
-    <mc:Choice xmlns:p14="http://schemas.microsoft.com/office/powerpoint/2010/main" Requires="p14">
+  <mc:AlternateContent xmlns:mc="http://schemas.openxmlformats.org/markup-compatibility/2006" xmlns:p14="http://schemas.microsoft.com/office/powerpoint/2010/main">
+    <mc:Choice Requires="p14">
       <p:transition spd="med" p14:dur="700">
         <p:fade/>
       </p:transition>
     </mc:Choice>
-    <mc:Fallback>
+    <mc:Fallback xmlns="">
       <p:transition spd="med">
         <p:fade/>
       </p:transition>
@@ -6034,7 +6208,7 @@
 </file>
 
 <file path=ppt/slides/slide16.xml><?xml version="1.0" encoding="utf-8"?>
-<p:sld xmlns:a="http://schemas.openxmlformats.org/drawingml/2006/main" xmlns:p="http://schemas.openxmlformats.org/presentationml/2006/main" xmlns:r="http://schemas.openxmlformats.org/officeDocument/2006/relationships">
+<p:sld xmlns:a="http://schemas.openxmlformats.org/drawingml/2006/main" xmlns:r="http://schemas.openxmlformats.org/officeDocument/2006/relationships" xmlns:p="http://schemas.openxmlformats.org/presentationml/2006/main">
   <p:cSld>
     <p:spTree>
       <p:nvGrpSpPr>
@@ -6042,7 +6216,14 @@
         <p:cNvGrpSpPr/>
         <p:nvPr/>
       </p:nvGrpSpPr>
-      <p:grpSpPr/>
+      <p:grpSpPr>
+        <a:xfrm>
+          <a:off x="0" y="0"/>
+          <a:ext cx="0" cy="0"/>
+          <a:chOff x="0" y="0"/>
+          <a:chExt cx="0" cy="0"/>
+        </a:xfrm>
+      </p:grpSpPr>
       <p:pic>
         <p:nvPicPr>
           <p:cNvPr id="2" name="Picture 1" descr="_bg.png"/>
@@ -6133,6 +6314,7 @@
           <a:lstStyle/>
           <a:p>
             <a:pPr algn="ctr"/>
+            <a:endParaRPr/>
           </a:p>
         </p:txBody>
       </p:sp>
@@ -6200,6 +6382,7 @@
           <a:lstStyle/>
           <a:p>
             <a:pPr algn="ctr"/>
+            <a:endParaRPr/>
           </a:p>
         </p:txBody>
       </p:sp>
@@ -6220,7 +6403,7 @@
           <a:noFill/>
         </p:spPr>
         <p:txBody>
-          <a:bodyPr wrap="square" lIns="0" rIns="0" tIns="0" bIns="0" anchor="t">
+          <a:bodyPr wrap="square" lIns="0" tIns="0" rIns="0" bIns="0" anchor="t">
             <a:spAutoFit/>
           </a:bodyPr>
           <a:lstStyle/>
@@ -6255,7 +6438,7 @@
           <a:noFill/>
         </p:spPr>
         <p:txBody>
-          <a:bodyPr wrap="square" lIns="0" rIns="0" tIns="0" bIns="0" anchor="t">
+          <a:bodyPr wrap="square" lIns="0" tIns="0" rIns="0" bIns="0" anchor="t">
             <a:spAutoFit/>
           </a:bodyPr>
           <a:lstStyle/>
@@ -6290,7 +6473,7 @@
           <a:noFill/>
         </p:spPr>
         <p:txBody>
-          <a:bodyPr wrap="square" lIns="0" rIns="0" tIns="0" bIns="0" anchor="t">
+          <a:bodyPr wrap="square" lIns="0" tIns="0" rIns="0" bIns="0" anchor="t">
             <a:spAutoFit/>
           </a:bodyPr>
           <a:lstStyle/>
@@ -6325,7 +6508,7 @@
           <a:noFill/>
         </p:spPr>
         <p:txBody>
-          <a:bodyPr wrap="square" lIns="0" rIns="0" tIns="0" bIns="0" anchor="t">
+          <a:bodyPr wrap="square" lIns="0" tIns="0" rIns="0" bIns="0" anchor="t">
             <a:spAutoFit/>
           </a:bodyPr>
           <a:lstStyle/>
@@ -6360,7 +6543,7 @@
           <a:noFill/>
         </p:spPr>
         <p:txBody>
-          <a:bodyPr wrap="square" lIns="0" rIns="0" tIns="0" bIns="0" anchor="t">
+          <a:bodyPr wrap="square" lIns="0" tIns="0" rIns="0" bIns="0" anchor="t">
             <a:spAutoFit/>
           </a:bodyPr>
           <a:lstStyle/>
@@ -6395,7 +6578,7 @@
           <a:noFill/>
         </p:spPr>
         <p:txBody>
-          <a:bodyPr wrap="square" lIns="0" rIns="0" tIns="0" bIns="0" anchor="t">
+          <a:bodyPr wrap="square" lIns="0" tIns="0" rIns="0" bIns="0" anchor="t">
             <a:spAutoFit/>
           </a:bodyPr>
           <a:lstStyle/>
@@ -6430,7 +6613,7 @@
           <a:noFill/>
         </p:spPr>
         <p:txBody>
-          <a:bodyPr wrap="square" lIns="0" rIns="0" tIns="0" bIns="0" anchor="t">
+          <a:bodyPr wrap="square" lIns="0" tIns="0" rIns="0" bIns="0" anchor="t">
             <a:spAutoFit/>
           </a:bodyPr>
           <a:lstStyle/>
@@ -6448,18 +6631,48 @@
           </a:p>
         </p:txBody>
       </p:sp>
+      <p:pic>
+        <p:nvPicPr>
+          <p:cNvPr id="14" name="Billede 13">
+            <a:extLst>
+              <a:ext uri="{FF2B5EF4-FFF2-40B4-BE49-F238E27FC236}">
+                <a16:creationId xmlns:a16="http://schemas.microsoft.com/office/drawing/2014/main" id="{3A98E93D-2C3B-183D-B799-393EBA7922F3}"/>
+              </a:ext>
+            </a:extLst>
+          </p:cNvPr>
+          <p:cNvPicPr>
+            <a:picLocks noChangeAspect="1"/>
+          </p:cNvPicPr>
+          <p:nvPr/>
+        </p:nvPicPr>
+        <p:blipFill>
+          <a:blip r:embed="rId5"/>
+          <a:stretch>
+            <a:fillRect/>
+          </a:stretch>
+        </p:blipFill>
+        <p:spPr>
+          <a:xfrm>
+            <a:off x="10439400" y="175260"/>
+            <a:ext cx="1572662" cy="1572662"/>
+          </a:xfrm>
+          <a:prstGeom prst="rect">
+            <a:avLst/>
+          </a:prstGeom>
+        </p:spPr>
+      </p:pic>
     </p:spTree>
   </p:cSld>
   <p:clrMapOvr>
     <a:masterClrMapping/>
   </p:clrMapOvr>
-  <mc:AlternateContent xmlns:mc="http://schemas.openxmlformats.org/markup-compatibility/2006">
-    <mc:Choice xmlns:p14="http://schemas.microsoft.com/office/powerpoint/2010/main" Requires="p14">
+  <mc:AlternateContent xmlns:mc="http://schemas.openxmlformats.org/markup-compatibility/2006" xmlns:p14="http://schemas.microsoft.com/office/powerpoint/2010/main">
+    <mc:Choice Requires="p14">
       <p:transition spd="med" p14:dur="700">
         <p:fade/>
       </p:transition>
     </mc:Choice>
-    <mc:Fallback>
+    <mc:Fallback xmlns="">
       <p:transition spd="med">
         <p:fade/>
       </p:transition>
@@ -6469,7 +6682,7 @@
 </file>
 
 <file path=ppt/slides/slide2.xml><?xml version="1.0" encoding="utf-8"?>
-<p:sld xmlns:a="http://schemas.openxmlformats.org/drawingml/2006/main" xmlns:p="http://schemas.openxmlformats.org/presentationml/2006/main" xmlns:r="http://schemas.openxmlformats.org/officeDocument/2006/relationships">
+<p:sld xmlns:a="http://schemas.openxmlformats.org/drawingml/2006/main" xmlns:r="http://schemas.openxmlformats.org/officeDocument/2006/relationships" xmlns:p="http://schemas.openxmlformats.org/presentationml/2006/main">
   <p:cSld>
     <p:spTree>
       <p:nvGrpSpPr>
@@ -6477,7 +6690,14 @@
         <p:cNvGrpSpPr/>
         <p:nvPr/>
       </p:nvGrpSpPr>
-      <p:grpSpPr/>
+      <p:grpSpPr>
+        <a:xfrm>
+          <a:off x="0" y="0"/>
+          <a:ext cx="0" cy="0"/>
+          <a:chOff x="0" y="0"/>
+          <a:chExt cx="0" cy="0"/>
+        </a:xfrm>
+      </p:grpSpPr>
       <p:pic>
         <p:nvPicPr>
           <p:cNvPr id="2" name="Picture 1" descr="_bg.png"/>
@@ -6566,6 +6786,7 @@
           <a:lstStyle/>
           <a:p>
             <a:pPr algn="ctr"/>
+            <a:endParaRPr/>
           </a:p>
         </p:txBody>
       </p:sp>
@@ -6586,7 +6807,7 @@
           <a:noFill/>
         </p:spPr>
         <p:txBody>
-          <a:bodyPr wrap="square" lIns="0" rIns="0" tIns="0" bIns="0" anchor="t">
+          <a:bodyPr wrap="square" lIns="0" tIns="0" rIns="0" bIns="0" anchor="t">
             <a:spAutoFit/>
           </a:bodyPr>
           <a:lstStyle/>
@@ -6621,7 +6842,7 @@
           <a:noFill/>
         </p:spPr>
         <p:txBody>
-          <a:bodyPr wrap="square" lIns="0" rIns="0" tIns="0" bIns="0" anchor="t">
+          <a:bodyPr wrap="square" lIns="0" tIns="0" rIns="0" bIns="0" anchor="t">
             <a:spAutoFit/>
           </a:bodyPr>
           <a:lstStyle/>
@@ -6681,6 +6902,7 @@
           <a:lstStyle/>
           <a:p>
             <a:pPr algn="ctr"/>
+            <a:endParaRPr/>
           </a:p>
         </p:txBody>
       </p:sp>
@@ -6725,7 +6947,7 @@
           <a:noFill/>
         </p:spPr>
         <p:txBody>
-          <a:bodyPr wrap="square" lIns="0" rIns="0" tIns="0" bIns="0" anchor="t">
+          <a:bodyPr wrap="square" lIns="0" tIns="0" rIns="0" bIns="0" anchor="t">
             <a:spAutoFit/>
           </a:bodyPr>
           <a:lstStyle/>
@@ -6760,7 +6982,7 @@
           <a:noFill/>
         </p:spPr>
         <p:txBody>
-          <a:bodyPr wrap="square" lIns="0" rIns="0" tIns="0" bIns="0" anchor="t">
+          <a:bodyPr wrap="square" lIns="0" tIns="0" rIns="0" bIns="0" anchor="t">
             <a:spAutoFit/>
           </a:bodyPr>
           <a:lstStyle/>
@@ -6822,6 +7044,7 @@
           <a:lstStyle/>
           <a:p>
             <a:pPr algn="ctr"/>
+            <a:endParaRPr/>
           </a:p>
         </p:txBody>
       </p:sp>
@@ -6842,7 +7065,7 @@
           <a:noFill/>
         </p:spPr>
         <p:txBody>
-          <a:bodyPr wrap="square" lIns="0" rIns="0" tIns="0" bIns="0" anchor="ctr">
+          <a:bodyPr wrap="square" lIns="0" tIns="0" rIns="0" bIns="0" anchor="ctr">
             <a:spAutoFit/>
           </a:bodyPr>
           <a:lstStyle/>
@@ -6877,7 +7100,7 @@
           <a:noFill/>
         </p:spPr>
         <p:txBody>
-          <a:bodyPr wrap="square" lIns="0" rIns="0" tIns="0" bIns="0" anchor="ctr">
+          <a:bodyPr wrap="square" lIns="0" tIns="0" rIns="0" bIns="0" anchor="ctr">
             <a:spAutoFit/>
           </a:bodyPr>
           <a:lstStyle/>
@@ -6912,7 +7135,7 @@
           <a:noFill/>
         </p:spPr>
         <p:txBody>
-          <a:bodyPr wrap="square" lIns="0" rIns="0" tIns="0" bIns="0" anchor="ctr">
+          <a:bodyPr wrap="square" lIns="0" tIns="0" rIns="0" bIns="0" anchor="ctr">
             <a:spAutoFit/>
           </a:bodyPr>
           <a:lstStyle/>
@@ -6947,7 +7170,7 @@
           <a:noFill/>
         </p:spPr>
         <p:txBody>
-          <a:bodyPr wrap="square" lIns="0" rIns="0" tIns="0" bIns="0" anchor="ctr">
+          <a:bodyPr wrap="square" lIns="0" tIns="0" rIns="0" bIns="0" anchor="ctr">
             <a:spAutoFit/>
           </a:bodyPr>
           <a:lstStyle/>
@@ -6982,7 +7205,7 @@
           <a:noFill/>
         </p:spPr>
         <p:txBody>
-          <a:bodyPr wrap="square" lIns="0" rIns="0" tIns="0" bIns="0" anchor="ctr">
+          <a:bodyPr wrap="square" lIns="0" tIns="0" rIns="0" bIns="0" anchor="ctr">
             <a:spAutoFit/>
           </a:bodyPr>
           <a:lstStyle/>
@@ -7017,7 +7240,7 @@
           <a:noFill/>
         </p:spPr>
         <p:txBody>
-          <a:bodyPr wrap="square" lIns="0" rIns="0" tIns="25400" bIns="25400" anchor="ctr">
+          <a:bodyPr wrap="square" lIns="0" tIns="25400" rIns="0" bIns="25400" anchor="ctr">
             <a:spAutoFit/>
           </a:bodyPr>
           <a:lstStyle/>
@@ -7064,7 +7287,7 @@
           <a:noFill/>
         </p:spPr>
         <p:txBody>
-          <a:bodyPr wrap="square" lIns="0" rIns="0" tIns="25400" bIns="25400" anchor="ctr">
+          <a:bodyPr wrap="square" lIns="0" tIns="25400" rIns="0" bIns="25400" anchor="ctr">
             <a:spAutoFit/>
           </a:bodyPr>
           <a:lstStyle/>
@@ -7111,7 +7334,7 @@
           <a:noFill/>
         </p:spPr>
         <p:txBody>
-          <a:bodyPr wrap="square" lIns="0" rIns="0" tIns="0" bIns="0" anchor="ctr">
+          <a:bodyPr wrap="square" lIns="0" tIns="0" rIns="0" bIns="0" anchor="ctr">
             <a:spAutoFit/>
           </a:bodyPr>
           <a:lstStyle/>
@@ -7146,7 +7369,7 @@
           <a:noFill/>
         </p:spPr>
         <p:txBody>
-          <a:bodyPr wrap="square" lIns="0" rIns="0" tIns="25400" bIns="25400" anchor="ctr">
+          <a:bodyPr wrap="square" lIns="0" tIns="25400" rIns="0" bIns="25400" anchor="ctr">
             <a:spAutoFit/>
           </a:bodyPr>
           <a:lstStyle/>
@@ -7193,7 +7416,7 @@
           <a:noFill/>
         </p:spPr>
         <p:txBody>
-          <a:bodyPr wrap="square" lIns="0" rIns="0" tIns="25400" bIns="25400" anchor="ctr">
+          <a:bodyPr wrap="square" lIns="0" tIns="25400" rIns="0" bIns="25400" anchor="ctr">
             <a:spAutoFit/>
           </a:bodyPr>
           <a:lstStyle/>
@@ -7240,7 +7463,7 @@
           <a:noFill/>
         </p:spPr>
         <p:txBody>
-          <a:bodyPr wrap="square" lIns="0" rIns="0" tIns="0" bIns="0" anchor="ctr">
+          <a:bodyPr wrap="square" lIns="0" tIns="0" rIns="0" bIns="0" anchor="ctr">
             <a:spAutoFit/>
           </a:bodyPr>
           <a:lstStyle/>
@@ -7275,7 +7498,7 @@
           <a:noFill/>
         </p:spPr>
         <p:txBody>
-          <a:bodyPr wrap="square" lIns="0" rIns="0" tIns="0" bIns="0" anchor="ctr">
+          <a:bodyPr wrap="square" lIns="0" tIns="0" rIns="0" bIns="0" anchor="ctr">
             <a:spAutoFit/>
           </a:bodyPr>
           <a:lstStyle/>
@@ -7310,7 +7533,7 @@
           <a:noFill/>
         </p:spPr>
         <p:txBody>
-          <a:bodyPr wrap="square" lIns="0" rIns="0" tIns="0" bIns="0" anchor="ctr">
+          <a:bodyPr wrap="square" lIns="0" tIns="0" rIns="0" bIns="0" anchor="ctr">
             <a:spAutoFit/>
           </a:bodyPr>
           <a:lstStyle/>
@@ -7345,7 +7568,7 @@
           <a:noFill/>
         </p:spPr>
         <p:txBody>
-          <a:bodyPr wrap="square" lIns="0" rIns="0" tIns="25400" bIns="25400" anchor="ctr">
+          <a:bodyPr wrap="square" lIns="0" tIns="25400" rIns="0" bIns="25400" anchor="ctr">
             <a:spAutoFit/>
           </a:bodyPr>
           <a:lstStyle/>
@@ -7392,7 +7615,7 @@
           <a:noFill/>
         </p:spPr>
         <p:txBody>
-          <a:bodyPr wrap="square" lIns="0" rIns="0" tIns="25400" bIns="25400" anchor="ctr">
+          <a:bodyPr wrap="square" lIns="0" tIns="25400" rIns="0" bIns="25400" anchor="ctr">
             <a:spAutoFit/>
           </a:bodyPr>
           <a:lstStyle/>
@@ -7439,7 +7662,7 @@
           <a:noFill/>
         </p:spPr>
         <p:txBody>
-          <a:bodyPr wrap="square" lIns="0" rIns="0" tIns="0" bIns="0" anchor="ctr">
+          <a:bodyPr wrap="square" lIns="0" tIns="0" rIns="0" bIns="0" anchor="ctr">
             <a:spAutoFit/>
           </a:bodyPr>
           <a:lstStyle/>
@@ -7474,7 +7697,7 @@
           <a:noFill/>
         </p:spPr>
         <p:txBody>
-          <a:bodyPr wrap="square" lIns="0" rIns="0" tIns="25400" bIns="25400" anchor="ctr">
+          <a:bodyPr wrap="square" lIns="0" tIns="25400" rIns="0" bIns="25400" anchor="ctr">
             <a:spAutoFit/>
           </a:bodyPr>
           <a:lstStyle/>
@@ -7521,7 +7744,7 @@
           <a:noFill/>
         </p:spPr>
         <p:txBody>
-          <a:bodyPr wrap="square" lIns="0" rIns="0" tIns="25400" bIns="25400" anchor="ctr">
+          <a:bodyPr wrap="square" lIns="0" tIns="25400" rIns="0" bIns="25400" anchor="ctr">
             <a:spAutoFit/>
           </a:bodyPr>
           <a:lstStyle/>
@@ -7568,7 +7791,7 @@
           <a:noFill/>
         </p:spPr>
         <p:txBody>
-          <a:bodyPr wrap="square" lIns="0" rIns="0" tIns="0" bIns="0" anchor="ctr">
+          <a:bodyPr wrap="square" lIns="0" tIns="0" rIns="0" bIns="0" anchor="ctr">
             <a:spAutoFit/>
           </a:bodyPr>
           <a:lstStyle/>
@@ -7603,7 +7826,7 @@
           <a:noFill/>
         </p:spPr>
         <p:txBody>
-          <a:bodyPr wrap="square" lIns="0" rIns="0" tIns="25400" bIns="25400" anchor="ctr">
+          <a:bodyPr wrap="square" lIns="0" tIns="25400" rIns="0" bIns="25400" anchor="ctr">
             <a:spAutoFit/>
           </a:bodyPr>
           <a:lstStyle/>
@@ -7650,7 +7873,7 @@
           <a:noFill/>
         </p:spPr>
         <p:txBody>
-          <a:bodyPr wrap="square" lIns="0" rIns="0" tIns="25400" bIns="25400" anchor="ctr">
+          <a:bodyPr wrap="square" lIns="0" tIns="25400" rIns="0" bIns="25400" anchor="ctr">
             <a:spAutoFit/>
           </a:bodyPr>
           <a:lstStyle/>
@@ -7697,7 +7920,7 @@
           <a:noFill/>
         </p:spPr>
         <p:txBody>
-          <a:bodyPr wrap="square" lIns="0" rIns="0" tIns="0" bIns="0" anchor="ctr">
+          <a:bodyPr wrap="square" lIns="0" tIns="0" rIns="0" bIns="0" anchor="ctr">
             <a:spAutoFit/>
           </a:bodyPr>
           <a:lstStyle/>
@@ -7732,7 +7955,7 @@
           <a:noFill/>
         </p:spPr>
         <p:txBody>
-          <a:bodyPr wrap="square" lIns="0" rIns="0" tIns="0" bIns="0" anchor="ctr">
+          <a:bodyPr wrap="square" lIns="0" tIns="0" rIns="0" bIns="0" anchor="ctr">
             <a:spAutoFit/>
           </a:bodyPr>
           <a:lstStyle/>
@@ -7767,7 +7990,7 @@
           <a:noFill/>
         </p:spPr>
         <p:txBody>
-          <a:bodyPr wrap="square" lIns="0" rIns="0" tIns="0" bIns="0" anchor="ctr">
+          <a:bodyPr wrap="square" lIns="0" tIns="0" rIns="0" bIns="0" anchor="ctr">
             <a:spAutoFit/>
           </a:bodyPr>
           <a:lstStyle/>
@@ -7802,7 +8025,7 @@
           <a:noFill/>
         </p:spPr>
         <p:txBody>
-          <a:bodyPr wrap="square" lIns="0" rIns="0" tIns="0" bIns="0" anchor="ctr">
+          <a:bodyPr wrap="square" lIns="0" tIns="0" rIns="0" bIns="0" anchor="ctr">
             <a:spAutoFit/>
           </a:bodyPr>
           <a:lstStyle/>
@@ -7837,7 +8060,7 @@
           <a:noFill/>
         </p:spPr>
         <p:txBody>
-          <a:bodyPr wrap="square" lIns="0" rIns="0" tIns="0" bIns="0" anchor="t">
+          <a:bodyPr wrap="square" lIns="0" tIns="0" rIns="0" bIns="0" anchor="t">
             <a:spAutoFit/>
           </a:bodyPr>
           <a:lstStyle/>
@@ -7872,7 +8095,7 @@
           <a:noFill/>
         </p:spPr>
         <p:txBody>
-          <a:bodyPr wrap="square" lIns="0" rIns="0" tIns="0" bIns="0" anchor="t">
+          <a:bodyPr wrap="square" lIns="0" tIns="0" rIns="0" bIns="0" anchor="t">
             <a:spAutoFit/>
           </a:bodyPr>
           <a:lstStyle/>
@@ -7895,13 +8118,13 @@
   <p:clrMapOvr>
     <a:masterClrMapping/>
   </p:clrMapOvr>
-  <mc:AlternateContent xmlns:mc="http://schemas.openxmlformats.org/markup-compatibility/2006">
-    <mc:Choice xmlns:p14="http://schemas.microsoft.com/office/powerpoint/2010/main" Requires="p14">
+  <mc:AlternateContent xmlns:mc="http://schemas.openxmlformats.org/markup-compatibility/2006" xmlns:p14="http://schemas.microsoft.com/office/powerpoint/2010/main">
+    <mc:Choice Requires="p14">
       <p:transition spd="med" p14:dur="700">
         <p:fade/>
       </p:transition>
     </mc:Choice>
-    <mc:Fallback>
+    <mc:Fallback xmlns="">
       <p:transition spd="med">
         <p:fade/>
       </p:transition>
@@ -7911,7 +8134,7 @@
 </file>
 
 <file path=ppt/slides/slide3.xml><?xml version="1.0" encoding="utf-8"?>
-<p:sld xmlns:a="http://schemas.openxmlformats.org/drawingml/2006/main" xmlns:p="http://schemas.openxmlformats.org/presentationml/2006/main" xmlns:r="http://schemas.openxmlformats.org/officeDocument/2006/relationships">
+<p:sld xmlns:a="http://schemas.openxmlformats.org/drawingml/2006/main" xmlns:r="http://schemas.openxmlformats.org/officeDocument/2006/relationships" xmlns:p="http://schemas.openxmlformats.org/presentationml/2006/main" show="0">
   <p:cSld>
     <p:spTree>
       <p:nvGrpSpPr>
@@ -7919,7 +8142,14 @@
         <p:cNvGrpSpPr/>
         <p:nvPr/>
       </p:nvGrpSpPr>
-      <p:grpSpPr/>
+      <p:grpSpPr>
+        <a:xfrm>
+          <a:off x="0" y="0"/>
+          <a:ext cx="0" cy="0"/>
+          <a:chOff x="0" y="0"/>
+          <a:chExt cx="0" cy="0"/>
+        </a:xfrm>
+      </p:grpSpPr>
       <p:pic>
         <p:nvPicPr>
           <p:cNvPr id="2" name="Picture 1" descr="_bg_elev.png"/>
@@ -7984,6 +8214,7 @@
           <a:lstStyle/>
           <a:p>
             <a:pPr algn="ctr"/>
+            <a:endParaRPr/>
           </a:p>
         </p:txBody>
       </p:sp>
@@ -8004,7 +8235,7 @@
           <a:noFill/>
         </p:spPr>
         <p:txBody>
-          <a:bodyPr wrap="square" lIns="0" rIns="0" tIns="0" bIns="0" anchor="t">
+          <a:bodyPr wrap="square" lIns="0" tIns="0" rIns="0" bIns="0" anchor="t">
             <a:spAutoFit/>
           </a:bodyPr>
           <a:lstStyle/>
@@ -8039,7 +8270,7 @@
           <a:noFill/>
         </p:spPr>
         <p:txBody>
-          <a:bodyPr wrap="square" lIns="0" rIns="0" tIns="0" bIns="0" anchor="t">
+          <a:bodyPr wrap="square" lIns="0" tIns="0" rIns="0" bIns="0" anchor="t">
             <a:spAutoFit/>
           </a:bodyPr>
           <a:lstStyle/>
@@ -8074,7 +8305,7 @@
           <a:noFill/>
         </p:spPr>
         <p:txBody>
-          <a:bodyPr wrap="square" lIns="0" rIns="0" tIns="0" bIns="0" anchor="t">
+          <a:bodyPr wrap="square" lIns="0" tIns="0" rIns="0" bIns="0" anchor="t">
             <a:spAutoFit/>
           </a:bodyPr>
           <a:lstStyle/>
@@ -8109,7 +8340,7 @@
           <a:noFill/>
         </p:spPr>
         <p:txBody>
-          <a:bodyPr wrap="square" lIns="0" rIns="0" tIns="0" bIns="0" anchor="t">
+          <a:bodyPr wrap="square" lIns="0" tIns="0" rIns="0" bIns="0" anchor="t">
             <a:spAutoFit/>
           </a:bodyPr>
           <a:lstStyle/>
@@ -8132,13 +8363,13 @@
   <p:clrMapOvr>
     <a:masterClrMapping/>
   </p:clrMapOvr>
-  <mc:AlternateContent xmlns:mc="http://schemas.openxmlformats.org/markup-compatibility/2006">
-    <mc:Choice xmlns:p14="http://schemas.microsoft.com/office/powerpoint/2010/main" Requires="p14">
+  <mc:AlternateContent xmlns:mc="http://schemas.openxmlformats.org/markup-compatibility/2006" xmlns:p14="http://schemas.microsoft.com/office/powerpoint/2010/main">
+    <mc:Choice Requires="p14">
       <p:transition spd="med" p14:dur="700">
         <p:fade/>
       </p:transition>
     </mc:Choice>
-    <mc:Fallback>
+    <mc:Fallback xmlns="">
       <p:transition spd="med">
         <p:fade/>
       </p:transition>
@@ -8148,7 +8379,7 @@
 </file>
 
 <file path=ppt/slides/slide4.xml><?xml version="1.0" encoding="utf-8"?>
-<p:sld xmlns:a="http://schemas.openxmlformats.org/drawingml/2006/main" xmlns:p="http://schemas.openxmlformats.org/presentationml/2006/main" xmlns:r="http://schemas.openxmlformats.org/officeDocument/2006/relationships">
+<p:sld xmlns:a="http://schemas.openxmlformats.org/drawingml/2006/main" xmlns:r="http://schemas.openxmlformats.org/officeDocument/2006/relationships" xmlns:p="http://schemas.openxmlformats.org/presentationml/2006/main" show="0">
   <p:cSld>
     <p:spTree>
       <p:nvGrpSpPr>
@@ -8156,7 +8387,14 @@
         <p:cNvGrpSpPr/>
         <p:nvPr/>
       </p:nvGrpSpPr>
-      <p:grpSpPr/>
+      <p:grpSpPr>
+        <a:xfrm>
+          <a:off x="0" y="0"/>
+          <a:ext cx="0" cy="0"/>
+          <a:chOff x="0" y="0"/>
+          <a:chExt cx="0" cy="0"/>
+        </a:xfrm>
+      </p:grpSpPr>
       <p:pic>
         <p:nvPicPr>
           <p:cNvPr id="2" name="Picture 1" descr="_bg.png"/>
@@ -8245,6 +8483,7 @@
           <a:lstStyle/>
           <a:p>
             <a:pPr algn="ctr"/>
+            <a:endParaRPr/>
           </a:p>
         </p:txBody>
       </p:sp>
@@ -8265,7 +8504,7 @@
           <a:noFill/>
         </p:spPr>
         <p:txBody>
-          <a:bodyPr wrap="square" lIns="0" rIns="0" tIns="0" bIns="0" anchor="t">
+          <a:bodyPr wrap="square" lIns="0" tIns="0" rIns="0" bIns="0" anchor="t">
             <a:spAutoFit/>
           </a:bodyPr>
           <a:lstStyle/>
@@ -8423,7 +8662,7 @@
           <a:noFill/>
         </p:spPr>
         <p:txBody>
-          <a:bodyPr wrap="square" lIns="0" rIns="0" tIns="0" bIns="0" anchor="t">
+          <a:bodyPr wrap="square" lIns="0" tIns="0" rIns="0" bIns="0" anchor="t">
             <a:spAutoFit/>
           </a:bodyPr>
           <a:lstStyle/>
@@ -8458,7 +8697,7 @@
           <a:noFill/>
         </p:spPr>
         <p:txBody>
-          <a:bodyPr wrap="square" lIns="0" rIns="0" tIns="0" bIns="0" anchor="t">
+          <a:bodyPr wrap="square" lIns="0" tIns="0" rIns="0" bIns="0" anchor="t">
             <a:spAutoFit/>
           </a:bodyPr>
           <a:lstStyle/>
@@ -8481,13 +8720,13 @@
   <p:clrMapOvr>
     <a:masterClrMapping/>
   </p:clrMapOvr>
-  <mc:AlternateContent xmlns:mc="http://schemas.openxmlformats.org/markup-compatibility/2006">
-    <mc:Choice xmlns:p14="http://schemas.microsoft.com/office/powerpoint/2010/main" Requires="p14">
+  <mc:AlternateContent xmlns:mc="http://schemas.openxmlformats.org/markup-compatibility/2006" xmlns:p14="http://schemas.microsoft.com/office/powerpoint/2010/main">
+    <mc:Choice Requires="p14">
       <p:transition spd="med" p14:dur="700">
         <p:fade/>
       </p:transition>
     </mc:Choice>
-    <mc:Fallback>
+    <mc:Fallback xmlns="">
       <p:transition spd="med">
         <p:fade/>
       </p:transition>
@@ -8497,7 +8736,7 @@
 </file>
 
 <file path=ppt/slides/slide5.xml><?xml version="1.0" encoding="utf-8"?>
-<p:sld xmlns:a="http://schemas.openxmlformats.org/drawingml/2006/main" xmlns:p="http://schemas.openxmlformats.org/presentationml/2006/main" xmlns:r="http://schemas.openxmlformats.org/officeDocument/2006/relationships">
+<p:sld xmlns:a="http://schemas.openxmlformats.org/drawingml/2006/main" xmlns:r="http://schemas.openxmlformats.org/officeDocument/2006/relationships" xmlns:p="http://schemas.openxmlformats.org/presentationml/2006/main" show="0">
   <p:cSld>
     <p:spTree>
       <p:nvGrpSpPr>
@@ -8505,7 +8744,14 @@
         <p:cNvGrpSpPr/>
         <p:nvPr/>
       </p:nvGrpSpPr>
-      <p:grpSpPr/>
+      <p:grpSpPr>
+        <a:xfrm>
+          <a:off x="0" y="0"/>
+          <a:ext cx="0" cy="0"/>
+          <a:chOff x="0" y="0"/>
+          <a:chExt cx="0" cy="0"/>
+        </a:xfrm>
+      </p:grpSpPr>
       <p:pic>
         <p:nvPicPr>
           <p:cNvPr id="2" name="Picture 1" descr="_bg.png"/>
@@ -8596,6 +8842,7 @@
           <a:lstStyle/>
           <a:p>
             <a:pPr algn="ctr"/>
+            <a:endParaRPr/>
           </a:p>
         </p:txBody>
       </p:sp>
@@ -8616,7 +8863,7 @@
           <a:noFill/>
         </p:spPr>
         <p:txBody>
-          <a:bodyPr wrap="square" lIns="0" rIns="0" tIns="0" bIns="0" anchor="t">
+          <a:bodyPr wrap="square" lIns="0" tIns="0" rIns="0" bIns="0" anchor="t">
             <a:spAutoFit/>
           </a:bodyPr>
           <a:lstStyle/>
@@ -8674,6 +8921,7 @@
           <a:lstStyle/>
           <a:p>
             <a:pPr algn="ctr"/>
+            <a:endParaRPr/>
           </a:p>
         </p:txBody>
       </p:sp>
@@ -8694,7 +8942,7 @@
           <a:noFill/>
         </p:spPr>
         <p:txBody>
-          <a:bodyPr wrap="square" lIns="0" rIns="0" tIns="0" bIns="0" anchor="t">
+          <a:bodyPr wrap="square" lIns="0" tIns="0" rIns="0" bIns="0" anchor="t">
             <a:spAutoFit/>
           </a:bodyPr>
           <a:lstStyle/>
@@ -8729,7 +8977,7 @@
           <a:noFill/>
         </p:spPr>
         <p:txBody>
-          <a:bodyPr wrap="square" lIns="0" rIns="0" tIns="0" bIns="0" anchor="t">
+          <a:bodyPr wrap="square" lIns="0" tIns="0" rIns="0" bIns="0" anchor="t">
             <a:spAutoFit/>
           </a:bodyPr>
           <a:lstStyle/>
@@ -8764,7 +9012,7 @@
           <a:noFill/>
         </p:spPr>
         <p:txBody>
-          <a:bodyPr wrap="square" lIns="0" rIns="0" tIns="0" bIns="0" anchor="t">
+          <a:bodyPr wrap="square" lIns="0" tIns="0" rIns="0" bIns="0" anchor="t">
             <a:spAutoFit/>
           </a:bodyPr>
           <a:lstStyle/>
@@ -8799,7 +9047,7 @@
           <a:noFill/>
         </p:spPr>
         <p:txBody>
-          <a:bodyPr wrap="square" lIns="0" rIns="0" tIns="0" bIns="0" anchor="t">
+          <a:bodyPr wrap="square" lIns="0" tIns="0" rIns="0" bIns="0" anchor="t">
             <a:spAutoFit/>
           </a:bodyPr>
           <a:lstStyle/>
@@ -8834,7 +9082,7 @@
           <a:noFill/>
         </p:spPr>
         <p:txBody>
-          <a:bodyPr wrap="square" lIns="0" rIns="0" tIns="0" bIns="0" anchor="t">
+          <a:bodyPr wrap="square" lIns="0" tIns="0" rIns="0" bIns="0" anchor="t">
             <a:spAutoFit/>
           </a:bodyPr>
           <a:lstStyle/>
@@ -8869,7 +9117,7 @@
           <a:noFill/>
         </p:spPr>
         <p:txBody>
-          <a:bodyPr wrap="square" lIns="0" rIns="0" tIns="0" bIns="0" anchor="t">
+          <a:bodyPr wrap="square" lIns="0" tIns="0" rIns="0" bIns="0" anchor="t">
             <a:spAutoFit/>
           </a:bodyPr>
           <a:lstStyle/>
@@ -8904,7 +9152,7 @@
           <a:noFill/>
         </p:spPr>
         <p:txBody>
-          <a:bodyPr wrap="square" lIns="0" rIns="0" tIns="0" bIns="0" anchor="t">
+          <a:bodyPr wrap="square" lIns="0" tIns="0" rIns="0" bIns="0" anchor="t">
             <a:spAutoFit/>
           </a:bodyPr>
           <a:lstStyle/>
@@ -8927,13 +9175,13 @@
   <p:clrMapOvr>
     <a:masterClrMapping/>
   </p:clrMapOvr>
-  <mc:AlternateContent xmlns:mc="http://schemas.openxmlformats.org/markup-compatibility/2006">
-    <mc:Choice xmlns:p14="http://schemas.microsoft.com/office/powerpoint/2010/main" Requires="p14">
+  <mc:AlternateContent xmlns:mc="http://schemas.openxmlformats.org/markup-compatibility/2006" xmlns:p14="http://schemas.microsoft.com/office/powerpoint/2010/main">
+    <mc:Choice Requires="p14">
       <p:transition spd="med" p14:dur="700">
         <p:fade/>
       </p:transition>
     </mc:Choice>
-    <mc:Fallback>
+    <mc:Fallback xmlns="">
       <p:transition spd="med">
         <p:fade/>
       </p:transition>
@@ -8943,7 +9191,7 @@
 </file>
 
 <file path=ppt/slides/slide6.xml><?xml version="1.0" encoding="utf-8"?>
-<p:sld xmlns:a="http://schemas.openxmlformats.org/drawingml/2006/main" xmlns:p="http://schemas.openxmlformats.org/presentationml/2006/main" xmlns:r="http://schemas.openxmlformats.org/officeDocument/2006/relationships">
+<p:sld xmlns:a="http://schemas.openxmlformats.org/drawingml/2006/main" xmlns:r="http://schemas.openxmlformats.org/officeDocument/2006/relationships" xmlns:p="http://schemas.openxmlformats.org/presentationml/2006/main">
   <p:cSld>
     <p:spTree>
       <p:nvGrpSpPr>
@@ -8951,7 +9199,14 @@
         <p:cNvGrpSpPr/>
         <p:nvPr/>
       </p:nvGrpSpPr>
-      <p:grpSpPr/>
+      <p:grpSpPr>
+        <a:xfrm>
+          <a:off x="0" y="0"/>
+          <a:ext cx="0" cy="0"/>
+          <a:chOff x="0" y="0"/>
+          <a:chExt cx="0" cy="0"/>
+        </a:xfrm>
+      </p:grpSpPr>
       <p:pic>
         <p:nvPicPr>
           <p:cNvPr id="2" name="Picture 1" descr="_bg.png"/>
@@ -9040,6 +9295,7 @@
           <a:lstStyle/>
           <a:p>
             <a:pPr algn="ctr"/>
+            <a:endParaRPr/>
           </a:p>
         </p:txBody>
       </p:sp>
@@ -9060,7 +9316,7 @@
           <a:noFill/>
         </p:spPr>
         <p:txBody>
-          <a:bodyPr wrap="square" lIns="0" rIns="0" tIns="0" bIns="0" anchor="t">
+          <a:bodyPr wrap="square" lIns="0" tIns="0" rIns="0" bIns="0" anchor="t">
             <a:spAutoFit/>
           </a:bodyPr>
           <a:lstStyle/>
@@ -9125,6 +9381,7 @@
           <a:lstStyle/>
           <a:p>
             <a:pPr algn="ctr"/>
+            <a:endParaRPr/>
           </a:p>
         </p:txBody>
       </p:sp>
@@ -9199,6 +9456,7 @@
           <a:lstStyle/>
           <a:p>
             <a:pPr algn="ctr"/>
+            <a:endParaRPr/>
           </a:p>
         </p:txBody>
       </p:sp>
@@ -9245,6 +9503,7 @@
           <a:lstStyle/>
           <a:p>
             <a:pPr algn="ctr"/>
+            <a:endParaRPr/>
           </a:p>
         </p:txBody>
       </p:sp>
@@ -9319,6 +9578,7 @@
           <a:lstStyle/>
           <a:p>
             <a:pPr algn="ctr"/>
+            <a:endParaRPr/>
           </a:p>
         </p:txBody>
       </p:sp>
@@ -9393,6 +9653,7 @@
           <a:lstStyle/>
           <a:p>
             <a:pPr algn="ctr"/>
+            <a:endParaRPr/>
           </a:p>
         </p:txBody>
       </p:sp>
@@ -9467,6 +9728,7 @@
           <a:lstStyle/>
           <a:p>
             <a:pPr algn="ctr"/>
+            <a:endParaRPr/>
           </a:p>
         </p:txBody>
       </p:sp>
@@ -9541,6 +9803,7 @@
           <a:lstStyle/>
           <a:p>
             <a:pPr algn="ctr"/>
+            <a:endParaRPr/>
           </a:p>
         </p:txBody>
       </p:sp>
@@ -9587,6 +9850,7 @@
           <a:lstStyle/>
           <a:p>
             <a:pPr algn="ctr"/>
+            <a:endParaRPr/>
           </a:p>
         </p:txBody>
       </p:sp>
@@ -9661,6 +9925,7 @@
           <a:lstStyle/>
           <a:p>
             <a:pPr algn="ctr"/>
+            <a:endParaRPr/>
           </a:p>
         </p:txBody>
       </p:sp>
@@ -9735,6 +10000,7 @@
           <a:lstStyle/>
           <a:p>
             <a:pPr algn="ctr"/>
+            <a:endParaRPr/>
           </a:p>
         </p:txBody>
       </p:sp>
@@ -9809,6 +10075,7 @@
           <a:lstStyle/>
           <a:p>
             <a:pPr algn="ctr"/>
+            <a:endParaRPr/>
           </a:p>
         </p:txBody>
       </p:sp>
@@ -9855,6 +10122,7 @@
           <a:lstStyle/>
           <a:p>
             <a:pPr algn="ctr"/>
+            <a:endParaRPr/>
           </a:p>
         </p:txBody>
       </p:sp>
@@ -9899,7 +10167,7 @@
           <a:noFill/>
         </p:spPr>
         <p:txBody>
-          <a:bodyPr wrap="square" lIns="0" rIns="0" tIns="0" bIns="0" anchor="t">
+          <a:bodyPr wrap="square" lIns="0" tIns="0" rIns="0" bIns="0" anchor="t">
             <a:spAutoFit/>
           </a:bodyPr>
           <a:lstStyle/>
@@ -9913,41 +10181,6 @@
                 <a:latin typeface="JetBrains Mono"/>
               </a:rPr>
               <a:t>BSides Aarhus 2026  ·  June 20  ·  INCUBA Next, Aarhus</a:t>
-            </a:r>
-          </a:p>
-        </p:txBody>
-      </p:sp>
-      <p:sp>
-        <p:nvSpPr>
-          <p:cNvPr id="28" name="TextBox 27"/>
-          <p:cNvSpPr txBox="1"/>
-          <p:nvPr/>
-        </p:nvSpPr>
-        <p:spPr>
-          <a:xfrm>
-            <a:off x="10515600" y="6446520"/>
-            <a:ext cx="1188720" cy="274320"/>
-          </a:xfrm>
-          <a:prstGeom prst="rect">
-            <a:avLst/>
-          </a:prstGeom>
-          <a:noFill/>
-        </p:spPr>
-        <p:txBody>
-          <a:bodyPr wrap="square" lIns="0" rIns="0" tIns="0" bIns="0" anchor="t">
-            <a:spAutoFit/>
-          </a:bodyPr>
-          <a:lstStyle/>
-          <a:p>
-            <a:pPr algn="r"/>
-            <a:r>
-              <a:rPr sz="1000" b="0">
-                <a:solidFill>
-                  <a:srgbClr val="8888A0"/>
-                </a:solidFill>
-                <a:latin typeface="JetBrains Mono"/>
-              </a:rPr>
-              <a:t>Sponsors</a:t>
             </a:r>
           </a:p>
         </p:txBody>
@@ -9957,13 +10190,13 @@
   <p:clrMapOvr>
     <a:masterClrMapping/>
   </p:clrMapOvr>
-  <mc:AlternateContent xmlns:mc="http://schemas.openxmlformats.org/markup-compatibility/2006">
-    <mc:Choice xmlns:p14="http://schemas.microsoft.com/office/powerpoint/2010/main" Requires="p14">
+  <mc:AlternateContent xmlns:mc="http://schemas.openxmlformats.org/markup-compatibility/2006" xmlns:p14="http://schemas.microsoft.com/office/powerpoint/2010/main">
+    <mc:Choice Requires="p14">
       <p:transition spd="med" p14:dur="700">
         <p:fade/>
       </p:transition>
     </mc:Choice>
-    <mc:Fallback>
+    <mc:Fallback xmlns="">
       <p:transition spd="med">
         <p:fade/>
       </p:transition>
@@ -9973,7 +10206,7 @@
 </file>
 
 <file path=ppt/slides/slide7.xml><?xml version="1.0" encoding="utf-8"?>
-<p:sld xmlns:a="http://schemas.openxmlformats.org/drawingml/2006/main" xmlns:p="http://schemas.openxmlformats.org/presentationml/2006/main" xmlns:r="http://schemas.openxmlformats.org/officeDocument/2006/relationships">
+<p:sld xmlns:a="http://schemas.openxmlformats.org/drawingml/2006/main" xmlns:r="http://schemas.openxmlformats.org/officeDocument/2006/relationships" xmlns:p="http://schemas.openxmlformats.org/presentationml/2006/main">
   <p:cSld>
     <p:spTree>
       <p:nvGrpSpPr>
@@ -9981,7 +10214,14 @@
         <p:cNvGrpSpPr/>
         <p:nvPr/>
       </p:nvGrpSpPr>
-      <p:grpSpPr/>
+      <p:grpSpPr>
+        <a:xfrm>
+          <a:off x="0" y="0"/>
+          <a:ext cx="0" cy="0"/>
+          <a:chOff x="0" y="0"/>
+          <a:chExt cx="0" cy="0"/>
+        </a:xfrm>
+      </p:grpSpPr>
       <p:pic>
         <p:nvPicPr>
           <p:cNvPr id="2" name="Picture 1" descr="_bg.png"/>
@@ -10072,6 +10312,7 @@
           <a:lstStyle/>
           <a:p>
             <a:pPr algn="ctr"/>
+            <a:endParaRPr/>
           </a:p>
         </p:txBody>
       </p:sp>
@@ -10139,6 +10380,7 @@
           <a:lstStyle/>
           <a:p>
             <a:pPr algn="ctr"/>
+            <a:endParaRPr/>
           </a:p>
         </p:txBody>
       </p:sp>
@@ -10159,7 +10401,7 @@
           <a:noFill/>
         </p:spPr>
         <p:txBody>
-          <a:bodyPr wrap="square" lIns="0" rIns="0" tIns="0" bIns="0" anchor="t">
+          <a:bodyPr wrap="square" lIns="0" tIns="0" rIns="0" bIns="0" anchor="t">
             <a:spAutoFit/>
           </a:bodyPr>
           <a:lstStyle/>
@@ -10194,7 +10436,7 @@
           <a:noFill/>
         </p:spPr>
         <p:txBody>
-          <a:bodyPr wrap="square" lIns="0" rIns="0" tIns="0" bIns="0" anchor="t">
+          <a:bodyPr wrap="square" lIns="0" tIns="0" rIns="0" bIns="0" anchor="t">
             <a:spAutoFit/>
           </a:bodyPr>
           <a:lstStyle/>
@@ -10229,7 +10471,7 @@
           <a:noFill/>
         </p:spPr>
         <p:txBody>
-          <a:bodyPr wrap="square" lIns="0" rIns="0" tIns="0" bIns="0" anchor="t">
+          <a:bodyPr wrap="square" lIns="0" tIns="0" rIns="0" bIns="0" anchor="t">
             <a:spAutoFit/>
           </a:bodyPr>
           <a:lstStyle/>
@@ -10264,7 +10506,7 @@
           <a:noFill/>
         </p:spPr>
         <p:txBody>
-          <a:bodyPr wrap="square" lIns="0" rIns="0" tIns="0" bIns="0" anchor="t">
+          <a:bodyPr wrap="square" lIns="0" tIns="0" rIns="0" bIns="0" anchor="t">
             <a:spAutoFit/>
           </a:bodyPr>
           <a:lstStyle/>
@@ -10299,7 +10541,7 @@
           <a:noFill/>
         </p:spPr>
         <p:txBody>
-          <a:bodyPr wrap="square" lIns="0" rIns="0" tIns="0" bIns="0" anchor="t">
+          <a:bodyPr wrap="square" lIns="0" tIns="0" rIns="0" bIns="0" anchor="t">
             <a:spAutoFit/>
           </a:bodyPr>
           <a:lstStyle/>
@@ -10334,7 +10576,7 @@
           <a:noFill/>
         </p:spPr>
         <p:txBody>
-          <a:bodyPr wrap="square" lIns="0" rIns="0" tIns="0" bIns="0" anchor="t">
+          <a:bodyPr wrap="square" lIns="0" tIns="0" rIns="0" bIns="0" anchor="t">
             <a:spAutoFit/>
           </a:bodyPr>
           <a:lstStyle/>
@@ -10369,7 +10611,7 @@
           <a:noFill/>
         </p:spPr>
         <p:txBody>
-          <a:bodyPr wrap="square" lIns="0" rIns="0" tIns="0" bIns="0" anchor="t">
+          <a:bodyPr wrap="square" lIns="0" tIns="0" rIns="0" bIns="0" anchor="t">
             <a:spAutoFit/>
           </a:bodyPr>
           <a:lstStyle/>
@@ -10387,18 +10629,48 @@
           </a:p>
         </p:txBody>
       </p:sp>
+      <p:pic>
+        <p:nvPicPr>
+          <p:cNvPr id="15" name="Billede 14">
+            <a:extLst>
+              <a:ext uri="{FF2B5EF4-FFF2-40B4-BE49-F238E27FC236}">
+                <a16:creationId xmlns:a16="http://schemas.microsoft.com/office/drawing/2014/main" id="{D4346532-3835-0703-7EE5-6FF2E07D8622}"/>
+              </a:ext>
+            </a:extLst>
+          </p:cNvPr>
+          <p:cNvPicPr>
+            <a:picLocks noChangeAspect="1"/>
+          </p:cNvPicPr>
+          <p:nvPr/>
+        </p:nvPicPr>
+        <p:blipFill>
+          <a:blip r:embed="rId5"/>
+          <a:stretch>
+            <a:fillRect/>
+          </a:stretch>
+        </p:blipFill>
+        <p:spPr>
+          <a:xfrm>
+            <a:off x="10412509" y="137160"/>
+            <a:ext cx="1637211" cy="1637211"/>
+          </a:xfrm>
+          <a:prstGeom prst="rect">
+            <a:avLst/>
+          </a:prstGeom>
+        </p:spPr>
+      </p:pic>
     </p:spTree>
   </p:cSld>
   <p:clrMapOvr>
     <a:masterClrMapping/>
   </p:clrMapOvr>
-  <mc:AlternateContent xmlns:mc="http://schemas.openxmlformats.org/markup-compatibility/2006">
-    <mc:Choice xmlns:p14="http://schemas.microsoft.com/office/powerpoint/2010/main" Requires="p14">
+  <mc:AlternateContent xmlns:mc="http://schemas.openxmlformats.org/markup-compatibility/2006" xmlns:p14="http://schemas.microsoft.com/office/powerpoint/2010/main">
+    <mc:Choice Requires="p14">
       <p:transition spd="med" p14:dur="700">
         <p:fade/>
       </p:transition>
     </mc:Choice>
-    <mc:Fallback>
+    <mc:Fallback xmlns="">
       <p:transition spd="med">
         <p:fade/>
       </p:transition>
@@ -10408,7 +10680,7 @@
 </file>
 
 <file path=ppt/slides/slide8.xml><?xml version="1.0" encoding="utf-8"?>
-<p:sld xmlns:a="http://schemas.openxmlformats.org/drawingml/2006/main" xmlns:p="http://schemas.openxmlformats.org/presentationml/2006/main" xmlns:r="http://schemas.openxmlformats.org/officeDocument/2006/relationships">
+<p:sld xmlns:a="http://schemas.openxmlformats.org/drawingml/2006/main" xmlns:r="http://schemas.openxmlformats.org/officeDocument/2006/relationships" xmlns:p="http://schemas.openxmlformats.org/presentationml/2006/main">
   <p:cSld>
     <p:spTree>
       <p:nvGrpSpPr>
@@ -10416,7 +10688,14 @@
         <p:cNvGrpSpPr/>
         <p:nvPr/>
       </p:nvGrpSpPr>
-      <p:grpSpPr/>
+      <p:grpSpPr>
+        <a:xfrm>
+          <a:off x="0" y="0"/>
+          <a:ext cx="0" cy="0"/>
+          <a:chOff x="0" y="0"/>
+          <a:chExt cx="0" cy="0"/>
+        </a:xfrm>
+      </p:grpSpPr>
       <p:pic>
         <p:nvPicPr>
           <p:cNvPr id="2" name="Picture 1" descr="_bg.png"/>
@@ -10507,6 +10786,7 @@
           <a:lstStyle/>
           <a:p>
             <a:pPr algn="ctr"/>
+            <a:endParaRPr/>
           </a:p>
         </p:txBody>
       </p:sp>
@@ -10574,6 +10854,7 @@
           <a:lstStyle/>
           <a:p>
             <a:pPr algn="ctr"/>
+            <a:endParaRPr/>
           </a:p>
         </p:txBody>
       </p:sp>
@@ -10594,7 +10875,7 @@
           <a:noFill/>
         </p:spPr>
         <p:txBody>
-          <a:bodyPr wrap="square" lIns="0" rIns="0" tIns="0" bIns="0" anchor="t">
+          <a:bodyPr wrap="square" lIns="0" tIns="0" rIns="0" bIns="0" anchor="t">
             <a:spAutoFit/>
           </a:bodyPr>
           <a:lstStyle/>
@@ -10629,7 +10910,7 @@
           <a:noFill/>
         </p:spPr>
         <p:txBody>
-          <a:bodyPr wrap="square" lIns="0" rIns="0" tIns="0" bIns="0" anchor="t">
+          <a:bodyPr wrap="square" lIns="0" tIns="0" rIns="0" bIns="0" anchor="t">
             <a:spAutoFit/>
           </a:bodyPr>
           <a:lstStyle/>
@@ -10664,7 +10945,7 @@
           <a:noFill/>
         </p:spPr>
         <p:txBody>
-          <a:bodyPr wrap="square" lIns="0" rIns="0" tIns="0" bIns="0" anchor="t">
+          <a:bodyPr wrap="square" lIns="0" tIns="0" rIns="0" bIns="0" anchor="t">
             <a:spAutoFit/>
           </a:bodyPr>
           <a:lstStyle/>
@@ -10699,7 +10980,7 @@
           <a:noFill/>
         </p:spPr>
         <p:txBody>
-          <a:bodyPr wrap="square" lIns="0" rIns="0" tIns="0" bIns="0" anchor="t">
+          <a:bodyPr wrap="square" lIns="0" tIns="0" rIns="0" bIns="0" anchor="t">
             <a:spAutoFit/>
           </a:bodyPr>
           <a:lstStyle/>
@@ -10734,7 +11015,7 @@
           <a:noFill/>
         </p:spPr>
         <p:txBody>
-          <a:bodyPr wrap="square" lIns="0" rIns="0" tIns="0" bIns="0" anchor="t">
+          <a:bodyPr wrap="square" lIns="0" tIns="0" rIns="0" bIns="0" anchor="t">
             <a:spAutoFit/>
           </a:bodyPr>
           <a:lstStyle/>
@@ -10769,7 +11050,7 @@
           <a:noFill/>
         </p:spPr>
         <p:txBody>
-          <a:bodyPr wrap="square" lIns="0" rIns="0" tIns="0" bIns="0" anchor="t">
+          <a:bodyPr wrap="square" lIns="0" tIns="0" rIns="0" bIns="0" anchor="t">
             <a:spAutoFit/>
           </a:bodyPr>
           <a:lstStyle/>
@@ -10804,7 +11085,7 @@
           <a:noFill/>
         </p:spPr>
         <p:txBody>
-          <a:bodyPr wrap="square" lIns="0" rIns="0" tIns="0" bIns="0" anchor="t">
+          <a:bodyPr wrap="square" lIns="0" tIns="0" rIns="0" bIns="0" anchor="t">
             <a:spAutoFit/>
           </a:bodyPr>
           <a:lstStyle/>
@@ -10822,18 +11103,48 @@
           </a:p>
         </p:txBody>
       </p:sp>
+      <p:pic>
+        <p:nvPicPr>
+          <p:cNvPr id="14" name="Billede 13">
+            <a:extLst>
+              <a:ext uri="{FF2B5EF4-FFF2-40B4-BE49-F238E27FC236}">
+                <a16:creationId xmlns:a16="http://schemas.microsoft.com/office/drawing/2014/main" id="{AAD4D23D-4BBD-343C-A14E-70763304175C}"/>
+              </a:ext>
+            </a:extLst>
+          </p:cNvPr>
+          <p:cNvPicPr>
+            <a:picLocks noChangeAspect="1"/>
+          </p:cNvPicPr>
+          <p:nvPr/>
+        </p:nvPicPr>
+        <p:blipFill>
+          <a:blip r:embed="rId5"/>
+          <a:stretch>
+            <a:fillRect/>
+          </a:stretch>
+        </p:blipFill>
+        <p:spPr>
+          <a:xfrm>
+            <a:off x="10412509" y="137160"/>
+            <a:ext cx="1637211" cy="1637211"/>
+          </a:xfrm>
+          <a:prstGeom prst="rect">
+            <a:avLst/>
+          </a:prstGeom>
+        </p:spPr>
+      </p:pic>
     </p:spTree>
   </p:cSld>
   <p:clrMapOvr>
     <a:masterClrMapping/>
   </p:clrMapOvr>
-  <mc:AlternateContent xmlns:mc="http://schemas.openxmlformats.org/markup-compatibility/2006">
-    <mc:Choice xmlns:p14="http://schemas.microsoft.com/office/powerpoint/2010/main" Requires="p14">
+  <mc:AlternateContent xmlns:mc="http://schemas.openxmlformats.org/markup-compatibility/2006" xmlns:p14="http://schemas.microsoft.com/office/powerpoint/2010/main">
+    <mc:Choice Requires="p14">
       <p:transition spd="med" p14:dur="700">
         <p:fade/>
       </p:transition>
     </mc:Choice>
-    <mc:Fallback>
+    <mc:Fallback xmlns="">
       <p:transition spd="med">
         <p:fade/>
       </p:transition>
@@ -10843,7 +11154,7 @@
 </file>
 
 <file path=ppt/slides/slide9.xml><?xml version="1.0" encoding="utf-8"?>
-<p:sld xmlns:a="http://schemas.openxmlformats.org/drawingml/2006/main" xmlns:p="http://schemas.openxmlformats.org/presentationml/2006/main" xmlns:r="http://schemas.openxmlformats.org/officeDocument/2006/relationships">
+<p:sld xmlns:a="http://schemas.openxmlformats.org/drawingml/2006/main" xmlns:r="http://schemas.openxmlformats.org/officeDocument/2006/relationships" xmlns:p="http://schemas.openxmlformats.org/presentationml/2006/main">
   <p:cSld>
     <p:spTree>
       <p:nvGrpSpPr>
@@ -10851,7 +11162,14 @@
         <p:cNvGrpSpPr/>
         <p:nvPr/>
       </p:nvGrpSpPr>
-      <p:grpSpPr/>
+      <p:grpSpPr>
+        <a:xfrm>
+          <a:off x="0" y="0"/>
+          <a:ext cx="0" cy="0"/>
+          <a:chOff x="0" y="0"/>
+          <a:chExt cx="0" cy="0"/>
+        </a:xfrm>
+      </p:grpSpPr>
       <p:pic>
         <p:nvPicPr>
           <p:cNvPr id="2" name="Picture 1" descr="_bg.png"/>
@@ -10942,6 +11260,7 @@
           <a:lstStyle/>
           <a:p>
             <a:pPr algn="ctr"/>
+            <a:endParaRPr/>
           </a:p>
         </p:txBody>
       </p:sp>
@@ -11009,6 +11328,7 @@
           <a:lstStyle/>
           <a:p>
             <a:pPr algn="ctr"/>
+            <a:endParaRPr/>
           </a:p>
         </p:txBody>
       </p:sp>
@@ -11029,7 +11349,7 @@
           <a:noFill/>
         </p:spPr>
         <p:txBody>
-          <a:bodyPr wrap="square" lIns="0" rIns="0" tIns="0" bIns="0" anchor="t">
+          <a:bodyPr wrap="square" lIns="0" tIns="0" rIns="0" bIns="0" anchor="t">
             <a:spAutoFit/>
           </a:bodyPr>
           <a:lstStyle/>
@@ -11064,7 +11384,7 @@
           <a:noFill/>
         </p:spPr>
         <p:txBody>
-          <a:bodyPr wrap="square" lIns="0" rIns="0" tIns="0" bIns="0" anchor="t">
+          <a:bodyPr wrap="square" lIns="0" tIns="0" rIns="0" bIns="0" anchor="t">
             <a:spAutoFit/>
           </a:bodyPr>
           <a:lstStyle/>
@@ -11099,7 +11419,7 @@
           <a:noFill/>
         </p:spPr>
         <p:txBody>
-          <a:bodyPr wrap="square" lIns="0" rIns="0" tIns="0" bIns="0" anchor="t">
+          <a:bodyPr wrap="square" lIns="0" tIns="0" rIns="0" bIns="0" anchor="t">
             <a:spAutoFit/>
           </a:bodyPr>
           <a:lstStyle/>
@@ -11134,7 +11454,7 @@
           <a:noFill/>
         </p:spPr>
         <p:txBody>
-          <a:bodyPr wrap="square" lIns="0" rIns="0" tIns="0" bIns="0" anchor="t">
+          <a:bodyPr wrap="square" lIns="0" tIns="0" rIns="0" bIns="0" anchor="t">
             <a:spAutoFit/>
           </a:bodyPr>
           <a:lstStyle/>
@@ -11169,7 +11489,7 @@
           <a:noFill/>
         </p:spPr>
         <p:txBody>
-          <a:bodyPr wrap="square" lIns="0" rIns="0" tIns="0" bIns="0" anchor="t">
+          <a:bodyPr wrap="square" lIns="0" tIns="0" rIns="0" bIns="0" anchor="t">
             <a:spAutoFit/>
           </a:bodyPr>
           <a:lstStyle/>
@@ -11204,7 +11524,7 @@
           <a:noFill/>
         </p:spPr>
         <p:txBody>
-          <a:bodyPr wrap="square" lIns="0" rIns="0" tIns="0" bIns="0" anchor="t">
+          <a:bodyPr wrap="square" lIns="0" tIns="0" rIns="0" bIns="0" anchor="t">
             <a:spAutoFit/>
           </a:bodyPr>
           <a:lstStyle/>
@@ -11239,7 +11559,7 @@
           <a:noFill/>
         </p:spPr>
         <p:txBody>
-          <a:bodyPr wrap="square" lIns="0" rIns="0" tIns="0" bIns="0" anchor="t">
+          <a:bodyPr wrap="square" lIns="0" tIns="0" rIns="0" bIns="0" anchor="t">
             <a:spAutoFit/>
           </a:bodyPr>
           <a:lstStyle/>
@@ -11257,18 +11577,48 @@
           </a:p>
         </p:txBody>
       </p:sp>
+      <p:pic>
+        <p:nvPicPr>
+          <p:cNvPr id="14" name="Billede 13">
+            <a:extLst>
+              <a:ext uri="{FF2B5EF4-FFF2-40B4-BE49-F238E27FC236}">
+                <a16:creationId xmlns:a16="http://schemas.microsoft.com/office/drawing/2014/main" id="{D85CAF3A-0966-18A4-4C09-C4D38F3F0D59}"/>
+              </a:ext>
+            </a:extLst>
+          </p:cNvPr>
+          <p:cNvPicPr>
+            <a:picLocks noChangeAspect="1"/>
+          </p:cNvPicPr>
+          <p:nvPr/>
+        </p:nvPicPr>
+        <p:blipFill>
+          <a:blip r:embed="rId5"/>
+          <a:stretch>
+            <a:fillRect/>
+          </a:stretch>
+        </p:blipFill>
+        <p:spPr>
+          <a:xfrm>
+            <a:off x="10412509" y="137160"/>
+            <a:ext cx="1637211" cy="1637211"/>
+          </a:xfrm>
+          <a:prstGeom prst="rect">
+            <a:avLst/>
+          </a:prstGeom>
+        </p:spPr>
+      </p:pic>
     </p:spTree>
   </p:cSld>
   <p:clrMapOvr>
     <a:masterClrMapping/>
   </p:clrMapOvr>
-  <mc:AlternateContent xmlns:mc="http://schemas.openxmlformats.org/markup-compatibility/2006">
-    <mc:Choice xmlns:p14="http://schemas.microsoft.com/office/powerpoint/2010/main" Requires="p14">
+  <mc:AlternateContent xmlns:mc="http://schemas.openxmlformats.org/markup-compatibility/2006" xmlns:p14="http://schemas.microsoft.com/office/powerpoint/2010/main">
+    <mc:Choice Requires="p14">
       <p:transition spd="med" p14:dur="700">
         <p:fade/>
       </p:transition>
     </mc:Choice>
-    <mc:Fallback>
+    <mc:Fallback xmlns="">
       <p:transition spd="med">
         <p:fade/>
       </p:transition>

</xml_diff>